<commit_message>
docs: update presentation with current project state (814 exams, guided picker, AGHU code)
</commit_message>
<xml_diff>
--- a/docs/Apresentacao_HC-UFPE.pptx
+++ b/docs/Apresentacao_HC-UFPE.pptx
@@ -3564,7 +3564,7 @@
                 </a:solidFill>
                 <a:latin typeface="Inter Tight"/>
               </a:rPr>
-              <a:t>RAG · Next.js · Serverless</a:t>
+              <a:t>Next.js · Serverless · Claude</a:t>
             </a:r>
           </a:p>
         </p:txBody>
@@ -3906,7 +3906,7 @@
                 </a:solidFill>
                 <a:latin typeface="Georgia"/>
               </a:rPr>
-              <a:t>Cobertura total</a:t>
+              <a:t>Preencher preparos</a:t>
             </a:r>
           </a:p>
           <a:p>
@@ -3922,7 +3922,7 @@
                 </a:solidFill>
                 <a:latin typeface="Inter Tight"/>
               </a:rPr>
-              <a:t>Digitalizar TC, RX e MN até os 914 exames.</a:t>
+              <a:t>Digitalizar folhas de TC e Medicina Nuclear → tirar 391 exames do pendente.</a:t>
             </a:r>
           </a:p>
         </p:txBody>
@@ -4025,7 +4025,7 @@
                 </a:solidFill>
                 <a:latin typeface="Georgia"/>
               </a:rPr>
-              <a:t>RAG persistido</a:t>
+              <a:t>Curar rótulos</a:t>
             </a:r>
           </a:p>
           <a:p>
@@ -4041,7 +4041,7 @@
                 </a:solidFill>
                 <a:latin typeface="Inter Tight"/>
               </a:rPr>
-              <a:t>Índice de embeddings dedicado se a base crescer.</a:t>
+              <a:t>Corrigir typos herdados da planilha nos nomes exibidos.</a:t>
             </a:r>
           </a:p>
         </p:txBody>
@@ -4160,7 +4160,7 @@
                 </a:solidFill>
                 <a:latin typeface="Inter Tight"/>
               </a:rPr>
-              <a:t>Reintroduzir navegação visual por região.</a:t>
+              <a:t>Reintroduzir navegação visual por região do corpo.</a:t>
             </a:r>
           </a:p>
         </p:txBody>
@@ -4279,7 +4279,7 @@
                 </a:solidFill>
                 <a:latin typeface="Inter Tight"/>
               </a:rPr>
-              <a:t>Equipe do HC edita conteúdo sem programador (Supabase).</a:t>
+              <a:t>Equipe do HC edita conteúdo sem programador (ex.: Supabase).</a:t>
             </a:r>
           </a:p>
         </p:txBody>
@@ -5562,16 +5562,16 @@
               </a:lnSpc>
             </a:pPr>
             <a:r>
-              <a:rPr sz="3800" i="0">
+              <a:rPr sz="3600" i="0">
                 <a:solidFill>
                   <a:srgbClr val="0B2545"/>
                 </a:solidFill>
                 <a:latin typeface="Georgia"/>
               </a:rPr>
-              <a:t>914 exames, </a:t>
-            </a:r>
-            <a:r>
-              <a:rPr sz="3800" i="1">
+              <a:t>814 exames ingeridos, </a:t>
+            </a:r>
+            <a:r>
+              <a:rPr sz="3600" i="1">
                 <a:solidFill>
                   <a:srgbClr val="14418A"/>
                 </a:solidFill>
@@ -5580,7 +5580,7 @@
               <a:t>3 fontes</a:t>
             </a:r>
             <a:r>
-              <a:rPr sz="3800" i="0">
+              <a:rPr sz="3600" i="0">
                 <a:solidFill>
                   <a:srgbClr val="0B2545"/>
                 </a:solidFill>
@@ -5599,8 +5599,8 @@
         </p:nvSpPr>
         <p:spPr>
           <a:xfrm>
-            <a:off x="777240" y="2148840"/>
-            <a:ext cx="3332378" cy="1691640"/>
+            <a:off x="777240" y="2103120"/>
+            <a:ext cx="3332378" cy="1554480"/>
           </a:xfrm>
           <a:prstGeom prst="roundRect">
             <a:avLst>
@@ -5647,8 +5647,8 @@
         </p:nvSpPr>
         <p:spPr>
           <a:xfrm>
-            <a:off x="1033272" y="2368296"/>
-            <a:ext cx="2820314" cy="1325880"/>
+            <a:off x="1033272" y="2304288"/>
+            <a:ext cx="2820314" cy="1188720"/>
           </a:xfrm>
           <a:prstGeom prst="rect">
             <a:avLst/>
@@ -5683,7 +5683,7 @@
               </a:spcAft>
             </a:pPr>
             <a:r>
-              <a:rPr sz="2000" b="0" i="0">
+              <a:rPr sz="1800" b="0" i="0">
                 <a:solidFill>
                   <a:srgbClr val="0B2545"/>
                 </a:solidFill>
@@ -5695,17 +5695,17 @@
           <a:p>
             <a:pPr algn="l">
               <a:lnSpc>
-                <a:spcPct val="128000"/>
+                <a:spcPct val="125000"/>
               </a:lnSpc>
             </a:pPr>
             <a:r>
-              <a:rPr sz="1100" b="0" i="0">
+              <a:rPr sz="1050" b="0" i="0">
                 <a:solidFill>
                   <a:srgbClr val="5A7299"/>
                 </a:solidFill>
                 <a:latin typeface="Inter Tight"/>
               </a:rPr>
-              <a:t>Planilha com os 914 exames: nome, sigla, sinônimos e modalidade.</a:t>
+              <a:t>Planilha com 914 linhas → 814 exames únicos: nome, sigla, sinônimos, modalidade.</a:t>
             </a:r>
           </a:p>
         </p:txBody>
@@ -5718,8 +5718,8 @@
         </p:nvSpPr>
         <p:spPr>
           <a:xfrm>
-            <a:off x="4429658" y="2148840"/>
-            <a:ext cx="3332378" cy="1691640"/>
+            <a:off x="4429658" y="2103120"/>
+            <a:ext cx="3332378" cy="1554480"/>
           </a:xfrm>
           <a:prstGeom prst="roundRect">
             <a:avLst>
@@ -5766,8 +5766,8 @@
         </p:nvSpPr>
         <p:spPr>
           <a:xfrm>
-            <a:off x="4685690" y="2368296"/>
-            <a:ext cx="2820314" cy="1325880"/>
+            <a:off x="4685690" y="2304288"/>
+            <a:ext cx="2820314" cy="1188720"/>
           </a:xfrm>
           <a:prstGeom prst="rect">
             <a:avLst/>
@@ -5802,7 +5802,7 @@
               </a:spcAft>
             </a:pPr>
             <a:r>
-              <a:rPr sz="2000" b="0" i="0">
+              <a:rPr sz="1800" b="0" i="0">
                 <a:solidFill>
                   <a:srgbClr val="0B2545"/>
                 </a:solidFill>
@@ -5814,11 +5814,11 @@
           <a:p>
             <a:pPr algn="l">
               <a:lnSpc>
-                <a:spcPct val="128000"/>
+                <a:spcPct val="125000"/>
               </a:lnSpc>
             </a:pPr>
             <a:r>
-              <a:rPr sz="1100" b="0" i="0">
+              <a:rPr sz="1050" b="0" i="0">
                 <a:solidFill>
                   <a:srgbClr val="5A7299"/>
                 </a:solidFill>
@@ -5837,8 +5837,8 @@
         </p:nvSpPr>
         <p:spPr>
           <a:xfrm>
-            <a:off x="8082076" y="2148840"/>
-            <a:ext cx="3332378" cy="1691640"/>
+            <a:off x="8082076" y="2103120"/>
+            <a:ext cx="3332378" cy="1554480"/>
           </a:xfrm>
           <a:prstGeom prst="roundRect">
             <a:avLst>
@@ -5885,8 +5885,8 @@
         </p:nvSpPr>
         <p:spPr>
           <a:xfrm>
-            <a:off x="8338108" y="2368296"/>
-            <a:ext cx="2820314" cy="1325880"/>
+            <a:off x="8338108" y="2304288"/>
+            <a:ext cx="2820314" cy="1188720"/>
           </a:xfrm>
           <a:prstGeom prst="rect">
             <a:avLst/>
@@ -5921,7 +5921,7 @@
               </a:spcAft>
             </a:pPr>
             <a:r>
-              <a:rPr sz="2000" b="0" i="0">
+              <a:rPr sz="1800" b="0" i="0">
                 <a:solidFill>
                   <a:srgbClr val="0B2545"/>
                 </a:solidFill>
@@ -5933,11 +5933,11 @@
           <a:p>
             <a:pPr algn="l">
               <a:lnSpc>
-                <a:spcPct val="128000"/>
+                <a:spcPct val="125000"/>
               </a:lnSpc>
             </a:pPr>
             <a:r>
-              <a:rPr sz="1100" b="0" i="0">
+              <a:rPr sz="1050" b="0" i="0">
                 <a:solidFill>
                   <a:srgbClr val="5A7299"/>
                 </a:solidFill>
@@ -5956,8 +5956,8 @@
         </p:nvSpPr>
         <p:spPr>
           <a:xfrm>
-            <a:off x="777240" y="4160520"/>
-            <a:ext cx="2194560" cy="384048"/>
+            <a:off x="777240" y="3886200"/>
+            <a:ext cx="2194560" cy="365760"/>
           </a:xfrm>
           <a:prstGeom prst="rect">
             <a:avLst/>
@@ -5972,7 +5972,7 @@
           <a:p>
             <a:pPr algn="l"/>
             <a:r>
-              <a:rPr sz="1200" b="0" i="0">
+              <a:rPr sz="1150" b="0" i="0">
                 <a:solidFill>
                   <a:srgbClr val="0B2545"/>
                 </a:solidFill>
@@ -5991,8 +5991,8 @@
         </p:nvSpPr>
         <p:spPr>
           <a:xfrm>
-            <a:off x="2971800" y="4270248"/>
-            <a:ext cx="6583680" cy="146304"/>
+            <a:off x="2971800" y="3986784"/>
+            <a:ext cx="6035040" cy="146304"/>
           </a:xfrm>
           <a:prstGeom prst="roundRect">
             <a:avLst>
@@ -6037,8 +6037,216 @@
         </p:nvSpPr>
         <p:spPr>
           <a:xfrm>
-            <a:off x="2971800" y="4270248"/>
-            <a:ext cx="6583680" cy="146304"/>
+            <a:off x="2971800" y="3986784"/>
+            <a:ext cx="6035040" cy="146304"/>
+          </a:xfrm>
+          <a:prstGeom prst="roundRect">
+            <a:avLst>
+              <a:gd name="adj" fmla="val 6000"/>
+            </a:avLst>
+          </a:prstGeom>
+          <a:solidFill>
+            <a:srgbClr val="DCE8FA"/>
+          </a:solidFill>
+          <a:ln>
+            <a:noFill/>
+          </a:ln>
+          <a:effectLst/>
+        </p:spPr>
+        <p:style>
+          <a:lnRef idx="1">
+            <a:schemeClr val="accent1"/>
+          </a:lnRef>
+          <a:fillRef idx="3">
+            <a:schemeClr val="accent1"/>
+          </a:fillRef>
+          <a:effectRef idx="2">
+            <a:schemeClr val="accent1"/>
+          </a:effectRef>
+          <a:fontRef idx="minor">
+            <a:schemeClr val="lt1"/>
+          </a:fontRef>
+        </p:style>
+        <p:txBody>
+          <a:bodyPr rtlCol="0" anchor="ctr"/>
+          <a:lstStyle/>
+          <a:p>
+            <a:pPr algn="ctr"/>
+          </a:p>
+        </p:txBody>
+      </p:sp>
+      <p:sp>
+        <p:nvSpPr>
+          <p:cNvPr id="15" name="TextBox 14"/>
+          <p:cNvSpPr txBox="1"/>
+          <p:nvPr/>
+        </p:nvSpPr>
+        <p:spPr>
+          <a:xfrm>
+            <a:off x="9189720" y="3886200"/>
+            <a:ext cx="1280160" cy="365760"/>
+          </a:xfrm>
+          <a:prstGeom prst="rect">
+            <a:avLst/>
+          </a:prstGeom>
+          <a:noFill/>
+        </p:spPr>
+        <p:txBody>
+          <a:bodyPr wrap="square" lIns="0" rIns="0" tIns="0" bIns="0" anchor="ctr">
+            <a:spAutoFit/>
+          </a:bodyPr>
+          <a:lstStyle/>
+          <a:p>
+            <a:pPr algn="l"/>
+            <a:r>
+              <a:rPr sz="1100" b="1" i="0">
+                <a:solidFill>
+                  <a:srgbClr val="14418A"/>
+                </a:solidFill>
+                <a:latin typeface="Inter Tight"/>
+              </a:rPr>
+              <a:t>0/259</a:t>
+            </a:r>
+          </a:p>
+        </p:txBody>
+      </p:sp>
+      <p:sp>
+        <p:nvSpPr>
+          <p:cNvPr id="16" name="TextBox 15"/>
+          <p:cNvSpPr txBox="1"/>
+          <p:nvPr/>
+        </p:nvSpPr>
+        <p:spPr>
+          <a:xfrm>
+            <a:off x="777240" y="4297680"/>
+            <a:ext cx="2194560" cy="365760"/>
+          </a:xfrm>
+          <a:prstGeom prst="rect">
+            <a:avLst/>
+          </a:prstGeom>
+          <a:noFill/>
+        </p:spPr>
+        <p:txBody>
+          <a:bodyPr wrap="square" lIns="0" rIns="0" tIns="0" bIns="0" anchor="ctr">
+            <a:spAutoFit/>
+          </a:bodyPr>
+          <a:lstStyle/>
+          <a:p>
+            <a:pPr algn="l"/>
+            <a:r>
+              <a:rPr sz="1150" b="0" i="0">
+                <a:solidFill>
+                  <a:srgbClr val="0B2545"/>
+                </a:solidFill>
+                <a:latin typeface="Inter Tight"/>
+              </a:rPr>
+              <a:t>Radiologia Conv.</a:t>
+            </a:r>
+          </a:p>
+        </p:txBody>
+      </p:sp>
+      <p:sp>
+        <p:nvSpPr>
+          <p:cNvPr id="17" name="Rounded Rectangle 16"/>
+          <p:cNvSpPr/>
+          <p:nvPr/>
+        </p:nvSpPr>
+        <p:spPr>
+          <a:xfrm>
+            <a:off x="2971800" y="4398264"/>
+            <a:ext cx="6035040" cy="146304"/>
+          </a:xfrm>
+          <a:prstGeom prst="roundRect">
+            <a:avLst>
+              <a:gd name="adj" fmla="val 6000"/>
+            </a:avLst>
+          </a:prstGeom>
+          <a:solidFill>
+            <a:srgbClr val="EAF1FB"/>
+          </a:solidFill>
+          <a:ln>
+            <a:noFill/>
+          </a:ln>
+          <a:effectLst/>
+        </p:spPr>
+        <p:style>
+          <a:lnRef idx="1">
+            <a:schemeClr val="accent1"/>
+          </a:lnRef>
+          <a:fillRef idx="3">
+            <a:schemeClr val="accent1"/>
+          </a:fillRef>
+          <a:effectRef idx="2">
+            <a:schemeClr val="accent1"/>
+          </a:effectRef>
+          <a:fontRef idx="minor">
+            <a:schemeClr val="lt1"/>
+          </a:fontRef>
+        </p:style>
+        <p:txBody>
+          <a:bodyPr rtlCol="0" anchor="ctr"/>
+          <a:lstStyle/>
+          <a:p>
+            <a:pPr algn="ctr"/>
+          </a:p>
+        </p:txBody>
+      </p:sp>
+      <p:sp>
+        <p:nvSpPr>
+          <p:cNvPr id="18" name="Rounded Rectangle 17"/>
+          <p:cNvSpPr/>
+          <p:nvPr/>
+        </p:nvSpPr>
+        <p:spPr>
+          <a:xfrm>
+            <a:off x="2971800" y="4398264"/>
+            <a:ext cx="4939878" cy="146304"/>
+          </a:xfrm>
+          <a:prstGeom prst="roundRect">
+            <a:avLst>
+              <a:gd name="adj" fmla="val 6000"/>
+            </a:avLst>
+          </a:prstGeom>
+          <a:solidFill>
+            <a:srgbClr val="DCE8FA"/>
+          </a:solidFill>
+          <a:ln>
+            <a:noFill/>
+          </a:ln>
+          <a:effectLst/>
+        </p:spPr>
+        <p:style>
+          <a:lnRef idx="1">
+            <a:schemeClr val="accent1"/>
+          </a:lnRef>
+          <a:fillRef idx="3">
+            <a:schemeClr val="accent1"/>
+          </a:fillRef>
+          <a:effectRef idx="2">
+            <a:schemeClr val="accent1"/>
+          </a:effectRef>
+          <a:fontRef idx="minor">
+            <a:schemeClr val="lt1"/>
+          </a:fontRef>
+        </p:style>
+        <p:txBody>
+          <a:bodyPr rtlCol="0" anchor="ctr"/>
+          <a:lstStyle/>
+          <a:p>
+            <a:pPr algn="ctr"/>
+          </a:p>
+        </p:txBody>
+      </p:sp>
+      <p:sp>
+        <p:nvSpPr>
+          <p:cNvPr id="19" name="Rounded Rectangle 18"/>
+          <p:cNvSpPr/>
+          <p:nvPr/>
+        </p:nvSpPr>
+        <p:spPr>
+          <a:xfrm>
+            <a:off x="2971800" y="4398264"/>
+            <a:ext cx="4753467" cy="146304"/>
           </a:xfrm>
           <a:prstGeom prst="roundRect">
             <a:avLst>
@@ -6077,14 +6285,14 @@
       </p:sp>
       <p:sp>
         <p:nvSpPr>
-          <p:cNvPr id="15" name="TextBox 14"/>
+          <p:cNvPr id="20" name="TextBox 19"/>
           <p:cNvSpPr txBox="1"/>
           <p:nvPr/>
         </p:nvSpPr>
         <p:spPr>
           <a:xfrm>
-            <a:off x="9784080" y="4160520"/>
-            <a:ext cx="822960" cy="384048"/>
+            <a:off x="9189720" y="4297680"/>
+            <a:ext cx="1280160" cy="365760"/>
           </a:xfrm>
           <a:prstGeom prst="rect">
             <a:avLst/>
@@ -6099,27 +6307,27 @@
           <a:p>
             <a:pPr algn="l"/>
             <a:r>
-              <a:rPr sz="1200" b="1" i="0">
+              <a:rPr sz="1100" b="1" i="0">
                 <a:solidFill>
                   <a:srgbClr val="14418A"/>
                 </a:solidFill>
                 <a:latin typeface="Inter Tight"/>
               </a:rPr>
-              <a:t>286</a:t>
-            </a:r>
-          </a:p>
-        </p:txBody>
-      </p:sp>
-      <p:sp>
-        <p:nvSpPr>
-          <p:cNvPr id="16" name="TextBox 15"/>
+              <a:t>204/212</a:t>
+            </a:r>
+          </a:p>
+        </p:txBody>
+      </p:sp>
+      <p:sp>
+        <p:nvSpPr>
+          <p:cNvPr id="21" name="TextBox 20"/>
           <p:cNvSpPr txBox="1"/>
           <p:nvPr/>
         </p:nvSpPr>
         <p:spPr>
           <a:xfrm>
-            <a:off x="777240" y="4599432"/>
-            <a:ext cx="2194560" cy="384048"/>
+            <a:off x="777240" y="4709160"/>
+            <a:ext cx="2194560" cy="365760"/>
           </a:xfrm>
           <a:prstGeom prst="rect">
             <a:avLst/>
@@ -6134,27 +6342,27 @@
           <a:p>
             <a:pPr algn="l"/>
             <a:r>
-              <a:rPr sz="1200" b="0" i="0">
+              <a:rPr sz="1150" b="0" i="0">
                 <a:solidFill>
                   <a:srgbClr val="0B2545"/>
                 </a:solidFill>
                 <a:latin typeface="Inter Tight"/>
               </a:rPr>
-              <a:t>Radiologia Conv.</a:t>
-            </a:r>
-          </a:p>
-        </p:txBody>
-      </p:sp>
-      <p:sp>
-        <p:nvSpPr>
-          <p:cNvPr id="17" name="Rounded Rectangle 16"/>
+              <a:t>Ressonância</a:t>
+            </a:r>
+          </a:p>
+        </p:txBody>
+      </p:sp>
+      <p:sp>
+        <p:nvSpPr>
+          <p:cNvPr id="22" name="Rounded Rectangle 21"/>
           <p:cNvSpPr/>
           <p:nvPr/>
         </p:nvSpPr>
         <p:spPr>
           <a:xfrm>
-            <a:off x="2971800" y="4709160"/>
-            <a:ext cx="6583680" cy="146304"/>
+            <a:off x="2971800" y="4809744"/>
+            <a:ext cx="6035040" cy="146304"/>
           </a:xfrm>
           <a:prstGeom prst="roundRect">
             <a:avLst>
@@ -6193,14 +6401,60 @@
       </p:sp>
       <p:sp>
         <p:nvSpPr>
-          <p:cNvPr id="18" name="Rounded Rectangle 17"/>
+          <p:cNvPr id="23" name="Rounded Rectangle 22"/>
           <p:cNvSpPr/>
           <p:nvPr/>
         </p:nvSpPr>
         <p:spPr>
           <a:xfrm>
-            <a:off x="2971800" y="4709160"/>
-            <a:ext cx="5003596" cy="146304"/>
+            <a:off x="2971800" y="4809744"/>
+            <a:ext cx="4497153" cy="146304"/>
+          </a:xfrm>
+          <a:prstGeom prst="roundRect">
+            <a:avLst>
+              <a:gd name="adj" fmla="val 6000"/>
+            </a:avLst>
+          </a:prstGeom>
+          <a:solidFill>
+            <a:srgbClr val="DCE8FA"/>
+          </a:solidFill>
+          <a:ln>
+            <a:noFill/>
+          </a:ln>
+          <a:effectLst/>
+        </p:spPr>
+        <p:style>
+          <a:lnRef idx="1">
+            <a:schemeClr val="accent1"/>
+          </a:lnRef>
+          <a:fillRef idx="3">
+            <a:schemeClr val="accent1"/>
+          </a:fillRef>
+          <a:effectRef idx="2">
+            <a:schemeClr val="accent1"/>
+          </a:effectRef>
+          <a:fontRef idx="minor">
+            <a:schemeClr val="lt1"/>
+          </a:fontRef>
+        </p:style>
+        <p:txBody>
+          <a:bodyPr rtlCol="0" anchor="ctr"/>
+          <a:lstStyle/>
+          <a:p>
+            <a:pPr algn="ctr"/>
+          </a:p>
+        </p:txBody>
+      </p:sp>
+      <p:sp>
+        <p:nvSpPr>
+          <p:cNvPr id="24" name="Rounded Rectangle 23"/>
+          <p:cNvSpPr/>
+          <p:nvPr/>
+        </p:nvSpPr>
+        <p:spPr>
+          <a:xfrm>
+            <a:off x="2971800" y="4809744"/>
+            <a:ext cx="4497153" cy="146304"/>
           </a:xfrm>
           <a:prstGeom prst="roundRect">
             <a:avLst>
@@ -6239,14 +6493,14 @@
       </p:sp>
       <p:sp>
         <p:nvSpPr>
-          <p:cNvPr id="19" name="TextBox 18"/>
+          <p:cNvPr id="25" name="TextBox 24"/>
           <p:cNvSpPr txBox="1"/>
           <p:nvPr/>
         </p:nvSpPr>
         <p:spPr>
           <a:xfrm>
-            <a:off x="9784080" y="4599432"/>
-            <a:ext cx="822960" cy="384048"/>
+            <a:off x="9189720" y="4709160"/>
+            <a:ext cx="1280160" cy="365760"/>
           </a:xfrm>
           <a:prstGeom prst="rect">
             <a:avLst/>
@@ -6261,27 +6515,27 @@
           <a:p>
             <a:pPr algn="l"/>
             <a:r>
-              <a:rPr sz="1200" b="1" i="0">
+              <a:rPr sz="1100" b="1" i="0">
                 <a:solidFill>
                   <a:srgbClr val="14418A"/>
                 </a:solidFill>
                 <a:latin typeface="Inter Tight"/>
               </a:rPr>
-              <a:t>217</a:t>
-            </a:r>
-          </a:p>
-        </p:txBody>
-      </p:sp>
-      <p:sp>
-        <p:nvSpPr>
-          <p:cNvPr id="20" name="TextBox 19"/>
+              <a:t>193/193</a:t>
+            </a:r>
+          </a:p>
+        </p:txBody>
+      </p:sp>
+      <p:sp>
+        <p:nvSpPr>
+          <p:cNvPr id="26" name="TextBox 25"/>
           <p:cNvSpPr txBox="1"/>
           <p:nvPr/>
         </p:nvSpPr>
         <p:spPr>
           <a:xfrm>
-            <a:off x="777240" y="5038344"/>
-            <a:ext cx="2194560" cy="384048"/>
+            <a:off x="777240" y="5120640"/>
+            <a:ext cx="2194560" cy="365760"/>
           </a:xfrm>
           <a:prstGeom prst="rect">
             <a:avLst/>
@@ -6296,27 +6550,27 @@
           <a:p>
             <a:pPr algn="l"/>
             <a:r>
-              <a:rPr sz="1200" b="0" i="0">
+              <a:rPr sz="1150" b="0" i="0">
                 <a:solidFill>
                   <a:srgbClr val="0B2545"/>
                 </a:solidFill>
                 <a:latin typeface="Inter Tight"/>
               </a:rPr>
-              <a:t>Ressonância</a:t>
-            </a:r>
-          </a:p>
-        </p:txBody>
-      </p:sp>
-      <p:sp>
-        <p:nvSpPr>
-          <p:cNvPr id="21" name="Rounded Rectangle 20"/>
+              <a:t>Ultrassonografia</a:t>
+            </a:r>
+          </a:p>
+        </p:txBody>
+      </p:sp>
+      <p:sp>
+        <p:nvSpPr>
+          <p:cNvPr id="27" name="Rounded Rectangle 26"/>
           <p:cNvSpPr/>
           <p:nvPr/>
         </p:nvSpPr>
         <p:spPr>
           <a:xfrm>
-            <a:off x="2971800" y="5148072"/>
-            <a:ext cx="6583680" cy="146304"/>
+            <a:off x="2971800" y="5221224"/>
+            <a:ext cx="6035040" cy="146304"/>
           </a:xfrm>
           <a:prstGeom prst="roundRect">
             <a:avLst>
@@ -6355,14 +6609,60 @@
       </p:sp>
       <p:sp>
         <p:nvSpPr>
-          <p:cNvPr id="22" name="Rounded Rectangle 21"/>
+          <p:cNvPr id="28" name="Rounded Rectangle 27"/>
           <p:cNvSpPr/>
           <p:nvPr/>
         </p:nvSpPr>
         <p:spPr>
           <a:xfrm>
-            <a:off x="2971800" y="5148072"/>
-            <a:ext cx="4411065" cy="146304"/>
+            <a:off x="2971800" y="5221224"/>
+            <a:ext cx="2516541" cy="146304"/>
+          </a:xfrm>
+          <a:prstGeom prst="roundRect">
+            <a:avLst>
+              <a:gd name="adj" fmla="val 6000"/>
+            </a:avLst>
+          </a:prstGeom>
+          <a:solidFill>
+            <a:srgbClr val="DCE8FA"/>
+          </a:solidFill>
+          <a:ln>
+            <a:noFill/>
+          </a:ln>
+          <a:effectLst/>
+        </p:spPr>
+        <p:style>
+          <a:lnRef idx="1">
+            <a:schemeClr val="accent1"/>
+          </a:lnRef>
+          <a:fillRef idx="3">
+            <a:schemeClr val="accent1"/>
+          </a:fillRef>
+          <a:effectRef idx="2">
+            <a:schemeClr val="accent1"/>
+          </a:effectRef>
+          <a:fontRef idx="minor">
+            <a:schemeClr val="lt1"/>
+          </a:fontRef>
+        </p:style>
+        <p:txBody>
+          <a:bodyPr rtlCol="0" anchor="ctr"/>
+          <a:lstStyle/>
+          <a:p>
+            <a:pPr algn="ctr"/>
+          </a:p>
+        </p:txBody>
+      </p:sp>
+      <p:sp>
+        <p:nvSpPr>
+          <p:cNvPr id="29" name="Rounded Rectangle 28"/>
+          <p:cNvSpPr/>
+          <p:nvPr/>
+        </p:nvSpPr>
+        <p:spPr>
+          <a:xfrm>
+            <a:off x="2971800" y="5221224"/>
+            <a:ext cx="372821" cy="146304"/>
           </a:xfrm>
           <a:prstGeom prst="roundRect">
             <a:avLst>
@@ -6401,14 +6701,14 @@
       </p:sp>
       <p:sp>
         <p:nvSpPr>
-          <p:cNvPr id="23" name="TextBox 22"/>
+          <p:cNvPr id="30" name="TextBox 29"/>
           <p:cNvSpPr txBox="1"/>
           <p:nvPr/>
         </p:nvSpPr>
         <p:spPr>
           <a:xfrm>
-            <a:off x="9784080" y="5038344"/>
-            <a:ext cx="822960" cy="384048"/>
+            <a:off x="9189720" y="5120640"/>
+            <a:ext cx="1280160" cy="365760"/>
           </a:xfrm>
           <a:prstGeom prst="rect">
             <a:avLst/>
@@ -6423,27 +6723,27 @@
           <a:p>
             <a:pPr algn="l"/>
             <a:r>
-              <a:rPr sz="1200" b="1" i="0">
+              <a:rPr sz="1100" b="1" i="0">
                 <a:solidFill>
                   <a:srgbClr val="14418A"/>
                 </a:solidFill>
                 <a:latin typeface="Inter Tight"/>
               </a:rPr>
-              <a:t>193</a:t>
-            </a:r>
-          </a:p>
-        </p:txBody>
-      </p:sp>
-      <p:sp>
-        <p:nvSpPr>
-          <p:cNvPr id="24" name="TextBox 23"/>
+              <a:t>16/108</a:t>
+            </a:r>
+          </a:p>
+        </p:txBody>
+      </p:sp>
+      <p:sp>
+        <p:nvSpPr>
+          <p:cNvPr id="31" name="TextBox 30"/>
           <p:cNvSpPr txBox="1"/>
           <p:nvPr/>
         </p:nvSpPr>
         <p:spPr>
           <a:xfrm>
-            <a:off x="777240" y="5477256"/>
-            <a:ext cx="2194560" cy="384048"/>
+            <a:off x="777240" y="5532120"/>
+            <a:ext cx="2194560" cy="365760"/>
           </a:xfrm>
           <a:prstGeom prst="rect">
             <a:avLst/>
@@ -6458,27 +6758,27 @@
           <a:p>
             <a:pPr algn="l"/>
             <a:r>
-              <a:rPr sz="1200" b="0" i="0">
+              <a:rPr sz="1150" b="0" i="0">
                 <a:solidFill>
                   <a:srgbClr val="0B2545"/>
                 </a:solidFill>
                 <a:latin typeface="Inter Tight"/>
               </a:rPr>
-              <a:t>Ultrassonografia</a:t>
-            </a:r>
-          </a:p>
-        </p:txBody>
-      </p:sp>
-      <p:sp>
-        <p:nvSpPr>
-          <p:cNvPr id="25" name="Rounded Rectangle 24"/>
+              <a:t>Medicina Nuclear</a:t>
+            </a:r>
+          </a:p>
+        </p:txBody>
+      </p:sp>
+      <p:sp>
+        <p:nvSpPr>
+          <p:cNvPr id="32" name="Rounded Rectangle 31"/>
           <p:cNvSpPr/>
           <p:nvPr/>
         </p:nvSpPr>
         <p:spPr>
           <a:xfrm>
-            <a:off x="2971800" y="5586984"/>
-            <a:ext cx="6583680" cy="146304"/>
+            <a:off x="2971800" y="5632704"/>
+            <a:ext cx="6035040" cy="146304"/>
           </a:xfrm>
           <a:prstGeom prst="roundRect">
             <a:avLst>
@@ -6517,14 +6817,222 @@
       </p:sp>
       <p:sp>
         <p:nvSpPr>
-          <p:cNvPr id="26" name="Rounded Rectangle 25"/>
+          <p:cNvPr id="33" name="Rounded Rectangle 32"/>
           <p:cNvSpPr/>
           <p:nvPr/>
         </p:nvSpPr>
         <p:spPr>
           <a:xfrm>
-            <a:off x="2971800" y="5586984"/>
-            <a:ext cx="3950208" cy="146304"/>
+            <a:off x="2971800" y="5632704"/>
+            <a:ext cx="745642" cy="146304"/>
+          </a:xfrm>
+          <a:prstGeom prst="roundRect">
+            <a:avLst>
+              <a:gd name="adj" fmla="val 6000"/>
+            </a:avLst>
+          </a:prstGeom>
+          <a:solidFill>
+            <a:srgbClr val="DCE8FA"/>
+          </a:solidFill>
+          <a:ln>
+            <a:noFill/>
+          </a:ln>
+          <a:effectLst/>
+        </p:spPr>
+        <p:style>
+          <a:lnRef idx="1">
+            <a:schemeClr val="accent1"/>
+          </a:lnRef>
+          <a:fillRef idx="3">
+            <a:schemeClr val="accent1"/>
+          </a:fillRef>
+          <a:effectRef idx="2">
+            <a:schemeClr val="accent1"/>
+          </a:effectRef>
+          <a:fontRef idx="minor">
+            <a:schemeClr val="lt1"/>
+          </a:fontRef>
+        </p:style>
+        <p:txBody>
+          <a:bodyPr rtlCol="0" anchor="ctr"/>
+          <a:lstStyle/>
+          <a:p>
+            <a:pPr algn="ctr"/>
+          </a:p>
+        </p:txBody>
+      </p:sp>
+      <p:sp>
+        <p:nvSpPr>
+          <p:cNvPr id="34" name="TextBox 33"/>
+          <p:cNvSpPr txBox="1"/>
+          <p:nvPr/>
+        </p:nvSpPr>
+        <p:spPr>
+          <a:xfrm>
+            <a:off x="9189720" y="5532120"/>
+            <a:ext cx="1280160" cy="365760"/>
+          </a:xfrm>
+          <a:prstGeom prst="rect">
+            <a:avLst/>
+          </a:prstGeom>
+          <a:noFill/>
+        </p:spPr>
+        <p:txBody>
+          <a:bodyPr wrap="square" lIns="0" rIns="0" tIns="0" bIns="0" anchor="ctr">
+            <a:spAutoFit/>
+          </a:bodyPr>
+          <a:lstStyle/>
+          <a:p>
+            <a:pPr algn="l"/>
+            <a:r>
+              <a:rPr sz="1100" b="1" i="0">
+                <a:solidFill>
+                  <a:srgbClr val="14418A"/>
+                </a:solidFill>
+                <a:latin typeface="Inter Tight"/>
+              </a:rPr>
+              <a:t>0/32</a:t>
+            </a:r>
+          </a:p>
+        </p:txBody>
+      </p:sp>
+      <p:sp>
+        <p:nvSpPr>
+          <p:cNvPr id="35" name="TextBox 34"/>
+          <p:cNvSpPr txBox="1"/>
+          <p:nvPr/>
+        </p:nvSpPr>
+        <p:spPr>
+          <a:xfrm>
+            <a:off x="777240" y="5943600"/>
+            <a:ext cx="2194560" cy="365760"/>
+          </a:xfrm>
+          <a:prstGeom prst="rect">
+            <a:avLst/>
+          </a:prstGeom>
+          <a:noFill/>
+        </p:spPr>
+        <p:txBody>
+          <a:bodyPr wrap="square" lIns="0" rIns="0" tIns="0" bIns="0" anchor="ctr">
+            <a:spAutoFit/>
+          </a:bodyPr>
+          <a:lstStyle/>
+          <a:p>
+            <a:pPr algn="l"/>
+            <a:r>
+              <a:rPr sz="1150" b="0" i="0">
+                <a:solidFill>
+                  <a:srgbClr val="0B2545"/>
+                </a:solidFill>
+                <a:latin typeface="Inter Tight"/>
+              </a:rPr>
+              <a:t>Mamografia / Densit.</a:t>
+            </a:r>
+          </a:p>
+        </p:txBody>
+      </p:sp>
+      <p:sp>
+        <p:nvSpPr>
+          <p:cNvPr id="36" name="Rounded Rectangle 35"/>
+          <p:cNvSpPr/>
+          <p:nvPr/>
+        </p:nvSpPr>
+        <p:spPr>
+          <a:xfrm>
+            <a:off x="2971800" y="6044184"/>
+            <a:ext cx="6035040" cy="146304"/>
+          </a:xfrm>
+          <a:prstGeom prst="roundRect">
+            <a:avLst>
+              <a:gd name="adj" fmla="val 6000"/>
+            </a:avLst>
+          </a:prstGeom>
+          <a:solidFill>
+            <a:srgbClr val="EAF1FB"/>
+          </a:solidFill>
+          <a:ln>
+            <a:noFill/>
+          </a:ln>
+          <a:effectLst/>
+        </p:spPr>
+        <p:style>
+          <a:lnRef idx="1">
+            <a:schemeClr val="accent1"/>
+          </a:lnRef>
+          <a:fillRef idx="3">
+            <a:schemeClr val="accent1"/>
+          </a:fillRef>
+          <a:effectRef idx="2">
+            <a:schemeClr val="accent1"/>
+          </a:effectRef>
+          <a:fontRef idx="minor">
+            <a:schemeClr val="lt1"/>
+          </a:fontRef>
+        </p:style>
+        <p:txBody>
+          <a:bodyPr rtlCol="0" anchor="ctr"/>
+          <a:lstStyle/>
+          <a:p>
+            <a:pPr algn="ctr"/>
+          </a:p>
+        </p:txBody>
+      </p:sp>
+      <p:sp>
+        <p:nvSpPr>
+          <p:cNvPr id="37" name="Rounded Rectangle 36"/>
+          <p:cNvSpPr/>
+          <p:nvPr/>
+        </p:nvSpPr>
+        <p:spPr>
+          <a:xfrm>
+            <a:off x="2971800" y="6044184"/>
+            <a:ext cx="233013" cy="146304"/>
+          </a:xfrm>
+          <a:prstGeom prst="roundRect">
+            <a:avLst>
+              <a:gd name="adj" fmla="val 6000"/>
+            </a:avLst>
+          </a:prstGeom>
+          <a:solidFill>
+            <a:srgbClr val="DCE8FA"/>
+          </a:solidFill>
+          <a:ln>
+            <a:noFill/>
+          </a:ln>
+          <a:effectLst/>
+        </p:spPr>
+        <p:style>
+          <a:lnRef idx="1">
+            <a:schemeClr val="accent1"/>
+          </a:lnRef>
+          <a:fillRef idx="3">
+            <a:schemeClr val="accent1"/>
+          </a:fillRef>
+          <a:effectRef idx="2">
+            <a:schemeClr val="accent1"/>
+          </a:effectRef>
+          <a:fontRef idx="minor">
+            <a:schemeClr val="lt1"/>
+          </a:fontRef>
+        </p:style>
+        <p:txBody>
+          <a:bodyPr rtlCol="0" anchor="ctr"/>
+          <a:lstStyle/>
+          <a:p>
+            <a:pPr algn="ctr"/>
+          </a:p>
+        </p:txBody>
+      </p:sp>
+      <p:sp>
+        <p:nvSpPr>
+          <p:cNvPr id="38" name="Rounded Rectangle 37"/>
+          <p:cNvSpPr/>
+          <p:nvPr/>
+        </p:nvSpPr>
+        <p:spPr>
+          <a:xfrm>
+            <a:off x="2971800" y="6044184"/>
+            <a:ext cx="233013" cy="146304"/>
           </a:xfrm>
           <a:prstGeom prst="roundRect">
             <a:avLst>
@@ -6563,14 +7071,14 @@
       </p:sp>
       <p:sp>
         <p:nvSpPr>
-          <p:cNvPr id="27" name="TextBox 26"/>
+          <p:cNvPr id="39" name="TextBox 38"/>
           <p:cNvSpPr txBox="1"/>
           <p:nvPr/>
         </p:nvSpPr>
         <p:spPr>
           <a:xfrm>
-            <a:off x="9784080" y="5477256"/>
-            <a:ext cx="822960" cy="384048"/>
+            <a:off x="9189720" y="5943600"/>
+            <a:ext cx="1280160" cy="365760"/>
           </a:xfrm>
           <a:prstGeom prst="rect">
             <a:avLst/>
@@ -6585,27 +7093,27 @@
           <a:p>
             <a:pPr algn="l"/>
             <a:r>
-              <a:rPr sz="1200" b="1" i="0">
+              <a:rPr sz="1100" b="1" i="0">
                 <a:solidFill>
                   <a:srgbClr val="14418A"/>
                 </a:solidFill>
                 <a:latin typeface="Inter Tight"/>
               </a:rPr>
-              <a:t>172</a:t>
-            </a:r>
-          </a:p>
-        </p:txBody>
-      </p:sp>
-      <p:sp>
-        <p:nvSpPr>
-          <p:cNvPr id="28" name="TextBox 27"/>
+              <a:t>10/10</a:t>
+            </a:r>
+          </a:p>
+        </p:txBody>
+      </p:sp>
+      <p:sp>
+        <p:nvSpPr>
+          <p:cNvPr id="40" name="TextBox 39"/>
           <p:cNvSpPr txBox="1"/>
           <p:nvPr/>
         </p:nvSpPr>
         <p:spPr>
           <a:xfrm>
-            <a:off x="777240" y="5916168"/>
-            <a:ext cx="2194560" cy="384048"/>
+            <a:off x="2971800" y="6400800"/>
+            <a:ext cx="6035040" cy="320040"/>
           </a:xfrm>
           <a:prstGeom prst="rect">
             <a:avLst/>
@@ -6613,126 +7121,60 @@
           <a:noFill/>
         </p:spPr>
         <p:txBody>
-          <a:bodyPr wrap="square" lIns="0" rIns="0" tIns="0" bIns="0" anchor="ctr">
+          <a:bodyPr wrap="square" lIns="0" rIns="0" tIns="0" bIns="0">
             <a:spAutoFit/>
           </a:bodyPr>
           <a:lstStyle/>
           <a:p>
-            <a:pPr algn="l"/>
-            <a:r>
-              <a:rPr sz="1200" b="0" i="0">
-                <a:solidFill>
-                  <a:srgbClr val="0B2545"/>
-                </a:solidFill>
-                <a:latin typeface="Inter Tight"/>
-              </a:rPr>
-              <a:t>Medicina Nuclear</a:t>
-            </a:r>
-          </a:p>
-        </p:txBody>
-      </p:sp>
-      <p:sp>
-        <p:nvSpPr>
-          <p:cNvPr id="29" name="Rounded Rectangle 28"/>
-          <p:cNvSpPr/>
-          <p:nvPr/>
-        </p:nvSpPr>
-        <p:spPr>
-          <a:xfrm>
-            <a:off x="2971800" y="6025896"/>
-            <a:ext cx="6583680" cy="146304"/>
-          </a:xfrm>
-          <a:prstGeom prst="roundRect">
-            <a:avLst>
-              <a:gd name="adj" fmla="val 6000"/>
-            </a:avLst>
-          </a:prstGeom>
-          <a:solidFill>
-            <a:srgbClr val="EAF1FB"/>
-          </a:solidFill>
-          <a:ln>
-            <a:noFill/>
-          </a:ln>
-          <a:effectLst/>
-        </p:spPr>
-        <p:style>
-          <a:lnRef idx="1">
-            <a:schemeClr val="accent1"/>
-          </a:lnRef>
-          <a:fillRef idx="3">
-            <a:schemeClr val="accent1"/>
-          </a:fillRef>
-          <a:effectRef idx="2">
-            <a:schemeClr val="accent1"/>
-          </a:effectRef>
-          <a:fontRef idx="minor">
-            <a:schemeClr val="lt1"/>
-          </a:fontRef>
-        </p:style>
-        <p:txBody>
-          <a:bodyPr rtlCol="0" anchor="ctr"/>
-          <a:lstStyle/>
-          <a:p>
-            <a:pPr algn="ctr"/>
-          </a:p>
-        </p:txBody>
-      </p:sp>
-      <p:sp>
-        <p:nvSpPr>
-          <p:cNvPr id="30" name="Rounded Rectangle 29"/>
-          <p:cNvSpPr/>
-          <p:nvPr/>
-        </p:nvSpPr>
-        <p:spPr>
-          <a:xfrm>
-            <a:off x="2971800" y="6025896"/>
-            <a:ext cx="790041" cy="146304"/>
-          </a:xfrm>
-          <a:prstGeom prst="roundRect">
-            <a:avLst>
-              <a:gd name="adj" fmla="val 6000"/>
-            </a:avLst>
-          </a:prstGeom>
-          <a:solidFill>
-            <a:srgbClr val="1D6FE0"/>
-          </a:solidFill>
-          <a:ln>
-            <a:noFill/>
-          </a:ln>
-          <a:effectLst/>
-        </p:spPr>
-        <p:style>
-          <a:lnRef idx="1">
-            <a:schemeClr val="accent1"/>
-          </a:lnRef>
-          <a:fillRef idx="3">
-            <a:schemeClr val="accent1"/>
-          </a:fillRef>
-          <a:effectRef idx="2">
-            <a:schemeClr val="accent1"/>
-          </a:effectRef>
-          <a:fontRef idx="minor">
-            <a:schemeClr val="lt1"/>
-          </a:fontRef>
-        </p:style>
-        <p:txBody>
-          <a:bodyPr rtlCol="0" anchor="ctr"/>
-          <a:lstStyle/>
-          <a:p>
-            <a:pPr algn="ctr"/>
-          </a:p>
-        </p:txBody>
-      </p:sp>
-      <p:sp>
-        <p:nvSpPr>
-          <p:cNvPr id="31" name="TextBox 30"/>
+            <a:r>
+              <a:rPr sz="1000">
+                <a:solidFill>
+                  <a:srgbClr val="1D6FE0"/>
+                </a:solidFill>
+                <a:latin typeface="Inter Tight"/>
+              </a:rPr>
+              <a:t>■ </a:t>
+            </a:r>
+            <a:r>
+              <a:rPr sz="1000">
+                <a:solidFill>
+                  <a:srgbClr val="5A7299"/>
+                </a:solidFill>
+                <a:latin typeface="Inter Tight"/>
+              </a:rPr>
+              <a:t>com preparo confirmado    </a:t>
+            </a:r>
+            <a:r>
+              <a:rPr sz="1000">
+                <a:solidFill>
+                  <a:srgbClr val="DCE8FA"/>
+                </a:solidFill>
+                <a:latin typeface="Inter Tight"/>
+              </a:rPr>
+              <a:t>■ </a:t>
+            </a:r>
+            <a:r>
+              <a:rPr sz="1000">
+                <a:solidFill>
+                  <a:srgbClr val="5A7299"/>
+                </a:solidFill>
+                <a:latin typeface="Inter Tight"/>
+              </a:rPr>
+              <a:t>pendente → roteado ao setor com segurança</a:t>
+            </a:r>
+          </a:p>
+        </p:txBody>
+      </p:sp>
+      <p:sp>
+        <p:nvSpPr>
+          <p:cNvPr id="41" name="TextBox 40"/>
           <p:cNvSpPr txBox="1"/>
           <p:nvPr/>
         </p:nvSpPr>
         <p:spPr>
           <a:xfrm>
-            <a:off x="9784080" y="5916168"/>
-            <a:ext cx="822960" cy="384048"/>
+            <a:off x="777240" y="6291072"/>
+            <a:ext cx="10637215" cy="320040"/>
           </a:xfrm>
           <a:prstGeom prst="rect">
             <a:avLst/>
@@ -6740,20 +7182,20 @@
           <a:noFill/>
         </p:spPr>
         <p:txBody>
-          <a:bodyPr wrap="square" lIns="0" rIns="0" tIns="0" bIns="0" anchor="ctr">
+          <a:bodyPr wrap="square" lIns="0" rIns="0" tIns="0" bIns="0">
             <a:spAutoFit/>
           </a:bodyPr>
           <a:lstStyle/>
           <a:p>
             <a:pPr algn="l"/>
             <a:r>
-              <a:rPr sz="1200" b="1" i="0">
-                <a:solidFill>
-                  <a:srgbClr val="14418A"/>
-                </a:solidFill>
-                <a:latin typeface="Inter Tight"/>
-              </a:rPr>
-              <a:t>35</a:t>
+              <a:rPr sz="850" b="1" i="0" spc="160">
+                <a:solidFill>
+                  <a:srgbClr val="5A7299"/>
+                </a:solidFill>
+                <a:latin typeface="Inter Tight"/>
+              </a:rPr>
+              <a:t>423 EXAMES COM PREPARO CONFIRMADO · 391 PENDENTES COM FALLBACK SEGURO (NUNCA PRESUME DISPENSA)</a:t>
             </a:r>
           </a:p>
         </p:txBody>
@@ -7137,17 +7579,17 @@
           <a:p>
             <a:pPr algn="l">
               <a:lnSpc>
-                <a:spcPct val="132000"/>
+                <a:spcPct val="130000"/>
               </a:lnSpc>
             </a:pPr>
             <a:r>
-              <a:rPr sz="1250" b="0" i="0">
+              <a:rPr sz="1200" b="0" i="0">
                 <a:solidFill>
                   <a:srgbClr val="5A7299"/>
                 </a:solidFill>
                 <a:latin typeface="Inter Tight"/>
               </a:rPr>
-              <a:t>Linguagem simples: jejum, horário, medicamentos, documentos, local de marcação e cuidados.</a:t>
+              <a:t>Picker guiado: escolhe a modalidade, o exame e responde contraste / sedação / lado. Resposta em linguagem simples.</a:t>
             </a:r>
           </a:p>
         </p:txBody>
@@ -7295,17 +7737,17 @@
           <a:p>
             <a:pPr algn="l">
               <a:lnSpc>
-                <a:spcPct val="132000"/>
+                <a:spcPct val="130000"/>
               </a:lnSpc>
             </a:pPr>
             <a:r>
-              <a:rPr sz="1250" b="0" i="0">
+              <a:rPr sz="1200" b="0" i="0">
                 <a:solidFill>
                   <a:srgbClr val="5A7299"/>
                 </a:solidFill>
                 <a:latin typeface="Inter Tight"/>
               </a:rPr>
-              <a:t>Linguagem técnica: protocolos, tipo de contraste, sedação, restrições e fluxo de agendamento.</a:t>
+              <a:t>Linguagem técnica + código AGHU do exame para o cadastro. Protocolos, contraste, sedação e fluxo de agendamento.</a:t>
             </a:r>
           </a:p>
         </p:txBody>
@@ -7682,7 +8124,7 @@
                 </a:solidFill>
                 <a:latin typeface="Inter Tight"/>
               </a:rPr>
-              <a:t>Identifica a modalidade de cada um dos 914 exames a partir da planilha.</a:t>
+              <a:t>Parseia as 914 linhas da planilha e deduplica por sigla + modalidade → 814 exames únicos.</a:t>
             </a:r>
           </a:p>
         </p:txBody>
@@ -7820,7 +8262,7 @@
                 </a:solidFill>
                 <a:latin typeface="Inter Tight"/>
               </a:rPr>
-              <a:t>Estruturar orientações com LLM</a:t>
+              <a:t>Mapear preparo por regra</a:t>
             </a:r>
           </a:p>
           <a:p>
@@ -7836,7 +8278,7 @@
                 </a:solidFill>
                 <a:latin typeface="Inter Tight"/>
               </a:rPr>
-              <a:t>Converte o documento em blocos: geral, por modalidade e específicos.</a:t>
+              <a:t>Cada exame recebe um preparo_id por modalidade + contraste + sedação, reaproveitando os preparos reais.</a:t>
             </a:r>
           </a:p>
         </p:txBody>
@@ -7974,7 +8416,7 @@
                 </a:solidFill>
                 <a:latin typeface="Inter Tight"/>
               </a:rPr>
-              <a:t>Associar por similaridade</a:t>
+              <a:t>Rotear pendentes com segurança</a:t>
             </a:r>
           </a:p>
           <a:p>
@@ -7990,7 +8432,7 @@
                 </a:solidFill>
                 <a:latin typeface="Inter Tight"/>
               </a:rPr>
-              <a:t>Casa preparos aos exames pela coluna de sinônimos — ajuda o RAG com termos leigos.</a:t>
+              <a:t>Exame sem preparo confirmado → fallback 'confirme com o setor'. NUNCA presume que dispensa preparo.</a:t>
             </a:r>
           </a:p>
         </p:txBody>
@@ -8128,7 +8570,7 @@
                 </a:solidFill>
                 <a:latin typeface="Inter Tight"/>
               </a:rPr>
-              <a:t>Digitalizar folhas físicas</a:t>
+              <a:t>Validar integridade (FK)</a:t>
             </a:r>
           </a:p>
           <a:p>
@@ -8144,7 +8586,7 @@
                 </a:solidFill>
                 <a:latin typeface="Inter Tight"/>
               </a:rPr>
-              <a:t>OCR + estruturação com Gemini multimodal, seguido de revisão humana obrigatória.</a:t>
+              <a:t>Todo preparo_id tem de existir; senão o script falha. Determinístico e idempotente.</a:t>
             </a:r>
           </a:p>
         </p:txBody>
@@ -8282,7 +8724,7 @@
                 </a:solidFill>
                 <a:latin typeface="Inter Tight"/>
               </a:rPr>
-              <a:t>Gerar embeddings → JSON</a:t>
+              <a:t>Emitir exames.json</a:t>
             </a:r>
           </a:p>
           <a:p>
@@ -8298,7 +8740,7 @@
                 </a:solidFill>
                 <a:latin typeface="Inter Tight"/>
               </a:rPr>
-              <a:t>Herança automática (geral + modalidade) evita 914 registros manuais.</a:t>
+              <a:t>Herança automática (geral + modalidade) evita redigir 814 registros à mão. npm run ingest.</a:t>
             </a:r>
           </a:p>
         </p:txBody>
@@ -8624,7 +9066,7 @@
                 </a:solidFill>
                 <a:latin typeface="Inter Tight"/>
               </a:rPr>
-              <a:t>Tela de chat e seletor de perfil, responsiva. Servida por CDN.</a:t>
+              <a:t>Chat, picker guiado e seletor de perfil, responsivo. Servido por CDN.</a:t>
             </a:r>
           </a:p>
         </p:txBody>
@@ -8797,7 +9239,7 @@
                 </a:solidFill>
                 <a:latin typeface="Inter Tight"/>
               </a:rPr>
-              <a:t>Recupera trechos, protege a chave de API e chama o modelo. Sem servidor a gerenciar.</a:t>
+              <a:t>Busca o exame, monta o contexto por perfil e chama o modelo. Protege a chave. Sem servidor.</a:t>
             </a:r>
           </a:p>
         </p:txBody>
@@ -8915,7 +9357,7 @@
                 </a:solidFill>
                 <a:latin typeface="Inter Tight"/>
               </a:rPr>
-              <a:t>DADOS · RAG</a:t>
+              <a:t>DADOS</a:t>
             </a:r>
           </a:p>
         </p:txBody>
@@ -8954,7 +9396,7 @@
                 </a:solidFill>
                 <a:latin typeface="Inter Tight"/>
               </a:rPr>
-              <a:t>JSON + embeddings em memória</a:t>
+              <a:t>JSON em memória + busca textual</a:t>
             </a:r>
           </a:p>
           <a:p>
@@ -8970,7 +9412,7 @@
                 </a:solidFill>
                 <a:latin typeface="Inter Tight"/>
               </a:rPr>
-              <a:t>914 exames dispensam banco vetorial; busca exata é instantânea.</a:t>
+              <a:t>814 exames; busca por nome/sigla/sinônimos é instantânea — dispensa banco vetorial.</a:t>
             </a:r>
           </a:p>
         </p:txBody>
@@ -9005,7 +9447,7 @@
                 </a:solidFill>
                 <a:latin typeface="Inter Tight"/>
               </a:rPr>
-              <a:t>NEXT.JS · VERCEL · GOOGLE GEMINI (CAMADA GRATUITA) · JSON EM MEMÓRIA</a:t>
+              <a:t>NEXT.JS · VERCEL · CLAUDE (ANTHROPIC) · JSON EM MEMÓRIA COM FALLBACK DETERMINÍSTICO</a:t>
             </a:r>
           </a:p>
         </p:txBody>
@@ -9285,7 +9727,7 @@
                 </a:solidFill>
                 <a:latin typeface="Georgia"/>
               </a:rPr>
-              <a:t>2</a:t>
+              <a:t>814</a:t>
             </a:r>
           </a:p>
           <a:p>
@@ -9301,7 +9743,7 @@
                 </a:solidFill>
                 <a:latin typeface="Inter Tight"/>
               </a:rPr>
-              <a:t>perfis com tom adaptado</a:t>
+              <a:t>exames reconhecidos</a:t>
             </a:r>
           </a:p>
         </p:txBody>
@@ -9384,7 +9826,7 @@
                 </a:solidFill>
                 <a:latin typeface="Georgia"/>
               </a:rPr>
-              <a:t>4</a:t>
+              <a:t>423</a:t>
             </a:r>
           </a:p>
           <a:p>
@@ -9400,7 +9842,7 @@
                 </a:solidFill>
                 <a:latin typeface="Inter Tight"/>
               </a:rPr>
-              <a:t>modalidades já cobertas</a:t>
+              <a:t>com preparo confirmado</a:t>
             </a:r>
           </a:p>
         </p:txBody>
@@ -9483,7 +9925,7 @@
                 </a:solidFill>
                 <a:latin typeface="Georgia"/>
               </a:rPr>
-              <a:t>RAG</a:t>
+              <a:t>2</a:t>
             </a:r>
           </a:p>
           <a:p>
@@ -9499,7 +9941,7 @@
                 </a:solidFill>
                 <a:latin typeface="Inter Tight"/>
               </a:rPr>
-              <a:t>respostas fundamentadas</a:t>
+              <a:t>perfis + código AGHU</a:t>
             </a:r>
           </a:p>
         </p:txBody>
@@ -9701,7 +10143,7 @@
                 </a:solidFill>
                 <a:latin typeface="Georgia"/>
               </a:rPr>
-              <a:t>Fluxo guiado</a:t>
+              <a:t>Picker guiado</a:t>
             </a:r>
           </a:p>
           <a:p>
@@ -9717,7 +10159,7 @@
                 </a:solidFill>
                 <a:latin typeface="Inter Tight"/>
               </a:rPr>
-              <a:t>Picker de exame antes do chat livre, como pediu a Karol no 3º checkpoint.</a:t>
+              <a:t>Modalidade → exame → contraste / sedação / lado, com busca. Pedido da Karol no 3º checkpoint.</a:t>
             </a:r>
           </a:p>
         </p:txBody>
@@ -9820,7 +10262,7 @@
                 </a:solidFill>
                 <a:latin typeface="Georgia"/>
               </a:rPr>
-              <a:t>Passo a passo</a:t>
+              <a:t>Código AGHU</a:t>
             </a:r>
           </a:p>
           <a:p>
@@ -9836,7 +10278,7 @@
                 </a:solidFill>
                 <a:latin typeface="Inter Tight"/>
               </a:rPr>
-              <a:t>Roteiro operacional p/ o profissional: contraste, sedação, acesso venoso.</a:t>
+              <a:t>Profissional busca o exame e recebe o código para o cadastro. Paciente nunca vê o código.</a:t>
             </a:r>
           </a:p>
         </p:txBody>
@@ -9955,7 +10397,7 @@
                 </a:solidFill>
                 <a:latin typeface="Inter Tight"/>
               </a:rPr>
-              <a:t>Recusa explícita quando falta info; aviso de que não substitui a equipe.</a:t>
+              <a:t>Recusa explícita quando falta info; pendentes roteados ao setor. Não substitui a equipe.</a:t>
             </a:r>
           </a:p>
         </p:txBody>
@@ -10630,7 +11072,7 @@
                 </a:solidFill>
                 <a:latin typeface="Inter Tight"/>
               </a:rPr>
-              <a:t>Linguagem natural</a:t>
+              <a:t>Picker guiado (paciente)</a:t>
             </a:r>
           </a:p>
           <a:p>
@@ -10646,7 +11088,7 @@
                 </a:solidFill>
                 <a:latin typeface="Inter Tight"/>
               </a:rPr>
-              <a:t>O usuário pergunta como falaria — sem conhecer a sigla técnica.</a:t>
+              <a:t>Escolhe modalidade e exame, responde contraste/sedação — sem saber o nome técnico.</a:t>
             </a:r>
           </a:p>
         </p:txBody>
@@ -10689,7 +11131,7 @@
                 </a:solidFill>
                 <a:latin typeface="Inter Tight"/>
               </a:rPr>
-              <a:t>Fundamentação visível</a:t>
+              <a:t>Código AGHU (profissional)</a:t>
             </a:r>
           </a:p>
           <a:p>
@@ -10705,7 +11147,7 @@
                 </a:solidFill>
                 <a:latin typeface="Inter Tight"/>
               </a:rPr>
-              <a:t>Cada resposta aponta a origem no documento oficial do hospital.</a:t>
+              <a:t>Busca o exame e recebe o código para o cadastro na AGHU. Paciente nunca vê.</a:t>
             </a:r>
           </a:p>
         </p:txBody>
@@ -10748,7 +11190,7 @@
                 </a:solidFill>
                 <a:latin typeface="Inter Tight"/>
               </a:rPr>
-              <a:t>Tom por perfil</a:t>
+              <a:t>Fundamentação + tom por perfil</a:t>
             </a:r>
           </a:p>
           <a:p>
@@ -10764,7 +11206,7 @@
                 </a:solidFill>
                 <a:latin typeface="Inter Tight"/>
               </a:rPr>
-              <a:t>A mesma base responde ao paciente e ao profissional em registros diferentes.</a:t>
+              <a:t>Resposta só dos documentos oficiais, no registro certo para cada público.</a:t>
             </a:r>
           </a:p>
         </p:txBody>
@@ -11039,7 +11481,7 @@
                 </a:solidFill>
                 <a:latin typeface="Inter Tight"/>
               </a:rPr>
-              <a:t>Custo mínimo e sem manutenção</a:t>
+              <a:t>Cobertura ampla e honesta</a:t>
             </a:r>
           </a:p>
           <a:p>
@@ -11055,7 +11497,7 @@
                 </a:solidFill>
                 <a:latin typeface="Inter Tight"/>
               </a:rPr>
-              <a:t>Serverless + JSON em memória: nada de servidor ou banco a administrar.</a:t>
+              <a:t>814 exames reconhecidos; 423 com preparo real, o resto roteado com segurança ao setor.</a:t>
             </a:r>
           </a:p>
         </p:txBody>
@@ -11098,7 +11540,7 @@
                 </a:solidFill>
                 <a:latin typeface="Inter Tight"/>
               </a:rPr>
-              <a:t>Baixo risco de alucinação</a:t>
+              <a:t>Segurança clínica</a:t>
             </a:r>
           </a:p>
           <a:p>
@@ -11114,7 +11556,7 @@
                 </a:solidFill>
                 <a:latin typeface="Inter Tight"/>
               </a:rPr>
-              <a:t>RAG obriga fundamentação; sem info, o assistente recusa.</a:t>
+              <a:t>Nunca presume que dispensa preparo; sem info, recusa e indica o setor.</a:t>
             </a:r>
           </a:p>
         </p:txBody>
@@ -11157,7 +11599,7 @@
                 </a:solidFill>
                 <a:latin typeface="Inter Tight"/>
               </a:rPr>
-              <a:t>Superfície de segurança mínima</a:t>
+              <a:t>Custo e privacidade mínimos</a:t>
             </a:r>
           </a:p>
           <a:p>
@@ -11173,7 +11615,7 @@
                 </a:solidFill>
                 <a:latin typeface="Inter Tight"/>
               </a:rPr>
-              <a:t>Sem login, sem dado de paciente — LGPD reduzida.</a:t>
+              <a:t>Serverless + JSON em memória; sem login nem dado de paciente — LGPD reduzida.</a:t>
             </a:r>
           </a:p>
         </p:txBody>
@@ -11310,7 +11752,7 @@
                 </a:solidFill>
                 <a:latin typeface="Inter Tight"/>
               </a:rPr>
-              <a:t>Cobertura parcial (~530 exames)</a:t>
+              <a:t>391 exames sem preparo confirmado</a:t>
             </a:r>
           </a:p>
           <a:p>
@@ -11326,7 +11768,7 @@
                 </a:solidFill>
                 <a:latin typeface="Inter Tight"/>
               </a:rPr>
-              <a:t>TC, RX e Medicina Nuclear ainda partem da orientação geral.</a:t>
+              <a:t>TC e Medicina Nuclear dependem das folhas físicas ainda por digitalizar.</a:t>
             </a:r>
           </a:p>
         </p:txBody>
@@ -11369,7 +11811,7 @@
                 </a:solidFill>
                 <a:latin typeface="Inter Tight"/>
               </a:rPr>
-              <a:t>Risco de OCR e nomes divergentes</a:t>
+              <a:t>Nomes com typos na planilha</a:t>
             </a:r>
           </a:p>
           <a:p>
@@ -11385,7 +11827,7 @@
                 </a:solidFill>
                 <a:latin typeface="Inter Tight"/>
               </a:rPr>
-              <a:t>Mitigado por revisão humana e coluna de sinônimos.</a:t>
+              <a:t>Alguns rótulos herdam erros da fonte; correção é curadoria incremental.</a:t>
             </a:r>
           </a:p>
         </p:txBody>

</xml_diff>

<commit_message>
docs: bump presentation body text to >=18pt, drop presentation-time meta
</commit_message>
<xml_diff>
--- a/docs/Apresentacao_HC-UFPE.pptx
+++ b/docs/Apresentacao_HC-UFPE.pptx
@@ -3209,7 +3209,7 @@
           <a:lstStyle/>
           <a:p>
             <a:r>
-              <a:rPr sz="1200">
+              <a:rPr sz="1400">
                 <a:solidFill>
                   <a:srgbClr val="1D6FE0"/>
                 </a:solidFill>
@@ -3218,7 +3218,7 @@
               <a:t>◆ </a:t>
             </a:r>
             <a:r>
-              <a:rPr sz="1100" b="1" spc="240">
+              <a:rPr sz="1300" b="1" spc="220">
                 <a:solidFill>
                   <a:srgbClr val="14418A"/>
                 </a:solidFill>
@@ -3237,8 +3237,8 @@
         </p:nvSpPr>
         <p:spPr>
           <a:xfrm>
-            <a:off x="8899855" y="502920"/>
-            <a:ext cx="2514600" cy="457200"/>
+            <a:off x="8671255" y="475488"/>
+            <a:ext cx="2743200" cy="502920"/>
           </a:xfrm>
           <a:prstGeom prst="roundRect">
             <a:avLst>
@@ -3273,7 +3273,7 @@
           <a:p>
             <a:pPr algn="ctr"/>
             <a:r>
-              <a:rPr sz="1000" b="1" i="0" spc="120">
+              <a:rPr sz="1300" b="1" i="0" spc="100">
                 <a:solidFill>
                   <a:srgbClr val="14418A"/>
                 </a:solidFill>
@@ -3307,7 +3307,7 @@
           <a:lstStyle/>
           <a:p>
             <a:r>
-              <a:rPr sz="1100">
+              <a:rPr sz="1300">
                 <a:solidFill>
                   <a:srgbClr val="1D6FE0"/>
                 </a:solidFill>
@@ -3316,7 +3316,7 @@
               <a:t>● </a:t>
             </a:r>
             <a:r>
-              <a:rPr sz="1100" b="1" spc="240">
+              <a:rPr sz="1300" b="1" spc="240">
                 <a:solidFill>
                   <a:srgbClr val="5A7299"/>
                 </a:solidFill>
@@ -3392,8 +3392,8 @@
         </p:nvSpPr>
         <p:spPr>
           <a:xfrm>
-            <a:off x="777240" y="4572000"/>
-            <a:ext cx="8686800" cy="822960"/>
+            <a:off x="777240" y="4526280"/>
+            <a:ext cx="9144000" cy="914400"/>
           </a:xfrm>
           <a:prstGeom prst="rect">
             <a:avLst/>
@@ -3412,7 +3412,7 @@
               </a:lnSpc>
             </a:pPr>
             <a:r>
-              <a:rPr sz="1600" b="0" i="0">
+              <a:rPr sz="1800" b="0" i="0">
                 <a:solidFill>
                   <a:srgbClr val="5A7299"/>
                 </a:solidFill>
@@ -3476,7 +3476,7 @@
         <p:spPr>
           <a:xfrm>
             <a:off x="777240" y="5806440"/>
-            <a:ext cx="3271418" cy="822960"/>
+            <a:ext cx="5044287" cy="822960"/>
           </a:xfrm>
           <a:prstGeom prst="rect">
             <a:avLst/>
@@ -3495,7 +3495,7 @@
               </a:spcAft>
             </a:pPr>
             <a:r>
-              <a:rPr sz="950" b="1" i="0" spc="140">
+              <a:rPr sz="1300" b="1" i="0" spc="140">
                 <a:solidFill>
                   <a:srgbClr val="5A7299"/>
                 </a:solidFill>
@@ -3507,7 +3507,7 @@
           <a:p>
             <a:pPr algn="l"/>
             <a:r>
-              <a:rPr sz="1300" b="1" i="0">
+              <a:rPr sz="1800" b="1" i="0">
                 <a:solidFill>
                   <a:srgbClr val="0B2545"/>
                 </a:solidFill>
@@ -3526,8 +3526,8 @@
         </p:nvSpPr>
         <p:spPr>
           <a:xfrm>
-            <a:off x="4322978" y="5806440"/>
-            <a:ext cx="3271418" cy="822960"/>
+            <a:off x="6095847" y="5806440"/>
+            <a:ext cx="5044287" cy="822960"/>
           </a:xfrm>
           <a:prstGeom prst="rect">
             <a:avLst/>
@@ -3546,7 +3546,7 @@
               </a:spcAft>
             </a:pPr>
             <a:r>
-              <a:rPr sz="950" b="1" i="0" spc="140">
+              <a:rPr sz="1300" b="1" i="0" spc="140">
                 <a:solidFill>
                   <a:srgbClr val="5A7299"/>
                 </a:solidFill>
@@ -3558,64 +3558,13 @@
           <a:p>
             <a:pPr algn="l"/>
             <a:r>
-              <a:rPr sz="1300" b="1" i="0">
+              <a:rPr sz="1800" b="1" i="0">
                 <a:solidFill>
                   <a:srgbClr val="0B2545"/>
                 </a:solidFill>
                 <a:latin typeface="Inter Tight"/>
               </a:rPr>
               <a:t>Next.js · Serverless · Claude</a:t>
-            </a:r>
-          </a:p>
-        </p:txBody>
-      </p:sp>
-      <p:sp>
-        <p:nvSpPr>
-          <p:cNvPr id="12" name="TextBox 11"/>
-          <p:cNvSpPr txBox="1"/>
-          <p:nvPr/>
-        </p:nvSpPr>
-        <p:spPr>
-          <a:xfrm>
-            <a:off x="7868716" y="5806440"/>
-            <a:ext cx="3271418" cy="822960"/>
-          </a:xfrm>
-          <a:prstGeom prst="rect">
-            <a:avLst/>
-          </a:prstGeom>
-          <a:noFill/>
-        </p:spPr>
-        <p:txBody>
-          <a:bodyPr wrap="square" lIns="0" rIns="0" tIns="0" bIns="0">
-            <a:spAutoFit/>
-          </a:bodyPr>
-          <a:lstStyle/>
-          <a:p>
-            <a:pPr algn="l">
-              <a:spcAft>
-                <a:spcPts val="400"/>
-              </a:spcAft>
-            </a:pPr>
-            <a:r>
-              <a:rPr sz="950" b="1" i="0" spc="140">
-                <a:solidFill>
-                  <a:srgbClr val="5A7299"/>
-                </a:solidFill>
-                <a:latin typeface="Inter Tight"/>
-              </a:rPr>
-              <a:t>APRESENTAÇÃO</a:t>
-            </a:r>
-          </a:p>
-          <a:p>
-            <a:pPr algn="l"/>
-            <a:r>
-              <a:rPr sz="1300" b="1" i="0">
-                <a:solidFill>
-                  <a:srgbClr val="0B2545"/>
-                </a:solidFill>
-                <a:latin typeface="Inter Tight"/>
-              </a:rPr>
-              <a:t>15 min + 5 min de demo</a:t>
             </a:r>
           </a:p>
         </p:txBody>
@@ -3690,8 +3639,8 @@
         </p:nvSpPr>
         <p:spPr>
           <a:xfrm>
-            <a:off x="10362895" y="640080"/>
-            <a:ext cx="1051560" cy="320040"/>
+            <a:off x="10271455" y="640080"/>
+            <a:ext cx="1143000" cy="320040"/>
           </a:xfrm>
           <a:prstGeom prst="rect">
             <a:avLst/>
@@ -3706,7 +3655,7 @@
           <a:p>
             <a:pPr algn="r"/>
             <a:r>
-              <a:rPr sz="1100" b="1" i="0" spc="150">
+              <a:rPr sz="1300" b="1" i="0" spc="150">
                 <a:solidFill>
                   <a:srgbClr val="5A7299"/>
                 </a:solidFill>
@@ -3740,7 +3689,7 @@
           <a:lstStyle/>
           <a:p>
             <a:r>
-              <a:rPr sz="1100">
+              <a:rPr sz="1300">
                 <a:solidFill>
                   <a:srgbClr val="1D6FE0"/>
                 </a:solidFill>
@@ -3749,7 +3698,7 @@
               <a:t>● </a:t>
             </a:r>
             <a:r>
-              <a:rPr sz="1100" b="1" spc="240">
+              <a:rPr sz="1300" b="1" spc="240">
                 <a:solidFill>
                   <a:srgbClr val="5A7299"/>
                 </a:solidFill>
@@ -3816,8 +3765,8 @@
         </p:nvSpPr>
         <p:spPr>
           <a:xfrm>
-            <a:off x="777240" y="2468880"/>
-            <a:ext cx="2453563" cy="3108960"/>
+            <a:off x="777240" y="2377440"/>
+            <a:ext cx="2453563" cy="3474720"/>
           </a:xfrm>
           <a:prstGeom prst="roundRect">
             <a:avLst>
@@ -3864,8 +3813,8 @@
         </p:nvSpPr>
         <p:spPr>
           <a:xfrm>
-            <a:off x="1033272" y="2743200"/>
-            <a:ext cx="1941499" cy="2651760"/>
+            <a:off x="1051560" y="2688336"/>
+            <a:ext cx="1904923" cy="2926080"/>
           </a:xfrm>
           <a:prstGeom prst="rect">
             <a:avLst/>
@@ -3880,11 +3829,11 @@
           <a:p>
             <a:pPr algn="l">
               <a:spcAft>
-                <a:spcPts val="800"/>
+                <a:spcPts val="1000"/>
               </a:spcAft>
             </a:pPr>
             <a:r>
-              <a:rPr sz="900" b="1" i="0" spc="110">
+              <a:rPr sz="1300" b="1" i="0" spc="80">
                 <a:solidFill>
                   <a:srgbClr val="1D6FE0"/>
                 </a:solidFill>
@@ -3896,11 +3845,11 @@
           <a:p>
             <a:pPr algn="l">
               <a:spcAft>
-                <a:spcPts val="800"/>
+                <a:spcPts val="1000"/>
               </a:spcAft>
             </a:pPr>
             <a:r>
-              <a:rPr sz="1900" b="0" i="0">
+              <a:rPr sz="2100" b="0" i="0">
                 <a:solidFill>
                   <a:srgbClr val="0B2545"/>
                 </a:solidFill>
@@ -3912,17 +3861,17 @@
           <a:p>
             <a:pPr algn="l">
               <a:lnSpc>
-                <a:spcPct val="130000"/>
+                <a:spcPct val="125000"/>
               </a:lnSpc>
             </a:pPr>
             <a:r>
-              <a:rPr sz="1200" b="0" i="0">
+              <a:rPr sz="1800" b="0" i="0">
                 <a:solidFill>
                   <a:srgbClr val="5A7299"/>
                 </a:solidFill>
                 <a:latin typeface="Inter Tight"/>
               </a:rPr>
-              <a:t>Digitalizar folhas de TC e Medicina Nuclear → tirar 391 exames do pendente.</a:t>
+              <a:t>Digitalizar TC e Medicina Nuclear → tirar os 391 exames do pendente.</a:t>
             </a:r>
           </a:p>
         </p:txBody>
@@ -3935,8 +3884,8 @@
         </p:nvSpPr>
         <p:spPr>
           <a:xfrm>
-            <a:off x="3505123" y="2468880"/>
-            <a:ext cx="2453563" cy="3108960"/>
+            <a:off x="3505123" y="2377440"/>
+            <a:ext cx="2453563" cy="3474720"/>
           </a:xfrm>
           <a:prstGeom prst="roundRect">
             <a:avLst>
@@ -3983,8 +3932,8 @@
         </p:nvSpPr>
         <p:spPr>
           <a:xfrm>
-            <a:off x="3761155" y="2743200"/>
-            <a:ext cx="1941499" cy="2651760"/>
+            <a:off x="3779443" y="2688336"/>
+            <a:ext cx="1904923" cy="2926080"/>
           </a:xfrm>
           <a:prstGeom prst="rect">
             <a:avLst/>
@@ -3999,11 +3948,11 @@
           <a:p>
             <a:pPr algn="l">
               <a:spcAft>
-                <a:spcPts val="800"/>
+                <a:spcPts val="1000"/>
               </a:spcAft>
             </a:pPr>
             <a:r>
-              <a:rPr sz="900" b="1" i="0" spc="110">
+              <a:rPr sz="1300" b="1" i="0" spc="80">
                 <a:solidFill>
                   <a:srgbClr val="1D6FE0"/>
                 </a:solidFill>
@@ -4015,11 +3964,11 @@
           <a:p>
             <a:pPr algn="l">
               <a:spcAft>
-                <a:spcPts val="800"/>
+                <a:spcPts val="1000"/>
               </a:spcAft>
             </a:pPr>
             <a:r>
-              <a:rPr sz="1900" b="0" i="0">
+              <a:rPr sz="2100" b="0" i="0">
                 <a:solidFill>
                   <a:srgbClr val="0B2545"/>
                 </a:solidFill>
@@ -4031,11 +3980,11 @@
           <a:p>
             <a:pPr algn="l">
               <a:lnSpc>
-                <a:spcPct val="130000"/>
+                <a:spcPct val="125000"/>
               </a:lnSpc>
             </a:pPr>
             <a:r>
-              <a:rPr sz="1200" b="0" i="0">
+              <a:rPr sz="1800" b="0" i="0">
                 <a:solidFill>
                   <a:srgbClr val="5A7299"/>
                 </a:solidFill>
@@ -4054,8 +4003,8 @@
         </p:nvSpPr>
         <p:spPr>
           <a:xfrm>
-            <a:off x="6233007" y="2468880"/>
-            <a:ext cx="2453563" cy="3108960"/>
+            <a:off x="6233007" y="2377440"/>
+            <a:ext cx="2453563" cy="3474720"/>
           </a:xfrm>
           <a:prstGeom prst="roundRect">
             <a:avLst>
@@ -4102,8 +4051,8 @@
         </p:nvSpPr>
         <p:spPr>
           <a:xfrm>
-            <a:off x="6489039" y="2743200"/>
-            <a:ext cx="1941499" cy="2651760"/>
+            <a:off x="6507327" y="2688336"/>
+            <a:ext cx="1904923" cy="2926080"/>
           </a:xfrm>
           <a:prstGeom prst="rect">
             <a:avLst/>
@@ -4118,11 +4067,11 @@
           <a:p>
             <a:pPr algn="l">
               <a:spcAft>
-                <a:spcPts val="800"/>
+                <a:spcPts val="1000"/>
               </a:spcAft>
             </a:pPr>
             <a:r>
-              <a:rPr sz="900" b="1" i="0" spc="110">
+              <a:rPr sz="1300" b="1" i="0" spc="80">
                 <a:solidFill>
                   <a:srgbClr val="1D6FE0"/>
                 </a:solidFill>
@@ -4134,11 +4083,11 @@
           <a:p>
             <a:pPr algn="l">
               <a:spcAft>
-                <a:spcPts val="800"/>
+                <a:spcPts val="1000"/>
               </a:spcAft>
             </a:pPr>
             <a:r>
-              <a:rPr sz="1900" b="0" i="0">
+              <a:rPr sz="2100" b="0" i="0">
                 <a:solidFill>
                   <a:srgbClr val="0B2545"/>
                 </a:solidFill>
@@ -4150,17 +4099,17 @@
           <a:p>
             <a:pPr algn="l">
               <a:lnSpc>
-                <a:spcPct val="130000"/>
+                <a:spcPct val="125000"/>
               </a:lnSpc>
             </a:pPr>
             <a:r>
-              <a:rPr sz="1200" b="0" i="0">
+              <a:rPr sz="1800" b="0" i="0">
                 <a:solidFill>
                   <a:srgbClr val="5A7299"/>
                 </a:solidFill>
                 <a:latin typeface="Inter Tight"/>
               </a:rPr>
-              <a:t>Reintroduzir navegação visual por região do corpo.</a:t>
+              <a:t>Navegação visual por região do corpo.</a:t>
             </a:r>
           </a:p>
         </p:txBody>
@@ -4173,8 +4122,8 @@
         </p:nvSpPr>
         <p:spPr>
           <a:xfrm>
-            <a:off x="8960891" y="2468880"/>
-            <a:ext cx="2453563" cy="3108960"/>
+            <a:off x="8960891" y="2377440"/>
+            <a:ext cx="2453563" cy="3474720"/>
           </a:xfrm>
           <a:prstGeom prst="roundRect">
             <a:avLst>
@@ -4221,8 +4170,8 @@
         </p:nvSpPr>
         <p:spPr>
           <a:xfrm>
-            <a:off x="9216923" y="2743200"/>
-            <a:ext cx="1941499" cy="2651760"/>
+            <a:off x="9235211" y="2688336"/>
+            <a:ext cx="1904923" cy="2926080"/>
           </a:xfrm>
           <a:prstGeom prst="rect">
             <a:avLst/>
@@ -4237,11 +4186,11 @@
           <a:p>
             <a:pPr algn="l">
               <a:spcAft>
-                <a:spcPts val="800"/>
+                <a:spcPts val="1000"/>
               </a:spcAft>
             </a:pPr>
             <a:r>
-              <a:rPr sz="900" b="1" i="0" spc="110">
+              <a:rPr sz="1300" b="1" i="0" spc="80">
                 <a:solidFill>
                   <a:srgbClr val="7FB0F2"/>
                 </a:solidFill>
@@ -4253,11 +4202,11 @@
           <a:p>
             <a:pPr algn="l">
               <a:spcAft>
-                <a:spcPts val="800"/>
+                <a:spcPts val="1000"/>
               </a:spcAft>
             </a:pPr>
             <a:r>
-              <a:rPr sz="1900" b="0" i="0">
+              <a:rPr sz="2100" b="0" i="0">
                 <a:solidFill>
                   <a:srgbClr val="FFFFFF"/>
                 </a:solidFill>
@@ -4269,17 +4218,17 @@
           <a:p>
             <a:pPr algn="l">
               <a:lnSpc>
-                <a:spcPct val="130000"/>
+                <a:spcPct val="125000"/>
               </a:lnSpc>
             </a:pPr>
             <a:r>
-              <a:rPr sz="1200" b="0" i="0">
+              <a:rPr sz="1800" b="0" i="0">
                 <a:solidFill>
                   <a:srgbClr val="AEC3E6"/>
                 </a:solidFill>
                 <a:latin typeface="Inter Tight"/>
               </a:rPr>
-              <a:t>Equipe do HC edita conteúdo sem programador (ex.: Supabase).</a:t>
+              <a:t>Equipe do HC edita conteúdo sem programador.</a:t>
             </a:r>
           </a:p>
         </p:txBody>
@@ -4413,7 +4362,7 @@
           <a:lstStyle/>
           <a:p>
             <a:r>
-              <a:rPr sz="1200">
+              <a:rPr sz="1400">
                 <a:solidFill>
                   <a:srgbClr val="7FB0F2"/>
                 </a:solidFill>
@@ -4422,7 +4371,7 @@
               <a:t>● </a:t>
             </a:r>
             <a:r>
-              <a:rPr sz="1100" b="1" spc="260">
+              <a:rPr sz="1400" b="1" spc="240">
                 <a:solidFill>
                   <a:srgbClr val="7FB0F2"/>
                 </a:solidFill>
@@ -4490,7 +4439,7 @@
         <p:spPr>
           <a:xfrm>
             <a:off x="777240" y="3383280"/>
-            <a:ext cx="8229600" cy="640080"/>
+            <a:ext cx="9144000" cy="731520"/>
           </a:xfrm>
           <a:prstGeom prst="rect">
             <a:avLst/>
@@ -4509,7 +4458,7 @@
               </a:lnSpc>
             </a:pPr>
             <a:r>
-              <a:rPr sz="1500" b="0" i="0">
+              <a:rPr sz="1800" b="0" i="0">
                 <a:solidFill>
                   <a:srgbClr val="AEC3E6"/>
                 </a:solidFill>
@@ -4528,8 +4477,8 @@
         </p:nvSpPr>
         <p:spPr>
           <a:xfrm>
-            <a:off x="777240" y="4297680"/>
-            <a:ext cx="3566160" cy="594360"/>
+            <a:off x="777240" y="4343400"/>
+            <a:ext cx="3931920" cy="640080"/>
           </a:xfrm>
           <a:prstGeom prst="roundRect">
             <a:avLst>
@@ -4564,7 +4513,7 @@
           <a:p>
             <a:pPr algn="ctr"/>
             <a:r>
-              <a:rPr sz="1400" b="1" i="0">
+              <a:rPr sz="1600" b="1" i="0">
                 <a:solidFill>
                   <a:srgbClr val="FFFFFF"/>
                 </a:solidFill>
@@ -4583,7 +4532,7 @@
         </p:nvSpPr>
         <p:spPr>
           <a:xfrm>
-            <a:off x="777240" y="5394960"/>
+            <a:off x="777240" y="5440680"/>
             <a:ext cx="10637215" cy="12700"/>
           </a:xfrm>
           <a:prstGeom prst="rect">
@@ -4627,8 +4576,8 @@
         </p:nvSpPr>
         <p:spPr>
           <a:xfrm>
-            <a:off x="777240" y="5623560"/>
-            <a:ext cx="10637215" cy="548640"/>
+            <a:off x="777240" y="5669280"/>
+            <a:ext cx="10637215" cy="640080"/>
           </a:xfrm>
           <a:prstGeom prst="rect">
             <a:avLst/>
@@ -4641,8 +4590,13 @@
           </a:bodyPr>
           <a:lstStyle/>
           <a:p>
-            <a:r>
-              <a:rPr sz="1200">
+            <a:pPr>
+              <a:lnSpc>
+                <a:spcPct val="130000"/>
+              </a:lnSpc>
+            </a:pPr>
+            <a:r>
+              <a:rPr sz="1600">
                 <a:solidFill>
                   <a:srgbClr val="AEC3E6"/>
                 </a:solidFill>
@@ -4651,7 +4605,7 @@
               <a:t>Antonio Robério      </a:t>
             </a:r>
             <a:r>
-              <a:rPr sz="1200">
+              <a:rPr sz="1600">
                 <a:solidFill>
                   <a:srgbClr val="AEC3E6"/>
                 </a:solidFill>
@@ -4660,7 +4614,7 @@
               <a:t>Ithalo      </a:t>
             </a:r>
             <a:r>
-              <a:rPr sz="1200">
+              <a:rPr sz="1600">
                 <a:solidFill>
                   <a:srgbClr val="AEC3E6"/>
                 </a:solidFill>
@@ -4669,7 +4623,7 @@
               <a:t>Mateus Ataide      </a:t>
             </a:r>
             <a:r>
-              <a:rPr sz="1200">
+              <a:rPr sz="1600">
                 <a:solidFill>
                   <a:srgbClr val="AEC3E6"/>
                 </a:solidFill>
@@ -4678,7 +4632,7 @@
               <a:t>Eric Barreto      </a:t>
             </a:r>
             <a:r>
-              <a:rPr sz="1200">
+              <a:rPr sz="1600">
                 <a:solidFill>
                   <a:srgbClr val="AEC3E6"/>
                 </a:solidFill>
@@ -4687,7 +4641,7 @@
               <a:t>Joyce Santana      </a:t>
             </a:r>
             <a:r>
-              <a:rPr sz="1200">
+              <a:rPr sz="1600">
                 <a:solidFill>
                   <a:srgbClr val="AEC3E6"/>
                 </a:solidFill>
@@ -4696,7 +4650,7 @@
               <a:t>Mateus Guerra      </a:t>
             </a:r>
             <a:r>
-              <a:rPr sz="1200">
+              <a:rPr sz="1600">
                 <a:solidFill>
                   <a:srgbClr val="AEC3E6"/>
                 </a:solidFill>
@@ -4777,8 +4731,8 @@
         </p:nvSpPr>
         <p:spPr>
           <a:xfrm>
-            <a:off x="10362895" y="640080"/>
-            <a:ext cx="1051560" cy="320040"/>
+            <a:off x="10271455" y="640080"/>
+            <a:ext cx="1143000" cy="320040"/>
           </a:xfrm>
           <a:prstGeom prst="rect">
             <a:avLst/>
@@ -4793,7 +4747,7 @@
           <a:p>
             <a:pPr algn="r"/>
             <a:r>
-              <a:rPr sz="1100" b="1" i="0" spc="150">
+              <a:rPr sz="1300" b="1" i="0" spc="150">
                 <a:solidFill>
                   <a:srgbClr val="5A7299"/>
                 </a:solidFill>
@@ -4827,7 +4781,7 @@
           <a:lstStyle/>
           <a:p>
             <a:r>
-              <a:rPr sz="1100">
+              <a:rPr sz="1300">
                 <a:solidFill>
                   <a:srgbClr val="1D6FE0"/>
                 </a:solidFill>
@@ -4836,7 +4790,7 @@
               <a:t>● </a:t>
             </a:r>
             <a:r>
-              <a:rPr sz="1100" b="1" spc="240">
+              <a:rPr sz="1300" b="1" spc="240">
                 <a:solidFill>
                   <a:srgbClr val="5A7299"/>
                 </a:solidFill>
@@ -4912,8 +4866,8 @@
         </p:nvSpPr>
         <p:spPr>
           <a:xfrm>
-            <a:off x="777240" y="2331720"/>
-            <a:ext cx="9601200" cy="822960"/>
+            <a:off x="777240" y="2286000"/>
+            <a:ext cx="10637215" cy="1005840"/>
           </a:xfrm>
           <a:prstGeom prst="rect">
             <a:avLst/>
@@ -4932,7 +4886,7 @@
               </a:lnSpc>
             </a:pPr>
             <a:r>
-              <a:rPr sz="1500" b="0" i="0">
+              <a:rPr sz="1800" b="0" i="0">
                 <a:solidFill>
                   <a:srgbClr val="5A7299"/>
                 </a:solidFill>
@@ -4951,8 +4905,8 @@
         </p:nvSpPr>
         <p:spPr>
           <a:xfrm>
-            <a:off x="777240" y="3566160"/>
-            <a:ext cx="2419273" cy="2103120"/>
+            <a:off x="777240" y="3703320"/>
+            <a:ext cx="2419273" cy="2286000"/>
           </a:xfrm>
           <a:prstGeom prst="rect">
             <a:avLst/>
@@ -4971,7 +4925,7 @@
               </a:spcAft>
             </a:pPr>
             <a:r>
-              <a:rPr sz="3000" b="0" i="0">
+              <a:rPr sz="3200" b="0" i="0">
                 <a:solidFill>
                   <a:srgbClr val="DCE8FA"/>
                 </a:solidFill>
@@ -4987,7 +4941,7 @@
               </a:spcAft>
             </a:pPr>
             <a:r>
-              <a:rPr sz="1400" b="1" i="0">
+              <a:rPr sz="1800" b="1" i="0">
                 <a:solidFill>
                   <a:srgbClr val="0B2545"/>
                 </a:solidFill>
@@ -4999,17 +4953,17 @@
           <a:p>
             <a:pPr algn="l">
               <a:lnSpc>
-                <a:spcPct val="125000"/>
+                <a:spcPct val="120000"/>
               </a:lnSpc>
             </a:pPr>
             <a:r>
-              <a:rPr sz="1100" b="0" i="0">
+              <a:rPr sz="1800" b="0" i="0">
                 <a:solidFill>
                   <a:srgbClr val="5A7299"/>
                 </a:solidFill>
                 <a:latin typeface="Inter Tight"/>
               </a:rPr>
-              <a:t>Médico registra o exame no AGHU durante a consulta.</a:t>
+              <a:t>Médico registra o exame no AGHU.</a:t>
             </a:r>
           </a:p>
         </p:txBody>
@@ -5022,8 +4976,8 @@
         </p:nvSpPr>
         <p:spPr>
           <a:xfrm>
-            <a:off x="3350183" y="3749040"/>
-            <a:ext cx="12700" cy="1737360"/>
+            <a:off x="3350183" y="3886200"/>
+            <a:ext cx="12700" cy="1920240"/>
           </a:xfrm>
           <a:prstGeom prst="rect">
             <a:avLst/>
@@ -5066,8 +5020,8 @@
         </p:nvSpPr>
         <p:spPr>
           <a:xfrm>
-            <a:off x="3516553" y="3566160"/>
-            <a:ext cx="2419273" cy="2103120"/>
+            <a:off x="3516553" y="3703320"/>
+            <a:ext cx="2419273" cy="2286000"/>
           </a:xfrm>
           <a:prstGeom prst="rect">
             <a:avLst/>
@@ -5086,7 +5040,7 @@
               </a:spcAft>
             </a:pPr>
             <a:r>
-              <a:rPr sz="3000" b="0" i="0">
+              <a:rPr sz="3200" b="0" i="0">
                 <a:solidFill>
                   <a:srgbClr val="DCE8FA"/>
                 </a:solidFill>
@@ -5102,7 +5056,7 @@
               </a:spcAft>
             </a:pPr>
             <a:r>
-              <a:rPr sz="1400" b="1" i="0">
+              <a:rPr sz="1800" b="1" i="0">
                 <a:solidFill>
                   <a:srgbClr val="0B2545"/>
                 </a:solidFill>
@@ -5114,17 +5068,17 @@
           <a:p>
             <a:pPr algn="l">
               <a:lnSpc>
-                <a:spcPct val="125000"/>
+                <a:spcPct val="120000"/>
               </a:lnSpc>
             </a:pPr>
             <a:r>
-              <a:rPr sz="1100" b="0" i="0">
+              <a:rPr sz="1800" b="0" i="0">
                 <a:solidFill>
                   <a:srgbClr val="5A7299"/>
                 </a:solidFill>
                 <a:latin typeface="Inter Tight"/>
               </a:rPr>
-              <a:t>Paciente ou enfermagem agenda — sem padrão único.</a:t>
+              <a:t>Paciente ou enfermagem agenda — sem padrão.</a:t>
             </a:r>
           </a:p>
         </p:txBody>
@@ -5137,8 +5091,8 @@
         </p:nvSpPr>
         <p:spPr>
           <a:xfrm>
-            <a:off x="6089497" y="3749040"/>
-            <a:ext cx="12700" cy="1737360"/>
+            <a:off x="6089497" y="3886200"/>
+            <a:ext cx="12700" cy="1920240"/>
           </a:xfrm>
           <a:prstGeom prst="rect">
             <a:avLst/>
@@ -5181,8 +5135,8 @@
         </p:nvSpPr>
         <p:spPr>
           <a:xfrm>
-            <a:off x="6255867" y="3566160"/>
-            <a:ext cx="2419273" cy="2103120"/>
+            <a:off x="6255867" y="3703320"/>
+            <a:ext cx="2419273" cy="2286000"/>
           </a:xfrm>
           <a:prstGeom prst="rect">
             <a:avLst/>
@@ -5201,7 +5155,7 @@
               </a:spcAft>
             </a:pPr>
             <a:r>
-              <a:rPr sz="3000" b="0" i="0">
+              <a:rPr sz="3200" b="0" i="0">
                 <a:solidFill>
                   <a:srgbClr val="1D6FE0"/>
                 </a:solidFill>
@@ -5217,7 +5171,7 @@
               </a:spcAft>
             </a:pPr>
             <a:r>
-              <a:rPr sz="1400" b="1" i="0">
+              <a:rPr sz="1800" b="1" i="0">
                 <a:solidFill>
                   <a:srgbClr val="0B2545"/>
                 </a:solidFill>
@@ -5229,17 +5183,17 @@
           <a:p>
             <a:pPr algn="l">
               <a:lnSpc>
-                <a:spcPct val="125000"/>
+                <a:spcPct val="120000"/>
               </a:lnSpc>
             </a:pPr>
             <a:r>
-              <a:rPr sz="1100" b="0" i="0">
+              <a:rPr sz="1800" b="0" i="0">
                 <a:solidFill>
                   <a:srgbClr val="5A7299"/>
                 </a:solidFill>
                 <a:latin typeface="Inter Tight"/>
               </a:rPr>
-              <a:t>Preparo não é passado corretamente ao paciente.</a:t>
+              <a:t>Preparo não chega ao paciente.</a:t>
             </a:r>
           </a:p>
         </p:txBody>
@@ -5252,8 +5206,8 @@
         </p:nvSpPr>
         <p:spPr>
           <a:xfrm>
-            <a:off x="8828811" y="3749040"/>
-            <a:ext cx="12700" cy="1737360"/>
+            <a:off x="8828811" y="3886200"/>
+            <a:ext cx="12700" cy="1920240"/>
           </a:xfrm>
           <a:prstGeom prst="rect">
             <a:avLst/>
@@ -5296,8 +5250,8 @@
         </p:nvSpPr>
         <p:spPr>
           <a:xfrm>
-            <a:off x="8995181" y="3566160"/>
-            <a:ext cx="2419273" cy="2103120"/>
+            <a:off x="8995181" y="3703320"/>
+            <a:ext cx="2419273" cy="2286000"/>
           </a:xfrm>
           <a:prstGeom prst="rect">
             <a:avLst/>
@@ -5316,7 +5270,7 @@
               </a:spcAft>
             </a:pPr>
             <a:r>
-              <a:rPr sz="3000" b="0" i="0">
+              <a:rPr sz="3200" b="0" i="0">
                 <a:solidFill>
                   <a:srgbClr val="1D6FE0"/>
                 </a:solidFill>
@@ -5332,7 +5286,7 @@
               </a:spcAft>
             </a:pPr>
             <a:r>
-              <a:rPr sz="1400" b="1" i="0">
+              <a:rPr sz="1800" b="1" i="0">
                 <a:solidFill>
                   <a:srgbClr val="0B2545"/>
                 </a:solidFill>
@@ -5344,17 +5298,17 @@
           <a:p>
             <a:pPr algn="l">
               <a:lnSpc>
-                <a:spcPct val="125000"/>
+                <a:spcPct val="120000"/>
               </a:lnSpc>
             </a:pPr>
             <a:r>
-              <a:rPr sz="1100" b="0" i="0">
+              <a:rPr sz="1800" b="0" i="0">
                 <a:solidFill>
                   <a:srgbClr val="5A7299"/>
                 </a:solidFill>
                 <a:latin typeface="Inter Tight"/>
               </a:rPr>
-              <a:t>Vaga desperdiçada, fila cresce, eficiência cai.</a:t>
+              <a:t>Vaga perdida, fila cresce.</a:t>
             </a:r>
           </a:p>
         </p:txBody>
@@ -5367,7 +5321,7 @@
         </p:nvSpPr>
         <p:spPr>
           <a:xfrm>
-            <a:off x="777240" y="6291072"/>
+            <a:off x="777240" y="6309360"/>
             <a:ext cx="10637215" cy="320040"/>
           </a:xfrm>
           <a:prstGeom prst="rect">
@@ -5383,13 +5337,13 @@
           <a:p>
             <a:pPr algn="l"/>
             <a:r>
-              <a:rPr sz="850" b="1" i="0" spc="160">
+              <a:rPr sz="1300" b="0" i="0" spc="40">
                 <a:solidFill>
                   <a:srgbClr val="5A7299"/>
                 </a:solidFill>
                 <a:latin typeface="Inter Tight"/>
               </a:rPr>
-              <a:t>VALIDADO EM 3 VISITAS COM TIAGO JORNADA E KAROLINE ANDRADE</a:t>
+              <a:t>Validado em 3 visitas com Tiago Jornada e Karoline Andrade</a:t>
             </a:r>
           </a:p>
         </p:txBody>
@@ -5464,8 +5418,8 @@
         </p:nvSpPr>
         <p:spPr>
           <a:xfrm>
-            <a:off x="10362895" y="640080"/>
-            <a:ext cx="1051560" cy="320040"/>
+            <a:off x="10271455" y="640080"/>
+            <a:ext cx="1143000" cy="320040"/>
           </a:xfrm>
           <a:prstGeom prst="rect">
             <a:avLst/>
@@ -5480,7 +5434,7 @@
           <a:p>
             <a:pPr algn="r"/>
             <a:r>
-              <a:rPr sz="1100" b="1" i="0" spc="150">
+              <a:rPr sz="1300" b="1" i="0" spc="150">
                 <a:solidFill>
                   <a:srgbClr val="5A7299"/>
                 </a:solidFill>
@@ -5514,7 +5468,7 @@
           <a:lstStyle/>
           <a:p>
             <a:r>
-              <a:rPr sz="1100">
+              <a:rPr sz="1300">
                 <a:solidFill>
                   <a:srgbClr val="1D6FE0"/>
                 </a:solidFill>
@@ -5523,7 +5477,7 @@
               <a:t>● </a:t>
             </a:r>
             <a:r>
-              <a:rPr sz="1100" b="1" spc="240">
+              <a:rPr sz="1300" b="1" spc="240">
                 <a:solidFill>
                   <a:srgbClr val="5A7299"/>
                 </a:solidFill>
@@ -5599,8 +5553,8 @@
         </p:nvSpPr>
         <p:spPr>
           <a:xfrm>
-            <a:off x="777240" y="2103120"/>
-            <a:ext cx="3332378" cy="1554480"/>
+            <a:off x="777240" y="1965960"/>
+            <a:ext cx="3332378" cy="1828800"/>
           </a:xfrm>
           <a:prstGeom prst="roundRect">
             <a:avLst>
@@ -5647,8 +5601,8 @@
         </p:nvSpPr>
         <p:spPr>
           <a:xfrm>
-            <a:off x="1033272" y="2304288"/>
-            <a:ext cx="2820314" cy="1188720"/>
+            <a:off x="1051560" y="2203704"/>
+            <a:ext cx="2783738" cy="1371600"/>
           </a:xfrm>
           <a:prstGeom prst="rect">
             <a:avLst/>
@@ -5663,11 +5617,11 @@
           <a:p>
             <a:pPr algn="l">
               <a:spcAft>
-                <a:spcPts val="600"/>
+                <a:spcPts val="800"/>
               </a:spcAft>
             </a:pPr>
             <a:r>
-              <a:rPr sz="900" b="1" i="0" spc="120">
+              <a:rPr sz="1300" b="1" i="0" spc="100">
                 <a:solidFill>
                   <a:srgbClr val="1D6FE0"/>
                 </a:solidFill>
@@ -5679,11 +5633,11 @@
           <a:p>
             <a:pPr algn="l">
               <a:spcAft>
-                <a:spcPts val="600"/>
+                <a:spcPts val="800"/>
               </a:spcAft>
             </a:pPr>
             <a:r>
-              <a:rPr sz="1800" b="0" i="0">
+              <a:rPr sz="2200" b="0" i="0">
                 <a:solidFill>
                   <a:srgbClr val="0B2545"/>
                 </a:solidFill>
@@ -5699,13 +5653,13 @@
               </a:lnSpc>
             </a:pPr>
             <a:r>
-              <a:rPr sz="1050" b="0" i="0">
+              <a:rPr sz="1800" b="0" i="0">
                 <a:solidFill>
                   <a:srgbClr val="5A7299"/>
                 </a:solidFill>
                 <a:latin typeface="Inter Tight"/>
               </a:rPr>
-              <a:t>Planilha com 914 linhas → 814 exames únicos: nome, sigla, sinônimos, modalidade.</a:t>
+              <a:t>914 linhas → 814 exames únicos: nome, sigla, sinônimos, modalidade.</a:t>
             </a:r>
           </a:p>
         </p:txBody>
@@ -5718,8 +5672,8 @@
         </p:nvSpPr>
         <p:spPr>
           <a:xfrm>
-            <a:off x="4429658" y="2103120"/>
-            <a:ext cx="3332378" cy="1554480"/>
+            <a:off x="4429658" y="1965960"/>
+            <a:ext cx="3332378" cy="1828800"/>
           </a:xfrm>
           <a:prstGeom prst="roundRect">
             <a:avLst>
@@ -5766,8 +5720,8 @@
         </p:nvSpPr>
         <p:spPr>
           <a:xfrm>
-            <a:off x="4685690" y="2304288"/>
-            <a:ext cx="2820314" cy="1188720"/>
+            <a:off x="4703978" y="2203704"/>
+            <a:ext cx="2783738" cy="1371600"/>
           </a:xfrm>
           <a:prstGeom prst="rect">
             <a:avLst/>
@@ -5782,11 +5736,11 @@
           <a:p>
             <a:pPr algn="l">
               <a:spcAft>
-                <a:spcPts val="600"/>
+                <a:spcPts val="800"/>
               </a:spcAft>
             </a:pPr>
             <a:r>
-              <a:rPr sz="900" b="1" i="0" spc="120">
+              <a:rPr sz="1300" b="1" i="0" spc="100">
                 <a:solidFill>
                   <a:srgbClr val="1D6FE0"/>
                 </a:solidFill>
@@ -5798,11 +5752,11 @@
           <a:p>
             <a:pPr algn="l">
               <a:spcAft>
-                <a:spcPts val="600"/>
+                <a:spcPts val="800"/>
               </a:spcAft>
             </a:pPr>
             <a:r>
-              <a:rPr sz="1800" b="0" i="0">
+              <a:rPr sz="2200" b="0" i="0">
                 <a:solidFill>
                   <a:srgbClr val="0B2545"/>
                 </a:solidFill>
@@ -5818,13 +5772,13 @@
               </a:lnSpc>
             </a:pPr>
             <a:r>
-              <a:rPr sz="1050" b="0" i="0">
+              <a:rPr sz="1800" b="0" i="0">
                 <a:solidFill>
                   <a:srgbClr val="5A7299"/>
                 </a:solidFill>
                 <a:latin typeface="Inter Tight"/>
               </a:rPr>
-              <a:t>Documento por modalidade: gerais, por grupo e específicos. Cobre USG, RM, MMG, DO.</a:t>
+              <a:t>Preparos por modalidade. Cobre USG, RM, MMG e DO.</a:t>
             </a:r>
           </a:p>
         </p:txBody>
@@ -5837,8 +5791,8 @@
         </p:nvSpPr>
         <p:spPr>
           <a:xfrm>
-            <a:off x="8082076" y="2103120"/>
-            <a:ext cx="3332378" cy="1554480"/>
+            <a:off x="8082076" y="1965960"/>
+            <a:ext cx="3332378" cy="1828800"/>
           </a:xfrm>
           <a:prstGeom prst="roundRect">
             <a:avLst>
@@ -5885,8 +5839,8 @@
         </p:nvSpPr>
         <p:spPr>
           <a:xfrm>
-            <a:off x="8338108" y="2304288"/>
-            <a:ext cx="2820314" cy="1188720"/>
+            <a:off x="8356396" y="2203704"/>
+            <a:ext cx="2783738" cy="1371600"/>
           </a:xfrm>
           <a:prstGeom prst="rect">
             <a:avLst/>
@@ -5901,11 +5855,11 @@
           <a:p>
             <a:pPr algn="l">
               <a:spcAft>
-                <a:spcPts val="600"/>
+                <a:spcPts val="800"/>
               </a:spcAft>
             </a:pPr>
             <a:r>
-              <a:rPr sz="900" b="1" i="0" spc="120">
+              <a:rPr sz="1300" b="1" i="0" spc="100">
                 <a:solidFill>
                   <a:srgbClr val="1D6FE0"/>
                 </a:solidFill>
@@ -5917,11 +5871,11 @@
           <a:p>
             <a:pPr algn="l">
               <a:spcAft>
-                <a:spcPts val="600"/>
+                <a:spcPts val="800"/>
               </a:spcAft>
             </a:pPr>
             <a:r>
-              <a:rPr sz="1800" b="0" i="0">
+              <a:rPr sz="2200" b="0" i="0">
                 <a:solidFill>
                   <a:srgbClr val="0B2545"/>
                 </a:solidFill>
@@ -5937,7 +5891,7 @@
               </a:lnSpc>
             </a:pPr>
             <a:r>
-              <a:rPr sz="1050" b="0" i="0">
+              <a:rPr sz="1800" b="0" i="0">
                 <a:solidFill>
                   <a:srgbClr val="5A7299"/>
                 </a:solidFill>
@@ -5956,8 +5910,8 @@
         </p:nvSpPr>
         <p:spPr>
           <a:xfrm>
-            <a:off x="777240" y="3886200"/>
-            <a:ext cx="2194560" cy="365760"/>
+            <a:off x="777240" y="3931920"/>
+            <a:ext cx="2743200" cy="384048"/>
           </a:xfrm>
           <a:prstGeom prst="rect">
             <a:avLst/>
@@ -5972,7 +5926,7 @@
           <a:p>
             <a:pPr algn="l"/>
             <a:r>
-              <a:rPr sz="1150" b="0" i="0">
+              <a:rPr sz="1800" b="0" i="0">
                 <a:solidFill>
                   <a:srgbClr val="0B2545"/>
                 </a:solidFill>
@@ -5991,8 +5945,8 @@
         </p:nvSpPr>
         <p:spPr>
           <a:xfrm>
-            <a:off x="2971800" y="3986784"/>
-            <a:ext cx="6035040" cy="146304"/>
+            <a:off x="3520440" y="4050792"/>
+            <a:ext cx="5669280" cy="164592"/>
           </a:xfrm>
           <a:prstGeom prst="roundRect">
             <a:avLst>
@@ -6037,8 +5991,8 @@
         </p:nvSpPr>
         <p:spPr>
           <a:xfrm>
-            <a:off x="2971800" y="3986784"/>
-            <a:ext cx="6035040" cy="146304"/>
+            <a:off x="3520440" y="4050792"/>
+            <a:ext cx="5669280" cy="164592"/>
           </a:xfrm>
           <a:prstGeom prst="roundRect">
             <a:avLst>
@@ -6083,8 +6037,8 @@
         </p:nvSpPr>
         <p:spPr>
           <a:xfrm>
-            <a:off x="9189720" y="3886200"/>
-            <a:ext cx="1280160" cy="365760"/>
+            <a:off x="9372600" y="3931920"/>
+            <a:ext cx="1280160" cy="384048"/>
           </a:xfrm>
           <a:prstGeom prst="rect">
             <a:avLst/>
@@ -6099,7 +6053,7 @@
           <a:p>
             <a:pPr algn="l"/>
             <a:r>
-              <a:rPr sz="1100" b="1" i="0">
+              <a:rPr sz="1500" b="1" i="0">
                 <a:solidFill>
                   <a:srgbClr val="14418A"/>
                 </a:solidFill>
@@ -6118,8 +6072,8 @@
         </p:nvSpPr>
         <p:spPr>
           <a:xfrm>
-            <a:off x="777240" y="4297680"/>
-            <a:ext cx="2194560" cy="365760"/>
+            <a:off x="777240" y="4315968"/>
+            <a:ext cx="2743200" cy="384048"/>
           </a:xfrm>
           <a:prstGeom prst="rect">
             <a:avLst/>
@@ -6134,7 +6088,7 @@
           <a:p>
             <a:pPr algn="l"/>
             <a:r>
-              <a:rPr sz="1150" b="0" i="0">
+              <a:rPr sz="1800" b="0" i="0">
                 <a:solidFill>
                   <a:srgbClr val="0B2545"/>
                 </a:solidFill>
@@ -6153,8 +6107,8 @@
         </p:nvSpPr>
         <p:spPr>
           <a:xfrm>
-            <a:off x="2971800" y="4398264"/>
-            <a:ext cx="6035040" cy="146304"/>
+            <a:off x="3520440" y="4434840"/>
+            <a:ext cx="5669280" cy="164592"/>
           </a:xfrm>
           <a:prstGeom prst="roundRect">
             <a:avLst>
@@ -6199,8 +6153,8 @@
         </p:nvSpPr>
         <p:spPr>
           <a:xfrm>
-            <a:off x="2971800" y="4398264"/>
-            <a:ext cx="4939878" cy="146304"/>
+            <a:off x="3520440" y="4434840"/>
+            <a:ext cx="4640491" cy="164592"/>
           </a:xfrm>
           <a:prstGeom prst="roundRect">
             <a:avLst>
@@ -6245,8 +6199,8 @@
         </p:nvSpPr>
         <p:spPr>
           <a:xfrm>
-            <a:off x="2971800" y="4398264"/>
-            <a:ext cx="4753467" cy="146304"/>
+            <a:off x="3520440" y="4434840"/>
+            <a:ext cx="4465378" cy="164592"/>
           </a:xfrm>
           <a:prstGeom prst="roundRect">
             <a:avLst>
@@ -6291,8 +6245,8 @@
         </p:nvSpPr>
         <p:spPr>
           <a:xfrm>
-            <a:off x="9189720" y="4297680"/>
-            <a:ext cx="1280160" cy="365760"/>
+            <a:off x="9372600" y="4315968"/>
+            <a:ext cx="1280160" cy="384048"/>
           </a:xfrm>
           <a:prstGeom prst="rect">
             <a:avLst/>
@@ -6307,7 +6261,7 @@
           <a:p>
             <a:pPr algn="l"/>
             <a:r>
-              <a:rPr sz="1100" b="1" i="0">
+              <a:rPr sz="1500" b="1" i="0">
                 <a:solidFill>
                   <a:srgbClr val="14418A"/>
                 </a:solidFill>
@@ -6326,8 +6280,8 @@
         </p:nvSpPr>
         <p:spPr>
           <a:xfrm>
-            <a:off x="777240" y="4709160"/>
-            <a:ext cx="2194560" cy="365760"/>
+            <a:off x="777240" y="4700016"/>
+            <a:ext cx="2743200" cy="384048"/>
           </a:xfrm>
           <a:prstGeom prst="rect">
             <a:avLst/>
@@ -6342,7 +6296,7 @@
           <a:p>
             <a:pPr algn="l"/>
             <a:r>
-              <a:rPr sz="1150" b="0" i="0">
+              <a:rPr sz="1800" b="0" i="0">
                 <a:solidFill>
                   <a:srgbClr val="0B2545"/>
                 </a:solidFill>
@@ -6361,8 +6315,8 @@
         </p:nvSpPr>
         <p:spPr>
           <a:xfrm>
-            <a:off x="2971800" y="4809744"/>
-            <a:ext cx="6035040" cy="146304"/>
+            <a:off x="3520440" y="4818888"/>
+            <a:ext cx="5669280" cy="164592"/>
           </a:xfrm>
           <a:prstGeom prst="roundRect">
             <a:avLst>
@@ -6407,8 +6361,8 @@
         </p:nvSpPr>
         <p:spPr>
           <a:xfrm>
-            <a:off x="2971800" y="4809744"/>
-            <a:ext cx="4497153" cy="146304"/>
+            <a:off x="3520440" y="4818888"/>
+            <a:ext cx="4224598" cy="164592"/>
           </a:xfrm>
           <a:prstGeom prst="roundRect">
             <a:avLst>
@@ -6453,8 +6407,8 @@
         </p:nvSpPr>
         <p:spPr>
           <a:xfrm>
-            <a:off x="2971800" y="4809744"/>
-            <a:ext cx="4497153" cy="146304"/>
+            <a:off x="3520440" y="4818888"/>
+            <a:ext cx="4224598" cy="164592"/>
           </a:xfrm>
           <a:prstGeom prst="roundRect">
             <a:avLst>
@@ -6499,8 +6453,8 @@
         </p:nvSpPr>
         <p:spPr>
           <a:xfrm>
-            <a:off x="9189720" y="4709160"/>
-            <a:ext cx="1280160" cy="365760"/>
+            <a:off x="9372600" y="4700016"/>
+            <a:ext cx="1280160" cy="384048"/>
           </a:xfrm>
           <a:prstGeom prst="rect">
             <a:avLst/>
@@ -6515,7 +6469,7 @@
           <a:p>
             <a:pPr algn="l"/>
             <a:r>
-              <a:rPr sz="1100" b="1" i="0">
+              <a:rPr sz="1500" b="1" i="0">
                 <a:solidFill>
                   <a:srgbClr val="14418A"/>
                 </a:solidFill>
@@ -6534,8 +6488,8 @@
         </p:nvSpPr>
         <p:spPr>
           <a:xfrm>
-            <a:off x="777240" y="5120640"/>
-            <a:ext cx="2194560" cy="365760"/>
+            <a:off x="777240" y="5084064"/>
+            <a:ext cx="2743200" cy="384048"/>
           </a:xfrm>
           <a:prstGeom prst="rect">
             <a:avLst/>
@@ -6550,7 +6504,7 @@
           <a:p>
             <a:pPr algn="l"/>
             <a:r>
-              <a:rPr sz="1150" b="0" i="0">
+              <a:rPr sz="1800" b="0" i="0">
                 <a:solidFill>
                   <a:srgbClr val="0B2545"/>
                 </a:solidFill>
@@ -6569,8 +6523,8 @@
         </p:nvSpPr>
         <p:spPr>
           <a:xfrm>
-            <a:off x="2971800" y="5221224"/>
-            <a:ext cx="6035040" cy="146304"/>
+            <a:off x="3520440" y="5202936"/>
+            <a:ext cx="5669280" cy="164592"/>
           </a:xfrm>
           <a:prstGeom prst="roundRect">
             <a:avLst>
@@ -6615,8 +6569,8 @@
         </p:nvSpPr>
         <p:spPr>
           <a:xfrm>
-            <a:off x="2971800" y="5221224"/>
-            <a:ext cx="2516541" cy="146304"/>
+            <a:off x="3520440" y="5202936"/>
+            <a:ext cx="2364024" cy="164592"/>
           </a:xfrm>
           <a:prstGeom prst="roundRect">
             <a:avLst>
@@ -6661,8 +6615,8 @@
         </p:nvSpPr>
         <p:spPr>
           <a:xfrm>
-            <a:off x="2971800" y="5221224"/>
-            <a:ext cx="372821" cy="146304"/>
+            <a:off x="3520440" y="5202936"/>
+            <a:ext cx="350225" cy="164592"/>
           </a:xfrm>
           <a:prstGeom prst="roundRect">
             <a:avLst>
@@ -6707,8 +6661,8 @@
         </p:nvSpPr>
         <p:spPr>
           <a:xfrm>
-            <a:off x="9189720" y="5120640"/>
-            <a:ext cx="1280160" cy="365760"/>
+            <a:off x="9372600" y="5084064"/>
+            <a:ext cx="1280160" cy="384048"/>
           </a:xfrm>
           <a:prstGeom prst="rect">
             <a:avLst/>
@@ -6723,7 +6677,7 @@
           <a:p>
             <a:pPr algn="l"/>
             <a:r>
-              <a:rPr sz="1100" b="1" i="0">
+              <a:rPr sz="1500" b="1" i="0">
                 <a:solidFill>
                   <a:srgbClr val="14418A"/>
                 </a:solidFill>
@@ -6742,8 +6696,8 @@
         </p:nvSpPr>
         <p:spPr>
           <a:xfrm>
-            <a:off x="777240" y="5532120"/>
-            <a:ext cx="2194560" cy="365760"/>
+            <a:off x="777240" y="5468112"/>
+            <a:ext cx="2743200" cy="384048"/>
           </a:xfrm>
           <a:prstGeom prst="rect">
             <a:avLst/>
@@ -6758,7 +6712,7 @@
           <a:p>
             <a:pPr algn="l"/>
             <a:r>
-              <a:rPr sz="1150" b="0" i="0">
+              <a:rPr sz="1800" b="0" i="0">
                 <a:solidFill>
                   <a:srgbClr val="0B2545"/>
                 </a:solidFill>
@@ -6777,8 +6731,8 @@
         </p:nvSpPr>
         <p:spPr>
           <a:xfrm>
-            <a:off x="2971800" y="5632704"/>
-            <a:ext cx="6035040" cy="146304"/>
+            <a:off x="3520440" y="5586984"/>
+            <a:ext cx="5669280" cy="164592"/>
           </a:xfrm>
           <a:prstGeom prst="roundRect">
             <a:avLst>
@@ -6823,8 +6777,8 @@
         </p:nvSpPr>
         <p:spPr>
           <a:xfrm>
-            <a:off x="2971800" y="5632704"/>
-            <a:ext cx="745642" cy="146304"/>
+            <a:off x="3520440" y="5586984"/>
+            <a:ext cx="700451" cy="164592"/>
           </a:xfrm>
           <a:prstGeom prst="roundRect">
             <a:avLst>
@@ -6869,8 +6823,8 @@
         </p:nvSpPr>
         <p:spPr>
           <a:xfrm>
-            <a:off x="9189720" y="5532120"/>
-            <a:ext cx="1280160" cy="365760"/>
+            <a:off x="9372600" y="5468112"/>
+            <a:ext cx="1280160" cy="384048"/>
           </a:xfrm>
           <a:prstGeom prst="rect">
             <a:avLst/>
@@ -6885,7 +6839,7 @@
           <a:p>
             <a:pPr algn="l"/>
             <a:r>
-              <a:rPr sz="1100" b="1" i="0">
+              <a:rPr sz="1500" b="1" i="0">
                 <a:solidFill>
                   <a:srgbClr val="14418A"/>
                 </a:solidFill>
@@ -6904,8 +6858,8 @@
         </p:nvSpPr>
         <p:spPr>
           <a:xfrm>
-            <a:off x="777240" y="5943600"/>
-            <a:ext cx="2194560" cy="365760"/>
+            <a:off x="777240" y="5852160"/>
+            <a:ext cx="2743200" cy="384048"/>
           </a:xfrm>
           <a:prstGeom prst="rect">
             <a:avLst/>
@@ -6920,7 +6874,7 @@
           <a:p>
             <a:pPr algn="l"/>
             <a:r>
-              <a:rPr sz="1150" b="0" i="0">
+              <a:rPr sz="1800" b="0" i="0">
                 <a:solidFill>
                   <a:srgbClr val="0B2545"/>
                 </a:solidFill>
@@ -6939,8 +6893,8 @@
         </p:nvSpPr>
         <p:spPr>
           <a:xfrm>
-            <a:off x="2971800" y="6044184"/>
-            <a:ext cx="6035040" cy="146304"/>
+            <a:off x="3520440" y="5971032"/>
+            <a:ext cx="5669280" cy="164592"/>
           </a:xfrm>
           <a:prstGeom prst="roundRect">
             <a:avLst>
@@ -6985,8 +6939,8 @@
         </p:nvSpPr>
         <p:spPr>
           <a:xfrm>
-            <a:off x="2971800" y="6044184"/>
-            <a:ext cx="233013" cy="146304"/>
+            <a:off x="3520440" y="5971032"/>
+            <a:ext cx="218891" cy="164592"/>
           </a:xfrm>
           <a:prstGeom prst="roundRect">
             <a:avLst>
@@ -7031,8 +6985,8 @@
         </p:nvSpPr>
         <p:spPr>
           <a:xfrm>
-            <a:off x="2971800" y="6044184"/>
-            <a:ext cx="233013" cy="146304"/>
+            <a:off x="3520440" y="5971032"/>
+            <a:ext cx="218891" cy="164592"/>
           </a:xfrm>
           <a:prstGeom prst="roundRect">
             <a:avLst>
@@ -7077,8 +7031,8 @@
         </p:nvSpPr>
         <p:spPr>
           <a:xfrm>
-            <a:off x="9189720" y="5943600"/>
-            <a:ext cx="1280160" cy="365760"/>
+            <a:off x="9372600" y="5852160"/>
+            <a:ext cx="1280160" cy="384048"/>
           </a:xfrm>
           <a:prstGeom prst="rect">
             <a:avLst/>
@@ -7093,7 +7047,7 @@
           <a:p>
             <a:pPr algn="l"/>
             <a:r>
-              <a:rPr sz="1100" b="1" i="0">
+              <a:rPr sz="1500" b="1" i="0">
                 <a:solidFill>
                   <a:srgbClr val="14418A"/>
                 </a:solidFill>
@@ -7112,8 +7066,8 @@
         </p:nvSpPr>
         <p:spPr>
           <a:xfrm>
-            <a:off x="2971800" y="6400800"/>
-            <a:ext cx="6035040" cy="320040"/>
+            <a:off x="3520440" y="6345936"/>
+            <a:ext cx="7132320" cy="274320"/>
           </a:xfrm>
           <a:prstGeom prst="rect">
             <a:avLst/>
@@ -7127,7 +7081,7 @@
           <a:lstStyle/>
           <a:p>
             <a:r>
-              <a:rPr sz="1000">
+              <a:rPr sz="1400">
                 <a:solidFill>
                   <a:srgbClr val="1D6FE0"/>
                 </a:solidFill>
@@ -7136,16 +7090,16 @@
               <a:t>■ </a:t>
             </a:r>
             <a:r>
-              <a:rPr sz="1000">
+              <a:rPr sz="1400">
                 <a:solidFill>
                   <a:srgbClr val="5A7299"/>
                 </a:solidFill>
                 <a:latin typeface="Inter Tight"/>
               </a:rPr>
-              <a:t>com preparo confirmado    </a:t>
-            </a:r>
-            <a:r>
-              <a:rPr sz="1000">
+              <a:t>com preparo confirmado     </a:t>
+            </a:r>
+            <a:r>
+              <a:rPr sz="1400">
                 <a:solidFill>
                   <a:srgbClr val="DCE8FA"/>
                 </a:solidFill>
@@ -7154,48 +7108,13 @@
               <a:t>■ </a:t>
             </a:r>
             <a:r>
-              <a:rPr sz="1000">
+              <a:rPr sz="1400">
                 <a:solidFill>
                   <a:srgbClr val="5A7299"/>
                 </a:solidFill>
                 <a:latin typeface="Inter Tight"/>
               </a:rPr>
-              <a:t>pendente → roteado ao setor com segurança</a:t>
-            </a:r>
-          </a:p>
-        </p:txBody>
-      </p:sp>
-      <p:sp>
-        <p:nvSpPr>
-          <p:cNvPr id="41" name="TextBox 40"/>
-          <p:cNvSpPr txBox="1"/>
-          <p:nvPr/>
-        </p:nvSpPr>
-        <p:spPr>
-          <a:xfrm>
-            <a:off x="777240" y="6291072"/>
-            <a:ext cx="10637215" cy="320040"/>
-          </a:xfrm>
-          <a:prstGeom prst="rect">
-            <a:avLst/>
-          </a:prstGeom>
-          <a:noFill/>
-        </p:spPr>
-        <p:txBody>
-          <a:bodyPr wrap="square" lIns="0" rIns="0" tIns="0" bIns="0">
-            <a:spAutoFit/>
-          </a:bodyPr>
-          <a:lstStyle/>
-          <a:p>
-            <a:pPr algn="l"/>
-            <a:r>
-              <a:rPr sz="850" b="1" i="0" spc="160">
-                <a:solidFill>
-                  <a:srgbClr val="5A7299"/>
-                </a:solidFill>
-                <a:latin typeface="Inter Tight"/>
-              </a:rPr>
-              <a:t>423 EXAMES COM PREPARO CONFIRMADO · 391 PENDENTES COM FALLBACK SEGURO (NUNCA PRESUME DISPENSA)</a:t>
+              <a:t>pendente → roteado ao setor</a:t>
             </a:r>
           </a:p>
         </p:txBody>
@@ -7270,8 +7189,8 @@
         </p:nvSpPr>
         <p:spPr>
           <a:xfrm>
-            <a:off x="10362895" y="640080"/>
-            <a:ext cx="1051560" cy="320040"/>
+            <a:off x="10271455" y="640080"/>
+            <a:ext cx="1143000" cy="320040"/>
           </a:xfrm>
           <a:prstGeom prst="rect">
             <a:avLst/>
@@ -7286,7 +7205,7 @@
           <a:p>
             <a:pPr algn="r"/>
             <a:r>
-              <a:rPr sz="1100" b="1" i="0" spc="150">
+              <a:rPr sz="1300" b="1" i="0" spc="150">
                 <a:solidFill>
                   <a:srgbClr val="5A7299"/>
                 </a:solidFill>
@@ -7320,7 +7239,7 @@
           <a:lstStyle/>
           <a:p>
             <a:r>
-              <a:rPr sz="1100">
+              <a:rPr sz="1300">
                 <a:solidFill>
                   <a:srgbClr val="1D6FE0"/>
                 </a:solidFill>
@@ -7329,7 +7248,7 @@
               <a:t>● </a:t>
             </a:r>
             <a:r>
-              <a:rPr sz="1100" b="1" spc="240">
+              <a:rPr sz="1300" b="1" spc="240">
                 <a:solidFill>
                   <a:srgbClr val="5A7299"/>
                 </a:solidFill>
@@ -7405,8 +7324,8 @@
         </p:nvSpPr>
         <p:spPr>
           <a:xfrm>
-            <a:off x="777240" y="2286000"/>
-            <a:ext cx="9601200" cy="822960"/>
+            <a:off x="777240" y="2240280"/>
+            <a:ext cx="10637215" cy="1005840"/>
           </a:xfrm>
           <a:prstGeom prst="rect">
             <a:avLst/>
@@ -7425,7 +7344,7 @@
               </a:lnSpc>
             </a:pPr>
             <a:r>
-              <a:rPr sz="1500" b="0" i="0">
+              <a:rPr sz="1800" b="0" i="0">
                 <a:solidFill>
                   <a:srgbClr val="5A7299"/>
                 </a:solidFill>
@@ -7444,8 +7363,8 @@
         </p:nvSpPr>
         <p:spPr>
           <a:xfrm>
-            <a:off x="777240" y="3383280"/>
-            <a:ext cx="5090007" cy="2011680"/>
+            <a:off x="777240" y="3429000"/>
+            <a:ext cx="5090007" cy="2286000"/>
           </a:xfrm>
           <a:prstGeom prst="roundRect">
             <a:avLst>
@@ -7492,8 +7411,8 @@
         </p:nvSpPr>
         <p:spPr>
           <a:xfrm>
-            <a:off x="1097280" y="3703320"/>
-            <a:ext cx="594360" cy="594360"/>
+            <a:off x="1143000" y="3794760"/>
+            <a:ext cx="640080" cy="640080"/>
           </a:xfrm>
           <a:prstGeom prst="roundRect">
             <a:avLst>
@@ -7528,7 +7447,7 @@
           <a:p>
             <a:pPr algn="ctr"/>
             <a:r>
-              <a:rPr sz="2000" b="0" i="0">
+              <a:rPr sz="2200" b="0" i="0">
                 <a:solidFill>
                   <a:srgbClr val="1D6FE0"/>
                 </a:solidFill>
@@ -7547,8 +7466,8 @@
         </p:nvSpPr>
         <p:spPr>
           <a:xfrm>
-            <a:off x="1097280" y="4434840"/>
-            <a:ext cx="4449927" cy="822960"/>
+            <a:off x="1143000" y="4617720"/>
+            <a:ext cx="4358487" cy="914400"/>
           </a:xfrm>
           <a:prstGeom prst="rect">
             <a:avLst/>
@@ -7563,11 +7482,11 @@
           <a:p>
             <a:pPr algn="l">
               <a:spcAft>
-                <a:spcPts val="600"/>
+                <a:spcPts val="800"/>
               </a:spcAft>
             </a:pPr>
             <a:r>
-              <a:rPr sz="2200" b="0" i="0">
+              <a:rPr sz="2400" b="0" i="0">
                 <a:solidFill>
                   <a:srgbClr val="0B2545"/>
                 </a:solidFill>
@@ -7583,13 +7502,13 @@
               </a:lnSpc>
             </a:pPr>
             <a:r>
-              <a:rPr sz="1200" b="0" i="0">
+              <a:rPr sz="1800" b="0" i="0">
                 <a:solidFill>
                   <a:srgbClr val="5A7299"/>
                 </a:solidFill>
                 <a:latin typeface="Inter Tight"/>
               </a:rPr>
-              <a:t>Picker guiado: escolhe a modalidade, o exame e responde contraste / sedação / lado. Resposta em linguagem simples.</a:t>
+              <a:t>Picker guiado: escolhe modalidade, exame e responde contraste / sedação / lado. Resposta em linguagem simples.</a:t>
             </a:r>
           </a:p>
         </p:txBody>
@@ -7602,8 +7521,8 @@
         </p:nvSpPr>
         <p:spPr>
           <a:xfrm>
-            <a:off x="6324447" y="3383280"/>
-            <a:ext cx="5090007" cy="2011680"/>
+            <a:off x="6324447" y="3429000"/>
+            <a:ext cx="5090007" cy="2286000"/>
           </a:xfrm>
           <a:prstGeom prst="roundRect">
             <a:avLst>
@@ -7650,8 +7569,8 @@
         </p:nvSpPr>
         <p:spPr>
           <a:xfrm>
-            <a:off x="6644487" y="3703320"/>
-            <a:ext cx="594360" cy="594360"/>
+            <a:off x="6690207" y="3794760"/>
+            <a:ext cx="640080" cy="640080"/>
           </a:xfrm>
           <a:prstGeom prst="roundRect">
             <a:avLst>
@@ -7686,7 +7605,7 @@
           <a:p>
             <a:pPr algn="ctr"/>
             <a:r>
-              <a:rPr sz="2000" b="0" i="0">
+              <a:rPr sz="2200" b="0" i="0">
                 <a:solidFill>
                   <a:srgbClr val="1D6FE0"/>
                 </a:solidFill>
@@ -7705,8 +7624,8 @@
         </p:nvSpPr>
         <p:spPr>
           <a:xfrm>
-            <a:off x="6644487" y="4434840"/>
-            <a:ext cx="4449927" cy="822960"/>
+            <a:off x="6690207" y="4617720"/>
+            <a:ext cx="4358487" cy="914400"/>
           </a:xfrm>
           <a:prstGeom prst="rect">
             <a:avLst/>
@@ -7721,11 +7640,11 @@
           <a:p>
             <a:pPr algn="l">
               <a:spcAft>
-                <a:spcPts val="600"/>
+                <a:spcPts val="800"/>
               </a:spcAft>
             </a:pPr>
             <a:r>
-              <a:rPr sz="2200" b="0" i="0">
+              <a:rPr sz="2400" b="0" i="0">
                 <a:solidFill>
                   <a:srgbClr val="0B2545"/>
                 </a:solidFill>
@@ -7741,13 +7660,13 @@
               </a:lnSpc>
             </a:pPr>
             <a:r>
-              <a:rPr sz="1200" b="0" i="0">
+              <a:rPr sz="1800" b="0" i="0">
                 <a:solidFill>
                   <a:srgbClr val="5A7299"/>
                 </a:solidFill>
                 <a:latin typeface="Inter Tight"/>
               </a:rPr>
-              <a:t>Linguagem técnica + código AGHU do exame para o cadastro. Protocolos, contraste, sedação e fluxo de agendamento.</a:t>
+              <a:t>Linguagem técnica + código AGHU do exame para o cadastro. Protocolos, contraste, sedação e fluxo.</a:t>
             </a:r>
           </a:p>
         </p:txBody>
@@ -7760,7 +7679,7 @@
         </p:nvSpPr>
         <p:spPr>
           <a:xfrm>
-            <a:off x="777240" y="6291072"/>
+            <a:off x="777240" y="6309360"/>
             <a:ext cx="10637215" cy="320040"/>
           </a:xfrm>
           <a:prstGeom prst="rect">
@@ -7776,13 +7695,13 @@
           <a:p>
             <a:pPr algn="l"/>
             <a:r>
-              <a:rPr sz="850" b="1" i="0" spc="160">
+              <a:rPr sz="1300" b="0" i="0" spc="40">
                 <a:solidFill>
                   <a:srgbClr val="5A7299"/>
                 </a:solidFill>
                 <a:latin typeface="Inter Tight"/>
               </a:rPr>
-              <a:t>FORA DO ESCOPO · NAVEGAÇÃO PELO CORPO HUMANO · MARCAÇÃO REAL · DADOS DE PACIENTE</a:t>
+              <a:t>Fora do escopo · navegação pelo corpo humano · marcação real · dados de paciente</a:t>
             </a:r>
           </a:p>
         </p:txBody>
@@ -7857,8 +7776,8 @@
         </p:nvSpPr>
         <p:spPr>
           <a:xfrm>
-            <a:off x="10362895" y="640080"/>
-            <a:ext cx="1051560" cy="320040"/>
+            <a:off x="10271455" y="640080"/>
+            <a:ext cx="1143000" cy="320040"/>
           </a:xfrm>
           <a:prstGeom prst="rect">
             <a:avLst/>
@@ -7873,7 +7792,7 @@
           <a:p>
             <a:pPr algn="r"/>
             <a:r>
-              <a:rPr sz="1100" b="1" i="0" spc="150">
+              <a:rPr sz="1300" b="1" i="0" spc="150">
                 <a:solidFill>
                   <a:srgbClr val="5A7299"/>
                 </a:solidFill>
@@ -7907,7 +7826,7 @@
           <a:lstStyle/>
           <a:p>
             <a:r>
-              <a:rPr sz="1100">
+              <a:rPr sz="1300">
                 <a:solidFill>
                   <a:srgbClr val="1D6FE0"/>
                 </a:solidFill>
@@ -7916,7 +7835,7 @@
               <a:t>● </a:t>
             </a:r>
             <a:r>
-              <a:rPr sz="1100" b="1" spc="240">
+              <a:rPr sz="1300" b="1" spc="240">
                 <a:solidFill>
                   <a:srgbClr val="5A7299"/>
                 </a:solidFill>
@@ -7983,7 +7902,7 @@
         </p:nvSpPr>
         <p:spPr>
           <a:xfrm>
-            <a:off x="777240" y="3059684"/>
+            <a:off x="777240" y="3123692"/>
             <a:ext cx="10637215" cy="12700"/>
           </a:xfrm>
           <a:prstGeom prst="rect">
@@ -8027,8 +7946,8 @@
         </p:nvSpPr>
         <p:spPr>
           <a:xfrm>
-            <a:off x="777240" y="2377440"/>
-            <a:ext cx="548640" cy="548640"/>
+            <a:off x="777240" y="2350008"/>
+            <a:ext cx="585216" cy="585216"/>
           </a:xfrm>
           <a:prstGeom prst="roundRect">
             <a:avLst>
@@ -8063,7 +7982,7 @@
           <a:p>
             <a:pPr algn="ctr"/>
             <a:r>
-              <a:rPr sz="1500" b="1" i="0">
+              <a:rPr sz="1800" b="1" i="0">
                 <a:solidFill>
                   <a:srgbClr val="FFFFFF"/>
                 </a:solidFill>
@@ -8082,8 +8001,8 @@
         </p:nvSpPr>
         <p:spPr>
           <a:xfrm>
-            <a:off x="1645920" y="2359152"/>
-            <a:ext cx="9631375" cy="603504"/>
+            <a:off x="1691640" y="2331720"/>
+            <a:ext cx="9585655" cy="694944"/>
           </a:xfrm>
           <a:prstGeom prst="rect">
             <a:avLst/>
@@ -8102,7 +8021,7 @@
               </a:spcAft>
             </a:pPr>
             <a:r>
-              <a:rPr sz="1500" b="1" i="0">
+              <a:rPr sz="1800" b="1" i="0">
                 <a:solidFill>
                   <a:srgbClr val="0B2545"/>
                 </a:solidFill>
@@ -8114,17 +8033,17 @@
           <a:p>
             <a:pPr algn="l">
               <a:lnSpc>
-                <a:spcPct val="125000"/>
+                <a:spcPct val="115000"/>
               </a:lnSpc>
             </a:pPr>
             <a:r>
-              <a:rPr sz="1200" b="0" i="0">
+              <a:rPr sz="1800" b="0" i="0">
                 <a:solidFill>
                   <a:srgbClr val="5A7299"/>
                 </a:solidFill>
                 <a:latin typeface="Inter Tight"/>
               </a:rPr>
-              <a:t>Parseia as 914 linhas da planilha e deduplica por sigla + modalidade → 814 exames únicos.</a:t>
+              <a:t>914 linhas → 814 exames únicos (dedupe por sigla + modalidade).</a:t>
             </a:r>
           </a:p>
         </p:txBody>
@@ -8137,7 +8056,7 @@
         </p:nvSpPr>
         <p:spPr>
           <a:xfrm>
-            <a:off x="777240" y="3846068"/>
+            <a:off x="777240" y="4019804"/>
             <a:ext cx="10637215" cy="12700"/>
           </a:xfrm>
           <a:prstGeom prst="rect">
@@ -8181,8 +8100,8 @@
         </p:nvSpPr>
         <p:spPr>
           <a:xfrm>
-            <a:off x="777240" y="3163824"/>
-            <a:ext cx="548640" cy="548640"/>
+            <a:off x="777240" y="3246120"/>
+            <a:ext cx="585216" cy="585216"/>
           </a:xfrm>
           <a:prstGeom prst="roundRect">
             <a:avLst>
@@ -8217,7 +8136,7 @@
           <a:p>
             <a:pPr algn="ctr"/>
             <a:r>
-              <a:rPr sz="1500" b="1" i="0">
+              <a:rPr sz="1800" b="1" i="0">
                 <a:solidFill>
                   <a:srgbClr val="FFFFFF"/>
                 </a:solidFill>
@@ -8236,8 +8155,8 @@
         </p:nvSpPr>
         <p:spPr>
           <a:xfrm>
-            <a:off x="1645920" y="3145536"/>
-            <a:ext cx="9631375" cy="603504"/>
+            <a:off x="1691640" y="3227832"/>
+            <a:ext cx="9585655" cy="694944"/>
           </a:xfrm>
           <a:prstGeom prst="rect">
             <a:avLst/>
@@ -8256,7 +8175,7 @@
               </a:spcAft>
             </a:pPr>
             <a:r>
-              <a:rPr sz="1500" b="1" i="0">
+              <a:rPr sz="1800" b="1" i="0">
                 <a:solidFill>
                   <a:srgbClr val="0B2545"/>
                 </a:solidFill>
@@ -8268,17 +8187,17 @@
           <a:p>
             <a:pPr algn="l">
               <a:lnSpc>
-                <a:spcPct val="125000"/>
+                <a:spcPct val="115000"/>
               </a:lnSpc>
             </a:pPr>
             <a:r>
-              <a:rPr sz="1200" b="0" i="0">
+              <a:rPr sz="1800" b="0" i="0">
                 <a:solidFill>
                   <a:srgbClr val="5A7299"/>
                 </a:solidFill>
                 <a:latin typeface="Inter Tight"/>
               </a:rPr>
-              <a:t>Cada exame recebe um preparo_id por modalidade + contraste + sedação, reaproveitando os preparos reais.</a:t>
+              <a:t>preparo_id por modalidade + contraste + sedação, reusando preparos reais.</a:t>
             </a:r>
           </a:p>
         </p:txBody>
@@ -8291,7 +8210,7 @@
         </p:nvSpPr>
         <p:spPr>
           <a:xfrm>
-            <a:off x="777240" y="4632452"/>
+            <a:off x="777240" y="4915916"/>
             <a:ext cx="10637215" cy="12700"/>
           </a:xfrm>
           <a:prstGeom prst="rect">
@@ -8335,8 +8254,8 @@
         </p:nvSpPr>
         <p:spPr>
           <a:xfrm>
-            <a:off x="777240" y="3950208"/>
-            <a:ext cx="548640" cy="548640"/>
+            <a:off x="777240" y="4142232"/>
+            <a:ext cx="585216" cy="585216"/>
           </a:xfrm>
           <a:prstGeom prst="roundRect">
             <a:avLst>
@@ -8371,7 +8290,7 @@
           <a:p>
             <a:pPr algn="ctr"/>
             <a:r>
-              <a:rPr sz="1500" b="1" i="0">
+              <a:rPr sz="1800" b="1" i="0">
                 <a:solidFill>
                   <a:srgbClr val="FFFFFF"/>
                 </a:solidFill>
@@ -8390,8 +8309,8 @@
         </p:nvSpPr>
         <p:spPr>
           <a:xfrm>
-            <a:off x="1645920" y="3931920"/>
-            <a:ext cx="9631375" cy="603504"/>
+            <a:off x="1691640" y="4123944"/>
+            <a:ext cx="9585655" cy="694944"/>
           </a:xfrm>
           <a:prstGeom prst="rect">
             <a:avLst/>
@@ -8410,7 +8329,7 @@
               </a:spcAft>
             </a:pPr>
             <a:r>
-              <a:rPr sz="1500" b="1" i="0">
+              <a:rPr sz="1800" b="1" i="0">
                 <a:solidFill>
                   <a:srgbClr val="0B2545"/>
                 </a:solidFill>
@@ -8422,17 +8341,17 @@
           <a:p>
             <a:pPr algn="l">
               <a:lnSpc>
-                <a:spcPct val="125000"/>
+                <a:spcPct val="115000"/>
               </a:lnSpc>
             </a:pPr>
             <a:r>
-              <a:rPr sz="1200" b="0" i="0">
+              <a:rPr sz="1800" b="0" i="0">
                 <a:solidFill>
                   <a:srgbClr val="5A7299"/>
                 </a:solidFill>
                 <a:latin typeface="Inter Tight"/>
               </a:rPr>
-              <a:t>Exame sem preparo confirmado → fallback 'confirme com o setor'. NUNCA presume que dispensa preparo.</a:t>
+              <a:t>Sem preparo confirmado → fallback. Nunca presume que dispensa preparo.</a:t>
             </a:r>
           </a:p>
         </p:txBody>
@@ -8445,7 +8364,7 @@
         </p:nvSpPr>
         <p:spPr>
           <a:xfrm>
-            <a:off x="777240" y="5418836"/>
+            <a:off x="777240" y="5812028"/>
             <a:ext cx="10637215" cy="12700"/>
           </a:xfrm>
           <a:prstGeom prst="rect">
@@ -8489,8 +8408,8 @@
         </p:nvSpPr>
         <p:spPr>
           <a:xfrm>
-            <a:off x="777240" y="4736592"/>
-            <a:ext cx="548640" cy="548640"/>
+            <a:off x="777240" y="5038344"/>
+            <a:ext cx="585216" cy="585216"/>
           </a:xfrm>
           <a:prstGeom prst="roundRect">
             <a:avLst>
@@ -8525,7 +8444,7 @@
           <a:p>
             <a:pPr algn="ctr"/>
             <a:r>
-              <a:rPr sz="1500" b="1" i="0">
+              <a:rPr sz="1800" b="1" i="0">
                 <a:solidFill>
                   <a:srgbClr val="FFFFFF"/>
                 </a:solidFill>
@@ -8544,8 +8463,8 @@
         </p:nvSpPr>
         <p:spPr>
           <a:xfrm>
-            <a:off x="1645920" y="4718304"/>
-            <a:ext cx="9631375" cy="603504"/>
+            <a:off x="1691640" y="5020056"/>
+            <a:ext cx="9585655" cy="694944"/>
           </a:xfrm>
           <a:prstGeom prst="rect">
             <a:avLst/>
@@ -8564,7 +8483,7 @@
               </a:spcAft>
             </a:pPr>
             <a:r>
-              <a:rPr sz="1500" b="1" i="0">
+              <a:rPr sz="1800" b="1" i="0">
                 <a:solidFill>
                   <a:srgbClr val="0B2545"/>
                 </a:solidFill>
@@ -8576,17 +8495,17 @@
           <a:p>
             <a:pPr algn="l">
               <a:lnSpc>
-                <a:spcPct val="125000"/>
+                <a:spcPct val="115000"/>
               </a:lnSpc>
             </a:pPr>
             <a:r>
-              <a:rPr sz="1200" b="0" i="0">
+              <a:rPr sz="1800" b="0" i="0">
                 <a:solidFill>
                   <a:srgbClr val="5A7299"/>
                 </a:solidFill>
                 <a:latin typeface="Inter Tight"/>
               </a:rPr>
-              <a:t>Todo preparo_id tem de existir; senão o script falha. Determinístico e idempotente.</a:t>
+              <a:t>Todo preparo_id existe; senão falha. Determinístico e idempotente.</a:t>
             </a:r>
           </a:p>
         </p:txBody>
@@ -8599,7 +8518,7 @@
         </p:nvSpPr>
         <p:spPr>
           <a:xfrm>
-            <a:off x="777240" y="6205220"/>
+            <a:off x="777240" y="6708140"/>
             <a:ext cx="10637215" cy="12700"/>
           </a:xfrm>
           <a:prstGeom prst="rect">
@@ -8643,8 +8562,8 @@
         </p:nvSpPr>
         <p:spPr>
           <a:xfrm>
-            <a:off x="777240" y="5522976"/>
-            <a:ext cx="548640" cy="548640"/>
+            <a:off x="777240" y="5934456"/>
+            <a:ext cx="585216" cy="585216"/>
           </a:xfrm>
           <a:prstGeom prst="roundRect">
             <a:avLst>
@@ -8679,7 +8598,7 @@
           <a:p>
             <a:pPr algn="ctr"/>
             <a:r>
-              <a:rPr sz="1500" b="1" i="0">
+              <a:rPr sz="1800" b="1" i="0">
                 <a:solidFill>
                   <a:srgbClr val="FFFFFF"/>
                 </a:solidFill>
@@ -8698,8 +8617,8 @@
         </p:nvSpPr>
         <p:spPr>
           <a:xfrm>
-            <a:off x="1645920" y="5504688"/>
-            <a:ext cx="9631375" cy="603504"/>
+            <a:off x="1691640" y="5916168"/>
+            <a:ext cx="9585655" cy="694944"/>
           </a:xfrm>
           <a:prstGeom prst="rect">
             <a:avLst/>
@@ -8718,7 +8637,7 @@
               </a:spcAft>
             </a:pPr>
             <a:r>
-              <a:rPr sz="1500" b="1" i="0">
+              <a:rPr sz="1800" b="1" i="0">
                 <a:solidFill>
                   <a:srgbClr val="0B2545"/>
                 </a:solidFill>
@@ -8730,17 +8649,17 @@
           <a:p>
             <a:pPr algn="l">
               <a:lnSpc>
-                <a:spcPct val="125000"/>
+                <a:spcPct val="115000"/>
               </a:lnSpc>
             </a:pPr>
             <a:r>
-              <a:rPr sz="1200" b="0" i="0">
+              <a:rPr sz="1800" b="0" i="0">
                 <a:solidFill>
                   <a:srgbClr val="5A7299"/>
                 </a:solidFill>
                 <a:latin typeface="Inter Tight"/>
               </a:rPr>
-              <a:t>Herança automática (geral + modalidade) evita redigir 814 registros à mão. npm run ingest.</a:t>
+              <a:t>Herança automática evita redigir 814 registros à mão. npm run ingest.</a:t>
             </a:r>
           </a:p>
         </p:txBody>
@@ -8815,8 +8734,8 @@
         </p:nvSpPr>
         <p:spPr>
           <a:xfrm>
-            <a:off x="10362895" y="640080"/>
-            <a:ext cx="1051560" cy="320040"/>
+            <a:off x="10271455" y="640080"/>
+            <a:ext cx="1143000" cy="320040"/>
           </a:xfrm>
           <a:prstGeom prst="rect">
             <a:avLst/>
@@ -8831,7 +8750,7 @@
           <a:p>
             <a:pPr algn="r"/>
             <a:r>
-              <a:rPr sz="1100" b="1" i="0" spc="150">
+              <a:rPr sz="1300" b="1" i="0" spc="150">
                 <a:solidFill>
                   <a:srgbClr val="5A7299"/>
                 </a:solidFill>
@@ -8865,7 +8784,7 @@
           <a:lstStyle/>
           <a:p>
             <a:r>
-              <a:rPr sz="1100">
+              <a:rPr sz="1300">
                 <a:solidFill>
                   <a:srgbClr val="1D6FE0"/>
                 </a:solidFill>
@@ -8874,7 +8793,7 @@
               <a:t>● </a:t>
             </a:r>
             <a:r>
-              <a:rPr sz="1100" b="1" spc="240">
+              <a:rPr sz="1300" b="1" spc="240">
                 <a:solidFill>
                   <a:srgbClr val="5A7299"/>
                 </a:solidFill>
@@ -8941,8 +8860,8 @@
         </p:nvSpPr>
         <p:spPr>
           <a:xfrm>
-            <a:off x="777240" y="2377440"/>
-            <a:ext cx="10637215" cy="1051560"/>
+            <a:off x="777240" y="2331720"/>
+            <a:ext cx="10637215" cy="1188720"/>
           </a:xfrm>
           <a:prstGeom prst="roundRect">
             <a:avLst>
@@ -8989,8 +8908,8 @@
         </p:nvSpPr>
         <p:spPr>
           <a:xfrm>
-            <a:off x="1143000" y="2377440"/>
-            <a:ext cx="2103120" cy="1051560"/>
+            <a:off x="1188720" y="2331720"/>
+            <a:ext cx="2377440" cy="1188720"/>
           </a:xfrm>
           <a:prstGeom prst="rect">
             <a:avLst/>
@@ -9005,7 +8924,7 @@
           <a:p>
             <a:pPr algn="l"/>
             <a:r>
-              <a:rPr sz="1100" b="1" i="0" spc="140">
+              <a:rPr sz="1400" b="1" i="0" spc="120">
                 <a:solidFill>
                   <a:srgbClr val="1D6FE0"/>
                 </a:solidFill>
@@ -9024,8 +8943,8 @@
         </p:nvSpPr>
         <p:spPr>
           <a:xfrm>
-            <a:off x="3429000" y="2542032"/>
-            <a:ext cx="7619695" cy="777240"/>
+            <a:off x="3794760" y="2514600"/>
+            <a:ext cx="7253935" cy="868680"/>
           </a:xfrm>
           <a:prstGeom prst="rect">
             <a:avLst/>
@@ -9040,11 +8959,11 @@
           <a:p>
             <a:pPr algn="l">
               <a:spcAft>
-                <a:spcPts val="300"/>
+                <a:spcPts val="400"/>
               </a:spcAft>
             </a:pPr>
             <a:r>
-              <a:rPr sz="1600" b="1" i="0">
+              <a:rPr sz="2000" b="1" i="0">
                 <a:solidFill>
                   <a:srgbClr val="0B2545"/>
                 </a:solidFill>
@@ -9056,11 +8975,11 @@
           <a:p>
             <a:pPr algn="l">
               <a:lnSpc>
-                <a:spcPct val="125000"/>
+                <a:spcPct val="120000"/>
               </a:lnSpc>
             </a:pPr>
             <a:r>
-              <a:rPr sz="1200" b="0" i="0">
+              <a:rPr sz="1800" b="0" i="0">
                 <a:solidFill>
                   <a:srgbClr val="5A7299"/>
                 </a:solidFill>
@@ -9079,8 +8998,8 @@
         </p:nvSpPr>
         <p:spPr>
           <a:xfrm>
-            <a:off x="777240" y="3410712"/>
-            <a:ext cx="10637215" cy="411480"/>
+            <a:off x="777240" y="3483864"/>
+            <a:ext cx="10637215" cy="365760"/>
           </a:xfrm>
           <a:prstGeom prst="rect">
             <a:avLst/>
@@ -9095,7 +9014,7 @@
           <a:p>
             <a:pPr algn="ctr"/>
             <a:r>
-              <a:rPr sz="1600" b="0" i="0">
+              <a:rPr sz="1800" b="0" i="0">
                 <a:solidFill>
                   <a:srgbClr val="5A7299"/>
                 </a:solidFill>
@@ -9114,8 +9033,8 @@
         </p:nvSpPr>
         <p:spPr>
           <a:xfrm>
-            <a:off x="777240" y="3840480"/>
-            <a:ext cx="10637215" cy="1051560"/>
+            <a:off x="777240" y="3886200"/>
+            <a:ext cx="10637215" cy="1188720"/>
           </a:xfrm>
           <a:prstGeom prst="roundRect">
             <a:avLst>
@@ -9162,8 +9081,8 @@
         </p:nvSpPr>
         <p:spPr>
           <a:xfrm>
-            <a:off x="1143000" y="3840480"/>
-            <a:ext cx="2103120" cy="1051560"/>
+            <a:off x="1188720" y="3886200"/>
+            <a:ext cx="2377440" cy="1188720"/>
           </a:xfrm>
           <a:prstGeom prst="rect">
             <a:avLst/>
@@ -9178,7 +9097,7 @@
           <a:p>
             <a:pPr algn="l"/>
             <a:r>
-              <a:rPr sz="1100" b="1" i="0" spc="140">
+              <a:rPr sz="1400" b="1" i="0" spc="120">
                 <a:solidFill>
                   <a:srgbClr val="1D6FE0"/>
                 </a:solidFill>
@@ -9197,8 +9116,8 @@
         </p:nvSpPr>
         <p:spPr>
           <a:xfrm>
-            <a:off x="3429000" y="4005072"/>
-            <a:ext cx="7619695" cy="777240"/>
+            <a:off x="3794760" y="4069080"/>
+            <a:ext cx="7253935" cy="868680"/>
           </a:xfrm>
           <a:prstGeom prst="rect">
             <a:avLst/>
@@ -9213,11 +9132,11 @@
           <a:p>
             <a:pPr algn="l">
               <a:spcAft>
-                <a:spcPts val="300"/>
+                <a:spcPts val="400"/>
               </a:spcAft>
             </a:pPr>
             <a:r>
-              <a:rPr sz="1600" b="1" i="0">
+              <a:rPr sz="2000" b="1" i="0">
                 <a:solidFill>
                   <a:srgbClr val="0B2545"/>
                 </a:solidFill>
@@ -9229,17 +9148,17 @@
           <a:p>
             <a:pPr algn="l">
               <a:lnSpc>
-                <a:spcPct val="125000"/>
+                <a:spcPct val="120000"/>
               </a:lnSpc>
             </a:pPr>
             <a:r>
-              <a:rPr sz="1200" b="0" i="0">
+              <a:rPr sz="1800" b="0" i="0">
                 <a:solidFill>
                   <a:srgbClr val="5A7299"/>
                 </a:solidFill>
                 <a:latin typeface="Inter Tight"/>
               </a:rPr>
-              <a:t>Busca o exame, monta o contexto por perfil e chama o modelo. Protege a chave. Sem servidor.</a:t>
+              <a:t>Busca o exame, monta o contexto por perfil e chama o modelo. Sem servidor.</a:t>
             </a:r>
           </a:p>
         </p:txBody>
@@ -9252,8 +9171,8 @@
         </p:nvSpPr>
         <p:spPr>
           <a:xfrm>
-            <a:off x="777240" y="4873752"/>
-            <a:ext cx="10637215" cy="411480"/>
+            <a:off x="777240" y="5038344"/>
+            <a:ext cx="10637215" cy="365760"/>
           </a:xfrm>
           <a:prstGeom prst="rect">
             <a:avLst/>
@@ -9268,7 +9187,7 @@
           <a:p>
             <a:pPr algn="ctr"/>
             <a:r>
-              <a:rPr sz="1600" b="0" i="0">
+              <a:rPr sz="1800" b="0" i="0">
                 <a:solidFill>
                   <a:srgbClr val="5A7299"/>
                 </a:solidFill>
@@ -9287,8 +9206,8 @@
         </p:nvSpPr>
         <p:spPr>
           <a:xfrm>
-            <a:off x="777240" y="5303520"/>
-            <a:ext cx="10637215" cy="1051560"/>
+            <a:off x="777240" y="5440680"/>
+            <a:ext cx="10637215" cy="1188720"/>
           </a:xfrm>
           <a:prstGeom prst="roundRect">
             <a:avLst>
@@ -9335,8 +9254,8 @@
         </p:nvSpPr>
         <p:spPr>
           <a:xfrm>
-            <a:off x="1143000" y="5303520"/>
-            <a:ext cx="2103120" cy="1051560"/>
+            <a:off x="1188720" y="5440680"/>
+            <a:ext cx="2377440" cy="1188720"/>
           </a:xfrm>
           <a:prstGeom prst="rect">
             <a:avLst/>
@@ -9351,7 +9270,7 @@
           <a:p>
             <a:pPr algn="l"/>
             <a:r>
-              <a:rPr sz="1100" b="1" i="0" spc="140">
+              <a:rPr sz="1400" b="1" i="0" spc="120">
                 <a:solidFill>
                   <a:srgbClr val="1D6FE0"/>
                 </a:solidFill>
@@ -9370,8 +9289,8 @@
         </p:nvSpPr>
         <p:spPr>
           <a:xfrm>
-            <a:off x="3429000" y="5468112"/>
-            <a:ext cx="7619695" cy="777240"/>
+            <a:off x="3794760" y="5623560"/>
+            <a:ext cx="7253935" cy="868680"/>
           </a:xfrm>
           <a:prstGeom prst="rect">
             <a:avLst/>
@@ -9386,33 +9305,33 @@
           <a:p>
             <a:pPr algn="l">
               <a:spcAft>
-                <a:spcPts val="300"/>
+                <a:spcPts val="400"/>
               </a:spcAft>
             </a:pPr>
             <a:r>
-              <a:rPr sz="1600" b="1" i="0">
+              <a:rPr sz="2000" b="1" i="0">
                 <a:solidFill>
                   <a:srgbClr val="0B2545"/>
                 </a:solidFill>
                 <a:latin typeface="Inter Tight"/>
               </a:rPr>
-              <a:t>JSON em memória + busca textual</a:t>
+              <a:t>JSON + busca textual</a:t>
             </a:r>
           </a:p>
           <a:p>
             <a:pPr algn="l">
               <a:lnSpc>
-                <a:spcPct val="125000"/>
+                <a:spcPct val="120000"/>
               </a:lnSpc>
             </a:pPr>
             <a:r>
-              <a:rPr sz="1200" b="0" i="0">
+              <a:rPr sz="1800" b="0" i="0">
                 <a:solidFill>
                   <a:srgbClr val="5A7299"/>
                 </a:solidFill>
                 <a:latin typeface="Inter Tight"/>
               </a:rPr>
-              <a:t>814 exames; busca por nome/sigla/sinônimos é instantânea — dispensa banco vetorial.</a:t>
+              <a:t>814 exames; busca por nome/sigla/sinônimos, instantânea — sem banco vetorial.</a:t>
             </a:r>
           </a:p>
         </p:txBody>
@@ -9425,7 +9344,7 @@
         </p:nvSpPr>
         <p:spPr>
           <a:xfrm>
-            <a:off x="777240" y="6291072"/>
+            <a:off x="777240" y="6309360"/>
             <a:ext cx="10637215" cy="320040"/>
           </a:xfrm>
           <a:prstGeom prst="rect">
@@ -9441,13 +9360,13 @@
           <a:p>
             <a:pPr algn="l"/>
             <a:r>
-              <a:rPr sz="850" b="1" i="0" spc="160">
+              <a:rPr sz="1300" b="0" i="0" spc="40">
                 <a:solidFill>
                   <a:srgbClr val="5A7299"/>
                 </a:solidFill>
                 <a:latin typeface="Inter Tight"/>
               </a:rPr>
-              <a:t>NEXT.JS · VERCEL · CLAUDE (ANTHROPIC) · JSON EM MEMÓRIA COM FALLBACK DETERMINÍSTICO</a:t>
+              <a:t>Next.js · Vercel · Claude (Anthropic) · JSON em memória com fallback determinístico</a:t>
             </a:r>
           </a:p>
         </p:txBody>
@@ -9522,8 +9441,8 @@
         </p:nvSpPr>
         <p:spPr>
           <a:xfrm>
-            <a:off x="10362895" y="640080"/>
-            <a:ext cx="1051560" cy="320040"/>
+            <a:off x="10271455" y="640080"/>
+            <a:ext cx="1143000" cy="320040"/>
           </a:xfrm>
           <a:prstGeom prst="rect">
             <a:avLst/>
@@ -9538,7 +9457,7 @@
           <a:p>
             <a:pPr algn="r"/>
             <a:r>
-              <a:rPr sz="1100" b="1" i="0" spc="150">
+              <a:rPr sz="1300" b="1" i="0" spc="150">
                 <a:solidFill>
                   <a:srgbClr val="5A7299"/>
                 </a:solidFill>
@@ -9572,7 +9491,7 @@
           <a:lstStyle/>
           <a:p>
             <a:r>
-              <a:rPr sz="1100">
+              <a:rPr sz="1300">
                 <a:solidFill>
                   <a:srgbClr val="1D6FE0"/>
                 </a:solidFill>
@@ -9581,7 +9500,7 @@
               <a:t>● </a:t>
             </a:r>
             <a:r>
-              <a:rPr sz="1100" b="1" spc="240">
+              <a:rPr sz="1300" b="1" spc="240">
                 <a:solidFill>
                   <a:srgbClr val="5A7299"/>
                 </a:solidFill>
@@ -9657,8 +9576,8 @@
         </p:nvSpPr>
         <p:spPr>
           <a:xfrm>
-            <a:off x="777240" y="2286000"/>
-            <a:ext cx="38100" cy="1371600"/>
+            <a:off x="777240" y="2240280"/>
+            <a:ext cx="38100" cy="1417320"/>
           </a:xfrm>
           <a:prstGeom prst="rect">
             <a:avLst/>
@@ -9701,8 +9620,8 @@
         </p:nvSpPr>
         <p:spPr>
           <a:xfrm>
-            <a:off x="1005840" y="2240280"/>
-            <a:ext cx="2224963" cy="1463040"/>
+            <a:off x="1033272" y="2194560"/>
+            <a:ext cx="2197531" cy="1554480"/>
           </a:xfrm>
           <a:prstGeom prst="rect">
             <a:avLst/>
@@ -9721,7 +9640,7 @@
               </a:spcAft>
             </a:pPr>
             <a:r>
-              <a:rPr sz="4000" b="0" i="0">
+              <a:rPr sz="4200" b="0" i="0">
                 <a:solidFill>
                   <a:srgbClr val="14418A"/>
                 </a:solidFill>
@@ -9733,11 +9652,11 @@
           <a:p>
             <a:pPr algn="l">
               <a:lnSpc>
-                <a:spcPct val="120000"/>
+                <a:spcPct val="115000"/>
               </a:lnSpc>
             </a:pPr>
             <a:r>
-              <a:rPr sz="1150" b="0" i="0">
+              <a:rPr sz="1800" b="0" i="0">
                 <a:solidFill>
                   <a:srgbClr val="5A7299"/>
                 </a:solidFill>
@@ -9756,8 +9675,8 @@
         </p:nvSpPr>
         <p:spPr>
           <a:xfrm>
-            <a:off x="3505123" y="2286000"/>
-            <a:ext cx="38100" cy="1371600"/>
+            <a:off x="3505123" y="2240280"/>
+            <a:ext cx="38100" cy="1417320"/>
           </a:xfrm>
           <a:prstGeom prst="rect">
             <a:avLst/>
@@ -9800,8 +9719,8 @@
         </p:nvSpPr>
         <p:spPr>
           <a:xfrm>
-            <a:off x="3733723" y="2240280"/>
-            <a:ext cx="2224963" cy="1463040"/>
+            <a:off x="3761155" y="2194560"/>
+            <a:ext cx="2197531" cy="1554480"/>
           </a:xfrm>
           <a:prstGeom prst="rect">
             <a:avLst/>
@@ -9820,7 +9739,7 @@
               </a:spcAft>
             </a:pPr>
             <a:r>
-              <a:rPr sz="4000" b="0" i="0">
+              <a:rPr sz="4200" b="0" i="0">
                 <a:solidFill>
                   <a:srgbClr val="14418A"/>
                 </a:solidFill>
@@ -9832,11 +9751,11 @@
           <a:p>
             <a:pPr algn="l">
               <a:lnSpc>
-                <a:spcPct val="120000"/>
+                <a:spcPct val="115000"/>
               </a:lnSpc>
             </a:pPr>
             <a:r>
-              <a:rPr sz="1150" b="0" i="0">
+              <a:rPr sz="1800" b="0" i="0">
                 <a:solidFill>
                   <a:srgbClr val="5A7299"/>
                 </a:solidFill>
@@ -9855,8 +9774,8 @@
         </p:nvSpPr>
         <p:spPr>
           <a:xfrm>
-            <a:off x="6233007" y="2286000"/>
-            <a:ext cx="38100" cy="1371600"/>
+            <a:off x="6233007" y="2240280"/>
+            <a:ext cx="38100" cy="1417320"/>
           </a:xfrm>
           <a:prstGeom prst="rect">
             <a:avLst/>
@@ -9899,8 +9818,8 @@
         </p:nvSpPr>
         <p:spPr>
           <a:xfrm>
-            <a:off x="6461607" y="2240280"/>
-            <a:ext cx="2224963" cy="1463040"/>
+            <a:off x="6489039" y="2194560"/>
+            <a:ext cx="2197531" cy="1554480"/>
           </a:xfrm>
           <a:prstGeom prst="rect">
             <a:avLst/>
@@ -9919,7 +9838,7 @@
               </a:spcAft>
             </a:pPr>
             <a:r>
-              <a:rPr sz="4000" b="0" i="0">
+              <a:rPr sz="4200" b="0" i="0">
                 <a:solidFill>
                   <a:srgbClr val="14418A"/>
                 </a:solidFill>
@@ -9931,11 +9850,11 @@
           <a:p>
             <a:pPr algn="l">
               <a:lnSpc>
-                <a:spcPct val="120000"/>
+                <a:spcPct val="115000"/>
               </a:lnSpc>
             </a:pPr>
             <a:r>
-              <a:rPr sz="1150" b="0" i="0">
+              <a:rPr sz="1800" b="0" i="0">
                 <a:solidFill>
                   <a:srgbClr val="5A7299"/>
                 </a:solidFill>
@@ -9954,8 +9873,8 @@
         </p:nvSpPr>
         <p:spPr>
           <a:xfrm>
-            <a:off x="8960891" y="2286000"/>
-            <a:ext cx="38100" cy="1371600"/>
+            <a:off x="8960891" y="2240280"/>
+            <a:ext cx="38100" cy="1417320"/>
           </a:xfrm>
           <a:prstGeom prst="rect">
             <a:avLst/>
@@ -9998,8 +9917,8 @@
         </p:nvSpPr>
         <p:spPr>
           <a:xfrm>
-            <a:off x="9189491" y="2240280"/>
-            <a:ext cx="2224963" cy="1463040"/>
+            <a:off x="9216923" y="2194560"/>
+            <a:ext cx="2197531" cy="1554480"/>
           </a:xfrm>
           <a:prstGeom prst="rect">
             <a:avLst/>
@@ -10018,7 +9937,7 @@
               </a:spcAft>
             </a:pPr>
             <a:r>
-              <a:rPr sz="4000" b="0" i="0">
+              <a:rPr sz="4200" b="0" i="0">
                 <a:solidFill>
                   <a:srgbClr val="14418A"/>
                 </a:solidFill>
@@ -10030,11 +9949,11 @@
           <a:p>
             <a:pPr algn="l">
               <a:lnSpc>
-                <a:spcPct val="120000"/>
+                <a:spcPct val="115000"/>
               </a:lnSpc>
             </a:pPr>
             <a:r>
-              <a:rPr sz="1150" b="0" i="0">
+              <a:rPr sz="1800" b="0" i="0">
                 <a:solidFill>
                   <a:srgbClr val="5A7299"/>
                 </a:solidFill>
@@ -10054,7 +9973,7 @@
         <p:spPr>
           <a:xfrm>
             <a:off x="777240" y="4069080"/>
-            <a:ext cx="3332378" cy="1737360"/>
+            <a:ext cx="3332378" cy="2011680"/>
           </a:xfrm>
           <a:prstGeom prst="roundRect">
             <a:avLst>
@@ -10101,8 +10020,8 @@
         </p:nvSpPr>
         <p:spPr>
           <a:xfrm>
-            <a:off x="1051560" y="4325112"/>
-            <a:ext cx="2783738" cy="1280160"/>
+            <a:off x="1069848" y="4343400"/>
+            <a:ext cx="2747162" cy="1508760"/>
           </a:xfrm>
           <a:prstGeom prst="rect">
             <a:avLst/>
@@ -10117,11 +10036,11 @@
           <a:p>
             <a:pPr algn="l">
               <a:spcAft>
-                <a:spcPts val="600"/>
+                <a:spcPts val="800"/>
               </a:spcAft>
             </a:pPr>
             <a:r>
-              <a:rPr sz="900" b="1" i="0" spc="120">
+              <a:rPr sz="1300" b="1" i="0" spc="100">
                 <a:solidFill>
                   <a:srgbClr val="1D6FE0"/>
                 </a:solidFill>
@@ -10133,11 +10052,11 @@
           <a:p>
             <a:pPr algn="l">
               <a:spcAft>
-                <a:spcPts val="600"/>
+                <a:spcPts val="800"/>
               </a:spcAft>
             </a:pPr>
             <a:r>
-              <a:rPr sz="1800" b="0" i="0">
+              <a:rPr sz="2000" b="0" i="0">
                 <a:solidFill>
                   <a:srgbClr val="0B2545"/>
                 </a:solidFill>
@@ -10149,17 +10068,17 @@
           <a:p>
             <a:pPr algn="l">
               <a:lnSpc>
-                <a:spcPct val="128000"/>
+                <a:spcPct val="122000"/>
               </a:lnSpc>
             </a:pPr>
             <a:r>
-              <a:rPr sz="1150" b="0" i="0">
+              <a:rPr sz="1800" b="0" i="0">
                 <a:solidFill>
                   <a:srgbClr val="5A7299"/>
                 </a:solidFill>
                 <a:latin typeface="Inter Tight"/>
               </a:rPr>
-              <a:t>Modalidade → exame → contraste / sedação / lado, com busca. Pedido da Karol no 3º checkpoint.</a:t>
+              <a:t>Modalidade → exame → contraste / sedação / lado. Pedido da Karol no 3º checkpoint.</a:t>
             </a:r>
           </a:p>
         </p:txBody>
@@ -10173,7 +10092,7 @@
         <p:spPr>
           <a:xfrm>
             <a:off x="4429658" y="4069080"/>
-            <a:ext cx="3332378" cy="1737360"/>
+            <a:ext cx="3332378" cy="2011680"/>
           </a:xfrm>
           <a:prstGeom prst="roundRect">
             <a:avLst>
@@ -10220,8 +10139,8 @@
         </p:nvSpPr>
         <p:spPr>
           <a:xfrm>
-            <a:off x="4703978" y="4325112"/>
-            <a:ext cx="2783738" cy="1280160"/>
+            <a:off x="4722266" y="4343400"/>
+            <a:ext cx="2747162" cy="1508760"/>
           </a:xfrm>
           <a:prstGeom prst="rect">
             <a:avLst/>
@@ -10236,11 +10155,11 @@
           <a:p>
             <a:pPr algn="l">
               <a:spcAft>
-                <a:spcPts val="600"/>
+                <a:spcPts val="800"/>
               </a:spcAft>
             </a:pPr>
             <a:r>
-              <a:rPr sz="900" b="1" i="0" spc="120">
+              <a:rPr sz="1300" b="1" i="0" spc="100">
                 <a:solidFill>
                   <a:srgbClr val="1D6FE0"/>
                 </a:solidFill>
@@ -10252,11 +10171,11 @@
           <a:p>
             <a:pPr algn="l">
               <a:spcAft>
-                <a:spcPts val="600"/>
+                <a:spcPts val="800"/>
               </a:spcAft>
             </a:pPr>
             <a:r>
-              <a:rPr sz="1800" b="0" i="0">
+              <a:rPr sz="2000" b="0" i="0">
                 <a:solidFill>
                   <a:srgbClr val="0B2545"/>
                 </a:solidFill>
@@ -10268,17 +10187,17 @@
           <a:p>
             <a:pPr algn="l">
               <a:lnSpc>
-                <a:spcPct val="128000"/>
+                <a:spcPct val="122000"/>
               </a:lnSpc>
             </a:pPr>
             <a:r>
-              <a:rPr sz="1150" b="0" i="0">
+              <a:rPr sz="1800" b="0" i="0">
                 <a:solidFill>
                   <a:srgbClr val="5A7299"/>
                 </a:solidFill>
                 <a:latin typeface="Inter Tight"/>
               </a:rPr>
-              <a:t>Profissional busca o exame e recebe o código para o cadastro. Paciente nunca vê o código.</a:t>
+              <a:t>Profissional busca o exame e recebe o código. Paciente nunca vê.</a:t>
             </a:r>
           </a:p>
         </p:txBody>
@@ -10292,7 +10211,7 @@
         <p:spPr>
           <a:xfrm>
             <a:off x="8082076" y="4069080"/>
-            <a:ext cx="3332378" cy="1737360"/>
+            <a:ext cx="3332378" cy="2011680"/>
           </a:xfrm>
           <a:prstGeom prst="roundRect">
             <a:avLst>
@@ -10339,8 +10258,8 @@
         </p:nvSpPr>
         <p:spPr>
           <a:xfrm>
-            <a:off x="8356396" y="4325112"/>
-            <a:ext cx="2783738" cy="1280160"/>
+            <a:off x="8374684" y="4343400"/>
+            <a:ext cx="2747162" cy="1508760"/>
           </a:xfrm>
           <a:prstGeom prst="rect">
             <a:avLst/>
@@ -10355,11 +10274,11 @@
           <a:p>
             <a:pPr algn="l">
               <a:spcAft>
-                <a:spcPts val="600"/>
+                <a:spcPts val="800"/>
               </a:spcAft>
             </a:pPr>
             <a:r>
-              <a:rPr sz="900" b="1" i="0" spc="120">
+              <a:rPr sz="1300" b="1" i="0" spc="100">
                 <a:solidFill>
                   <a:srgbClr val="1D6FE0"/>
                 </a:solidFill>
@@ -10371,11 +10290,11 @@
           <a:p>
             <a:pPr algn="l">
               <a:spcAft>
-                <a:spcPts val="600"/>
+                <a:spcPts val="800"/>
               </a:spcAft>
             </a:pPr>
             <a:r>
-              <a:rPr sz="1800" b="0" i="0">
+              <a:rPr sz="2000" b="0" i="0">
                 <a:solidFill>
                   <a:srgbClr val="0B2545"/>
                 </a:solidFill>
@@ -10387,17 +10306,17 @@
           <a:p>
             <a:pPr algn="l">
               <a:lnSpc>
-                <a:spcPct val="128000"/>
+                <a:spcPct val="122000"/>
               </a:lnSpc>
             </a:pPr>
             <a:r>
-              <a:rPr sz="1150" b="0" i="0">
+              <a:rPr sz="1800" b="0" i="0">
                 <a:solidFill>
                   <a:srgbClr val="5A7299"/>
                 </a:solidFill>
                 <a:latin typeface="Inter Tight"/>
               </a:rPr>
-              <a:t>Recusa explícita quando falta info; pendentes roteados ao setor. Não substitui a equipe.</a:t>
+              <a:t>Recusa quando falta info; pendentes roteados ao setor. Não substitui a equipe.</a:t>
             </a:r>
           </a:p>
         </p:txBody>
@@ -10472,8 +10391,8 @@
         </p:nvSpPr>
         <p:spPr>
           <a:xfrm>
-            <a:off x="10362895" y="640080"/>
-            <a:ext cx="1051560" cy="320040"/>
+            <a:off x="10271455" y="640080"/>
+            <a:ext cx="1143000" cy="320040"/>
           </a:xfrm>
           <a:prstGeom prst="rect">
             <a:avLst/>
@@ -10488,7 +10407,7 @@
           <a:p>
             <a:pPr algn="r"/>
             <a:r>
-              <a:rPr sz="1100" b="1" i="0" spc="150">
+              <a:rPr sz="1300" b="1" i="0" spc="150">
                 <a:solidFill>
                   <a:srgbClr val="5A7299"/>
                 </a:solidFill>
@@ -10522,7 +10441,7 @@
           <a:lstStyle/>
           <a:p>
             <a:r>
-              <a:rPr sz="1100">
+              <a:rPr sz="1300">
                 <a:solidFill>
                   <a:srgbClr val="1D6FE0"/>
                 </a:solidFill>
@@ -10531,7 +10450,7 @@
               <a:t>● </a:t>
             </a:r>
             <a:r>
-              <a:rPr sz="1100" b="1" spc="240">
+              <a:rPr sz="1300" b="1" spc="240">
                 <a:solidFill>
                   <a:srgbClr val="5A7299"/>
                 </a:solidFill>
@@ -10598,8 +10517,8 @@
         </p:nvSpPr>
         <p:spPr>
           <a:xfrm>
-            <a:off x="777240" y="2286000"/>
-            <a:ext cx="5669280" cy="3840480"/>
+            <a:off x="777240" y="2148840"/>
+            <a:ext cx="5669280" cy="4160520"/>
           </a:xfrm>
           <a:prstGeom prst="roundRect">
             <a:avLst>
@@ -10646,7 +10565,7 @@
         </p:nvSpPr>
         <p:spPr>
           <a:xfrm>
-            <a:off x="777240" y="2286000"/>
+            <a:off x="777240" y="2148840"/>
             <a:ext cx="5669280" cy="640080"/>
           </a:xfrm>
           <a:prstGeom prst="rect">
@@ -10690,8 +10609,8 @@
         </p:nvSpPr>
         <p:spPr>
           <a:xfrm>
-            <a:off x="1051560" y="2286000"/>
-            <a:ext cx="3657600" cy="640080"/>
+            <a:off x="1051560" y="2148840"/>
+            <a:ext cx="3657600" cy="685800"/>
           </a:xfrm>
           <a:prstGeom prst="rect">
             <a:avLst/>
@@ -10706,7 +10625,7 @@
           <a:p>
             <a:pPr algn="l"/>
             <a:r>
-              <a:rPr sz="1300" b="0" i="0">
+              <a:rPr sz="1500" b="0" i="0">
                 <a:solidFill>
                   <a:srgbClr val="0B2545"/>
                 </a:solidFill>
@@ -10725,8 +10644,8 @@
         </p:nvSpPr>
         <p:spPr>
           <a:xfrm>
-            <a:off x="5029200" y="2432304"/>
-            <a:ext cx="1143000" cy="347472"/>
+            <a:off x="4892040" y="2313432"/>
+            <a:ext cx="1280160" cy="365760"/>
           </a:xfrm>
           <a:prstGeom prst="roundRect">
             <a:avLst>
@@ -10763,7 +10682,7 @@
           <a:p>
             <a:pPr algn="ctr"/>
             <a:r>
-              <a:rPr sz="1000" b="1" i="0">
+              <a:rPr sz="1300" b="1" i="0">
                 <a:solidFill>
                   <a:srgbClr val="14418A"/>
                 </a:solidFill>
@@ -10782,8 +10701,8 @@
         </p:nvSpPr>
         <p:spPr>
           <a:xfrm>
-            <a:off x="2880360" y="3154680"/>
-            <a:ext cx="3291840" cy="658368"/>
+            <a:off x="2606040" y="2971800"/>
+            <a:ext cx="3566160" cy="658368"/>
           </a:xfrm>
           <a:prstGeom prst="roundRect">
             <a:avLst>
@@ -10813,7 +10732,7 @@
           </a:fontRef>
         </p:style>
         <p:txBody>
-          <a:bodyPr rtlCol="0" anchor="ctr" wrap="square" lIns="127000" rIns="127000" tIns="88900" bIns="88900"/>
+          <a:bodyPr rtlCol="0" anchor="ctr" wrap="square" lIns="139700" rIns="139700" tIns="101600" bIns="101600"/>
           <a:lstStyle/>
           <a:p>
             <a:pPr algn="l">
@@ -10822,7 +10741,7 @@
               </a:lnSpc>
             </a:pPr>
             <a:r>
-              <a:rPr sz="1100" b="0" i="0">
+              <a:rPr sz="1400" b="0" i="0">
                 <a:solidFill>
                   <a:srgbClr val="FFFFFF"/>
                 </a:solidFill>
@@ -10841,8 +10760,8 @@
         </p:nvSpPr>
         <p:spPr>
           <a:xfrm>
-            <a:off x="1051560" y="3950208"/>
-            <a:ext cx="3840480" cy="896112"/>
+            <a:off x="1051560" y="3758184"/>
+            <a:ext cx="4023360" cy="896112"/>
           </a:xfrm>
           <a:prstGeom prst="roundRect">
             <a:avLst>
@@ -10872,7 +10791,7 @@
           </a:fontRef>
         </p:style>
         <p:txBody>
-          <a:bodyPr rtlCol="0" anchor="ctr" wrap="square" lIns="127000" rIns="127000" tIns="88900" bIns="88900"/>
+          <a:bodyPr rtlCol="0" anchor="ctr" wrap="square" lIns="139700" rIns="139700" tIns="101600" bIns="101600"/>
           <a:lstStyle/>
           <a:p>
             <a:pPr algn="l">
@@ -10881,25 +10800,25 @@
               </a:lnSpc>
             </a:pPr>
             <a:r>
-              <a:rPr sz="1100" b="0" i="0">
+              <a:rPr sz="1400" b="0" i="0">
                 <a:solidFill>
                   <a:srgbClr val="0B2545"/>
                 </a:solidFill>
                 <a:latin typeface="Inter Tight"/>
               </a:rPr>
-              <a:t>Sim. Mantenha jejum de 4 horas. Leve o pedido médico e um documento com foto.</a:t>
+              <a:t>Sim. Jejum de 4 horas. Leve o pedido médico e um documento com foto.</a:t>
             </a:r>
           </a:p>
           <a:p>
             <a:pPr algn="l"/>
             <a:r>
-              <a:rPr sz="800" b="1" i="0" spc="60">
+              <a:rPr sz="1100" b="1" i="0" spc="40">
                 <a:solidFill>
                   <a:srgbClr val="14418A"/>
                 </a:solidFill>
                 <a:latin typeface="Inter Tight"/>
               </a:rPr>
-              <a:t>FONTE · ORIENTAÇÕES RM · HC-UFPE</a:t>
+              <a:t>Fonte · Orientações RM · HC-UFPE</a:t>
             </a:r>
           </a:p>
         </p:txBody>
@@ -10912,8 +10831,8 @@
         </p:nvSpPr>
         <p:spPr>
           <a:xfrm>
-            <a:off x="4160520" y="4983480"/>
-            <a:ext cx="2011680" cy="457200"/>
+            <a:off x="3977640" y="4782312"/>
+            <a:ext cx="2194560" cy="438912"/>
           </a:xfrm>
           <a:prstGeom prst="roundRect">
             <a:avLst>
@@ -10943,7 +10862,7 @@
           </a:fontRef>
         </p:style>
         <p:txBody>
-          <a:bodyPr rtlCol="0" anchor="ctr" wrap="square" lIns="127000" rIns="127000" tIns="88900" bIns="88900"/>
+          <a:bodyPr rtlCol="0" anchor="ctr" wrap="square" lIns="139700" rIns="139700" tIns="101600" bIns="101600"/>
           <a:lstStyle/>
           <a:p>
             <a:pPr algn="l">
@@ -10952,7 +10871,7 @@
               </a:lnSpc>
             </a:pPr>
             <a:r>
-              <a:rPr sz="1100" b="0" i="0">
+              <a:rPr sz="1400" b="0" i="0">
                 <a:solidFill>
                   <a:srgbClr val="FFFFFF"/>
                 </a:solidFill>
@@ -10971,8 +10890,8 @@
         </p:nvSpPr>
         <p:spPr>
           <a:xfrm>
-            <a:off x="1051560" y="5577840"/>
-            <a:ext cx="3840480" cy="896112"/>
+            <a:off x="1051560" y="5349240"/>
+            <a:ext cx="4023360" cy="896112"/>
           </a:xfrm>
           <a:prstGeom prst="roundRect">
             <a:avLst>
@@ -11002,7 +10921,7 @@
           </a:fontRef>
         </p:style>
         <p:txBody>
-          <a:bodyPr rtlCol="0" anchor="ctr" wrap="square" lIns="127000" rIns="127000" tIns="88900" bIns="88900"/>
+          <a:bodyPr rtlCol="0" anchor="ctr" wrap="square" lIns="139700" rIns="139700" tIns="101600" bIns="101600"/>
           <a:lstStyle/>
           <a:p>
             <a:pPr algn="l">
@@ -11011,7 +10930,7 @@
               </a:lnSpc>
             </a:pPr>
             <a:r>
-              <a:rPr sz="1100" b="0" i="0">
+              <a:rPr sz="1400" b="0" i="0">
                 <a:solidFill>
                   <a:srgbClr val="0B2545"/>
                 </a:solidFill>
@@ -11023,13 +10942,13 @@
           <a:p>
             <a:pPr algn="l"/>
             <a:r>
-              <a:rPr sz="800" b="1" i="0" spc="60">
+              <a:rPr sz="1100" b="1" i="0" spc="40">
                 <a:solidFill>
                   <a:srgbClr val="14418A"/>
                 </a:solidFill>
                 <a:latin typeface="Inter Tight"/>
               </a:rPr>
-              <a:t>FONTE · FLUXO DE AGENDAMENTO</a:t>
+              <a:t>Fonte · Fluxo de agendamento</a:t>
             </a:r>
           </a:p>
         </p:txBody>
@@ -11042,8 +10961,8 @@
         </p:nvSpPr>
         <p:spPr>
           <a:xfrm>
-            <a:off x="7086600" y="2468880"/>
-            <a:ext cx="4327855" cy="1097280"/>
+            <a:off x="7086600" y="2423160"/>
+            <a:ext cx="4327855" cy="1325880"/>
           </a:xfrm>
           <a:prstGeom prst="rect">
             <a:avLst/>
@@ -11057,7 +10976,7 @@
           <a:lstStyle/>
           <a:p>
             <a:r>
-              <a:rPr sz="1500">
+              <a:rPr sz="1800">
                 <a:solidFill>
                   <a:srgbClr val="1D6FE0"/>
                 </a:solidFill>
@@ -11066,7 +10985,7 @@
               <a:t>→  </a:t>
             </a:r>
             <a:r>
-              <a:rPr sz="1500" b="1">
+              <a:rPr sz="1800" b="1">
                 <a:solidFill>
                   <a:srgbClr val="0B2545"/>
                 </a:solidFill>
@@ -11078,11 +10997,11 @@
           <a:p>
             <a:pPr algn="l">
               <a:lnSpc>
-                <a:spcPct val="130000"/>
+                <a:spcPct val="125000"/>
               </a:lnSpc>
             </a:pPr>
             <a:r>
-              <a:rPr sz="1200" b="0" i="0">
+              <a:rPr sz="1800" b="0" i="0">
                 <a:solidFill>
                   <a:srgbClr val="5A7299"/>
                 </a:solidFill>
@@ -11101,8 +11020,8 @@
         </p:nvSpPr>
         <p:spPr>
           <a:xfrm>
-            <a:off x="7086600" y="3703320"/>
-            <a:ext cx="4327855" cy="1097280"/>
+            <a:off x="7086600" y="3794760"/>
+            <a:ext cx="4327855" cy="1325880"/>
           </a:xfrm>
           <a:prstGeom prst="rect">
             <a:avLst/>
@@ -11116,7 +11035,7 @@
           <a:lstStyle/>
           <a:p>
             <a:r>
-              <a:rPr sz="1500">
+              <a:rPr sz="1800">
                 <a:solidFill>
                   <a:srgbClr val="1D6FE0"/>
                 </a:solidFill>
@@ -11125,7 +11044,7 @@
               <a:t>→  </a:t>
             </a:r>
             <a:r>
-              <a:rPr sz="1500" b="1">
+              <a:rPr sz="1800" b="1">
                 <a:solidFill>
                   <a:srgbClr val="0B2545"/>
                 </a:solidFill>
@@ -11137,17 +11056,17 @@
           <a:p>
             <a:pPr algn="l">
               <a:lnSpc>
-                <a:spcPct val="130000"/>
+                <a:spcPct val="125000"/>
               </a:lnSpc>
             </a:pPr>
             <a:r>
-              <a:rPr sz="1200" b="0" i="0">
+              <a:rPr sz="1800" b="0" i="0">
                 <a:solidFill>
                   <a:srgbClr val="5A7299"/>
                 </a:solidFill>
                 <a:latin typeface="Inter Tight"/>
               </a:rPr>
-              <a:t>Busca o exame e recebe o código para o cadastro na AGHU. Paciente nunca vê.</a:t>
+              <a:t>Busca o exame e recebe o código para o cadastro. Paciente nunca vê.</a:t>
             </a:r>
           </a:p>
         </p:txBody>
@@ -11160,8 +11079,8 @@
         </p:nvSpPr>
         <p:spPr>
           <a:xfrm>
-            <a:off x="7086600" y="4937760"/>
-            <a:ext cx="4327855" cy="1097280"/>
+            <a:off x="7086600" y="5166360"/>
+            <a:ext cx="4327855" cy="1325880"/>
           </a:xfrm>
           <a:prstGeom prst="rect">
             <a:avLst/>
@@ -11175,7 +11094,7 @@
           <a:lstStyle/>
           <a:p>
             <a:r>
-              <a:rPr sz="1500">
+              <a:rPr sz="1800">
                 <a:solidFill>
                   <a:srgbClr val="1D6FE0"/>
                 </a:solidFill>
@@ -11184,7 +11103,7 @@
               <a:t>→  </a:t>
             </a:r>
             <a:r>
-              <a:rPr sz="1500" b="1">
+              <a:rPr sz="1800" b="1">
                 <a:solidFill>
                   <a:srgbClr val="0B2545"/>
                 </a:solidFill>
@@ -11196,17 +11115,17 @@
           <a:p>
             <a:pPr algn="l">
               <a:lnSpc>
-                <a:spcPct val="130000"/>
+                <a:spcPct val="125000"/>
               </a:lnSpc>
             </a:pPr>
             <a:r>
-              <a:rPr sz="1200" b="0" i="0">
+              <a:rPr sz="1800" b="0" i="0">
                 <a:solidFill>
                   <a:srgbClr val="5A7299"/>
                 </a:solidFill>
                 <a:latin typeface="Inter Tight"/>
               </a:rPr>
-              <a:t>Resposta só dos documentos oficiais, no registro certo para cada público.</a:t>
+              <a:t>Só dos documentos oficiais, no registro certo para cada público.</a:t>
             </a:r>
           </a:p>
         </p:txBody>
@@ -11281,8 +11200,8 @@
         </p:nvSpPr>
         <p:spPr>
           <a:xfrm>
-            <a:off x="10362895" y="640080"/>
-            <a:ext cx="1051560" cy="320040"/>
+            <a:off x="10271455" y="640080"/>
+            <a:ext cx="1143000" cy="320040"/>
           </a:xfrm>
           <a:prstGeom prst="rect">
             <a:avLst/>
@@ -11297,7 +11216,7 @@
           <a:p>
             <a:pPr algn="r"/>
             <a:r>
-              <a:rPr sz="1100" b="1" i="0" spc="150">
+              <a:rPr sz="1300" b="1" i="0" spc="150">
                 <a:solidFill>
                   <a:srgbClr val="5A7299"/>
                 </a:solidFill>
@@ -11331,7 +11250,7 @@
           <a:lstStyle/>
           <a:p>
             <a:r>
-              <a:rPr sz="1100">
+              <a:rPr sz="1300">
                 <a:solidFill>
                   <a:srgbClr val="1D6FE0"/>
                 </a:solidFill>
@@ -11340,7 +11259,7 @@
               <a:t>● </a:t>
             </a:r>
             <a:r>
-              <a:rPr sz="1100" b="1" spc="240">
+              <a:rPr sz="1300" b="1" spc="240">
                 <a:solidFill>
                   <a:srgbClr val="5A7299"/>
                 </a:solidFill>
@@ -11416,7 +11335,7 @@
         </p:nvSpPr>
         <p:spPr>
           <a:xfrm>
-            <a:off x="777240" y="2286000"/>
+            <a:off x="777240" y="2240280"/>
             <a:ext cx="4861407" cy="365760"/>
           </a:xfrm>
           <a:prstGeom prst="rect">
@@ -11432,7 +11351,7 @@
           <a:p>
             <a:pPr algn="l"/>
             <a:r>
-              <a:rPr sz="1200" b="1" i="0" spc="160">
+              <a:rPr sz="1500" b="1" i="0" spc="140">
                 <a:solidFill>
                   <a:srgbClr val="14418A"/>
                 </a:solidFill>
@@ -11452,7 +11371,7 @@
         <p:spPr>
           <a:xfrm>
             <a:off x="777240" y="2880360"/>
-            <a:ext cx="4861407" cy="1188720"/>
+            <a:ext cx="4861407" cy="1234440"/>
           </a:xfrm>
           <a:prstGeom prst="rect">
             <a:avLst/>
@@ -11466,7 +11385,7 @@
           <a:lstStyle/>
           <a:p>
             <a:r>
-              <a:rPr sz="1500" b="1">
+              <a:rPr sz="1800" b="1">
                 <a:solidFill>
                   <a:srgbClr val="1D6FE0"/>
                 </a:solidFill>
@@ -11475,7 +11394,7 @@
               <a:t>+  </a:t>
             </a:r>
             <a:r>
-              <a:rPr sz="1450" b="1">
+              <a:rPr sz="1800" b="1">
                 <a:solidFill>
                   <a:srgbClr val="0B2545"/>
                 </a:solidFill>
@@ -11487,11 +11406,11 @@
           <a:p>
             <a:pPr algn="l">
               <a:lnSpc>
-                <a:spcPct val="130000"/>
+                <a:spcPct val="125000"/>
               </a:lnSpc>
             </a:pPr>
             <a:r>
-              <a:rPr sz="1200" b="0" i="0">
+              <a:rPr sz="1800" b="0" i="0">
                 <a:solidFill>
                   <a:srgbClr val="5A7299"/>
                 </a:solidFill>
@@ -11510,8 +11429,8 @@
         </p:nvSpPr>
         <p:spPr>
           <a:xfrm>
-            <a:off x="777240" y="4069080"/>
-            <a:ext cx="4861407" cy="1188720"/>
+            <a:off x="777240" y="4142232"/>
+            <a:ext cx="4861407" cy="1234440"/>
           </a:xfrm>
           <a:prstGeom prst="rect">
             <a:avLst/>
@@ -11525,7 +11444,7 @@
           <a:lstStyle/>
           <a:p>
             <a:r>
-              <a:rPr sz="1500" b="1">
+              <a:rPr sz="1800" b="1">
                 <a:solidFill>
                   <a:srgbClr val="1D6FE0"/>
                 </a:solidFill>
@@ -11534,7 +11453,7 @@
               <a:t>+  </a:t>
             </a:r>
             <a:r>
-              <a:rPr sz="1450" b="1">
+              <a:rPr sz="1800" b="1">
                 <a:solidFill>
                   <a:srgbClr val="0B2545"/>
                 </a:solidFill>
@@ -11546,11 +11465,11 @@
           <a:p>
             <a:pPr algn="l">
               <a:lnSpc>
-                <a:spcPct val="130000"/>
+                <a:spcPct val="125000"/>
               </a:lnSpc>
             </a:pPr>
             <a:r>
-              <a:rPr sz="1200" b="0" i="0">
+              <a:rPr sz="1800" b="0" i="0">
                 <a:solidFill>
                   <a:srgbClr val="5A7299"/>
                 </a:solidFill>
@@ -11569,8 +11488,8 @@
         </p:nvSpPr>
         <p:spPr>
           <a:xfrm>
-            <a:off x="777240" y="5257800"/>
-            <a:ext cx="4861407" cy="1188720"/>
+            <a:off x="777240" y="5404104"/>
+            <a:ext cx="4861407" cy="1234440"/>
           </a:xfrm>
           <a:prstGeom prst="rect">
             <a:avLst/>
@@ -11584,7 +11503,7 @@
           <a:lstStyle/>
           <a:p>
             <a:r>
-              <a:rPr sz="1500" b="1">
+              <a:rPr sz="1800" b="1">
                 <a:solidFill>
                   <a:srgbClr val="1D6FE0"/>
                 </a:solidFill>
@@ -11593,7 +11512,7 @@
               <a:t>+  </a:t>
             </a:r>
             <a:r>
-              <a:rPr sz="1450" b="1">
+              <a:rPr sz="1800" b="1">
                 <a:solidFill>
                   <a:srgbClr val="0B2545"/>
                 </a:solidFill>
@@ -11605,11 +11524,11 @@
           <a:p>
             <a:pPr algn="l">
               <a:lnSpc>
-                <a:spcPct val="130000"/>
+                <a:spcPct val="125000"/>
               </a:lnSpc>
             </a:pPr>
             <a:r>
-              <a:rPr sz="1200" b="0" i="0">
+              <a:rPr sz="1800" b="0" i="0">
                 <a:solidFill>
                   <a:srgbClr val="5A7299"/>
                 </a:solidFill>
@@ -11628,7 +11547,7 @@
         </p:nvSpPr>
         <p:spPr>
           <a:xfrm>
-            <a:off x="6553047" y="2286000"/>
+            <a:off x="6553047" y="2240280"/>
             <a:ext cx="4861407" cy="365760"/>
           </a:xfrm>
           <a:prstGeom prst="rect">
@@ -11644,7 +11563,7 @@
           <a:p>
             <a:pPr algn="l"/>
             <a:r>
-              <a:rPr sz="1200" b="1" i="0" spc="160">
+              <a:rPr sz="1500" b="1" i="0" spc="140">
                 <a:solidFill>
                   <a:srgbClr val="5A7299"/>
                 </a:solidFill>
@@ -11664,7 +11583,7 @@
         <p:spPr>
           <a:xfrm>
             <a:off x="6553047" y="2880360"/>
-            <a:ext cx="4861407" cy="1188720"/>
+            <a:ext cx="4861407" cy="1234440"/>
           </a:xfrm>
           <a:prstGeom prst="rect">
             <a:avLst/>
@@ -11678,7 +11597,7 @@
           <a:lstStyle/>
           <a:p>
             <a:r>
-              <a:rPr sz="1500" b="1">
+              <a:rPr sz="1800" b="1">
                 <a:solidFill>
                   <a:srgbClr val="5A7299"/>
                 </a:solidFill>
@@ -11687,7 +11606,7 @@
               <a:t>–  </a:t>
             </a:r>
             <a:r>
-              <a:rPr sz="1450" b="1">
+              <a:rPr sz="1800" b="1">
                 <a:solidFill>
                   <a:srgbClr val="0B2545"/>
                 </a:solidFill>
@@ -11699,11 +11618,11 @@
           <a:p>
             <a:pPr algn="l">
               <a:lnSpc>
-                <a:spcPct val="130000"/>
+                <a:spcPct val="125000"/>
               </a:lnSpc>
             </a:pPr>
             <a:r>
-              <a:rPr sz="1200" b="0" i="0">
+              <a:rPr sz="1800" b="0" i="0">
                 <a:solidFill>
                   <a:srgbClr val="5A7299"/>
                 </a:solidFill>
@@ -11722,8 +11641,8 @@
         </p:nvSpPr>
         <p:spPr>
           <a:xfrm>
-            <a:off x="6553047" y="4069080"/>
-            <a:ext cx="4861407" cy="1188720"/>
+            <a:off x="6553047" y="4142232"/>
+            <a:ext cx="4861407" cy="1234440"/>
           </a:xfrm>
           <a:prstGeom prst="rect">
             <a:avLst/>
@@ -11737,7 +11656,7 @@
           <a:lstStyle/>
           <a:p>
             <a:r>
-              <a:rPr sz="1500" b="1">
+              <a:rPr sz="1800" b="1">
                 <a:solidFill>
                   <a:srgbClr val="5A7299"/>
                 </a:solidFill>
@@ -11746,7 +11665,7 @@
               <a:t>–  </a:t>
             </a:r>
             <a:r>
-              <a:rPr sz="1450" b="1">
+              <a:rPr sz="1800" b="1">
                 <a:solidFill>
                   <a:srgbClr val="0B2545"/>
                 </a:solidFill>
@@ -11758,11 +11677,11 @@
           <a:p>
             <a:pPr algn="l">
               <a:lnSpc>
-                <a:spcPct val="130000"/>
+                <a:spcPct val="125000"/>
               </a:lnSpc>
             </a:pPr>
             <a:r>
-              <a:rPr sz="1200" b="0" i="0">
+              <a:rPr sz="1800" b="0" i="0">
                 <a:solidFill>
                   <a:srgbClr val="5A7299"/>
                 </a:solidFill>
@@ -11781,8 +11700,8 @@
         </p:nvSpPr>
         <p:spPr>
           <a:xfrm>
-            <a:off x="6553047" y="5257800"/>
-            <a:ext cx="4861407" cy="1188720"/>
+            <a:off x="6553047" y="5404104"/>
+            <a:ext cx="4861407" cy="1234440"/>
           </a:xfrm>
           <a:prstGeom prst="rect">
             <a:avLst/>
@@ -11796,7 +11715,7 @@
           <a:lstStyle/>
           <a:p>
             <a:r>
-              <a:rPr sz="1500" b="1">
+              <a:rPr sz="1800" b="1">
                 <a:solidFill>
                   <a:srgbClr val="5A7299"/>
                 </a:solidFill>
@@ -11805,7 +11724,7 @@
               <a:t>–  </a:t>
             </a:r>
             <a:r>
-              <a:rPr sz="1450" b="1">
+              <a:rPr sz="1800" b="1">
                 <a:solidFill>
                   <a:srgbClr val="0B2545"/>
                 </a:solidFill>
@@ -11817,11 +11736,11 @@
           <a:p>
             <a:pPr algn="l">
               <a:lnSpc>
-                <a:spcPct val="130000"/>
+                <a:spcPct val="125000"/>
               </a:lnSpc>
             </a:pPr>
             <a:r>
-              <a:rPr sz="1200" b="0" i="0">
+              <a:rPr sz="1800" b="0" i="0">
                 <a:solidFill>
                   <a:srgbClr val="5A7299"/>
                 </a:solidFill>

</xml_diff>

<commit_message>
docs: enlarge remaining small text to >=16-18pt in presentation
</commit_message>
<xml_diff>
--- a/docs/Apresentacao_HC-UFPE.pptx
+++ b/docs/Apresentacao_HC-UFPE.pptx
@@ -4596,7 +4596,7 @@
               </a:lnSpc>
             </a:pPr>
             <a:r>
-              <a:rPr sz="1600">
+              <a:rPr sz="1800">
                 <a:solidFill>
                   <a:srgbClr val="AEC3E6"/>
                 </a:solidFill>
@@ -4605,7 +4605,7 @@
               <a:t>Antonio Robério      </a:t>
             </a:r>
             <a:r>
-              <a:rPr sz="1600">
+              <a:rPr sz="1800">
                 <a:solidFill>
                   <a:srgbClr val="AEC3E6"/>
                 </a:solidFill>
@@ -4614,7 +4614,7 @@
               <a:t>Ithalo      </a:t>
             </a:r>
             <a:r>
-              <a:rPr sz="1600">
+              <a:rPr sz="1800">
                 <a:solidFill>
                   <a:srgbClr val="AEC3E6"/>
                 </a:solidFill>
@@ -4623,7 +4623,7 @@
               <a:t>Mateus Ataide      </a:t>
             </a:r>
             <a:r>
-              <a:rPr sz="1600">
+              <a:rPr sz="1800">
                 <a:solidFill>
                   <a:srgbClr val="AEC3E6"/>
                 </a:solidFill>
@@ -4632,7 +4632,7 @@
               <a:t>Eric Barreto      </a:t>
             </a:r>
             <a:r>
-              <a:rPr sz="1600">
+              <a:rPr sz="1800">
                 <a:solidFill>
                   <a:srgbClr val="AEC3E6"/>
                 </a:solidFill>
@@ -4641,7 +4641,7 @@
               <a:t>Joyce Santana      </a:t>
             </a:r>
             <a:r>
-              <a:rPr sz="1600">
+              <a:rPr sz="1800">
                 <a:solidFill>
                   <a:srgbClr val="AEC3E6"/>
                 </a:solidFill>
@@ -4650,7 +4650,7 @@
               <a:t>Mateus Guerra      </a:t>
             </a:r>
             <a:r>
-              <a:rPr sz="1600">
+              <a:rPr sz="1800">
                 <a:solidFill>
                   <a:srgbClr val="AEC3E6"/>
                 </a:solidFill>
@@ -7081,7 +7081,7 @@
           <a:lstStyle/>
           <a:p>
             <a:r>
-              <a:rPr sz="1400">
+              <a:rPr sz="1600">
                 <a:solidFill>
                   <a:srgbClr val="1D6FE0"/>
                 </a:solidFill>
@@ -7090,7 +7090,7 @@
               <a:t>■ </a:t>
             </a:r>
             <a:r>
-              <a:rPr sz="1400">
+              <a:rPr sz="1600">
                 <a:solidFill>
                   <a:srgbClr val="5A7299"/>
                 </a:solidFill>
@@ -7099,7 +7099,7 @@
               <a:t>com preparo confirmado     </a:t>
             </a:r>
             <a:r>
-              <a:rPr sz="1400">
+              <a:rPr sz="1600">
                 <a:solidFill>
                   <a:srgbClr val="DCE8FA"/>
                 </a:solidFill>
@@ -7108,7 +7108,7 @@
               <a:t>■ </a:t>
             </a:r>
             <a:r>
-              <a:rPr sz="1400">
+              <a:rPr sz="1600">
                 <a:solidFill>
                   <a:srgbClr val="5A7299"/>
                 </a:solidFill>
@@ -10702,7 +10702,7 @@
         <p:spPr>
           <a:xfrm>
             <a:off x="2606040" y="2971800"/>
-            <a:ext cx="3566160" cy="658368"/>
+            <a:ext cx="3566160" cy="685800"/>
           </a:xfrm>
           <a:prstGeom prst="roundRect">
             <a:avLst>
@@ -10741,7 +10741,7 @@
               </a:lnSpc>
             </a:pPr>
             <a:r>
-              <a:rPr sz="1400" b="0" i="0">
+              <a:rPr sz="1500" b="0" i="0">
                 <a:solidFill>
                   <a:srgbClr val="FFFFFF"/>
                 </a:solidFill>
@@ -10760,8 +10760,8 @@
         </p:nvSpPr>
         <p:spPr>
           <a:xfrm>
-            <a:off x="1051560" y="3758184"/>
-            <a:ext cx="4023360" cy="896112"/>
+            <a:off x="1051560" y="3785616"/>
+            <a:ext cx="4023360" cy="1170432"/>
           </a:xfrm>
           <a:prstGeom prst="roundRect">
             <a:avLst>
@@ -10800,7 +10800,7 @@
               </a:lnSpc>
             </a:pPr>
             <a:r>
-              <a:rPr sz="1400" b="0" i="0">
+              <a:rPr sz="1500" b="0" i="0">
                 <a:solidFill>
                   <a:srgbClr val="0B2545"/>
                 </a:solidFill>
@@ -10812,7 +10812,7 @@
           <a:p>
             <a:pPr algn="l"/>
             <a:r>
-              <a:rPr sz="1100" b="1" i="0" spc="40">
+              <a:rPr sz="1300" b="1" i="0" spc="40">
                 <a:solidFill>
                   <a:srgbClr val="14418A"/>
                 </a:solidFill>
@@ -10831,8 +10831,8 @@
         </p:nvSpPr>
         <p:spPr>
           <a:xfrm>
-            <a:off x="3977640" y="4782312"/>
-            <a:ext cx="2194560" cy="438912"/>
+            <a:off x="3977640" y="5084064"/>
+            <a:ext cx="2194560" cy="457200"/>
           </a:xfrm>
           <a:prstGeom prst="roundRect">
             <a:avLst>
@@ -10871,7 +10871,7 @@
               </a:lnSpc>
             </a:pPr>
             <a:r>
-              <a:rPr sz="1400" b="0" i="0">
+              <a:rPr sz="1500" b="0" i="0">
                 <a:solidFill>
                   <a:srgbClr val="FFFFFF"/>
                 </a:solidFill>
@@ -10890,8 +10890,8 @@
         </p:nvSpPr>
         <p:spPr>
           <a:xfrm>
-            <a:off x="1051560" y="5349240"/>
-            <a:ext cx="4023360" cy="896112"/>
+            <a:off x="1051560" y="5669280"/>
+            <a:ext cx="4023360" cy="941832"/>
           </a:xfrm>
           <a:prstGeom prst="roundRect">
             <a:avLst>
@@ -10930,7 +10930,7 @@
               </a:lnSpc>
             </a:pPr>
             <a:r>
-              <a:rPr sz="1400" b="0" i="0">
+              <a:rPr sz="1500" b="0" i="0">
                 <a:solidFill>
                   <a:srgbClr val="0B2545"/>
                 </a:solidFill>
@@ -10942,7 +10942,7 @@
           <a:p>
             <a:pPr algn="l"/>
             <a:r>
-              <a:rPr sz="1100" b="1" i="0" spc="40">
+              <a:rPr sz="1300" b="1" i="0" spc="40">
                 <a:solidFill>
                   <a:srgbClr val="14418A"/>
                 </a:solidFill>

</xml_diff>

<commit_message>
docs: fix presentation text overlaps, keep all body text >=18pt
</commit_message>
<xml_diff>
--- a/docs/Apresentacao_HC-UFPE.pptx
+++ b/docs/Apresentacao_HC-UFPE.pptx
@@ -3293,7 +3293,7 @@
         <p:spPr>
           <a:xfrm>
             <a:off x="777240" y="1965960"/>
-            <a:ext cx="10637215" cy="365760"/>
+            <a:ext cx="8351215" cy="365760"/>
           </a:xfrm>
           <a:prstGeom prst="rect">
             <a:avLst/>
@@ -3675,7 +3675,7 @@
         <p:spPr>
           <a:xfrm>
             <a:off x="777240" y="640080"/>
-            <a:ext cx="10637215" cy="365760"/>
+            <a:ext cx="8351215" cy="365760"/>
           </a:xfrm>
           <a:prstGeom prst="rect">
             <a:avLst/>
@@ -4767,7 +4767,7 @@
         <p:spPr>
           <a:xfrm>
             <a:off x="777240" y="640080"/>
-            <a:ext cx="10637215" cy="365760"/>
+            <a:ext cx="8351215" cy="365760"/>
           </a:xfrm>
           <a:prstGeom prst="rect">
             <a:avLst/>
@@ -5454,7 +5454,7 @@
         <p:spPr>
           <a:xfrm>
             <a:off x="777240" y="640080"/>
-            <a:ext cx="10637215" cy="365760"/>
+            <a:ext cx="8351215" cy="365760"/>
           </a:xfrm>
           <a:prstGeom prst="rect">
             <a:avLst/>
@@ -5553,8 +5553,8 @@
         </p:nvSpPr>
         <p:spPr>
           <a:xfrm>
-            <a:off x="777240" y="1965960"/>
-            <a:ext cx="3332378" cy="1828800"/>
+            <a:off x="777240" y="1920240"/>
+            <a:ext cx="3332378" cy="2011680"/>
           </a:xfrm>
           <a:prstGeom prst="roundRect">
             <a:avLst>
@@ -5601,8 +5601,8 @@
         </p:nvSpPr>
         <p:spPr>
           <a:xfrm>
-            <a:off x="1051560" y="2203704"/>
-            <a:ext cx="2783738" cy="1371600"/>
+            <a:off x="1051560" y="2176272"/>
+            <a:ext cx="2783738" cy="1554480"/>
           </a:xfrm>
           <a:prstGeom prst="rect">
             <a:avLst/>
@@ -5617,7 +5617,7 @@
           <a:p>
             <a:pPr algn="l">
               <a:spcAft>
-                <a:spcPts val="800"/>
+                <a:spcPts val="1000"/>
               </a:spcAft>
             </a:pPr>
             <a:r>
@@ -5633,7 +5633,7 @@
           <a:p>
             <a:pPr algn="l">
               <a:spcAft>
-                <a:spcPts val="800"/>
+                <a:spcPts val="1000"/>
               </a:spcAft>
             </a:pPr>
             <a:r>
@@ -5649,7 +5649,7 @@
           <a:p>
             <a:pPr algn="l">
               <a:lnSpc>
-                <a:spcPct val="125000"/>
+                <a:spcPct val="122000"/>
               </a:lnSpc>
             </a:pPr>
             <a:r>
@@ -5659,7 +5659,7 @@
                 </a:solidFill>
                 <a:latin typeface="Inter Tight"/>
               </a:rPr>
-              <a:t>914 linhas → 814 exames únicos: nome, sigla, sinônimos, modalidade.</a:t>
+              <a:t>914 linhas → 814 exames únicos, com sigla e sinônimos.</a:t>
             </a:r>
           </a:p>
         </p:txBody>
@@ -5672,8 +5672,8 @@
         </p:nvSpPr>
         <p:spPr>
           <a:xfrm>
-            <a:off x="4429658" y="1965960"/>
-            <a:ext cx="3332378" cy="1828800"/>
+            <a:off x="4429658" y="1920240"/>
+            <a:ext cx="3332378" cy="2011680"/>
           </a:xfrm>
           <a:prstGeom prst="roundRect">
             <a:avLst>
@@ -5720,8 +5720,8 @@
         </p:nvSpPr>
         <p:spPr>
           <a:xfrm>
-            <a:off x="4703978" y="2203704"/>
-            <a:ext cx="2783738" cy="1371600"/>
+            <a:off x="4703978" y="2176272"/>
+            <a:ext cx="2783738" cy="1554480"/>
           </a:xfrm>
           <a:prstGeom prst="rect">
             <a:avLst/>
@@ -5736,7 +5736,7 @@
           <a:p>
             <a:pPr algn="l">
               <a:spcAft>
-                <a:spcPts val="800"/>
+                <a:spcPts val="1000"/>
               </a:spcAft>
             </a:pPr>
             <a:r>
@@ -5752,7 +5752,7 @@
           <a:p>
             <a:pPr algn="l">
               <a:spcAft>
-                <a:spcPts val="800"/>
+                <a:spcPts val="1000"/>
               </a:spcAft>
             </a:pPr>
             <a:r>
@@ -5768,7 +5768,7 @@
           <a:p>
             <a:pPr algn="l">
               <a:lnSpc>
-                <a:spcPct val="125000"/>
+                <a:spcPct val="122000"/>
               </a:lnSpc>
             </a:pPr>
             <a:r>
@@ -5791,8 +5791,8 @@
         </p:nvSpPr>
         <p:spPr>
           <a:xfrm>
-            <a:off x="8082076" y="1965960"/>
-            <a:ext cx="3332378" cy="1828800"/>
+            <a:off x="8082076" y="1920240"/>
+            <a:ext cx="3332378" cy="2011680"/>
           </a:xfrm>
           <a:prstGeom prst="roundRect">
             <a:avLst>
@@ -5839,8 +5839,8 @@
         </p:nvSpPr>
         <p:spPr>
           <a:xfrm>
-            <a:off x="8356396" y="2203704"/>
-            <a:ext cx="2783738" cy="1371600"/>
+            <a:off x="8356396" y="2176272"/>
+            <a:ext cx="2783738" cy="1554480"/>
           </a:xfrm>
           <a:prstGeom prst="rect">
             <a:avLst/>
@@ -5855,7 +5855,7 @@
           <a:p>
             <a:pPr algn="l">
               <a:spcAft>
-                <a:spcPts val="800"/>
+                <a:spcPts val="1000"/>
               </a:spcAft>
             </a:pPr>
             <a:r>
@@ -5871,7 +5871,7 @@
           <a:p>
             <a:pPr algn="l">
               <a:spcAft>
-                <a:spcPts val="800"/>
+                <a:spcPts val="1000"/>
               </a:spcAft>
             </a:pPr>
             <a:r>
@@ -5887,7 +5887,7 @@
           <a:p>
             <a:pPr algn="l">
               <a:lnSpc>
-                <a:spcPct val="125000"/>
+                <a:spcPct val="122000"/>
               </a:lnSpc>
             </a:pPr>
             <a:r>
@@ -5897,7 +5897,7 @@
                 </a:solidFill>
                 <a:latin typeface="Inter Tight"/>
               </a:rPr>
-              <a:t>Preparos de TC, RX e Medicina Nuclear — ainda a digitalizar.</a:t>
+              <a:t>Preparos de TC, RX e Medicina Nuclear — a digitalizar.</a:t>
             </a:r>
           </a:p>
         </p:txBody>
@@ -5910,8 +5910,8 @@
         </p:nvSpPr>
         <p:spPr>
           <a:xfrm>
-            <a:off x="777240" y="3931920"/>
-            <a:ext cx="2743200" cy="384048"/>
+            <a:off x="777240" y="4160520"/>
+            <a:ext cx="2743200" cy="365760"/>
           </a:xfrm>
           <a:prstGeom prst="rect">
             <a:avLst/>
@@ -5945,7 +5945,7 @@
         </p:nvSpPr>
         <p:spPr>
           <a:xfrm>
-            <a:off x="3520440" y="4050792"/>
+            <a:off x="3520440" y="4279392"/>
             <a:ext cx="5669280" cy="164592"/>
           </a:xfrm>
           <a:prstGeom prst="roundRect">
@@ -5991,7 +5991,7 @@
         </p:nvSpPr>
         <p:spPr>
           <a:xfrm>
-            <a:off x="3520440" y="4050792"/>
+            <a:off x="3520440" y="4279392"/>
             <a:ext cx="5669280" cy="164592"/>
           </a:xfrm>
           <a:prstGeom prst="roundRect">
@@ -6037,8 +6037,8 @@
         </p:nvSpPr>
         <p:spPr>
           <a:xfrm>
-            <a:off x="9372600" y="3931920"/>
-            <a:ext cx="1280160" cy="384048"/>
+            <a:off x="9372600" y="4160520"/>
+            <a:ext cx="1280160" cy="365760"/>
           </a:xfrm>
           <a:prstGeom prst="rect">
             <a:avLst/>
@@ -6072,8 +6072,8 @@
         </p:nvSpPr>
         <p:spPr>
           <a:xfrm>
-            <a:off x="777240" y="4315968"/>
-            <a:ext cx="2743200" cy="384048"/>
+            <a:off x="777240" y="4526280"/>
+            <a:ext cx="2743200" cy="365760"/>
           </a:xfrm>
           <a:prstGeom prst="rect">
             <a:avLst/>
@@ -6107,7 +6107,7 @@
         </p:nvSpPr>
         <p:spPr>
           <a:xfrm>
-            <a:off x="3520440" y="4434840"/>
+            <a:off x="3520440" y="4645152"/>
             <a:ext cx="5669280" cy="164592"/>
           </a:xfrm>
           <a:prstGeom prst="roundRect">
@@ -6153,7 +6153,7 @@
         </p:nvSpPr>
         <p:spPr>
           <a:xfrm>
-            <a:off x="3520440" y="4434840"/>
+            <a:off x="3520440" y="4645152"/>
             <a:ext cx="4640491" cy="164592"/>
           </a:xfrm>
           <a:prstGeom prst="roundRect">
@@ -6199,7 +6199,7 @@
         </p:nvSpPr>
         <p:spPr>
           <a:xfrm>
-            <a:off x="3520440" y="4434840"/>
+            <a:off x="3520440" y="4645152"/>
             <a:ext cx="4465378" cy="164592"/>
           </a:xfrm>
           <a:prstGeom prst="roundRect">
@@ -6245,8 +6245,8 @@
         </p:nvSpPr>
         <p:spPr>
           <a:xfrm>
-            <a:off x="9372600" y="4315968"/>
-            <a:ext cx="1280160" cy="384048"/>
+            <a:off x="9372600" y="4526280"/>
+            <a:ext cx="1280160" cy="365760"/>
           </a:xfrm>
           <a:prstGeom prst="rect">
             <a:avLst/>
@@ -6280,8 +6280,8 @@
         </p:nvSpPr>
         <p:spPr>
           <a:xfrm>
-            <a:off x="777240" y="4700016"/>
-            <a:ext cx="2743200" cy="384048"/>
+            <a:off x="777240" y="4892040"/>
+            <a:ext cx="2743200" cy="365760"/>
           </a:xfrm>
           <a:prstGeom prst="rect">
             <a:avLst/>
@@ -6315,7 +6315,7 @@
         </p:nvSpPr>
         <p:spPr>
           <a:xfrm>
-            <a:off x="3520440" y="4818888"/>
+            <a:off x="3520440" y="5010912"/>
             <a:ext cx="5669280" cy="164592"/>
           </a:xfrm>
           <a:prstGeom prst="roundRect">
@@ -6361,7 +6361,7 @@
         </p:nvSpPr>
         <p:spPr>
           <a:xfrm>
-            <a:off x="3520440" y="4818888"/>
+            <a:off x="3520440" y="5010912"/>
             <a:ext cx="4224598" cy="164592"/>
           </a:xfrm>
           <a:prstGeom prst="roundRect">
@@ -6407,7 +6407,7 @@
         </p:nvSpPr>
         <p:spPr>
           <a:xfrm>
-            <a:off x="3520440" y="4818888"/>
+            <a:off x="3520440" y="5010912"/>
             <a:ext cx="4224598" cy="164592"/>
           </a:xfrm>
           <a:prstGeom prst="roundRect">
@@ -6453,8 +6453,8 @@
         </p:nvSpPr>
         <p:spPr>
           <a:xfrm>
-            <a:off x="9372600" y="4700016"/>
-            <a:ext cx="1280160" cy="384048"/>
+            <a:off x="9372600" y="4892040"/>
+            <a:ext cx="1280160" cy="365760"/>
           </a:xfrm>
           <a:prstGeom prst="rect">
             <a:avLst/>
@@ -6488,8 +6488,8 @@
         </p:nvSpPr>
         <p:spPr>
           <a:xfrm>
-            <a:off x="777240" y="5084064"/>
-            <a:ext cx="2743200" cy="384048"/>
+            <a:off x="777240" y="5257800"/>
+            <a:ext cx="2743200" cy="365760"/>
           </a:xfrm>
           <a:prstGeom prst="rect">
             <a:avLst/>
@@ -6523,7 +6523,7 @@
         </p:nvSpPr>
         <p:spPr>
           <a:xfrm>
-            <a:off x="3520440" y="5202936"/>
+            <a:off x="3520440" y="5376672"/>
             <a:ext cx="5669280" cy="164592"/>
           </a:xfrm>
           <a:prstGeom prst="roundRect">
@@ -6569,7 +6569,7 @@
         </p:nvSpPr>
         <p:spPr>
           <a:xfrm>
-            <a:off x="3520440" y="5202936"/>
+            <a:off x="3520440" y="5376672"/>
             <a:ext cx="2364024" cy="164592"/>
           </a:xfrm>
           <a:prstGeom prst="roundRect">
@@ -6615,7 +6615,7 @@
         </p:nvSpPr>
         <p:spPr>
           <a:xfrm>
-            <a:off x="3520440" y="5202936"/>
+            <a:off x="3520440" y="5376672"/>
             <a:ext cx="350225" cy="164592"/>
           </a:xfrm>
           <a:prstGeom prst="roundRect">
@@ -6661,8 +6661,8 @@
         </p:nvSpPr>
         <p:spPr>
           <a:xfrm>
-            <a:off x="9372600" y="5084064"/>
-            <a:ext cx="1280160" cy="384048"/>
+            <a:off x="9372600" y="5257800"/>
+            <a:ext cx="1280160" cy="365760"/>
           </a:xfrm>
           <a:prstGeom prst="rect">
             <a:avLst/>
@@ -6696,8 +6696,8 @@
         </p:nvSpPr>
         <p:spPr>
           <a:xfrm>
-            <a:off x="777240" y="5468112"/>
-            <a:ext cx="2743200" cy="384048"/>
+            <a:off x="777240" y="5623560"/>
+            <a:ext cx="2743200" cy="365760"/>
           </a:xfrm>
           <a:prstGeom prst="rect">
             <a:avLst/>
@@ -6731,7 +6731,7 @@
         </p:nvSpPr>
         <p:spPr>
           <a:xfrm>
-            <a:off x="3520440" y="5586984"/>
+            <a:off x="3520440" y="5742432"/>
             <a:ext cx="5669280" cy="164592"/>
           </a:xfrm>
           <a:prstGeom prst="roundRect">
@@ -6777,7 +6777,7 @@
         </p:nvSpPr>
         <p:spPr>
           <a:xfrm>
-            <a:off x="3520440" y="5586984"/>
+            <a:off x="3520440" y="5742432"/>
             <a:ext cx="700451" cy="164592"/>
           </a:xfrm>
           <a:prstGeom prst="roundRect">
@@ -6823,8 +6823,8 @@
         </p:nvSpPr>
         <p:spPr>
           <a:xfrm>
-            <a:off x="9372600" y="5468112"/>
-            <a:ext cx="1280160" cy="384048"/>
+            <a:off x="9372600" y="5623560"/>
+            <a:ext cx="1280160" cy="365760"/>
           </a:xfrm>
           <a:prstGeom prst="rect">
             <a:avLst/>
@@ -6858,8 +6858,8 @@
         </p:nvSpPr>
         <p:spPr>
           <a:xfrm>
-            <a:off x="777240" y="5852160"/>
-            <a:ext cx="2743200" cy="384048"/>
+            <a:off x="777240" y="5989320"/>
+            <a:ext cx="2743200" cy="365760"/>
           </a:xfrm>
           <a:prstGeom prst="rect">
             <a:avLst/>
@@ -6893,7 +6893,7 @@
         </p:nvSpPr>
         <p:spPr>
           <a:xfrm>
-            <a:off x="3520440" y="5971032"/>
+            <a:off x="3520440" y="6108192"/>
             <a:ext cx="5669280" cy="164592"/>
           </a:xfrm>
           <a:prstGeom prst="roundRect">
@@ -6939,7 +6939,7 @@
         </p:nvSpPr>
         <p:spPr>
           <a:xfrm>
-            <a:off x="3520440" y="5971032"/>
+            <a:off x="3520440" y="6108192"/>
             <a:ext cx="218891" cy="164592"/>
           </a:xfrm>
           <a:prstGeom prst="roundRect">
@@ -6985,7 +6985,7 @@
         </p:nvSpPr>
         <p:spPr>
           <a:xfrm>
-            <a:off x="3520440" y="5971032"/>
+            <a:off x="3520440" y="6108192"/>
             <a:ext cx="218891" cy="164592"/>
           </a:xfrm>
           <a:prstGeom prst="roundRect">
@@ -7031,8 +7031,8 @@
         </p:nvSpPr>
         <p:spPr>
           <a:xfrm>
-            <a:off x="9372600" y="5852160"/>
-            <a:ext cx="1280160" cy="384048"/>
+            <a:off x="9372600" y="5989320"/>
+            <a:ext cx="1280160" cy="365760"/>
           </a:xfrm>
           <a:prstGeom prst="rect">
             <a:avLst/>
@@ -7066,7 +7066,7 @@
         </p:nvSpPr>
         <p:spPr>
           <a:xfrm>
-            <a:off x="3520440" y="6345936"/>
+            <a:off x="3520440" y="6464808"/>
             <a:ext cx="7132320" cy="274320"/>
           </a:xfrm>
           <a:prstGeom prst="rect">
@@ -7225,7 +7225,7 @@
         <p:spPr>
           <a:xfrm>
             <a:off x="777240" y="640080"/>
-            <a:ext cx="10637215" cy="365760"/>
+            <a:ext cx="8351215" cy="365760"/>
           </a:xfrm>
           <a:prstGeom prst="rect">
             <a:avLst/>
@@ -7363,8 +7363,8 @@
         </p:nvSpPr>
         <p:spPr>
           <a:xfrm>
-            <a:off x="777240" y="3429000"/>
-            <a:ext cx="5090007" cy="2286000"/>
+            <a:off x="777240" y="3200400"/>
+            <a:ext cx="5090007" cy="2331720"/>
           </a:xfrm>
           <a:prstGeom prst="roundRect">
             <a:avLst>
@@ -7411,7 +7411,7 @@
         </p:nvSpPr>
         <p:spPr>
           <a:xfrm>
-            <a:off x="1143000" y="3794760"/>
+            <a:off x="1143000" y="3520440"/>
             <a:ext cx="640080" cy="640080"/>
           </a:xfrm>
           <a:prstGeom prst="roundRect">
@@ -7466,8 +7466,8 @@
         </p:nvSpPr>
         <p:spPr>
           <a:xfrm>
-            <a:off x="1143000" y="4617720"/>
-            <a:ext cx="4358487" cy="914400"/>
+            <a:off x="1143000" y="4297680"/>
+            <a:ext cx="4358487" cy="1097280"/>
           </a:xfrm>
           <a:prstGeom prst="rect">
             <a:avLst/>
@@ -7498,7 +7498,7 @@
           <a:p>
             <a:pPr algn="l">
               <a:lnSpc>
-                <a:spcPct val="130000"/>
+                <a:spcPct val="125000"/>
               </a:lnSpc>
             </a:pPr>
             <a:r>
@@ -7508,7 +7508,7 @@
                 </a:solidFill>
                 <a:latin typeface="Inter Tight"/>
               </a:rPr>
-              <a:t>Picker guiado: escolhe modalidade, exame e responde contraste / sedação / lado. Resposta em linguagem simples.</a:t>
+              <a:t>Picker guiado: modalidade → exame → contraste / sedação. Linguagem simples.</a:t>
             </a:r>
           </a:p>
         </p:txBody>
@@ -7521,8 +7521,8 @@
         </p:nvSpPr>
         <p:spPr>
           <a:xfrm>
-            <a:off x="6324447" y="3429000"/>
-            <a:ext cx="5090007" cy="2286000"/>
+            <a:off x="6324447" y="3200400"/>
+            <a:ext cx="5090007" cy="2331720"/>
           </a:xfrm>
           <a:prstGeom prst="roundRect">
             <a:avLst>
@@ -7569,7 +7569,7 @@
         </p:nvSpPr>
         <p:spPr>
           <a:xfrm>
-            <a:off x="6690207" y="3794760"/>
+            <a:off x="6690207" y="3520440"/>
             <a:ext cx="640080" cy="640080"/>
           </a:xfrm>
           <a:prstGeom prst="roundRect">
@@ -7624,8 +7624,8 @@
         </p:nvSpPr>
         <p:spPr>
           <a:xfrm>
-            <a:off x="6690207" y="4617720"/>
-            <a:ext cx="4358487" cy="914400"/>
+            <a:off x="6690207" y="4297680"/>
+            <a:ext cx="4358487" cy="1097280"/>
           </a:xfrm>
           <a:prstGeom prst="rect">
             <a:avLst/>
@@ -7656,7 +7656,7 @@
           <a:p>
             <a:pPr algn="l">
               <a:lnSpc>
-                <a:spcPct val="130000"/>
+                <a:spcPct val="125000"/>
               </a:lnSpc>
             </a:pPr>
             <a:r>
@@ -7666,7 +7666,7 @@
                 </a:solidFill>
                 <a:latin typeface="Inter Tight"/>
               </a:rPr>
-              <a:t>Linguagem técnica + código AGHU do exame para o cadastro. Protocolos, contraste, sedação e fluxo.</a:t>
+              <a:t>Linguagem técnica + código AGHU para o cadastro. Protocolos e fluxo.</a:t>
             </a:r>
           </a:p>
         </p:txBody>
@@ -7701,7 +7701,7 @@
                 </a:solidFill>
                 <a:latin typeface="Inter Tight"/>
               </a:rPr>
-              <a:t>Fora do escopo · navegação pelo corpo humano · marcação real · dados de paciente</a:t>
+              <a:t>Fora do escopo · corpo humano · marcação real · dados de paciente</a:t>
             </a:r>
           </a:p>
         </p:txBody>
@@ -7812,7 +7812,7 @@
         <p:spPr>
           <a:xfrm>
             <a:off x="777240" y="640080"/>
-            <a:ext cx="10637215" cy="365760"/>
+            <a:ext cx="8351215" cy="365760"/>
           </a:xfrm>
           <a:prstGeom prst="rect">
             <a:avLst/>
@@ -8770,7 +8770,7 @@
         <p:spPr>
           <a:xfrm>
             <a:off x="777240" y="640080"/>
-            <a:ext cx="10637215" cy="365760"/>
+            <a:ext cx="8351215" cy="365760"/>
           </a:xfrm>
           <a:prstGeom prst="rect">
             <a:avLst/>
@@ -8860,8 +8860,8 @@
         </p:nvSpPr>
         <p:spPr>
           <a:xfrm>
-            <a:off x="777240" y="2331720"/>
-            <a:ext cx="10637215" cy="1188720"/>
+            <a:off x="777240" y="2148840"/>
+            <a:ext cx="10637215" cy="1097280"/>
           </a:xfrm>
           <a:prstGeom prst="roundRect">
             <a:avLst>
@@ -8908,8 +8908,8 @@
         </p:nvSpPr>
         <p:spPr>
           <a:xfrm>
-            <a:off x="1188720" y="2331720"/>
-            <a:ext cx="2377440" cy="1188720"/>
+            <a:off x="1188720" y="2148840"/>
+            <a:ext cx="2377440" cy="1097280"/>
           </a:xfrm>
           <a:prstGeom prst="rect">
             <a:avLst/>
@@ -8943,8 +8943,8 @@
         </p:nvSpPr>
         <p:spPr>
           <a:xfrm>
-            <a:off x="3794760" y="2514600"/>
-            <a:ext cx="7253935" cy="868680"/>
+            <a:off x="3794760" y="2295144"/>
+            <a:ext cx="7253935" cy="822960"/>
           </a:xfrm>
           <a:prstGeom prst="rect">
             <a:avLst/>
@@ -8975,7 +8975,7 @@
           <a:p>
             <a:pPr algn="l">
               <a:lnSpc>
-                <a:spcPct val="120000"/>
+                <a:spcPct val="115000"/>
               </a:lnSpc>
             </a:pPr>
             <a:r>
@@ -8985,7 +8985,7 @@
                 </a:solidFill>
                 <a:latin typeface="Inter Tight"/>
               </a:rPr>
-              <a:t>Chat, picker guiado e seletor de perfil, responsivo. Servido por CDN.</a:t>
+              <a:t>Chat, picker guiado e seletor de perfil. Servido por CDN.</a:t>
             </a:r>
           </a:p>
         </p:txBody>
@@ -8998,8 +8998,8 @@
         </p:nvSpPr>
         <p:spPr>
           <a:xfrm>
-            <a:off x="777240" y="3483864"/>
-            <a:ext cx="10637215" cy="365760"/>
+            <a:off x="1188720" y="3191256"/>
+            <a:ext cx="2377440" cy="347472"/>
           </a:xfrm>
           <a:prstGeom prst="rect">
             <a:avLst/>
@@ -9007,7 +9007,7 @@
           <a:noFill/>
         </p:spPr>
         <p:txBody>
-          <a:bodyPr wrap="square" lIns="0" rIns="0" tIns="0" bIns="0">
+          <a:bodyPr wrap="square" lIns="0" rIns="0" tIns="0" bIns="0" anchor="ctr">
             <a:spAutoFit/>
           </a:bodyPr>
           <a:lstStyle/>
@@ -9033,8 +9033,8 @@
         </p:nvSpPr>
         <p:spPr>
           <a:xfrm>
-            <a:off x="777240" y="3886200"/>
-            <a:ext cx="10637215" cy="1188720"/>
+            <a:off x="777240" y="3593592"/>
+            <a:ext cx="10637215" cy="1097280"/>
           </a:xfrm>
           <a:prstGeom prst="roundRect">
             <a:avLst>
@@ -9081,8 +9081,8 @@
         </p:nvSpPr>
         <p:spPr>
           <a:xfrm>
-            <a:off x="1188720" y="3886200"/>
-            <a:ext cx="2377440" cy="1188720"/>
+            <a:off x="1188720" y="3593592"/>
+            <a:ext cx="2377440" cy="1097280"/>
           </a:xfrm>
           <a:prstGeom prst="rect">
             <a:avLst/>
@@ -9116,8 +9116,8 @@
         </p:nvSpPr>
         <p:spPr>
           <a:xfrm>
-            <a:off x="3794760" y="4069080"/>
-            <a:ext cx="7253935" cy="868680"/>
+            <a:off x="3794760" y="3739896"/>
+            <a:ext cx="7253935" cy="822960"/>
           </a:xfrm>
           <a:prstGeom prst="rect">
             <a:avLst/>
@@ -9148,7 +9148,7 @@
           <a:p>
             <a:pPr algn="l">
               <a:lnSpc>
-                <a:spcPct val="120000"/>
+                <a:spcPct val="115000"/>
               </a:lnSpc>
             </a:pPr>
             <a:r>
@@ -9158,7 +9158,7 @@
                 </a:solidFill>
                 <a:latin typeface="Inter Tight"/>
               </a:rPr>
-              <a:t>Busca o exame, monta o contexto por perfil e chama o modelo. Sem servidor.</a:t>
+              <a:t>Busca o exame, monta o contexto por perfil e chama o modelo.</a:t>
             </a:r>
           </a:p>
         </p:txBody>
@@ -9171,8 +9171,8 @@
         </p:nvSpPr>
         <p:spPr>
           <a:xfrm>
-            <a:off x="777240" y="5038344"/>
-            <a:ext cx="10637215" cy="365760"/>
+            <a:off x="1188720" y="4636008"/>
+            <a:ext cx="2377440" cy="347472"/>
           </a:xfrm>
           <a:prstGeom prst="rect">
             <a:avLst/>
@@ -9180,7 +9180,7 @@
           <a:noFill/>
         </p:spPr>
         <p:txBody>
-          <a:bodyPr wrap="square" lIns="0" rIns="0" tIns="0" bIns="0">
+          <a:bodyPr wrap="square" lIns="0" rIns="0" tIns="0" bIns="0" anchor="ctr">
             <a:spAutoFit/>
           </a:bodyPr>
           <a:lstStyle/>
@@ -9206,8 +9206,8 @@
         </p:nvSpPr>
         <p:spPr>
           <a:xfrm>
-            <a:off x="777240" y="5440680"/>
-            <a:ext cx="10637215" cy="1188720"/>
+            <a:off x="777240" y="5038344"/>
+            <a:ext cx="10637215" cy="1097280"/>
           </a:xfrm>
           <a:prstGeom prst="roundRect">
             <a:avLst>
@@ -9254,8 +9254,8 @@
         </p:nvSpPr>
         <p:spPr>
           <a:xfrm>
-            <a:off x="1188720" y="5440680"/>
-            <a:ext cx="2377440" cy="1188720"/>
+            <a:off x="1188720" y="5038344"/>
+            <a:ext cx="2377440" cy="1097280"/>
           </a:xfrm>
           <a:prstGeom prst="rect">
             <a:avLst/>
@@ -9289,8 +9289,8 @@
         </p:nvSpPr>
         <p:spPr>
           <a:xfrm>
-            <a:off x="3794760" y="5623560"/>
-            <a:ext cx="7253935" cy="868680"/>
+            <a:off x="3794760" y="5184648"/>
+            <a:ext cx="7253935" cy="822960"/>
           </a:xfrm>
           <a:prstGeom prst="rect">
             <a:avLst/>
@@ -9321,7 +9321,7 @@
           <a:p>
             <a:pPr algn="l">
               <a:lnSpc>
-                <a:spcPct val="120000"/>
+                <a:spcPct val="115000"/>
               </a:lnSpc>
             </a:pPr>
             <a:r>
@@ -9331,7 +9331,7 @@
                 </a:solidFill>
                 <a:latin typeface="Inter Tight"/>
               </a:rPr>
-              <a:t>814 exames; busca por nome/sigla/sinônimos, instantânea — sem banco vetorial.</a:t>
+              <a:t>814 exames; busca instantânea, sem banco vetorial.</a:t>
             </a:r>
           </a:p>
         </p:txBody>
@@ -9477,7 +9477,7 @@
         <p:spPr>
           <a:xfrm>
             <a:off x="777240" y="640080"/>
-            <a:ext cx="10637215" cy="365760"/>
+            <a:ext cx="8351215" cy="365760"/>
           </a:xfrm>
           <a:prstGeom prst="rect">
             <a:avLst/>
@@ -10078,7 +10078,7 @@
                 </a:solidFill>
                 <a:latin typeface="Inter Tight"/>
               </a:rPr>
-              <a:t>Modalidade → exame → contraste / sedação / lado. Pedido da Karol no 3º checkpoint.</a:t>
+              <a:t>Modalidade → exame → contraste / sedação. Pedido da Karol.</a:t>
             </a:r>
           </a:p>
         </p:txBody>
@@ -10316,7 +10316,7 @@
                 </a:solidFill>
                 <a:latin typeface="Inter Tight"/>
               </a:rPr>
-              <a:t>Recusa quando falta info; pendentes roteados ao setor. Não substitui a equipe.</a:t>
+              <a:t>Recusa quando falta info; pendentes roteados ao setor.</a:t>
             </a:r>
           </a:p>
         </p:txBody>
@@ -10427,7 +10427,7 @@
         <p:spPr>
           <a:xfrm>
             <a:off x="777240" y="640080"/>
-            <a:ext cx="10637215" cy="365760"/>
+            <a:ext cx="8351215" cy="365760"/>
           </a:xfrm>
           <a:prstGeom prst="rect">
             <a:avLst/>
@@ -10517,8 +10517,8 @@
         </p:nvSpPr>
         <p:spPr>
           <a:xfrm>
-            <a:off x="777240" y="2148840"/>
-            <a:ext cx="5669280" cy="4160520"/>
+            <a:off x="777240" y="2057400"/>
+            <a:ext cx="5669280" cy="4343400"/>
           </a:xfrm>
           <a:prstGeom prst="roundRect">
             <a:avLst>
@@ -10565,7 +10565,7 @@
         </p:nvSpPr>
         <p:spPr>
           <a:xfrm>
-            <a:off x="777240" y="2148840"/>
+            <a:off x="777240" y="2057400"/>
             <a:ext cx="5669280" cy="640080"/>
           </a:xfrm>
           <a:prstGeom prst="rect">
@@ -10609,7 +10609,7 @@
         </p:nvSpPr>
         <p:spPr>
           <a:xfrm>
-            <a:off x="1051560" y="2148840"/>
+            <a:off x="1051560" y="2057400"/>
             <a:ext cx="3657600" cy="685800"/>
           </a:xfrm>
           <a:prstGeom prst="rect">
@@ -10644,7 +10644,7 @@
         </p:nvSpPr>
         <p:spPr>
           <a:xfrm>
-            <a:off x="4892040" y="2313432"/>
+            <a:off x="4892040" y="2221992"/>
             <a:ext cx="1280160" cy="365760"/>
           </a:xfrm>
           <a:prstGeom prst="roundRect">
@@ -10701,8 +10701,8 @@
         </p:nvSpPr>
         <p:spPr>
           <a:xfrm>
-            <a:off x="2606040" y="2971800"/>
-            <a:ext cx="3566160" cy="685800"/>
+            <a:off x="2606040" y="2807208"/>
+            <a:ext cx="3566160" cy="640080"/>
           </a:xfrm>
           <a:prstGeom prst="roundRect">
             <a:avLst>
@@ -10732,12 +10732,12 @@
           </a:fontRef>
         </p:style>
         <p:txBody>
-          <a:bodyPr rtlCol="0" anchor="ctr" wrap="square" lIns="139700" rIns="139700" tIns="101600" bIns="101600"/>
+          <a:bodyPr rtlCol="0" anchor="ctr" wrap="square" lIns="139700" rIns="139700" tIns="88900" bIns="88900"/>
           <a:lstStyle/>
           <a:p>
             <a:pPr algn="l">
               <a:lnSpc>
-                <a:spcPct val="120000"/>
+                <a:spcPct val="115000"/>
               </a:lnSpc>
             </a:pPr>
             <a:r>
@@ -10760,8 +10760,8 @@
         </p:nvSpPr>
         <p:spPr>
           <a:xfrm>
-            <a:off x="1051560" y="3785616"/>
-            <a:ext cx="4023360" cy="1170432"/>
+            <a:off x="1051560" y="3557016"/>
+            <a:ext cx="4023360" cy="1097280"/>
           </a:xfrm>
           <a:prstGeom prst="roundRect">
             <a:avLst>
@@ -10791,12 +10791,12 @@
           </a:fontRef>
         </p:style>
         <p:txBody>
-          <a:bodyPr rtlCol="0" anchor="ctr" wrap="square" lIns="139700" rIns="139700" tIns="101600" bIns="101600"/>
+          <a:bodyPr rtlCol="0" anchor="ctr" wrap="square" lIns="139700" rIns="139700" tIns="88900" bIns="88900"/>
           <a:lstStyle/>
           <a:p>
             <a:pPr algn="l">
               <a:lnSpc>
-                <a:spcPct val="120000"/>
+                <a:spcPct val="115000"/>
               </a:lnSpc>
             </a:pPr>
             <a:r>
@@ -10831,8 +10831,8 @@
         </p:nvSpPr>
         <p:spPr>
           <a:xfrm>
-            <a:off x="3977640" y="5084064"/>
-            <a:ext cx="2194560" cy="457200"/>
+            <a:off x="3977640" y="4764024"/>
+            <a:ext cx="2194560" cy="420624"/>
           </a:xfrm>
           <a:prstGeom prst="roundRect">
             <a:avLst>
@@ -10862,12 +10862,12 @@
           </a:fontRef>
         </p:style>
         <p:txBody>
-          <a:bodyPr rtlCol="0" anchor="ctr" wrap="square" lIns="139700" rIns="139700" tIns="101600" bIns="101600"/>
+          <a:bodyPr rtlCol="0" anchor="ctr" wrap="square" lIns="139700" rIns="139700" tIns="88900" bIns="88900"/>
           <a:lstStyle/>
           <a:p>
             <a:pPr algn="l">
               <a:lnSpc>
-                <a:spcPct val="120000"/>
+                <a:spcPct val="115000"/>
               </a:lnSpc>
             </a:pPr>
             <a:r>
@@ -10890,8 +10890,8 @@
         </p:nvSpPr>
         <p:spPr>
           <a:xfrm>
-            <a:off x="1051560" y="5669280"/>
-            <a:ext cx="4023360" cy="941832"/>
+            <a:off x="1051560" y="5294376"/>
+            <a:ext cx="4023360" cy="877824"/>
           </a:xfrm>
           <a:prstGeom prst="roundRect">
             <a:avLst>
@@ -10921,12 +10921,12 @@
           </a:fontRef>
         </p:style>
         <p:txBody>
-          <a:bodyPr rtlCol="0" anchor="ctr" wrap="square" lIns="139700" rIns="139700" tIns="101600" bIns="101600"/>
+          <a:bodyPr rtlCol="0" anchor="ctr" wrap="square" lIns="139700" rIns="139700" tIns="88900" bIns="88900"/>
           <a:lstStyle/>
           <a:p>
             <a:pPr algn="l">
               <a:lnSpc>
-                <a:spcPct val="120000"/>
+                <a:spcPct val="115000"/>
               </a:lnSpc>
             </a:pPr>
             <a:r>
@@ -11236,7 +11236,7 @@
         <p:spPr>
           <a:xfrm>
             <a:off x="777240" y="640080"/>
-            <a:ext cx="10637215" cy="365760"/>
+            <a:ext cx="8351215" cy="365760"/>
           </a:xfrm>
           <a:prstGeom prst="rect">
             <a:avLst/>

</xml_diff>

<commit_message>
docs: rebuild presentation with proper typographic scale
</commit_message>
<xml_diff>
--- a/docs/Apresentacao_HC-UFPE.pptx
+++ b/docs/Apresentacao_HC-UFPE.pptx
@@ -3150,8 +3150,8 @@
         </p:nvSpPr>
         <p:spPr>
           <a:xfrm>
-            <a:off x="7619695" y="0"/>
-            <a:ext cx="4572000" cy="3108960"/>
+            <a:off x="7985455" y="0"/>
+            <a:ext cx="4206240" cy="2834640"/>
           </a:xfrm>
           <a:prstGeom prst="rect">
             <a:avLst/>
@@ -3194,7 +3194,7 @@
         </p:nvSpPr>
         <p:spPr>
           <a:xfrm>
-            <a:off x="777240" y="548640"/>
+            <a:off x="822960" y="548640"/>
             <a:ext cx="6400800" cy="365760"/>
           </a:xfrm>
           <a:prstGeom prst="rect">
@@ -3209,7 +3209,7 @@
           <a:lstStyle/>
           <a:p>
             <a:r>
-              <a:rPr sz="1400">
+              <a:rPr sz="1100">
                 <a:solidFill>
                   <a:srgbClr val="1D6FE0"/>
                 </a:solidFill>
@@ -3218,7 +3218,7 @@
               <a:t>◆ </a:t>
             </a:r>
             <a:r>
-              <a:rPr sz="1300" b="1" spc="220">
+              <a:rPr sz="1000" b="1" spc="260">
                 <a:solidFill>
                   <a:srgbClr val="14418A"/>
                 </a:solidFill>
@@ -3237,12 +3237,12 @@
         </p:nvSpPr>
         <p:spPr>
           <a:xfrm>
-            <a:off x="8671255" y="475488"/>
-            <a:ext cx="2743200" cy="502920"/>
+            <a:off x="8991295" y="502920"/>
+            <a:ext cx="2377440" cy="457200"/>
           </a:xfrm>
           <a:prstGeom prst="roundRect">
             <a:avLst>
-              <a:gd name="adj" fmla="val 6000"/>
+              <a:gd name="adj" fmla="val 8000"/>
             </a:avLst>
           </a:prstGeom>
           <a:solidFill>
@@ -3268,12 +3268,12 @@
           </a:fontRef>
         </p:style>
         <p:txBody>
-          <a:bodyPr rtlCol="0" anchor="ctr" wrap="none" tIns="25400" bIns="25400"/>
+          <a:bodyPr rtlCol="0" anchor="ctr"/>
           <a:lstStyle/>
           <a:p>
             <a:pPr algn="ctr"/>
             <a:r>
-              <a:rPr sz="1300" b="1" i="0" spc="100">
+              <a:rPr sz="1000" b="1" i="0" spc="120">
                 <a:solidFill>
                   <a:srgbClr val="14418A"/>
                 </a:solidFill>
@@ -3292,8 +3292,8 @@
         </p:nvSpPr>
         <p:spPr>
           <a:xfrm>
-            <a:off x="777240" y="1965960"/>
-            <a:ext cx="8351215" cy="365760"/>
+            <a:off x="822960" y="1874519"/>
+            <a:ext cx="8229600" cy="365760"/>
           </a:xfrm>
           <a:prstGeom prst="rect">
             <a:avLst/>
@@ -3307,7 +3307,7 @@
           <a:lstStyle/>
           <a:p>
             <a:r>
-              <a:rPr sz="1300">
+              <a:rPr sz="1000">
                 <a:solidFill>
                   <a:srgbClr val="1D6FE0"/>
                 </a:solidFill>
@@ -3316,7 +3316,7 @@
               <a:t>● </a:t>
             </a:r>
             <a:r>
-              <a:rPr sz="1300" b="1" spc="240">
+              <a:rPr sz="1000" b="1" spc="260">
                 <a:solidFill>
                   <a:srgbClr val="5A7299"/>
                 </a:solidFill>
@@ -3335,8 +3335,8 @@
         </p:nvSpPr>
         <p:spPr>
           <a:xfrm>
-            <a:off x="777240" y="2331720"/>
-            <a:ext cx="10058400" cy="2011680"/>
+            <a:off x="822960" y="2286000"/>
+            <a:ext cx="10058400" cy="1371600"/>
           </a:xfrm>
           <a:prstGeom prst="rect">
             <a:avLst/>
@@ -3351,11 +3351,11 @@
           <a:p>
             <a:pPr>
               <a:lnSpc>
-                <a:spcPct val="102000"/>
+                <a:spcPct val="103000"/>
               </a:lnSpc>
             </a:pPr>
             <a:r>
-              <a:rPr sz="4800" i="0">
+              <a:rPr sz="4600" i="0">
                 <a:solidFill>
                   <a:srgbClr val="0B2545"/>
                 </a:solidFill>
@@ -3364,7 +3364,7 @@
               <a:t>Saiba exatamente como </a:t>
             </a:r>
             <a:r>
-              <a:rPr sz="4800" i="1">
+              <a:rPr sz="4600" i="1">
                 <a:solidFill>
                   <a:srgbClr val="14418A"/>
                 </a:solidFill>
@@ -3373,7 +3373,7 @@
               <a:t>se preparar</a:t>
             </a:r>
             <a:r>
-              <a:rPr sz="4800" i="0">
+              <a:rPr sz="4600" i="0">
                 <a:solidFill>
                   <a:srgbClr val="0B2545"/>
                 </a:solidFill>
@@ -3392,8 +3392,8 @@
         </p:nvSpPr>
         <p:spPr>
           <a:xfrm>
-            <a:off x="777240" y="4526280"/>
-            <a:ext cx="9144000" cy="914400"/>
+            <a:off x="822960" y="4343400"/>
+            <a:ext cx="8686800" cy="822960"/>
           </a:xfrm>
           <a:prstGeom prst="rect">
             <a:avLst/>
@@ -3412,7 +3412,7 @@
               </a:lnSpc>
             </a:pPr>
             <a:r>
-              <a:rPr sz="1800" b="0" i="0">
+              <a:rPr sz="1500" b="0" i="0">
                 <a:solidFill>
                   <a:srgbClr val="5A7299"/>
                 </a:solidFill>
@@ -3431,8 +3431,8 @@
         </p:nvSpPr>
         <p:spPr>
           <a:xfrm>
-            <a:off x="777240" y="5623560"/>
-            <a:ext cx="10637215" cy="12700"/>
+            <a:off x="822960" y="5532120"/>
+            <a:ext cx="10545775" cy="12700"/>
           </a:xfrm>
           <a:prstGeom prst="rect">
             <a:avLst/>
@@ -3475,8 +3475,8 @@
         </p:nvSpPr>
         <p:spPr>
           <a:xfrm>
-            <a:off x="777240" y="5806440"/>
-            <a:ext cx="5044287" cy="822960"/>
+            <a:off x="822960" y="5760720"/>
+            <a:ext cx="4998567" cy="822960"/>
           </a:xfrm>
           <a:prstGeom prst="rect">
             <a:avLst/>
@@ -3495,7 +3495,7 @@
               </a:spcAft>
             </a:pPr>
             <a:r>
-              <a:rPr sz="1300" b="1" i="0" spc="140">
+              <a:rPr sz="1000" b="1" i="0" spc="140">
                 <a:solidFill>
                   <a:srgbClr val="5A7299"/>
                 </a:solidFill>
@@ -3507,7 +3507,7 @@
           <a:p>
             <a:pPr algn="l"/>
             <a:r>
-              <a:rPr sz="1800" b="1" i="0">
+              <a:rPr sz="1350" b="1" i="0">
                 <a:solidFill>
                   <a:srgbClr val="0B2545"/>
                 </a:solidFill>
@@ -3526,8 +3526,8 @@
         </p:nvSpPr>
         <p:spPr>
           <a:xfrm>
-            <a:off x="6095847" y="5806440"/>
-            <a:ext cx="5044287" cy="822960"/>
+            <a:off x="6095847" y="5760720"/>
+            <a:ext cx="4998567" cy="822960"/>
           </a:xfrm>
           <a:prstGeom prst="rect">
             <a:avLst/>
@@ -3546,7 +3546,7 @@
               </a:spcAft>
             </a:pPr>
             <a:r>
-              <a:rPr sz="1300" b="1" i="0" spc="140">
+              <a:rPr sz="1000" b="1" i="0" spc="140">
                 <a:solidFill>
                   <a:srgbClr val="5A7299"/>
                 </a:solidFill>
@@ -3558,7 +3558,7 @@
           <a:p>
             <a:pPr algn="l"/>
             <a:r>
-              <a:rPr sz="1800" b="1" i="0">
+              <a:rPr sz="1350" b="1" i="0">
                 <a:solidFill>
                   <a:srgbClr val="0B2545"/>
                 </a:solidFill>
@@ -3639,8 +3639,8 @@
         </p:nvSpPr>
         <p:spPr>
           <a:xfrm>
-            <a:off x="10271455" y="640080"/>
-            <a:ext cx="1143000" cy="320040"/>
+            <a:off x="10362895" y="566928"/>
+            <a:ext cx="1051560" cy="320040"/>
           </a:xfrm>
           <a:prstGeom prst="rect">
             <a:avLst/>
@@ -3655,7 +3655,7 @@
           <a:p>
             <a:pPr algn="r"/>
             <a:r>
-              <a:rPr sz="1300" b="1" i="0" spc="150">
+              <a:rPr sz="1000" b="1" i="0" spc="180">
                 <a:solidFill>
                   <a:srgbClr val="5A7299"/>
                 </a:solidFill>
@@ -3674,8 +3674,8 @@
         </p:nvSpPr>
         <p:spPr>
           <a:xfrm>
-            <a:off x="777240" y="640080"/>
-            <a:ext cx="8351215" cy="365760"/>
+            <a:off x="822960" y="566928"/>
+            <a:ext cx="8534095" cy="365760"/>
           </a:xfrm>
           <a:prstGeom prst="rect">
             <a:avLst/>
@@ -3689,7 +3689,7 @@
           <a:lstStyle/>
           <a:p>
             <a:r>
-              <a:rPr sz="1300">
+              <a:rPr sz="1000">
                 <a:solidFill>
                   <a:srgbClr val="1D6FE0"/>
                 </a:solidFill>
@@ -3698,7 +3698,7 @@
               <a:t>● </a:t>
             </a:r>
             <a:r>
-              <a:rPr sz="1300" b="1" spc="240">
+              <a:rPr sz="1000" b="1" spc="260">
                 <a:solidFill>
                   <a:srgbClr val="5A7299"/>
                 </a:solidFill>
@@ -3717,8 +3717,8 @@
         </p:nvSpPr>
         <p:spPr>
           <a:xfrm>
-            <a:off x="777240" y="1097280"/>
-            <a:ext cx="10637215" cy="2011680"/>
+            <a:off x="822960" y="1051560"/>
+            <a:ext cx="10545775" cy="1371600"/>
           </a:xfrm>
           <a:prstGeom prst="rect">
             <a:avLst/>
@@ -3733,11 +3733,11 @@
           <a:p>
             <a:pPr>
               <a:lnSpc>
-                <a:spcPct val="102000"/>
+                <a:spcPct val="103000"/>
               </a:lnSpc>
             </a:pPr>
             <a:r>
-              <a:rPr sz="3800" i="0">
+              <a:rPr sz="3400" i="0">
                 <a:solidFill>
                   <a:srgbClr val="0B2545"/>
                 </a:solidFill>
@@ -3746,7 +3746,7 @@
               <a:t>Se continuássemos, </a:t>
             </a:r>
             <a:r>
-              <a:rPr sz="3800" i="1">
+              <a:rPr sz="3400" i="1">
                 <a:solidFill>
                   <a:srgbClr val="14418A"/>
                 </a:solidFill>
@@ -3765,12 +3765,12 @@
         </p:nvSpPr>
         <p:spPr>
           <a:xfrm>
-            <a:off x="777240" y="2377440"/>
-            <a:ext cx="2453563" cy="3474720"/>
+            <a:off x="822960" y="2286000"/>
+            <a:ext cx="2430703" cy="3383280"/>
           </a:xfrm>
           <a:prstGeom prst="roundRect">
             <a:avLst>
-              <a:gd name="adj" fmla="val 6000"/>
+              <a:gd name="adj" fmla="val 8000"/>
             </a:avLst>
           </a:prstGeom>
           <a:solidFill>
@@ -3813,8 +3813,8 @@
         </p:nvSpPr>
         <p:spPr>
           <a:xfrm>
-            <a:off x="1051560" y="2688336"/>
-            <a:ext cx="1904923" cy="2926080"/>
+            <a:off x="1097280" y="2578608"/>
+            <a:ext cx="1882063" cy="2834640"/>
           </a:xfrm>
           <a:prstGeom prst="rect">
             <a:avLst/>
@@ -3829,11 +3829,11 @@
           <a:p>
             <a:pPr algn="l">
               <a:spcAft>
-                <a:spcPts val="1000"/>
+                <a:spcPts val="800"/>
               </a:spcAft>
             </a:pPr>
             <a:r>
-              <a:rPr sz="1300" b="1" i="0" spc="80">
+              <a:rPr sz="1000" b="1" i="0" spc="80">
                 <a:solidFill>
                   <a:srgbClr val="1D6FE0"/>
                 </a:solidFill>
@@ -3845,11 +3845,11 @@
           <a:p>
             <a:pPr algn="l">
               <a:spcAft>
-                <a:spcPts val="1000"/>
+                <a:spcPts val="800"/>
               </a:spcAft>
             </a:pPr>
             <a:r>
-              <a:rPr sz="2100" b="0" i="0">
+              <a:rPr sz="1900" b="0" i="0">
                 <a:solidFill>
                   <a:srgbClr val="0B2545"/>
                 </a:solidFill>
@@ -3861,17 +3861,17 @@
           <a:p>
             <a:pPr algn="l">
               <a:lnSpc>
-                <a:spcPct val="125000"/>
+                <a:spcPct val="130000"/>
               </a:lnSpc>
             </a:pPr>
             <a:r>
-              <a:rPr sz="1800" b="0" i="0">
+              <a:rPr sz="1250" b="0" i="0">
                 <a:solidFill>
                   <a:srgbClr val="5A7299"/>
                 </a:solidFill>
                 <a:latin typeface="Inter Tight"/>
               </a:rPr>
-              <a:t>Digitalizar TC e Medicina Nuclear → tirar os 391 exames do pendente.</a:t>
+              <a:t>Digitalizar as folhas de TC e Medicina Nuclear para tirar os 391 exames do estado pendente.</a:t>
             </a:r>
           </a:p>
         </p:txBody>
@@ -3884,12 +3884,12 @@
         </p:nvSpPr>
         <p:spPr>
           <a:xfrm>
-            <a:off x="3505123" y="2377440"/>
-            <a:ext cx="2453563" cy="3474720"/>
+            <a:off x="3527983" y="2286000"/>
+            <a:ext cx="2430703" cy="3383280"/>
           </a:xfrm>
           <a:prstGeom prst="roundRect">
             <a:avLst>
-              <a:gd name="adj" fmla="val 6000"/>
+              <a:gd name="adj" fmla="val 8000"/>
             </a:avLst>
           </a:prstGeom>
           <a:solidFill>
@@ -3932,8 +3932,8 @@
         </p:nvSpPr>
         <p:spPr>
           <a:xfrm>
-            <a:off x="3779443" y="2688336"/>
-            <a:ext cx="1904923" cy="2926080"/>
+            <a:off x="3802303" y="2578608"/>
+            <a:ext cx="1882063" cy="2834640"/>
           </a:xfrm>
           <a:prstGeom prst="rect">
             <a:avLst/>
@@ -3948,11 +3948,11 @@
           <a:p>
             <a:pPr algn="l">
               <a:spcAft>
-                <a:spcPts val="1000"/>
+                <a:spcPts val="800"/>
               </a:spcAft>
             </a:pPr>
             <a:r>
-              <a:rPr sz="1300" b="1" i="0" spc="80">
+              <a:rPr sz="1000" b="1" i="0" spc="80">
                 <a:solidFill>
                   <a:srgbClr val="1D6FE0"/>
                 </a:solidFill>
@@ -3964,11 +3964,11 @@
           <a:p>
             <a:pPr algn="l">
               <a:spcAft>
-                <a:spcPts val="1000"/>
+                <a:spcPts val="800"/>
               </a:spcAft>
             </a:pPr>
             <a:r>
-              <a:rPr sz="2100" b="0" i="0">
+              <a:rPr sz="1900" b="0" i="0">
                 <a:solidFill>
                   <a:srgbClr val="0B2545"/>
                 </a:solidFill>
@@ -3980,17 +3980,17 @@
           <a:p>
             <a:pPr algn="l">
               <a:lnSpc>
-                <a:spcPct val="125000"/>
+                <a:spcPct val="130000"/>
               </a:lnSpc>
             </a:pPr>
             <a:r>
-              <a:rPr sz="1800" b="0" i="0">
+              <a:rPr sz="1250" b="0" i="0">
                 <a:solidFill>
                   <a:srgbClr val="5A7299"/>
                 </a:solidFill>
                 <a:latin typeface="Inter Tight"/>
               </a:rPr>
-              <a:t>Corrigir typos herdados da planilha nos nomes exibidos.</a:t>
+              <a:t>Corrigir os typos herdados da planilha nos nomes exibidos ao paciente.</a:t>
             </a:r>
           </a:p>
         </p:txBody>
@@ -4003,12 +4003,12 @@
         </p:nvSpPr>
         <p:spPr>
           <a:xfrm>
-            <a:off x="6233007" y="2377440"/>
-            <a:ext cx="2453563" cy="3474720"/>
+            <a:off x="6233007" y="2286000"/>
+            <a:ext cx="2430703" cy="3383280"/>
           </a:xfrm>
           <a:prstGeom prst="roundRect">
             <a:avLst>
-              <a:gd name="adj" fmla="val 6000"/>
+              <a:gd name="adj" fmla="val 8000"/>
             </a:avLst>
           </a:prstGeom>
           <a:solidFill>
@@ -4051,8 +4051,8 @@
         </p:nvSpPr>
         <p:spPr>
           <a:xfrm>
-            <a:off x="6507327" y="2688336"/>
-            <a:ext cx="1904923" cy="2926080"/>
+            <a:off x="6507327" y="2578608"/>
+            <a:ext cx="1882063" cy="2834640"/>
           </a:xfrm>
           <a:prstGeom prst="rect">
             <a:avLst/>
@@ -4067,11 +4067,11 @@
           <a:p>
             <a:pPr algn="l">
               <a:spcAft>
-                <a:spcPts val="1000"/>
+                <a:spcPts val="800"/>
               </a:spcAft>
             </a:pPr>
             <a:r>
-              <a:rPr sz="1300" b="1" i="0" spc="80">
+              <a:rPr sz="1000" b="1" i="0" spc="80">
                 <a:solidFill>
                   <a:srgbClr val="1D6FE0"/>
                 </a:solidFill>
@@ -4083,11 +4083,11 @@
           <a:p>
             <a:pPr algn="l">
               <a:spcAft>
-                <a:spcPts val="1000"/>
+                <a:spcPts val="800"/>
               </a:spcAft>
             </a:pPr>
             <a:r>
-              <a:rPr sz="2100" b="0" i="0">
+              <a:rPr sz="1900" b="0" i="0">
                 <a:solidFill>
                   <a:srgbClr val="0B2545"/>
                 </a:solidFill>
@@ -4099,17 +4099,17 @@
           <a:p>
             <a:pPr algn="l">
               <a:lnSpc>
-                <a:spcPct val="125000"/>
+                <a:spcPct val="130000"/>
               </a:lnSpc>
             </a:pPr>
             <a:r>
-              <a:rPr sz="1800" b="0" i="0">
+              <a:rPr sz="1250" b="0" i="0">
                 <a:solidFill>
                   <a:srgbClr val="5A7299"/>
                 </a:solidFill>
                 <a:latin typeface="Inter Tight"/>
               </a:rPr>
-              <a:t>Navegação visual por região do corpo.</a:t>
+              <a:t>Reintroduzir a navegação visual por região do corpo.</a:t>
             </a:r>
           </a:p>
         </p:txBody>
@@ -4122,12 +4122,12 @@
         </p:nvSpPr>
         <p:spPr>
           <a:xfrm>
-            <a:off x="8960891" y="2377440"/>
-            <a:ext cx="2453563" cy="3474720"/>
+            <a:off x="8938031" y="2286000"/>
+            <a:ext cx="2430703" cy="3383280"/>
           </a:xfrm>
           <a:prstGeom prst="roundRect">
             <a:avLst>
-              <a:gd name="adj" fmla="val 6000"/>
+              <a:gd name="adj" fmla="val 8000"/>
             </a:avLst>
           </a:prstGeom>
           <a:solidFill>
@@ -4170,8 +4170,8 @@
         </p:nvSpPr>
         <p:spPr>
           <a:xfrm>
-            <a:off x="9235211" y="2688336"/>
-            <a:ext cx="1904923" cy="2926080"/>
+            <a:off x="9212351" y="2578608"/>
+            <a:ext cx="1882063" cy="2834640"/>
           </a:xfrm>
           <a:prstGeom prst="rect">
             <a:avLst/>
@@ -4186,11 +4186,11 @@
           <a:p>
             <a:pPr algn="l">
               <a:spcAft>
-                <a:spcPts val="1000"/>
+                <a:spcPts val="800"/>
               </a:spcAft>
             </a:pPr>
             <a:r>
-              <a:rPr sz="1300" b="1" i="0" spc="80">
+              <a:rPr sz="1000" b="1" i="0" spc="80">
                 <a:solidFill>
                   <a:srgbClr val="7FB0F2"/>
                 </a:solidFill>
@@ -4202,11 +4202,11 @@
           <a:p>
             <a:pPr algn="l">
               <a:spcAft>
-                <a:spcPts val="1000"/>
+                <a:spcPts val="800"/>
               </a:spcAft>
             </a:pPr>
             <a:r>
-              <a:rPr sz="2100" b="0" i="0">
+              <a:rPr sz="1900" b="0" i="0">
                 <a:solidFill>
                   <a:srgbClr val="FFFFFF"/>
                 </a:solidFill>
@@ -4218,17 +4218,17 @@
           <a:p>
             <a:pPr algn="l">
               <a:lnSpc>
-                <a:spcPct val="125000"/>
+                <a:spcPct val="130000"/>
               </a:lnSpc>
             </a:pPr>
             <a:r>
-              <a:rPr sz="1800" b="0" i="0">
+              <a:rPr sz="1250" b="0" i="0">
                 <a:solidFill>
                   <a:srgbClr val="AEC3E6"/>
                 </a:solidFill>
                 <a:latin typeface="Inter Tight"/>
               </a:rPr>
-              <a:t>Equipe do HC edita conteúdo sem programador.</a:t>
+              <a:t>Equipe do HC edita o conteúdo sem depender de programador (ex.: Supabase).</a:t>
             </a:r>
           </a:p>
         </p:txBody>
@@ -4347,7 +4347,7 @@
         </p:nvSpPr>
         <p:spPr>
           <a:xfrm>
-            <a:off x="777240" y="1463040"/>
+            <a:off x="822960" y="1554480"/>
             <a:ext cx="9144000" cy="365760"/>
           </a:xfrm>
           <a:prstGeom prst="rect">
@@ -4362,7 +4362,7 @@
           <a:lstStyle/>
           <a:p>
             <a:r>
-              <a:rPr sz="1400">
+              <a:rPr sz="1000">
                 <a:solidFill>
                   <a:srgbClr val="7FB0F2"/>
                 </a:solidFill>
@@ -4371,7 +4371,7 @@
               <a:t>● </a:t>
             </a:r>
             <a:r>
-              <a:rPr sz="1400" b="1" spc="240">
+              <a:rPr sz="1000" b="1" spc="260">
                 <a:solidFill>
                   <a:srgbClr val="7FB0F2"/>
                 </a:solidFill>
@@ -4390,8 +4390,8 @@
         </p:nvSpPr>
         <p:spPr>
           <a:xfrm>
-            <a:off x="777240" y="1965960"/>
-            <a:ext cx="10058400" cy="1463040"/>
+            <a:off x="822960" y="2057400"/>
+            <a:ext cx="10058400" cy="1371600"/>
           </a:xfrm>
           <a:prstGeom prst="rect">
             <a:avLst/>
@@ -4410,7 +4410,7 @@
               </a:lnSpc>
             </a:pPr>
             <a:r>
-              <a:rPr sz="5000">
+              <a:rPr sz="4800">
                 <a:solidFill>
                   <a:srgbClr val="FFFFFF"/>
                 </a:solidFill>
@@ -4419,7 +4419,7 @@
               <a:t>Vamos ver </a:t>
             </a:r>
             <a:r>
-              <a:rPr sz="5000" i="1">
+              <a:rPr sz="4800" i="1">
                 <a:solidFill>
                   <a:srgbClr val="7FB0F2"/>
                 </a:solidFill>
@@ -4438,8 +4438,8 @@
         </p:nvSpPr>
         <p:spPr>
           <a:xfrm>
-            <a:off x="777240" y="3383280"/>
-            <a:ext cx="9144000" cy="731520"/>
+            <a:off x="822960" y="3429000"/>
+            <a:ext cx="9144000" cy="640080"/>
           </a:xfrm>
           <a:prstGeom prst="rect">
             <a:avLst/>
@@ -4458,7 +4458,7 @@
               </a:lnSpc>
             </a:pPr>
             <a:r>
-              <a:rPr sz="1800" b="0" i="0">
+              <a:rPr sz="1500" b="0" i="0">
                 <a:solidFill>
                   <a:srgbClr val="AEC3E6"/>
                 </a:solidFill>
@@ -4477,12 +4477,12 @@
         </p:nvSpPr>
         <p:spPr>
           <a:xfrm>
-            <a:off x="777240" y="4343400"/>
-            <a:ext cx="3931920" cy="640080"/>
+            <a:off x="822960" y="4297680"/>
+            <a:ext cx="3657600" cy="566928"/>
           </a:xfrm>
           <a:prstGeom prst="roundRect">
             <a:avLst>
-              <a:gd name="adj" fmla="val 6000"/>
+              <a:gd name="adj" fmla="val 8000"/>
             </a:avLst>
           </a:prstGeom>
           <a:solidFill>
@@ -4513,7 +4513,7 @@
           <a:p>
             <a:pPr algn="ctr"/>
             <a:r>
-              <a:rPr sz="1600" b="1" i="0">
+              <a:rPr sz="1400" b="1" i="0">
                 <a:solidFill>
                   <a:srgbClr val="FFFFFF"/>
                 </a:solidFill>
@@ -4532,8 +4532,8 @@
         </p:nvSpPr>
         <p:spPr>
           <a:xfrm>
-            <a:off x="777240" y="5440680"/>
-            <a:ext cx="10637215" cy="12700"/>
+            <a:off x="822960" y="5440680"/>
+            <a:ext cx="10545775" cy="12700"/>
           </a:xfrm>
           <a:prstGeom prst="rect">
             <a:avLst/>
@@ -4576,8 +4576,8 @@
         </p:nvSpPr>
         <p:spPr>
           <a:xfrm>
-            <a:off x="777240" y="5669280"/>
-            <a:ext cx="10637215" cy="640080"/>
+            <a:off x="822960" y="5669280"/>
+            <a:ext cx="10545775" cy="548640"/>
           </a:xfrm>
           <a:prstGeom prst="rect">
             <a:avLst/>
@@ -4596,7 +4596,7 @@
               </a:lnSpc>
             </a:pPr>
             <a:r>
-              <a:rPr sz="1800">
+              <a:rPr sz="1300">
                 <a:solidFill>
                   <a:srgbClr val="AEC3E6"/>
                 </a:solidFill>
@@ -4605,7 +4605,7 @@
               <a:t>Antonio Robério      </a:t>
             </a:r>
             <a:r>
-              <a:rPr sz="1800">
+              <a:rPr sz="1300">
                 <a:solidFill>
                   <a:srgbClr val="AEC3E6"/>
                 </a:solidFill>
@@ -4614,7 +4614,7 @@
               <a:t>Ithalo      </a:t>
             </a:r>
             <a:r>
-              <a:rPr sz="1800">
+              <a:rPr sz="1300">
                 <a:solidFill>
                   <a:srgbClr val="AEC3E6"/>
                 </a:solidFill>
@@ -4623,7 +4623,7 @@
               <a:t>Mateus Ataide      </a:t>
             </a:r>
             <a:r>
-              <a:rPr sz="1800">
+              <a:rPr sz="1300">
                 <a:solidFill>
                   <a:srgbClr val="AEC3E6"/>
                 </a:solidFill>
@@ -4632,7 +4632,7 @@
               <a:t>Eric Barreto      </a:t>
             </a:r>
             <a:r>
-              <a:rPr sz="1800">
+              <a:rPr sz="1300">
                 <a:solidFill>
                   <a:srgbClr val="AEC3E6"/>
                 </a:solidFill>
@@ -4641,7 +4641,7 @@
               <a:t>Joyce Santana      </a:t>
             </a:r>
             <a:r>
-              <a:rPr sz="1800">
+              <a:rPr sz="1300">
                 <a:solidFill>
                   <a:srgbClr val="AEC3E6"/>
                 </a:solidFill>
@@ -4650,7 +4650,7 @@
               <a:t>Mateus Guerra      </a:t>
             </a:r>
             <a:r>
-              <a:rPr sz="1800">
+              <a:rPr sz="1300">
                 <a:solidFill>
                   <a:srgbClr val="AEC3E6"/>
                 </a:solidFill>
@@ -4731,8 +4731,8 @@
         </p:nvSpPr>
         <p:spPr>
           <a:xfrm>
-            <a:off x="10271455" y="640080"/>
-            <a:ext cx="1143000" cy="320040"/>
+            <a:off x="10362895" y="566928"/>
+            <a:ext cx="1051560" cy="320040"/>
           </a:xfrm>
           <a:prstGeom prst="rect">
             <a:avLst/>
@@ -4747,7 +4747,7 @@
           <a:p>
             <a:pPr algn="r"/>
             <a:r>
-              <a:rPr sz="1300" b="1" i="0" spc="150">
+              <a:rPr sz="1000" b="1" i="0" spc="180">
                 <a:solidFill>
                   <a:srgbClr val="5A7299"/>
                 </a:solidFill>
@@ -4766,8 +4766,8 @@
         </p:nvSpPr>
         <p:spPr>
           <a:xfrm>
-            <a:off x="777240" y="640080"/>
-            <a:ext cx="8351215" cy="365760"/>
+            <a:off x="822960" y="566928"/>
+            <a:ext cx="8534095" cy="365760"/>
           </a:xfrm>
           <a:prstGeom prst="rect">
             <a:avLst/>
@@ -4781,7 +4781,7 @@
           <a:lstStyle/>
           <a:p>
             <a:r>
-              <a:rPr sz="1300">
+              <a:rPr sz="1000">
                 <a:solidFill>
                   <a:srgbClr val="1D6FE0"/>
                 </a:solidFill>
@@ -4790,7 +4790,7 @@
               <a:t>● </a:t>
             </a:r>
             <a:r>
-              <a:rPr sz="1300" b="1" spc="240">
+              <a:rPr sz="1000" b="1" spc="260">
                 <a:solidFill>
                   <a:srgbClr val="5A7299"/>
                 </a:solidFill>
@@ -4809,8 +4809,8 @@
         </p:nvSpPr>
         <p:spPr>
           <a:xfrm>
-            <a:off x="777240" y="1097280"/>
-            <a:ext cx="10637215" cy="2011680"/>
+            <a:off x="822960" y="1051560"/>
+            <a:ext cx="10545775" cy="1371600"/>
           </a:xfrm>
           <a:prstGeom prst="rect">
             <a:avLst/>
@@ -4825,11 +4825,11 @@
           <a:p>
             <a:pPr>
               <a:lnSpc>
-                <a:spcPct val="102000"/>
+                <a:spcPct val="103000"/>
               </a:lnSpc>
             </a:pPr>
             <a:r>
-              <a:rPr sz="3800" i="0">
+              <a:rPr sz="3400" i="0">
                 <a:solidFill>
                   <a:srgbClr val="0B2545"/>
                 </a:solidFill>
@@ -4838,7 +4838,7 @@
               <a:t>A orientação certa </a:t>
             </a:r>
             <a:r>
-              <a:rPr sz="3800" i="1">
+              <a:rPr sz="3400" i="1">
                 <a:solidFill>
                   <a:srgbClr val="14418A"/>
                 </a:solidFill>
@@ -4847,7 +4847,7 @@
               <a:t>não chega</a:t>
             </a:r>
             <a:r>
-              <a:rPr sz="3800" i="0">
+              <a:rPr sz="3400" i="0">
                 <a:solidFill>
                   <a:srgbClr val="0B2545"/>
                 </a:solidFill>
@@ -4866,8 +4866,8 @@
         </p:nvSpPr>
         <p:spPr>
           <a:xfrm>
-            <a:off x="777240" y="2286000"/>
-            <a:ext cx="10637215" cy="1005840"/>
+            <a:off x="822960" y="2148840"/>
+            <a:ext cx="10058400" cy="822960"/>
           </a:xfrm>
           <a:prstGeom prst="rect">
             <a:avLst/>
@@ -4886,7 +4886,7 @@
               </a:lnSpc>
             </a:pPr>
             <a:r>
-              <a:rPr sz="1800" b="0" i="0">
+              <a:rPr sz="1500" b="0" i="0">
                 <a:solidFill>
                   <a:srgbClr val="5A7299"/>
                 </a:solidFill>
@@ -4905,8 +4905,8 @@
         </p:nvSpPr>
         <p:spPr>
           <a:xfrm>
-            <a:off x="777240" y="3703320"/>
-            <a:ext cx="2419273" cy="2286000"/>
+            <a:off x="822960" y="3566160"/>
+            <a:ext cx="2224963" cy="2194560"/>
           </a:xfrm>
           <a:prstGeom prst="rect">
             <a:avLst/>
@@ -4921,11 +4921,11 @@
           <a:p>
             <a:pPr algn="l">
               <a:spcAft>
-                <a:spcPts val="600"/>
+                <a:spcPts val="800"/>
               </a:spcAft>
             </a:pPr>
             <a:r>
-              <a:rPr sz="3200" b="0" i="0">
+              <a:rPr sz="3000" b="0" i="0">
                 <a:solidFill>
                   <a:srgbClr val="DCE8FA"/>
                 </a:solidFill>
@@ -4937,11 +4937,11 @@
           <a:p>
             <a:pPr algn="l">
               <a:spcAft>
-                <a:spcPts val="400"/>
+                <a:spcPts val="500"/>
               </a:spcAft>
             </a:pPr>
             <a:r>
-              <a:rPr sz="1800" b="1" i="0">
+              <a:rPr sz="1500" b="1" i="0">
                 <a:solidFill>
                   <a:srgbClr val="0B2545"/>
                 </a:solidFill>
@@ -4953,17 +4953,17 @@
           <a:p>
             <a:pPr algn="l">
               <a:lnSpc>
-                <a:spcPct val="120000"/>
+                <a:spcPct val="130000"/>
               </a:lnSpc>
             </a:pPr>
             <a:r>
-              <a:rPr sz="1800" b="0" i="0">
+              <a:rPr sz="1250" b="0" i="0">
                 <a:solidFill>
                   <a:srgbClr val="5A7299"/>
                 </a:solidFill>
                 <a:latin typeface="Inter Tight"/>
               </a:rPr>
-              <a:t>Médico registra o exame no AGHU.</a:t>
+              <a:t>Médico registra o exame no AGHU durante a consulta.</a:t>
             </a:r>
           </a:p>
         </p:txBody>
@@ -4976,8 +4976,8 @@
         </p:nvSpPr>
         <p:spPr>
           <a:xfrm>
-            <a:off x="3350183" y="3886200"/>
-            <a:ext cx="12700" cy="1920240"/>
+            <a:off x="3367963" y="3703320"/>
+            <a:ext cx="12700" cy="1737360"/>
           </a:xfrm>
           <a:prstGeom prst="rect">
             <a:avLst/>
@@ -5020,8 +5020,8 @@
         </p:nvSpPr>
         <p:spPr>
           <a:xfrm>
-            <a:off x="3516553" y="3703320"/>
-            <a:ext cx="2419273" cy="2286000"/>
+            <a:off x="3550843" y="3566160"/>
+            <a:ext cx="2224963" cy="2194560"/>
           </a:xfrm>
           <a:prstGeom prst="rect">
             <a:avLst/>
@@ -5036,11 +5036,11 @@
           <a:p>
             <a:pPr algn="l">
               <a:spcAft>
-                <a:spcPts val="600"/>
+                <a:spcPts val="800"/>
               </a:spcAft>
             </a:pPr>
             <a:r>
-              <a:rPr sz="3200" b="0" i="0">
+              <a:rPr sz="3000" b="0" i="0">
                 <a:solidFill>
                   <a:srgbClr val="DCE8FA"/>
                 </a:solidFill>
@@ -5052,11 +5052,11 @@
           <a:p>
             <a:pPr algn="l">
               <a:spcAft>
-                <a:spcPts val="400"/>
+                <a:spcPts val="500"/>
               </a:spcAft>
             </a:pPr>
             <a:r>
-              <a:rPr sz="1800" b="1" i="0">
+              <a:rPr sz="1500" b="1" i="0">
                 <a:solidFill>
                   <a:srgbClr val="0B2545"/>
                 </a:solidFill>
@@ -5068,17 +5068,17 @@
           <a:p>
             <a:pPr algn="l">
               <a:lnSpc>
-                <a:spcPct val="120000"/>
+                <a:spcPct val="130000"/>
               </a:lnSpc>
             </a:pPr>
             <a:r>
-              <a:rPr sz="1800" b="0" i="0">
+              <a:rPr sz="1250" b="0" i="0">
                 <a:solidFill>
                   <a:srgbClr val="5A7299"/>
                 </a:solidFill>
                 <a:latin typeface="Inter Tight"/>
               </a:rPr>
-              <a:t>Paciente ou enfermagem agenda — sem padrão.</a:t>
+              <a:t>Paciente ou enfermagem agenda — sem padrão único.</a:t>
             </a:r>
           </a:p>
         </p:txBody>
@@ -5091,8 +5091,8 @@
         </p:nvSpPr>
         <p:spPr>
           <a:xfrm>
-            <a:off x="6089497" y="3886200"/>
-            <a:ext cx="12700" cy="1920240"/>
+            <a:off x="6095847" y="3703320"/>
+            <a:ext cx="12700" cy="1737360"/>
           </a:xfrm>
           <a:prstGeom prst="rect">
             <a:avLst/>
@@ -5135,8 +5135,8 @@
         </p:nvSpPr>
         <p:spPr>
           <a:xfrm>
-            <a:off x="6255867" y="3703320"/>
-            <a:ext cx="2419273" cy="2286000"/>
+            <a:off x="6278727" y="3566160"/>
+            <a:ext cx="2224963" cy="2194560"/>
           </a:xfrm>
           <a:prstGeom prst="rect">
             <a:avLst/>
@@ -5151,11 +5151,11 @@
           <a:p>
             <a:pPr algn="l">
               <a:spcAft>
-                <a:spcPts val="600"/>
+                <a:spcPts val="800"/>
               </a:spcAft>
             </a:pPr>
             <a:r>
-              <a:rPr sz="3200" b="0" i="0">
+              <a:rPr sz="3000" b="0" i="0">
                 <a:solidFill>
                   <a:srgbClr val="1D6FE0"/>
                 </a:solidFill>
@@ -5167,11 +5167,11 @@
           <a:p>
             <a:pPr algn="l">
               <a:spcAft>
-                <a:spcPts val="400"/>
+                <a:spcPts val="500"/>
               </a:spcAft>
             </a:pPr>
             <a:r>
-              <a:rPr sz="1800" b="1" i="0">
+              <a:rPr sz="1500" b="1" i="0">
                 <a:solidFill>
                   <a:srgbClr val="0B2545"/>
                 </a:solidFill>
@@ -5183,17 +5183,17 @@
           <a:p>
             <a:pPr algn="l">
               <a:lnSpc>
-                <a:spcPct val="120000"/>
+                <a:spcPct val="130000"/>
               </a:lnSpc>
             </a:pPr>
             <a:r>
-              <a:rPr sz="1800" b="0" i="0">
+              <a:rPr sz="1250" b="0" i="0">
                 <a:solidFill>
                   <a:srgbClr val="5A7299"/>
                 </a:solidFill>
                 <a:latin typeface="Inter Tight"/>
               </a:rPr>
-              <a:t>Preparo não chega ao paciente.</a:t>
+              <a:t>O preparo não é passado corretamente ao paciente.</a:t>
             </a:r>
           </a:p>
         </p:txBody>
@@ -5206,8 +5206,8 @@
         </p:nvSpPr>
         <p:spPr>
           <a:xfrm>
-            <a:off x="8828811" y="3886200"/>
-            <a:ext cx="12700" cy="1920240"/>
+            <a:off x="8823731" y="3703320"/>
+            <a:ext cx="12700" cy="1737360"/>
           </a:xfrm>
           <a:prstGeom prst="rect">
             <a:avLst/>
@@ -5250,8 +5250,8 @@
         </p:nvSpPr>
         <p:spPr>
           <a:xfrm>
-            <a:off x="8995181" y="3703320"/>
-            <a:ext cx="2419273" cy="2286000"/>
+            <a:off x="9006611" y="3566160"/>
+            <a:ext cx="2224963" cy="2194560"/>
           </a:xfrm>
           <a:prstGeom prst="rect">
             <a:avLst/>
@@ -5266,11 +5266,11 @@
           <a:p>
             <a:pPr algn="l">
               <a:spcAft>
-                <a:spcPts val="600"/>
+                <a:spcPts val="800"/>
               </a:spcAft>
             </a:pPr>
             <a:r>
-              <a:rPr sz="3200" b="0" i="0">
+              <a:rPr sz="3000" b="0" i="0">
                 <a:solidFill>
                   <a:srgbClr val="1D6FE0"/>
                 </a:solidFill>
@@ -5282,11 +5282,11 @@
           <a:p>
             <a:pPr algn="l">
               <a:spcAft>
-                <a:spcPts val="400"/>
+                <a:spcPts val="500"/>
               </a:spcAft>
             </a:pPr>
             <a:r>
-              <a:rPr sz="1800" b="1" i="0">
+              <a:rPr sz="1500" b="1" i="0">
                 <a:solidFill>
                   <a:srgbClr val="0B2545"/>
                 </a:solidFill>
@@ -5298,17 +5298,17 @@
           <a:p>
             <a:pPr algn="l">
               <a:lnSpc>
-                <a:spcPct val="120000"/>
+                <a:spcPct val="130000"/>
               </a:lnSpc>
             </a:pPr>
             <a:r>
-              <a:rPr sz="1800" b="0" i="0">
+              <a:rPr sz="1250" b="0" i="0">
                 <a:solidFill>
                   <a:srgbClr val="5A7299"/>
                 </a:solidFill>
                 <a:latin typeface="Inter Tight"/>
               </a:rPr>
-              <a:t>Vaga perdida, fila cresce.</a:t>
+              <a:t>Vaga desperdiçada, fila cresce, eficiência cai.</a:t>
             </a:r>
           </a:p>
         </p:txBody>
@@ -5321,8 +5321,8 @@
         </p:nvSpPr>
         <p:spPr>
           <a:xfrm>
-            <a:off x="777240" y="6309360"/>
-            <a:ext cx="10637215" cy="320040"/>
+            <a:off x="822960" y="6327648"/>
+            <a:ext cx="10545775" cy="292608"/>
           </a:xfrm>
           <a:prstGeom prst="rect">
             <a:avLst/>
@@ -5337,7 +5337,7 @@
           <a:p>
             <a:pPr algn="l"/>
             <a:r>
-              <a:rPr sz="1300" b="0" i="0" spc="40">
+              <a:rPr sz="950" b="0" i="0" spc="30">
                 <a:solidFill>
                   <a:srgbClr val="5A7299"/>
                 </a:solidFill>
@@ -5418,8 +5418,8 @@
         </p:nvSpPr>
         <p:spPr>
           <a:xfrm>
-            <a:off x="10271455" y="640080"/>
-            <a:ext cx="1143000" cy="320040"/>
+            <a:off x="10362895" y="566928"/>
+            <a:ext cx="1051560" cy="320040"/>
           </a:xfrm>
           <a:prstGeom prst="rect">
             <a:avLst/>
@@ -5434,7 +5434,7 @@
           <a:p>
             <a:pPr algn="r"/>
             <a:r>
-              <a:rPr sz="1300" b="1" i="0" spc="150">
+              <a:rPr sz="1000" b="1" i="0" spc="180">
                 <a:solidFill>
                   <a:srgbClr val="5A7299"/>
                 </a:solidFill>
@@ -5453,8 +5453,8 @@
         </p:nvSpPr>
         <p:spPr>
           <a:xfrm>
-            <a:off x="777240" y="640080"/>
-            <a:ext cx="8351215" cy="365760"/>
+            <a:off x="822960" y="566928"/>
+            <a:ext cx="8534095" cy="365760"/>
           </a:xfrm>
           <a:prstGeom prst="rect">
             <a:avLst/>
@@ -5468,7 +5468,7 @@
           <a:lstStyle/>
           <a:p>
             <a:r>
-              <a:rPr sz="1300">
+              <a:rPr sz="1000">
                 <a:solidFill>
                   <a:srgbClr val="1D6FE0"/>
                 </a:solidFill>
@@ -5477,7 +5477,7 @@
               <a:t>● </a:t>
             </a:r>
             <a:r>
-              <a:rPr sz="1300" b="1" spc="240">
+              <a:rPr sz="1000" b="1" spc="260">
                 <a:solidFill>
                   <a:srgbClr val="5A7299"/>
                 </a:solidFill>
@@ -5496,8 +5496,8 @@
         </p:nvSpPr>
         <p:spPr>
           <a:xfrm>
-            <a:off x="777240" y="1097280"/>
-            <a:ext cx="10637215" cy="2011680"/>
+            <a:off x="822960" y="1051560"/>
+            <a:ext cx="10545775" cy="1371600"/>
           </a:xfrm>
           <a:prstGeom prst="rect">
             <a:avLst/>
@@ -5512,11 +5512,11 @@
           <a:p>
             <a:pPr>
               <a:lnSpc>
-                <a:spcPct val="102000"/>
+                <a:spcPct val="103000"/>
               </a:lnSpc>
             </a:pPr>
             <a:r>
-              <a:rPr sz="3600" i="0">
+              <a:rPr sz="3400" i="0">
                 <a:solidFill>
                   <a:srgbClr val="0B2545"/>
                 </a:solidFill>
@@ -5525,7 +5525,7 @@
               <a:t>814 exames ingeridos, </a:t>
             </a:r>
             <a:r>
-              <a:rPr sz="3600" i="1">
+              <a:rPr sz="3400" i="1">
                 <a:solidFill>
                   <a:srgbClr val="14418A"/>
                 </a:solidFill>
@@ -5534,7 +5534,7 @@
               <a:t>3 fontes</a:t>
             </a:r>
             <a:r>
-              <a:rPr sz="3600" i="0">
+              <a:rPr sz="3400" i="0">
                 <a:solidFill>
                   <a:srgbClr val="0B2545"/>
                 </a:solidFill>
@@ -5553,12 +5553,12 @@
         </p:nvSpPr>
         <p:spPr>
           <a:xfrm>
-            <a:off x="777240" y="1920240"/>
-            <a:ext cx="3332378" cy="2011680"/>
+            <a:off x="822960" y="2011680"/>
+            <a:ext cx="3301898" cy="1554480"/>
           </a:xfrm>
           <a:prstGeom prst="roundRect">
             <a:avLst>
-              <a:gd name="adj" fmla="val 6000"/>
+              <a:gd name="adj" fmla="val 8000"/>
             </a:avLst>
           </a:prstGeom>
           <a:solidFill>
@@ -5601,8 +5601,8 @@
         </p:nvSpPr>
         <p:spPr>
           <a:xfrm>
-            <a:off x="1051560" y="2176272"/>
-            <a:ext cx="2783738" cy="1554480"/>
+            <a:off x="1097280" y="2240280"/>
+            <a:ext cx="2753258" cy="1143000"/>
           </a:xfrm>
           <a:prstGeom prst="rect">
             <a:avLst/>
@@ -5617,11 +5617,11 @@
           <a:p>
             <a:pPr algn="l">
               <a:spcAft>
-                <a:spcPts val="1000"/>
+                <a:spcPts val="600"/>
               </a:spcAft>
             </a:pPr>
             <a:r>
-              <a:rPr sz="1300" b="1" i="0" spc="100">
+              <a:rPr sz="1000" b="1" i="0" spc="100">
                 <a:solidFill>
                   <a:srgbClr val="1D6FE0"/>
                 </a:solidFill>
@@ -5633,11 +5633,11 @@
           <a:p>
             <a:pPr algn="l">
               <a:spcAft>
-                <a:spcPts val="1000"/>
+                <a:spcPts val="600"/>
               </a:spcAft>
             </a:pPr>
             <a:r>
-              <a:rPr sz="2200" b="0" i="0">
+              <a:rPr sz="1800" b="0" i="0">
                 <a:solidFill>
                   <a:srgbClr val="0B2545"/>
                 </a:solidFill>
@@ -5649,17 +5649,17 @@
           <a:p>
             <a:pPr algn="l">
               <a:lnSpc>
-                <a:spcPct val="122000"/>
+                <a:spcPct val="130000"/>
               </a:lnSpc>
             </a:pPr>
             <a:r>
-              <a:rPr sz="1800" b="0" i="0">
+              <a:rPr sz="1250" b="0" i="0">
                 <a:solidFill>
                   <a:srgbClr val="5A7299"/>
                 </a:solidFill>
                 <a:latin typeface="Inter Tight"/>
               </a:rPr>
-              <a:t>914 linhas → 814 exames únicos, com sigla e sinônimos.</a:t>
+              <a:t>914 linhas → 814 exames únicos: nome, sigla, sinônimos e modalidade.</a:t>
             </a:r>
           </a:p>
         </p:txBody>
@@ -5672,12 +5672,12 @@
         </p:nvSpPr>
         <p:spPr>
           <a:xfrm>
-            <a:off x="4429658" y="1920240"/>
-            <a:ext cx="3332378" cy="2011680"/>
+            <a:off x="4444898" y="2011680"/>
+            <a:ext cx="3301898" cy="1554480"/>
           </a:xfrm>
           <a:prstGeom prst="roundRect">
             <a:avLst>
-              <a:gd name="adj" fmla="val 6000"/>
+              <a:gd name="adj" fmla="val 8000"/>
             </a:avLst>
           </a:prstGeom>
           <a:solidFill>
@@ -5720,8 +5720,8 @@
         </p:nvSpPr>
         <p:spPr>
           <a:xfrm>
-            <a:off x="4703978" y="2176272"/>
-            <a:ext cx="2783738" cy="1554480"/>
+            <a:off x="4719218" y="2240280"/>
+            <a:ext cx="2753258" cy="1143000"/>
           </a:xfrm>
           <a:prstGeom prst="rect">
             <a:avLst/>
@@ -5736,11 +5736,11 @@
           <a:p>
             <a:pPr algn="l">
               <a:spcAft>
-                <a:spcPts val="1000"/>
+                <a:spcPts val="600"/>
               </a:spcAft>
             </a:pPr>
             <a:r>
-              <a:rPr sz="1300" b="1" i="0" spc="100">
+              <a:rPr sz="1000" b="1" i="0" spc="100">
                 <a:solidFill>
                   <a:srgbClr val="1D6FE0"/>
                 </a:solidFill>
@@ -5752,11 +5752,11 @@
           <a:p>
             <a:pPr algn="l">
               <a:spcAft>
-                <a:spcPts val="1000"/>
+                <a:spcPts val="600"/>
               </a:spcAft>
             </a:pPr>
             <a:r>
-              <a:rPr sz="2200" b="0" i="0">
+              <a:rPr sz="1800" b="0" i="0">
                 <a:solidFill>
                   <a:srgbClr val="0B2545"/>
                 </a:solidFill>
@@ -5768,17 +5768,17 @@
           <a:p>
             <a:pPr algn="l">
               <a:lnSpc>
-                <a:spcPct val="122000"/>
+                <a:spcPct val="130000"/>
               </a:lnSpc>
             </a:pPr>
             <a:r>
-              <a:rPr sz="1800" b="0" i="0">
+              <a:rPr sz="1250" b="0" i="0">
                 <a:solidFill>
                   <a:srgbClr val="5A7299"/>
                 </a:solidFill>
                 <a:latin typeface="Inter Tight"/>
               </a:rPr>
-              <a:t>Preparos por modalidade. Cobre USG, RM, MMG e DO.</a:t>
+              <a:t>Preparos organizados por modalidade. Cobre USG, RM, MMG e DO.</a:t>
             </a:r>
           </a:p>
         </p:txBody>
@@ -5791,12 +5791,12 @@
         </p:nvSpPr>
         <p:spPr>
           <a:xfrm>
-            <a:off x="8082076" y="1920240"/>
-            <a:ext cx="3332378" cy="2011680"/>
+            <a:off x="8066836" y="2011680"/>
+            <a:ext cx="3301898" cy="1554480"/>
           </a:xfrm>
           <a:prstGeom prst="roundRect">
             <a:avLst>
-              <a:gd name="adj" fmla="val 6000"/>
+              <a:gd name="adj" fmla="val 8000"/>
             </a:avLst>
           </a:prstGeom>
           <a:solidFill>
@@ -5839,8 +5839,8 @@
         </p:nvSpPr>
         <p:spPr>
           <a:xfrm>
-            <a:off x="8356396" y="2176272"/>
-            <a:ext cx="2783738" cy="1554480"/>
+            <a:off x="8341156" y="2240280"/>
+            <a:ext cx="2753258" cy="1143000"/>
           </a:xfrm>
           <a:prstGeom prst="rect">
             <a:avLst/>
@@ -5855,11 +5855,11 @@
           <a:p>
             <a:pPr algn="l">
               <a:spcAft>
-                <a:spcPts val="1000"/>
+                <a:spcPts val="600"/>
               </a:spcAft>
             </a:pPr>
             <a:r>
-              <a:rPr sz="1300" b="1" i="0" spc="100">
+              <a:rPr sz="1000" b="1" i="0" spc="100">
                 <a:solidFill>
                   <a:srgbClr val="1D6FE0"/>
                 </a:solidFill>
@@ -5871,11 +5871,11 @@
           <a:p>
             <a:pPr algn="l">
               <a:spcAft>
-                <a:spcPts val="1000"/>
+                <a:spcPts val="600"/>
               </a:spcAft>
             </a:pPr>
             <a:r>
-              <a:rPr sz="2200" b="0" i="0">
+              <a:rPr sz="1800" b="0" i="0">
                 <a:solidFill>
                   <a:srgbClr val="0B2545"/>
                 </a:solidFill>
@@ -5887,17 +5887,17 @@
           <a:p>
             <a:pPr algn="l">
               <a:lnSpc>
-                <a:spcPct val="122000"/>
+                <a:spcPct val="130000"/>
               </a:lnSpc>
             </a:pPr>
             <a:r>
-              <a:rPr sz="1800" b="0" i="0">
+              <a:rPr sz="1250" b="0" i="0">
                 <a:solidFill>
                   <a:srgbClr val="5A7299"/>
                 </a:solidFill>
                 <a:latin typeface="Inter Tight"/>
               </a:rPr>
-              <a:t>Preparos de TC, RX e Medicina Nuclear — a digitalizar.</a:t>
+              <a:t>Preparos de TC, RX e Medicina Nuclear — ainda a digitalizar.</a:t>
             </a:r>
           </a:p>
         </p:txBody>
@@ -5910,8 +5910,8 @@
         </p:nvSpPr>
         <p:spPr>
           <a:xfrm>
-            <a:off x="777240" y="4160520"/>
-            <a:ext cx="2743200" cy="365760"/>
+            <a:off x="822960" y="3977639"/>
+            <a:ext cx="2377440" cy="365760"/>
           </a:xfrm>
           <a:prstGeom prst="rect">
             <a:avLst/>
@@ -5926,7 +5926,7 @@
           <a:p>
             <a:pPr algn="l"/>
             <a:r>
-              <a:rPr sz="1800" b="0" i="0">
+              <a:rPr sz="1250" b="0" i="0">
                 <a:solidFill>
                   <a:srgbClr val="0B2545"/>
                 </a:solidFill>
@@ -5945,12 +5945,12 @@
         </p:nvSpPr>
         <p:spPr>
           <a:xfrm>
-            <a:off x="3520440" y="4279392"/>
-            <a:ext cx="5669280" cy="164592"/>
+            <a:off x="3200400" y="4087367"/>
+            <a:ext cx="6035040" cy="146304"/>
           </a:xfrm>
           <a:prstGeom prst="roundRect">
             <a:avLst>
-              <a:gd name="adj" fmla="val 6000"/>
+              <a:gd name="adj" fmla="val 8000"/>
             </a:avLst>
           </a:prstGeom>
           <a:solidFill>
@@ -5991,12 +5991,12 @@
         </p:nvSpPr>
         <p:spPr>
           <a:xfrm>
-            <a:off x="3520440" y="4279392"/>
-            <a:ext cx="5669280" cy="164592"/>
+            <a:off x="3200400" y="4087367"/>
+            <a:ext cx="6035040" cy="146304"/>
           </a:xfrm>
           <a:prstGeom prst="roundRect">
             <a:avLst>
-              <a:gd name="adj" fmla="val 6000"/>
+              <a:gd name="adj" fmla="val 8000"/>
             </a:avLst>
           </a:prstGeom>
           <a:solidFill>
@@ -6037,8 +6037,8 @@
         </p:nvSpPr>
         <p:spPr>
           <a:xfrm>
-            <a:off x="9372600" y="4160520"/>
-            <a:ext cx="1280160" cy="365760"/>
+            <a:off x="9418320" y="3977639"/>
+            <a:ext cx="1188720" cy="365760"/>
           </a:xfrm>
           <a:prstGeom prst="rect">
             <a:avLst/>
@@ -6053,7 +6053,7 @@
           <a:p>
             <a:pPr algn="l"/>
             <a:r>
-              <a:rPr sz="1500" b="1" i="0">
+              <a:rPr sz="1200" b="1" i="0">
                 <a:solidFill>
                   <a:srgbClr val="14418A"/>
                 </a:solidFill>
@@ -6072,8 +6072,8 @@
         </p:nvSpPr>
         <p:spPr>
           <a:xfrm>
-            <a:off x="777240" y="4526280"/>
-            <a:ext cx="2743200" cy="365760"/>
+            <a:off x="822960" y="4343399"/>
+            <a:ext cx="2377440" cy="365760"/>
           </a:xfrm>
           <a:prstGeom prst="rect">
             <a:avLst/>
@@ -6088,7 +6088,7 @@
           <a:p>
             <a:pPr algn="l"/>
             <a:r>
-              <a:rPr sz="1800" b="0" i="0">
+              <a:rPr sz="1250" b="0" i="0">
                 <a:solidFill>
                   <a:srgbClr val="0B2545"/>
                 </a:solidFill>
@@ -6107,12 +6107,12 @@
         </p:nvSpPr>
         <p:spPr>
           <a:xfrm>
-            <a:off x="3520440" y="4645152"/>
-            <a:ext cx="5669280" cy="164592"/>
+            <a:off x="3200400" y="4453127"/>
+            <a:ext cx="6035040" cy="146304"/>
           </a:xfrm>
           <a:prstGeom prst="roundRect">
             <a:avLst>
-              <a:gd name="adj" fmla="val 6000"/>
+              <a:gd name="adj" fmla="val 8000"/>
             </a:avLst>
           </a:prstGeom>
           <a:solidFill>
@@ -6153,12 +6153,12 @@
         </p:nvSpPr>
         <p:spPr>
           <a:xfrm>
-            <a:off x="3520440" y="4645152"/>
-            <a:ext cx="4640491" cy="164592"/>
+            <a:off x="3200400" y="4453127"/>
+            <a:ext cx="4939878" cy="146304"/>
           </a:xfrm>
           <a:prstGeom prst="roundRect">
             <a:avLst>
-              <a:gd name="adj" fmla="val 6000"/>
+              <a:gd name="adj" fmla="val 8000"/>
             </a:avLst>
           </a:prstGeom>
           <a:solidFill>
@@ -6199,12 +6199,12 @@
         </p:nvSpPr>
         <p:spPr>
           <a:xfrm>
-            <a:off x="3520440" y="4645152"/>
-            <a:ext cx="4465378" cy="164592"/>
+            <a:off x="3200400" y="4453127"/>
+            <a:ext cx="4753467" cy="146304"/>
           </a:xfrm>
           <a:prstGeom prst="roundRect">
             <a:avLst>
-              <a:gd name="adj" fmla="val 6000"/>
+              <a:gd name="adj" fmla="val 8000"/>
             </a:avLst>
           </a:prstGeom>
           <a:solidFill>
@@ -6245,8 +6245,8 @@
         </p:nvSpPr>
         <p:spPr>
           <a:xfrm>
-            <a:off x="9372600" y="4526280"/>
-            <a:ext cx="1280160" cy="365760"/>
+            <a:off x="9418320" y="4343399"/>
+            <a:ext cx="1188720" cy="365760"/>
           </a:xfrm>
           <a:prstGeom prst="rect">
             <a:avLst/>
@@ -6261,7 +6261,7 @@
           <a:p>
             <a:pPr algn="l"/>
             <a:r>
-              <a:rPr sz="1500" b="1" i="0">
+              <a:rPr sz="1200" b="1" i="0">
                 <a:solidFill>
                   <a:srgbClr val="14418A"/>
                 </a:solidFill>
@@ -6280,8 +6280,8 @@
         </p:nvSpPr>
         <p:spPr>
           <a:xfrm>
-            <a:off x="777240" y="4892040"/>
-            <a:ext cx="2743200" cy="365760"/>
+            <a:off x="822960" y="4709159"/>
+            <a:ext cx="2377440" cy="365760"/>
           </a:xfrm>
           <a:prstGeom prst="rect">
             <a:avLst/>
@@ -6296,7 +6296,7 @@
           <a:p>
             <a:pPr algn="l"/>
             <a:r>
-              <a:rPr sz="1800" b="0" i="0">
+              <a:rPr sz="1250" b="0" i="0">
                 <a:solidFill>
                   <a:srgbClr val="0B2545"/>
                 </a:solidFill>
@@ -6315,12 +6315,12 @@
         </p:nvSpPr>
         <p:spPr>
           <a:xfrm>
-            <a:off x="3520440" y="5010912"/>
-            <a:ext cx="5669280" cy="164592"/>
+            <a:off x="3200400" y="4818887"/>
+            <a:ext cx="6035040" cy="146304"/>
           </a:xfrm>
           <a:prstGeom prst="roundRect">
             <a:avLst>
-              <a:gd name="adj" fmla="val 6000"/>
+              <a:gd name="adj" fmla="val 8000"/>
             </a:avLst>
           </a:prstGeom>
           <a:solidFill>
@@ -6361,12 +6361,12 @@
         </p:nvSpPr>
         <p:spPr>
           <a:xfrm>
-            <a:off x="3520440" y="5010912"/>
-            <a:ext cx="4224598" cy="164592"/>
+            <a:off x="3200400" y="4818887"/>
+            <a:ext cx="4497153" cy="146304"/>
           </a:xfrm>
           <a:prstGeom prst="roundRect">
             <a:avLst>
-              <a:gd name="adj" fmla="val 6000"/>
+              <a:gd name="adj" fmla="val 8000"/>
             </a:avLst>
           </a:prstGeom>
           <a:solidFill>
@@ -6407,12 +6407,12 @@
         </p:nvSpPr>
         <p:spPr>
           <a:xfrm>
-            <a:off x="3520440" y="5010912"/>
-            <a:ext cx="4224598" cy="164592"/>
+            <a:off x="3200400" y="4818887"/>
+            <a:ext cx="4497153" cy="146304"/>
           </a:xfrm>
           <a:prstGeom prst="roundRect">
             <a:avLst>
-              <a:gd name="adj" fmla="val 6000"/>
+              <a:gd name="adj" fmla="val 8000"/>
             </a:avLst>
           </a:prstGeom>
           <a:solidFill>
@@ -6453,8 +6453,8 @@
         </p:nvSpPr>
         <p:spPr>
           <a:xfrm>
-            <a:off x="9372600" y="4892040"/>
-            <a:ext cx="1280160" cy="365760"/>
+            <a:off x="9418320" y="4709159"/>
+            <a:ext cx="1188720" cy="365760"/>
           </a:xfrm>
           <a:prstGeom prst="rect">
             <a:avLst/>
@@ -6469,7 +6469,7 @@
           <a:p>
             <a:pPr algn="l"/>
             <a:r>
-              <a:rPr sz="1500" b="1" i="0">
+              <a:rPr sz="1200" b="1" i="0">
                 <a:solidFill>
                   <a:srgbClr val="14418A"/>
                 </a:solidFill>
@@ -6488,8 +6488,8 @@
         </p:nvSpPr>
         <p:spPr>
           <a:xfrm>
-            <a:off x="777240" y="5257800"/>
-            <a:ext cx="2743200" cy="365760"/>
+            <a:off x="822960" y="5074919"/>
+            <a:ext cx="2377440" cy="365760"/>
           </a:xfrm>
           <a:prstGeom prst="rect">
             <a:avLst/>
@@ -6504,7 +6504,7 @@
           <a:p>
             <a:pPr algn="l"/>
             <a:r>
-              <a:rPr sz="1800" b="0" i="0">
+              <a:rPr sz="1250" b="0" i="0">
                 <a:solidFill>
                   <a:srgbClr val="0B2545"/>
                 </a:solidFill>
@@ -6523,12 +6523,12 @@
         </p:nvSpPr>
         <p:spPr>
           <a:xfrm>
-            <a:off x="3520440" y="5376672"/>
-            <a:ext cx="5669280" cy="164592"/>
+            <a:off x="3200400" y="5184647"/>
+            <a:ext cx="6035040" cy="146304"/>
           </a:xfrm>
           <a:prstGeom prst="roundRect">
             <a:avLst>
-              <a:gd name="adj" fmla="val 6000"/>
+              <a:gd name="adj" fmla="val 8000"/>
             </a:avLst>
           </a:prstGeom>
           <a:solidFill>
@@ -6569,12 +6569,12 @@
         </p:nvSpPr>
         <p:spPr>
           <a:xfrm>
-            <a:off x="3520440" y="5376672"/>
-            <a:ext cx="2364024" cy="164592"/>
+            <a:off x="3200400" y="5184647"/>
+            <a:ext cx="2516541" cy="146304"/>
           </a:xfrm>
           <a:prstGeom prst="roundRect">
             <a:avLst>
-              <a:gd name="adj" fmla="val 6000"/>
+              <a:gd name="adj" fmla="val 8000"/>
             </a:avLst>
           </a:prstGeom>
           <a:solidFill>
@@ -6615,12 +6615,12 @@
         </p:nvSpPr>
         <p:spPr>
           <a:xfrm>
-            <a:off x="3520440" y="5376672"/>
-            <a:ext cx="350225" cy="164592"/>
+            <a:off x="3200400" y="5184647"/>
+            <a:ext cx="372821" cy="146304"/>
           </a:xfrm>
           <a:prstGeom prst="roundRect">
             <a:avLst>
-              <a:gd name="adj" fmla="val 6000"/>
+              <a:gd name="adj" fmla="val 8000"/>
             </a:avLst>
           </a:prstGeom>
           <a:solidFill>
@@ -6661,8 +6661,8 @@
         </p:nvSpPr>
         <p:spPr>
           <a:xfrm>
-            <a:off x="9372600" y="5257800"/>
-            <a:ext cx="1280160" cy="365760"/>
+            <a:off x="9418320" y="5074919"/>
+            <a:ext cx="1188720" cy="365760"/>
           </a:xfrm>
           <a:prstGeom prst="rect">
             <a:avLst/>
@@ -6677,7 +6677,7 @@
           <a:p>
             <a:pPr algn="l"/>
             <a:r>
-              <a:rPr sz="1500" b="1" i="0">
+              <a:rPr sz="1200" b="1" i="0">
                 <a:solidFill>
                   <a:srgbClr val="14418A"/>
                 </a:solidFill>
@@ -6696,8 +6696,8 @@
         </p:nvSpPr>
         <p:spPr>
           <a:xfrm>
-            <a:off x="777240" y="5623560"/>
-            <a:ext cx="2743200" cy="365760"/>
+            <a:off x="822960" y="5440679"/>
+            <a:ext cx="2377440" cy="365760"/>
           </a:xfrm>
           <a:prstGeom prst="rect">
             <a:avLst/>
@@ -6712,7 +6712,7 @@
           <a:p>
             <a:pPr algn="l"/>
             <a:r>
-              <a:rPr sz="1800" b="0" i="0">
+              <a:rPr sz="1250" b="0" i="0">
                 <a:solidFill>
                   <a:srgbClr val="0B2545"/>
                 </a:solidFill>
@@ -6731,12 +6731,12 @@
         </p:nvSpPr>
         <p:spPr>
           <a:xfrm>
-            <a:off x="3520440" y="5742432"/>
-            <a:ext cx="5669280" cy="164592"/>
+            <a:off x="3200400" y="5550407"/>
+            <a:ext cx="6035040" cy="146304"/>
           </a:xfrm>
           <a:prstGeom prst="roundRect">
             <a:avLst>
-              <a:gd name="adj" fmla="val 6000"/>
+              <a:gd name="adj" fmla="val 8000"/>
             </a:avLst>
           </a:prstGeom>
           <a:solidFill>
@@ -6777,12 +6777,12 @@
         </p:nvSpPr>
         <p:spPr>
           <a:xfrm>
-            <a:off x="3520440" y="5742432"/>
-            <a:ext cx="700451" cy="164592"/>
+            <a:off x="3200400" y="5550407"/>
+            <a:ext cx="745642" cy="146304"/>
           </a:xfrm>
           <a:prstGeom prst="roundRect">
             <a:avLst>
-              <a:gd name="adj" fmla="val 6000"/>
+              <a:gd name="adj" fmla="val 8000"/>
             </a:avLst>
           </a:prstGeom>
           <a:solidFill>
@@ -6823,8 +6823,8 @@
         </p:nvSpPr>
         <p:spPr>
           <a:xfrm>
-            <a:off x="9372600" y="5623560"/>
-            <a:ext cx="1280160" cy="365760"/>
+            <a:off x="9418320" y="5440679"/>
+            <a:ext cx="1188720" cy="365760"/>
           </a:xfrm>
           <a:prstGeom prst="rect">
             <a:avLst/>
@@ -6839,7 +6839,7 @@
           <a:p>
             <a:pPr algn="l"/>
             <a:r>
-              <a:rPr sz="1500" b="1" i="0">
+              <a:rPr sz="1200" b="1" i="0">
                 <a:solidFill>
                   <a:srgbClr val="14418A"/>
                 </a:solidFill>
@@ -6858,8 +6858,8 @@
         </p:nvSpPr>
         <p:spPr>
           <a:xfrm>
-            <a:off x="777240" y="5989320"/>
-            <a:ext cx="2743200" cy="365760"/>
+            <a:off x="822960" y="5806439"/>
+            <a:ext cx="2377440" cy="365760"/>
           </a:xfrm>
           <a:prstGeom prst="rect">
             <a:avLst/>
@@ -6874,7 +6874,7 @@
           <a:p>
             <a:pPr algn="l"/>
             <a:r>
-              <a:rPr sz="1800" b="0" i="0">
+              <a:rPr sz="1250" b="0" i="0">
                 <a:solidFill>
                   <a:srgbClr val="0B2545"/>
                 </a:solidFill>
@@ -6893,12 +6893,12 @@
         </p:nvSpPr>
         <p:spPr>
           <a:xfrm>
-            <a:off x="3520440" y="6108192"/>
-            <a:ext cx="5669280" cy="164592"/>
+            <a:off x="3200400" y="5916167"/>
+            <a:ext cx="6035040" cy="146304"/>
           </a:xfrm>
           <a:prstGeom prst="roundRect">
             <a:avLst>
-              <a:gd name="adj" fmla="val 6000"/>
+              <a:gd name="adj" fmla="val 8000"/>
             </a:avLst>
           </a:prstGeom>
           <a:solidFill>
@@ -6939,12 +6939,12 @@
         </p:nvSpPr>
         <p:spPr>
           <a:xfrm>
-            <a:off x="3520440" y="6108192"/>
-            <a:ext cx="218891" cy="164592"/>
+            <a:off x="3200400" y="5916167"/>
+            <a:ext cx="233013" cy="146304"/>
           </a:xfrm>
           <a:prstGeom prst="roundRect">
             <a:avLst>
-              <a:gd name="adj" fmla="val 6000"/>
+              <a:gd name="adj" fmla="val 8000"/>
             </a:avLst>
           </a:prstGeom>
           <a:solidFill>
@@ -6985,12 +6985,12 @@
         </p:nvSpPr>
         <p:spPr>
           <a:xfrm>
-            <a:off x="3520440" y="6108192"/>
-            <a:ext cx="218891" cy="164592"/>
+            <a:off x="3200400" y="5916167"/>
+            <a:ext cx="233013" cy="146304"/>
           </a:xfrm>
           <a:prstGeom prst="roundRect">
             <a:avLst>
-              <a:gd name="adj" fmla="val 6000"/>
+              <a:gd name="adj" fmla="val 8000"/>
             </a:avLst>
           </a:prstGeom>
           <a:solidFill>
@@ -7031,8 +7031,8 @@
         </p:nvSpPr>
         <p:spPr>
           <a:xfrm>
-            <a:off x="9372600" y="5989320"/>
-            <a:ext cx="1280160" cy="365760"/>
+            <a:off x="9418320" y="5806439"/>
+            <a:ext cx="1188720" cy="365760"/>
           </a:xfrm>
           <a:prstGeom prst="rect">
             <a:avLst/>
@@ -7047,7 +7047,7 @@
           <a:p>
             <a:pPr algn="l"/>
             <a:r>
-              <a:rPr sz="1500" b="1" i="0">
+              <a:rPr sz="1200" b="1" i="0">
                 <a:solidFill>
                   <a:srgbClr val="14418A"/>
                 </a:solidFill>
@@ -7066,8 +7066,8 @@
         </p:nvSpPr>
         <p:spPr>
           <a:xfrm>
-            <a:off x="3520440" y="6464808"/>
-            <a:ext cx="7132320" cy="274320"/>
+            <a:off x="3200400" y="6263639"/>
+            <a:ext cx="7406640" cy="274320"/>
           </a:xfrm>
           <a:prstGeom prst="rect">
             <a:avLst/>
@@ -7081,7 +7081,7 @@
           <a:lstStyle/>
           <a:p>
             <a:r>
-              <a:rPr sz="1600">
+              <a:rPr sz="950">
                 <a:solidFill>
                   <a:srgbClr val="1D6FE0"/>
                 </a:solidFill>
@@ -7090,7 +7090,7 @@
               <a:t>■ </a:t>
             </a:r>
             <a:r>
-              <a:rPr sz="1600">
+              <a:rPr sz="950">
                 <a:solidFill>
                   <a:srgbClr val="5A7299"/>
                 </a:solidFill>
@@ -7099,7 +7099,7 @@
               <a:t>com preparo confirmado     </a:t>
             </a:r>
             <a:r>
-              <a:rPr sz="1600">
+              <a:rPr sz="950">
                 <a:solidFill>
                   <a:srgbClr val="DCE8FA"/>
                 </a:solidFill>
@@ -7108,7 +7108,7 @@
               <a:t>■ </a:t>
             </a:r>
             <a:r>
-              <a:rPr sz="1600">
+              <a:rPr sz="950">
                 <a:solidFill>
                   <a:srgbClr val="5A7299"/>
                 </a:solidFill>
@@ -7189,8 +7189,8 @@
         </p:nvSpPr>
         <p:spPr>
           <a:xfrm>
-            <a:off x="10271455" y="640080"/>
-            <a:ext cx="1143000" cy="320040"/>
+            <a:off x="10362895" y="566928"/>
+            <a:ext cx="1051560" cy="320040"/>
           </a:xfrm>
           <a:prstGeom prst="rect">
             <a:avLst/>
@@ -7205,7 +7205,7 @@
           <a:p>
             <a:pPr algn="r"/>
             <a:r>
-              <a:rPr sz="1300" b="1" i="0" spc="150">
+              <a:rPr sz="1000" b="1" i="0" spc="180">
                 <a:solidFill>
                   <a:srgbClr val="5A7299"/>
                 </a:solidFill>
@@ -7224,8 +7224,8 @@
         </p:nvSpPr>
         <p:spPr>
           <a:xfrm>
-            <a:off x="777240" y="640080"/>
-            <a:ext cx="8351215" cy="365760"/>
+            <a:off x="822960" y="566928"/>
+            <a:ext cx="8534095" cy="365760"/>
           </a:xfrm>
           <a:prstGeom prst="rect">
             <a:avLst/>
@@ -7239,7 +7239,7 @@
           <a:lstStyle/>
           <a:p>
             <a:r>
-              <a:rPr sz="1300">
+              <a:rPr sz="1000">
                 <a:solidFill>
                   <a:srgbClr val="1D6FE0"/>
                 </a:solidFill>
@@ -7248,7 +7248,7 @@
               <a:t>● </a:t>
             </a:r>
             <a:r>
-              <a:rPr sz="1300" b="1" spc="240">
+              <a:rPr sz="1000" b="1" spc="260">
                 <a:solidFill>
                   <a:srgbClr val="5A7299"/>
                 </a:solidFill>
@@ -7267,8 +7267,8 @@
         </p:nvSpPr>
         <p:spPr>
           <a:xfrm>
-            <a:off x="777240" y="1097280"/>
-            <a:ext cx="10637215" cy="2011680"/>
+            <a:off x="822960" y="1051560"/>
+            <a:ext cx="10545775" cy="1371600"/>
           </a:xfrm>
           <a:prstGeom prst="rect">
             <a:avLst/>
@@ -7283,11 +7283,11 @@
           <a:p>
             <a:pPr>
               <a:lnSpc>
-                <a:spcPct val="102000"/>
+                <a:spcPct val="103000"/>
               </a:lnSpc>
             </a:pPr>
             <a:r>
-              <a:rPr sz="3600" i="0">
+              <a:rPr sz="3400" i="0">
                 <a:solidFill>
                   <a:srgbClr val="0B2545"/>
                 </a:solidFill>
@@ -7296,7 +7296,7 @@
               <a:t>Chatbot de acesso aberto que </a:t>
             </a:r>
             <a:r>
-              <a:rPr sz="3600" i="1">
+              <a:rPr sz="3400" i="1">
                 <a:solidFill>
                   <a:srgbClr val="14418A"/>
                 </a:solidFill>
@@ -7305,7 +7305,7 @@
               <a:t>adapta o tom</a:t>
             </a:r>
             <a:r>
-              <a:rPr sz="3600" i="0">
+              <a:rPr sz="3400" i="0">
                 <a:solidFill>
                   <a:srgbClr val="0B2545"/>
                 </a:solidFill>
@@ -7324,8 +7324,8 @@
         </p:nvSpPr>
         <p:spPr>
           <a:xfrm>
-            <a:off x="777240" y="2240280"/>
-            <a:ext cx="10637215" cy="1005840"/>
+            <a:off x="822960" y="2148840"/>
+            <a:ext cx="10058400" cy="822960"/>
           </a:xfrm>
           <a:prstGeom prst="rect">
             <a:avLst/>
@@ -7344,7 +7344,7 @@
               </a:lnSpc>
             </a:pPr>
             <a:r>
-              <a:rPr sz="1800" b="0" i="0">
+              <a:rPr sz="1500" b="0" i="0">
                 <a:solidFill>
                   <a:srgbClr val="5A7299"/>
                 </a:solidFill>
@@ -7363,12 +7363,12 @@
         </p:nvSpPr>
         <p:spPr>
           <a:xfrm>
-            <a:off x="777240" y="3200400"/>
-            <a:ext cx="5090007" cy="2331720"/>
+            <a:off x="822960" y="3246120"/>
+            <a:ext cx="5044287" cy="2606040"/>
           </a:xfrm>
           <a:prstGeom prst="roundRect">
             <a:avLst>
-              <a:gd name="adj" fmla="val 6000"/>
+              <a:gd name="adj" fmla="val 8000"/>
             </a:avLst>
           </a:prstGeom>
           <a:solidFill>
@@ -7411,12 +7411,12 @@
         </p:nvSpPr>
         <p:spPr>
           <a:xfrm>
-            <a:off x="1143000" y="3520440"/>
-            <a:ext cx="640080" cy="640080"/>
+            <a:off x="1188720" y="3593592"/>
+            <a:ext cx="594360" cy="594360"/>
           </a:xfrm>
           <a:prstGeom prst="roundRect">
             <a:avLst>
-              <a:gd name="adj" fmla="val 6000"/>
+              <a:gd name="adj" fmla="val 8000"/>
             </a:avLst>
           </a:prstGeom>
           <a:solidFill>
@@ -7447,7 +7447,7 @@
           <a:p>
             <a:pPr algn="ctr"/>
             <a:r>
-              <a:rPr sz="2200" b="0" i="0">
+              <a:rPr sz="2000" b="0" i="0">
                 <a:solidFill>
                   <a:srgbClr val="1D6FE0"/>
                 </a:solidFill>
@@ -7466,8 +7466,8 @@
         </p:nvSpPr>
         <p:spPr>
           <a:xfrm>
-            <a:off x="1143000" y="4297680"/>
-            <a:ext cx="4358487" cy="1097280"/>
+            <a:off x="1188720" y="4343400"/>
+            <a:ext cx="4312767" cy="1371600"/>
           </a:xfrm>
           <a:prstGeom prst="rect">
             <a:avLst/>
@@ -7486,7 +7486,7 @@
               </a:spcAft>
             </a:pPr>
             <a:r>
-              <a:rPr sz="2400" b="0" i="0">
+              <a:rPr sz="2200" b="0" i="0">
                 <a:solidFill>
                   <a:srgbClr val="0B2545"/>
                 </a:solidFill>
@@ -7498,17 +7498,17 @@
           <a:p>
             <a:pPr algn="l">
               <a:lnSpc>
-                <a:spcPct val="125000"/>
+                <a:spcPct val="130000"/>
               </a:lnSpc>
             </a:pPr>
             <a:r>
-              <a:rPr sz="1800" b="0" i="0">
+              <a:rPr sz="1300" b="0" i="0">
                 <a:solidFill>
                   <a:srgbClr val="5A7299"/>
                 </a:solidFill>
                 <a:latin typeface="Inter Tight"/>
               </a:rPr>
-              <a:t>Picker guiado: modalidade → exame → contraste / sedação. Linguagem simples.</a:t>
+              <a:t>Picker guiado: escolhe modalidade, exame e responde contraste, sedação e lado. Resposta em linguagem simples e acolhedora.</a:t>
             </a:r>
           </a:p>
         </p:txBody>
@@ -7521,12 +7521,12 @@
         </p:nvSpPr>
         <p:spPr>
           <a:xfrm>
-            <a:off x="6324447" y="3200400"/>
-            <a:ext cx="5090007" cy="2331720"/>
+            <a:off x="6324447" y="3246120"/>
+            <a:ext cx="5044287" cy="2606040"/>
           </a:xfrm>
           <a:prstGeom prst="roundRect">
             <a:avLst>
-              <a:gd name="adj" fmla="val 6000"/>
+              <a:gd name="adj" fmla="val 8000"/>
             </a:avLst>
           </a:prstGeom>
           <a:solidFill>
@@ -7569,12 +7569,12 @@
         </p:nvSpPr>
         <p:spPr>
           <a:xfrm>
-            <a:off x="6690207" y="3520440"/>
-            <a:ext cx="640080" cy="640080"/>
+            <a:off x="6690207" y="3593592"/>
+            <a:ext cx="594360" cy="594360"/>
           </a:xfrm>
           <a:prstGeom prst="roundRect">
             <a:avLst>
-              <a:gd name="adj" fmla="val 6000"/>
+              <a:gd name="adj" fmla="val 8000"/>
             </a:avLst>
           </a:prstGeom>
           <a:solidFill>
@@ -7605,7 +7605,7 @@
           <a:p>
             <a:pPr algn="ctr"/>
             <a:r>
-              <a:rPr sz="2200" b="0" i="0">
+              <a:rPr sz="2000" b="0" i="0">
                 <a:solidFill>
                   <a:srgbClr val="1D6FE0"/>
                 </a:solidFill>
@@ -7624,8 +7624,8 @@
         </p:nvSpPr>
         <p:spPr>
           <a:xfrm>
-            <a:off x="6690207" y="4297680"/>
-            <a:ext cx="4358487" cy="1097280"/>
+            <a:off x="6690207" y="4343400"/>
+            <a:ext cx="4312767" cy="1371600"/>
           </a:xfrm>
           <a:prstGeom prst="rect">
             <a:avLst/>
@@ -7644,7 +7644,7 @@
               </a:spcAft>
             </a:pPr>
             <a:r>
-              <a:rPr sz="2400" b="0" i="0">
+              <a:rPr sz="2200" b="0" i="0">
                 <a:solidFill>
                   <a:srgbClr val="0B2545"/>
                 </a:solidFill>
@@ -7656,17 +7656,17 @@
           <a:p>
             <a:pPr algn="l">
               <a:lnSpc>
-                <a:spcPct val="125000"/>
+                <a:spcPct val="130000"/>
               </a:lnSpc>
             </a:pPr>
             <a:r>
-              <a:rPr sz="1800" b="0" i="0">
+              <a:rPr sz="1300" b="0" i="0">
                 <a:solidFill>
                   <a:srgbClr val="5A7299"/>
                 </a:solidFill>
                 <a:latin typeface="Inter Tight"/>
               </a:rPr>
-              <a:t>Linguagem técnica + código AGHU para o cadastro. Protocolos e fluxo.</a:t>
+              <a:t>Linguagem técnica e o código AGHU do exame para o cadastro. Protocolos, contraste, sedação e fluxo de agendamento.</a:t>
             </a:r>
           </a:p>
         </p:txBody>
@@ -7679,8 +7679,8 @@
         </p:nvSpPr>
         <p:spPr>
           <a:xfrm>
-            <a:off x="777240" y="6309360"/>
-            <a:ext cx="10637215" cy="320040"/>
+            <a:off x="822960" y="6327648"/>
+            <a:ext cx="10545775" cy="292608"/>
           </a:xfrm>
           <a:prstGeom prst="rect">
             <a:avLst/>
@@ -7695,13 +7695,13 @@
           <a:p>
             <a:pPr algn="l"/>
             <a:r>
-              <a:rPr sz="1300" b="0" i="0" spc="40">
+              <a:rPr sz="950" b="0" i="0" spc="30">
                 <a:solidFill>
                   <a:srgbClr val="5A7299"/>
                 </a:solidFill>
                 <a:latin typeface="Inter Tight"/>
               </a:rPr>
-              <a:t>Fora do escopo · corpo humano · marcação real · dados de paciente</a:t>
+              <a:t>Fora do escopo · navegação pelo corpo humano · marcação real · dados de paciente</a:t>
             </a:r>
           </a:p>
         </p:txBody>
@@ -7776,8 +7776,8 @@
         </p:nvSpPr>
         <p:spPr>
           <a:xfrm>
-            <a:off x="10271455" y="640080"/>
-            <a:ext cx="1143000" cy="320040"/>
+            <a:off x="10362895" y="566928"/>
+            <a:ext cx="1051560" cy="320040"/>
           </a:xfrm>
           <a:prstGeom prst="rect">
             <a:avLst/>
@@ -7792,7 +7792,7 @@
           <a:p>
             <a:pPr algn="r"/>
             <a:r>
-              <a:rPr sz="1300" b="1" i="0" spc="150">
+              <a:rPr sz="1000" b="1" i="0" spc="180">
                 <a:solidFill>
                   <a:srgbClr val="5A7299"/>
                 </a:solidFill>
@@ -7811,8 +7811,8 @@
         </p:nvSpPr>
         <p:spPr>
           <a:xfrm>
-            <a:off x="777240" y="640080"/>
-            <a:ext cx="8351215" cy="365760"/>
+            <a:off x="822960" y="566928"/>
+            <a:ext cx="8534095" cy="365760"/>
           </a:xfrm>
           <a:prstGeom prst="rect">
             <a:avLst/>
@@ -7826,7 +7826,7 @@
           <a:lstStyle/>
           <a:p>
             <a:r>
-              <a:rPr sz="1300">
+              <a:rPr sz="1000">
                 <a:solidFill>
                   <a:srgbClr val="1D6FE0"/>
                 </a:solidFill>
@@ -7835,7 +7835,7 @@
               <a:t>● </a:t>
             </a:r>
             <a:r>
-              <a:rPr sz="1300" b="1" spc="240">
+              <a:rPr sz="1000" b="1" spc="260">
                 <a:solidFill>
                   <a:srgbClr val="5A7299"/>
                 </a:solidFill>
@@ -7854,8 +7854,8 @@
         </p:nvSpPr>
         <p:spPr>
           <a:xfrm>
-            <a:off x="777240" y="1097280"/>
-            <a:ext cx="10637215" cy="2011680"/>
+            <a:off x="822960" y="1051560"/>
+            <a:ext cx="10545775" cy="1371600"/>
           </a:xfrm>
           <a:prstGeom prst="rect">
             <a:avLst/>
@@ -7870,7 +7870,7 @@
           <a:p>
             <a:pPr>
               <a:lnSpc>
-                <a:spcPct val="102000"/>
+                <a:spcPct val="103000"/>
               </a:lnSpc>
             </a:pPr>
             <a:r>
@@ -7902,8 +7902,8 @@
         </p:nvSpPr>
         <p:spPr>
           <a:xfrm>
-            <a:off x="777240" y="3123692"/>
-            <a:ext cx="10637215" cy="12700"/>
+            <a:off x="822960" y="2977388"/>
+            <a:ext cx="10545775" cy="12700"/>
           </a:xfrm>
           <a:prstGeom prst="rect">
             <a:avLst/>
@@ -7946,12 +7946,12 @@
         </p:nvSpPr>
         <p:spPr>
           <a:xfrm>
-            <a:off x="777240" y="2350008"/>
-            <a:ext cx="585216" cy="585216"/>
+            <a:off x="822960" y="2267712"/>
+            <a:ext cx="512064" cy="512064"/>
           </a:xfrm>
           <a:prstGeom prst="roundRect">
             <a:avLst>
-              <a:gd name="adj" fmla="val 6000"/>
+              <a:gd name="adj" fmla="val 8000"/>
             </a:avLst>
           </a:prstGeom>
           <a:solidFill>
@@ -7982,7 +7982,7 @@
           <a:p>
             <a:pPr algn="ctr"/>
             <a:r>
-              <a:rPr sz="1800" b="1" i="0">
+              <a:rPr sz="1500" b="1" i="0">
                 <a:solidFill>
                   <a:srgbClr val="FFFFFF"/>
                 </a:solidFill>
@@ -8001,8 +8001,8 @@
         </p:nvSpPr>
         <p:spPr>
           <a:xfrm>
-            <a:off x="1691640" y="2331720"/>
-            <a:ext cx="9585655" cy="694944"/>
+            <a:off x="1691640" y="2258568"/>
+            <a:ext cx="9539935" cy="621792"/>
           </a:xfrm>
           <a:prstGeom prst="rect">
             <a:avLst/>
@@ -8021,7 +8021,7 @@
               </a:spcAft>
             </a:pPr>
             <a:r>
-              <a:rPr sz="1800" b="1" i="0">
+              <a:rPr sz="1500" b="1" i="0">
                 <a:solidFill>
                   <a:srgbClr val="0B2545"/>
                 </a:solidFill>
@@ -8033,17 +8033,17 @@
           <a:p>
             <a:pPr algn="l">
               <a:lnSpc>
-                <a:spcPct val="115000"/>
+                <a:spcPct val="125000"/>
               </a:lnSpc>
             </a:pPr>
             <a:r>
-              <a:rPr sz="1800" b="0" i="0">
+              <a:rPr sz="1250" b="0" i="0">
                 <a:solidFill>
                   <a:srgbClr val="5A7299"/>
                 </a:solidFill>
                 <a:latin typeface="Inter Tight"/>
               </a:rPr>
-              <a:t>914 linhas → 814 exames únicos (dedupe por sigla + modalidade).</a:t>
+              <a:t>Parseia as 914 linhas da planilha e deduplica por sigla + modalidade → 814 exames únicos.</a:t>
             </a:r>
           </a:p>
         </p:txBody>
@@ -8056,8 +8056,8 @@
         </p:nvSpPr>
         <p:spPr>
           <a:xfrm>
-            <a:off x="777240" y="4019804"/>
-            <a:ext cx="10637215" cy="12700"/>
+            <a:off x="822960" y="3818636"/>
+            <a:ext cx="10545775" cy="12700"/>
           </a:xfrm>
           <a:prstGeom prst="rect">
             <a:avLst/>
@@ -8100,12 +8100,12 @@
         </p:nvSpPr>
         <p:spPr>
           <a:xfrm>
-            <a:off x="777240" y="3246120"/>
-            <a:ext cx="585216" cy="585216"/>
+            <a:off x="822960" y="3108960"/>
+            <a:ext cx="512064" cy="512064"/>
           </a:xfrm>
           <a:prstGeom prst="roundRect">
             <a:avLst>
-              <a:gd name="adj" fmla="val 6000"/>
+              <a:gd name="adj" fmla="val 8000"/>
             </a:avLst>
           </a:prstGeom>
           <a:solidFill>
@@ -8136,7 +8136,7 @@
           <a:p>
             <a:pPr algn="ctr"/>
             <a:r>
-              <a:rPr sz="1800" b="1" i="0">
+              <a:rPr sz="1500" b="1" i="0">
                 <a:solidFill>
                   <a:srgbClr val="FFFFFF"/>
                 </a:solidFill>
@@ -8155,8 +8155,8 @@
         </p:nvSpPr>
         <p:spPr>
           <a:xfrm>
-            <a:off x="1691640" y="3227832"/>
-            <a:ext cx="9585655" cy="694944"/>
+            <a:off x="1691640" y="3099816"/>
+            <a:ext cx="9539935" cy="621792"/>
           </a:xfrm>
           <a:prstGeom prst="rect">
             <a:avLst/>
@@ -8175,7 +8175,7 @@
               </a:spcAft>
             </a:pPr>
             <a:r>
-              <a:rPr sz="1800" b="1" i="0">
+              <a:rPr sz="1500" b="1" i="0">
                 <a:solidFill>
                   <a:srgbClr val="0B2545"/>
                 </a:solidFill>
@@ -8187,17 +8187,17 @@
           <a:p>
             <a:pPr algn="l">
               <a:lnSpc>
-                <a:spcPct val="115000"/>
+                <a:spcPct val="125000"/>
               </a:lnSpc>
             </a:pPr>
             <a:r>
-              <a:rPr sz="1800" b="0" i="0">
+              <a:rPr sz="1250" b="0" i="0">
                 <a:solidFill>
                   <a:srgbClr val="5A7299"/>
                 </a:solidFill>
                 <a:latin typeface="Inter Tight"/>
               </a:rPr>
-              <a:t>preparo_id por modalidade + contraste + sedação, reusando preparos reais.</a:t>
+              <a:t>Cada exame recebe um preparo_id por modalidade, contraste e sedação, reusando os preparos reais.</a:t>
             </a:r>
           </a:p>
         </p:txBody>
@@ -8210,8 +8210,8 @@
         </p:nvSpPr>
         <p:spPr>
           <a:xfrm>
-            <a:off x="777240" y="4915916"/>
-            <a:ext cx="10637215" cy="12700"/>
+            <a:off x="822960" y="4659884"/>
+            <a:ext cx="10545775" cy="12700"/>
           </a:xfrm>
           <a:prstGeom prst="rect">
             <a:avLst/>
@@ -8254,12 +8254,12 @@
         </p:nvSpPr>
         <p:spPr>
           <a:xfrm>
-            <a:off x="777240" y="4142232"/>
-            <a:ext cx="585216" cy="585216"/>
+            <a:off x="822960" y="3950208"/>
+            <a:ext cx="512064" cy="512064"/>
           </a:xfrm>
           <a:prstGeom prst="roundRect">
             <a:avLst>
-              <a:gd name="adj" fmla="val 6000"/>
+              <a:gd name="adj" fmla="val 8000"/>
             </a:avLst>
           </a:prstGeom>
           <a:solidFill>
@@ -8290,7 +8290,7 @@
           <a:p>
             <a:pPr algn="ctr"/>
             <a:r>
-              <a:rPr sz="1800" b="1" i="0">
+              <a:rPr sz="1500" b="1" i="0">
                 <a:solidFill>
                   <a:srgbClr val="FFFFFF"/>
                 </a:solidFill>
@@ -8309,8 +8309,8 @@
         </p:nvSpPr>
         <p:spPr>
           <a:xfrm>
-            <a:off x="1691640" y="4123944"/>
-            <a:ext cx="9585655" cy="694944"/>
+            <a:off x="1691640" y="3941064"/>
+            <a:ext cx="9539935" cy="621792"/>
           </a:xfrm>
           <a:prstGeom prst="rect">
             <a:avLst/>
@@ -8329,7 +8329,7 @@
               </a:spcAft>
             </a:pPr>
             <a:r>
-              <a:rPr sz="1800" b="1" i="0">
+              <a:rPr sz="1500" b="1" i="0">
                 <a:solidFill>
                   <a:srgbClr val="0B2545"/>
                 </a:solidFill>
@@ -8341,17 +8341,17 @@
           <a:p>
             <a:pPr algn="l">
               <a:lnSpc>
-                <a:spcPct val="115000"/>
+                <a:spcPct val="125000"/>
               </a:lnSpc>
             </a:pPr>
             <a:r>
-              <a:rPr sz="1800" b="0" i="0">
+              <a:rPr sz="1250" b="0" i="0">
                 <a:solidFill>
                   <a:srgbClr val="5A7299"/>
                 </a:solidFill>
                 <a:latin typeface="Inter Tight"/>
               </a:rPr>
-              <a:t>Sem preparo confirmado → fallback. Nunca presume que dispensa preparo.</a:t>
+              <a:t>Exame sem preparo confirmado cai num fallback — nunca presume que dispensa preparo.</a:t>
             </a:r>
           </a:p>
         </p:txBody>
@@ -8364,8 +8364,8 @@
         </p:nvSpPr>
         <p:spPr>
           <a:xfrm>
-            <a:off x="777240" y="5812028"/>
-            <a:ext cx="10637215" cy="12700"/>
+            <a:off x="822960" y="5501132"/>
+            <a:ext cx="10545775" cy="12700"/>
           </a:xfrm>
           <a:prstGeom prst="rect">
             <a:avLst/>
@@ -8408,12 +8408,12 @@
         </p:nvSpPr>
         <p:spPr>
           <a:xfrm>
-            <a:off x="777240" y="5038344"/>
-            <a:ext cx="585216" cy="585216"/>
+            <a:off x="822960" y="4791456"/>
+            <a:ext cx="512064" cy="512064"/>
           </a:xfrm>
           <a:prstGeom prst="roundRect">
             <a:avLst>
-              <a:gd name="adj" fmla="val 6000"/>
+              <a:gd name="adj" fmla="val 8000"/>
             </a:avLst>
           </a:prstGeom>
           <a:solidFill>
@@ -8444,7 +8444,7 @@
           <a:p>
             <a:pPr algn="ctr"/>
             <a:r>
-              <a:rPr sz="1800" b="1" i="0">
+              <a:rPr sz="1500" b="1" i="0">
                 <a:solidFill>
                   <a:srgbClr val="FFFFFF"/>
                 </a:solidFill>
@@ -8463,8 +8463,8 @@
         </p:nvSpPr>
         <p:spPr>
           <a:xfrm>
-            <a:off x="1691640" y="5020056"/>
-            <a:ext cx="9585655" cy="694944"/>
+            <a:off x="1691640" y="4782312"/>
+            <a:ext cx="9539935" cy="621792"/>
           </a:xfrm>
           <a:prstGeom prst="rect">
             <a:avLst/>
@@ -8483,7 +8483,7 @@
               </a:spcAft>
             </a:pPr>
             <a:r>
-              <a:rPr sz="1800" b="1" i="0">
+              <a:rPr sz="1500" b="1" i="0">
                 <a:solidFill>
                   <a:srgbClr val="0B2545"/>
                 </a:solidFill>
@@ -8495,17 +8495,17 @@
           <a:p>
             <a:pPr algn="l">
               <a:lnSpc>
-                <a:spcPct val="115000"/>
+                <a:spcPct val="125000"/>
               </a:lnSpc>
             </a:pPr>
             <a:r>
-              <a:rPr sz="1800" b="0" i="0">
+              <a:rPr sz="1250" b="0" i="0">
                 <a:solidFill>
                   <a:srgbClr val="5A7299"/>
                 </a:solidFill>
                 <a:latin typeface="Inter Tight"/>
               </a:rPr>
-              <a:t>Todo preparo_id existe; senão falha. Determinístico e idempotente.</a:t>
+              <a:t>Todo preparo_id precisa existir; senão o script falha. Determinístico e idempotente.</a:t>
             </a:r>
           </a:p>
         </p:txBody>
@@ -8518,8 +8518,8 @@
         </p:nvSpPr>
         <p:spPr>
           <a:xfrm>
-            <a:off x="777240" y="6708140"/>
-            <a:ext cx="10637215" cy="12700"/>
+            <a:off x="822960" y="6342380"/>
+            <a:ext cx="10545775" cy="12700"/>
           </a:xfrm>
           <a:prstGeom prst="rect">
             <a:avLst/>
@@ -8562,12 +8562,12 @@
         </p:nvSpPr>
         <p:spPr>
           <a:xfrm>
-            <a:off x="777240" y="5934456"/>
-            <a:ext cx="585216" cy="585216"/>
+            <a:off x="822960" y="5632704"/>
+            <a:ext cx="512064" cy="512064"/>
           </a:xfrm>
           <a:prstGeom prst="roundRect">
             <a:avLst>
-              <a:gd name="adj" fmla="val 6000"/>
+              <a:gd name="adj" fmla="val 8000"/>
             </a:avLst>
           </a:prstGeom>
           <a:solidFill>
@@ -8598,7 +8598,7 @@
           <a:p>
             <a:pPr algn="ctr"/>
             <a:r>
-              <a:rPr sz="1800" b="1" i="0">
+              <a:rPr sz="1500" b="1" i="0">
                 <a:solidFill>
                   <a:srgbClr val="FFFFFF"/>
                 </a:solidFill>
@@ -8617,8 +8617,8 @@
         </p:nvSpPr>
         <p:spPr>
           <a:xfrm>
-            <a:off x="1691640" y="5916168"/>
-            <a:ext cx="9585655" cy="694944"/>
+            <a:off x="1691640" y="5623560"/>
+            <a:ext cx="9539935" cy="621792"/>
           </a:xfrm>
           <a:prstGeom prst="rect">
             <a:avLst/>
@@ -8637,7 +8637,7 @@
               </a:spcAft>
             </a:pPr>
             <a:r>
-              <a:rPr sz="1800" b="1" i="0">
+              <a:rPr sz="1500" b="1" i="0">
                 <a:solidFill>
                   <a:srgbClr val="0B2545"/>
                 </a:solidFill>
@@ -8649,17 +8649,17 @@
           <a:p>
             <a:pPr algn="l">
               <a:lnSpc>
-                <a:spcPct val="115000"/>
+                <a:spcPct val="125000"/>
               </a:lnSpc>
             </a:pPr>
             <a:r>
-              <a:rPr sz="1800" b="0" i="0">
+              <a:rPr sz="1250" b="0" i="0">
                 <a:solidFill>
                   <a:srgbClr val="5A7299"/>
                 </a:solidFill>
                 <a:latin typeface="Inter Tight"/>
               </a:rPr>
-              <a:t>Herança automática evita redigir 814 registros à mão. npm run ingest.</a:t>
+              <a:t>Herança automática (geral + modalidade) evita redigir 814 registros à mão. npm run ingest.</a:t>
             </a:r>
           </a:p>
         </p:txBody>
@@ -8734,8 +8734,8 @@
         </p:nvSpPr>
         <p:spPr>
           <a:xfrm>
-            <a:off x="10271455" y="640080"/>
-            <a:ext cx="1143000" cy="320040"/>
+            <a:off x="10362895" y="566928"/>
+            <a:ext cx="1051560" cy="320040"/>
           </a:xfrm>
           <a:prstGeom prst="rect">
             <a:avLst/>
@@ -8750,7 +8750,7 @@
           <a:p>
             <a:pPr algn="r"/>
             <a:r>
-              <a:rPr sz="1300" b="1" i="0" spc="150">
+              <a:rPr sz="1000" b="1" i="0" spc="180">
                 <a:solidFill>
                   <a:srgbClr val="5A7299"/>
                 </a:solidFill>
@@ -8769,8 +8769,8 @@
         </p:nvSpPr>
         <p:spPr>
           <a:xfrm>
-            <a:off x="777240" y="640080"/>
-            <a:ext cx="8351215" cy="365760"/>
+            <a:off x="822960" y="566928"/>
+            <a:ext cx="8534095" cy="365760"/>
           </a:xfrm>
           <a:prstGeom prst="rect">
             <a:avLst/>
@@ -8784,7 +8784,7 @@
           <a:lstStyle/>
           <a:p>
             <a:r>
-              <a:rPr sz="1300">
+              <a:rPr sz="1000">
                 <a:solidFill>
                   <a:srgbClr val="1D6FE0"/>
                 </a:solidFill>
@@ -8793,7 +8793,7 @@
               <a:t>● </a:t>
             </a:r>
             <a:r>
-              <a:rPr sz="1300" b="1" spc="240">
+              <a:rPr sz="1000" b="1" spc="260">
                 <a:solidFill>
                   <a:srgbClr val="5A7299"/>
                 </a:solidFill>
@@ -8812,8 +8812,8 @@
         </p:nvSpPr>
         <p:spPr>
           <a:xfrm>
-            <a:off x="777240" y="1097280"/>
-            <a:ext cx="10637215" cy="2011680"/>
+            <a:off x="822960" y="1051560"/>
+            <a:ext cx="10545775" cy="1371600"/>
           </a:xfrm>
           <a:prstGeom prst="rect">
             <a:avLst/>
@@ -8828,11 +8828,11 @@
           <a:p>
             <a:pPr>
               <a:lnSpc>
-                <a:spcPct val="102000"/>
+                <a:spcPct val="103000"/>
               </a:lnSpc>
             </a:pPr>
             <a:r>
-              <a:rPr sz="3600" i="0">
+              <a:rPr sz="3400" i="0">
                 <a:solidFill>
                   <a:srgbClr val="0B2545"/>
                 </a:solidFill>
@@ -8841,7 +8841,7 @@
               <a:t>Uma aplicação, </a:t>
             </a:r>
             <a:r>
-              <a:rPr sz="3600" i="1">
+              <a:rPr sz="3400" i="1">
                 <a:solidFill>
                   <a:srgbClr val="14418A"/>
                 </a:solidFill>
@@ -8860,12 +8860,12 @@
         </p:nvSpPr>
         <p:spPr>
           <a:xfrm>
-            <a:off x="777240" y="2148840"/>
-            <a:ext cx="10637215" cy="1097280"/>
+            <a:off x="822960" y="2194560"/>
+            <a:ext cx="10545775" cy="1097280"/>
           </a:xfrm>
           <a:prstGeom prst="roundRect">
             <a:avLst>
-              <a:gd name="adj" fmla="val 6000"/>
+              <a:gd name="adj" fmla="val 8000"/>
             </a:avLst>
           </a:prstGeom>
           <a:solidFill>
@@ -8908,8 +8908,8 @@
         </p:nvSpPr>
         <p:spPr>
           <a:xfrm>
-            <a:off x="1188720" y="2148840"/>
-            <a:ext cx="2377440" cy="1097280"/>
+            <a:off x="1234440" y="2194560"/>
+            <a:ext cx="2468880" cy="1097280"/>
           </a:xfrm>
           <a:prstGeom prst="rect">
             <a:avLst/>
@@ -8924,7 +8924,7 @@
           <a:p>
             <a:pPr algn="l"/>
             <a:r>
-              <a:rPr sz="1400" b="1" i="0" spc="120">
+              <a:rPr sz="1000" b="1" i="0" spc="140">
                 <a:solidFill>
                   <a:srgbClr val="1D6FE0"/>
                 </a:solidFill>
@@ -8943,8 +8943,8 @@
         </p:nvSpPr>
         <p:spPr>
           <a:xfrm>
-            <a:off x="3794760" y="2295144"/>
-            <a:ext cx="7253935" cy="822960"/>
+            <a:off x="3931920" y="2395728"/>
+            <a:ext cx="7071055" cy="731520"/>
           </a:xfrm>
           <a:prstGeom prst="rect">
             <a:avLst/>
@@ -8959,11 +8959,11 @@
           <a:p>
             <a:pPr algn="l">
               <a:spcAft>
-                <a:spcPts val="400"/>
+                <a:spcPts val="300"/>
               </a:spcAft>
             </a:pPr>
             <a:r>
-              <a:rPr sz="2000" b="1" i="0">
+              <a:rPr sz="1700" b="1" i="0">
                 <a:solidFill>
                   <a:srgbClr val="0B2545"/>
                 </a:solidFill>
@@ -8975,17 +8975,17 @@
           <a:p>
             <a:pPr algn="l">
               <a:lnSpc>
-                <a:spcPct val="115000"/>
+                <a:spcPct val="125000"/>
               </a:lnSpc>
             </a:pPr>
             <a:r>
-              <a:rPr sz="1800" b="0" i="0">
+              <a:rPr sz="1250" b="0" i="0">
                 <a:solidFill>
                   <a:srgbClr val="5A7299"/>
                 </a:solidFill>
                 <a:latin typeface="Inter Tight"/>
               </a:rPr>
-              <a:t>Chat, picker guiado e seletor de perfil. Servido por CDN.</a:t>
+              <a:t>Chat, picker guiado e seletor de perfil, responsivo. Servido por CDN.</a:t>
             </a:r>
           </a:p>
         </p:txBody>
@@ -8998,8 +8998,8 @@
         </p:nvSpPr>
         <p:spPr>
           <a:xfrm>
-            <a:off x="1188720" y="3191256"/>
-            <a:ext cx="2377440" cy="347472"/>
+            <a:off x="1234440" y="3255264"/>
+            <a:ext cx="2468880" cy="384048"/>
           </a:xfrm>
           <a:prstGeom prst="rect">
             <a:avLst/>
@@ -9014,7 +9014,7 @@
           <a:p>
             <a:pPr algn="ctr"/>
             <a:r>
-              <a:rPr sz="1800" b="0" i="0">
+              <a:rPr sz="1500" b="0" i="0">
                 <a:solidFill>
                   <a:srgbClr val="5A7299"/>
                 </a:solidFill>
@@ -9033,12 +9033,12 @@
         </p:nvSpPr>
         <p:spPr>
           <a:xfrm>
-            <a:off x="777240" y="3593592"/>
-            <a:ext cx="10637215" cy="1097280"/>
+            <a:off x="822960" y="3675888"/>
+            <a:ext cx="10545775" cy="1097280"/>
           </a:xfrm>
           <a:prstGeom prst="roundRect">
             <a:avLst>
-              <a:gd name="adj" fmla="val 6000"/>
+              <a:gd name="adj" fmla="val 8000"/>
             </a:avLst>
           </a:prstGeom>
           <a:solidFill>
@@ -9081,8 +9081,8 @@
         </p:nvSpPr>
         <p:spPr>
           <a:xfrm>
-            <a:off x="1188720" y="3593592"/>
-            <a:ext cx="2377440" cy="1097280"/>
+            <a:off x="1234440" y="3675888"/>
+            <a:ext cx="2468880" cy="1097280"/>
           </a:xfrm>
           <a:prstGeom prst="rect">
             <a:avLst/>
@@ -9097,7 +9097,7 @@
           <a:p>
             <a:pPr algn="l"/>
             <a:r>
-              <a:rPr sz="1400" b="1" i="0" spc="120">
+              <a:rPr sz="1000" b="1" i="0" spc="140">
                 <a:solidFill>
                   <a:srgbClr val="1D6FE0"/>
                 </a:solidFill>
@@ -9116,8 +9116,8 @@
         </p:nvSpPr>
         <p:spPr>
           <a:xfrm>
-            <a:off x="3794760" y="3739896"/>
-            <a:ext cx="7253935" cy="822960"/>
+            <a:off x="3931920" y="3877056"/>
+            <a:ext cx="7071055" cy="731520"/>
           </a:xfrm>
           <a:prstGeom prst="rect">
             <a:avLst/>
@@ -9132,11 +9132,11 @@
           <a:p>
             <a:pPr algn="l">
               <a:spcAft>
-                <a:spcPts val="400"/>
+                <a:spcPts val="300"/>
               </a:spcAft>
             </a:pPr>
             <a:r>
-              <a:rPr sz="2000" b="1" i="0">
+              <a:rPr sz="1700" b="1" i="0">
                 <a:solidFill>
                   <a:srgbClr val="0B2545"/>
                 </a:solidFill>
@@ -9148,17 +9148,17 @@
           <a:p>
             <a:pPr algn="l">
               <a:lnSpc>
-                <a:spcPct val="115000"/>
+                <a:spcPct val="125000"/>
               </a:lnSpc>
             </a:pPr>
             <a:r>
-              <a:rPr sz="1800" b="0" i="0">
+              <a:rPr sz="1250" b="0" i="0">
                 <a:solidFill>
                   <a:srgbClr val="5A7299"/>
                 </a:solidFill>
                 <a:latin typeface="Inter Tight"/>
               </a:rPr>
-              <a:t>Busca o exame, monta o contexto por perfil e chama o modelo.</a:t>
+              <a:t>Busca o exame, monta o contexto por perfil e chama o modelo. Sem servidor a gerenciar.</a:t>
             </a:r>
           </a:p>
         </p:txBody>
@@ -9171,8 +9171,8 @@
         </p:nvSpPr>
         <p:spPr>
           <a:xfrm>
-            <a:off x="1188720" y="4636008"/>
-            <a:ext cx="2377440" cy="347472"/>
+            <a:off x="1234440" y="4736592"/>
+            <a:ext cx="2468880" cy="384048"/>
           </a:xfrm>
           <a:prstGeom prst="rect">
             <a:avLst/>
@@ -9187,7 +9187,7 @@
           <a:p>
             <a:pPr algn="ctr"/>
             <a:r>
-              <a:rPr sz="1800" b="0" i="0">
+              <a:rPr sz="1500" b="0" i="0">
                 <a:solidFill>
                   <a:srgbClr val="5A7299"/>
                 </a:solidFill>
@@ -9206,12 +9206,12 @@
         </p:nvSpPr>
         <p:spPr>
           <a:xfrm>
-            <a:off x="777240" y="5038344"/>
-            <a:ext cx="10637215" cy="1097280"/>
+            <a:off x="822960" y="5157216"/>
+            <a:ext cx="10545775" cy="1097280"/>
           </a:xfrm>
           <a:prstGeom prst="roundRect">
             <a:avLst>
-              <a:gd name="adj" fmla="val 6000"/>
+              <a:gd name="adj" fmla="val 8000"/>
             </a:avLst>
           </a:prstGeom>
           <a:solidFill>
@@ -9254,8 +9254,8 @@
         </p:nvSpPr>
         <p:spPr>
           <a:xfrm>
-            <a:off x="1188720" y="5038344"/>
-            <a:ext cx="2377440" cy="1097280"/>
+            <a:off x="1234440" y="5157216"/>
+            <a:ext cx="2468880" cy="1097280"/>
           </a:xfrm>
           <a:prstGeom prst="rect">
             <a:avLst/>
@@ -9270,7 +9270,7 @@
           <a:p>
             <a:pPr algn="l"/>
             <a:r>
-              <a:rPr sz="1400" b="1" i="0" spc="120">
+              <a:rPr sz="1000" b="1" i="0" spc="140">
                 <a:solidFill>
                   <a:srgbClr val="1D6FE0"/>
                 </a:solidFill>
@@ -9289,8 +9289,8 @@
         </p:nvSpPr>
         <p:spPr>
           <a:xfrm>
-            <a:off x="3794760" y="5184648"/>
-            <a:ext cx="7253935" cy="822960"/>
+            <a:off x="3931920" y="5358384"/>
+            <a:ext cx="7071055" cy="731520"/>
           </a:xfrm>
           <a:prstGeom prst="rect">
             <a:avLst/>
@@ -9305,33 +9305,33 @@
           <a:p>
             <a:pPr algn="l">
               <a:spcAft>
-                <a:spcPts val="400"/>
+                <a:spcPts val="300"/>
               </a:spcAft>
             </a:pPr>
             <a:r>
-              <a:rPr sz="2000" b="1" i="0">
+              <a:rPr sz="1700" b="1" i="0">
                 <a:solidFill>
                   <a:srgbClr val="0B2545"/>
                 </a:solidFill>
                 <a:latin typeface="Inter Tight"/>
               </a:rPr>
-              <a:t>JSON + busca textual</a:t>
+              <a:t>JSON + busca textual em memória</a:t>
             </a:r>
           </a:p>
           <a:p>
             <a:pPr algn="l">
               <a:lnSpc>
-                <a:spcPct val="115000"/>
+                <a:spcPct val="125000"/>
               </a:lnSpc>
             </a:pPr>
             <a:r>
-              <a:rPr sz="1800" b="0" i="0">
+              <a:rPr sz="1250" b="0" i="0">
                 <a:solidFill>
                   <a:srgbClr val="5A7299"/>
                 </a:solidFill>
                 <a:latin typeface="Inter Tight"/>
               </a:rPr>
-              <a:t>814 exames; busca instantânea, sem banco vetorial.</a:t>
+              <a:t>814 exames; busca por nome, sigla e sinônimos é instantânea — sem banco vetorial.</a:t>
             </a:r>
           </a:p>
         </p:txBody>
@@ -9344,8 +9344,8 @@
         </p:nvSpPr>
         <p:spPr>
           <a:xfrm>
-            <a:off x="777240" y="6309360"/>
-            <a:ext cx="10637215" cy="320040"/>
+            <a:off x="822960" y="6327648"/>
+            <a:ext cx="10545775" cy="292608"/>
           </a:xfrm>
           <a:prstGeom prst="rect">
             <a:avLst/>
@@ -9360,7 +9360,7 @@
           <a:p>
             <a:pPr algn="l"/>
             <a:r>
-              <a:rPr sz="1300" b="0" i="0" spc="40">
+              <a:rPr sz="950" b="0" i="0" spc="30">
                 <a:solidFill>
                   <a:srgbClr val="5A7299"/>
                 </a:solidFill>
@@ -9441,8 +9441,8 @@
         </p:nvSpPr>
         <p:spPr>
           <a:xfrm>
-            <a:off x="10271455" y="640080"/>
-            <a:ext cx="1143000" cy="320040"/>
+            <a:off x="10362895" y="566928"/>
+            <a:ext cx="1051560" cy="320040"/>
           </a:xfrm>
           <a:prstGeom prst="rect">
             <a:avLst/>
@@ -9457,7 +9457,7 @@
           <a:p>
             <a:pPr algn="r"/>
             <a:r>
-              <a:rPr sz="1300" b="1" i="0" spc="150">
+              <a:rPr sz="1000" b="1" i="0" spc="180">
                 <a:solidFill>
                   <a:srgbClr val="5A7299"/>
                 </a:solidFill>
@@ -9476,8 +9476,8 @@
         </p:nvSpPr>
         <p:spPr>
           <a:xfrm>
-            <a:off x="777240" y="640080"/>
-            <a:ext cx="8351215" cy="365760"/>
+            <a:off x="822960" y="566928"/>
+            <a:ext cx="8534095" cy="365760"/>
           </a:xfrm>
           <a:prstGeom prst="rect">
             <a:avLst/>
@@ -9491,7 +9491,7 @@
           <a:lstStyle/>
           <a:p>
             <a:r>
-              <a:rPr sz="1300">
+              <a:rPr sz="1000">
                 <a:solidFill>
                   <a:srgbClr val="1D6FE0"/>
                 </a:solidFill>
@@ -9500,7 +9500,7 @@
               <a:t>● </a:t>
             </a:r>
             <a:r>
-              <a:rPr sz="1300" b="1" spc="240">
+              <a:rPr sz="1000" b="1" spc="260">
                 <a:solidFill>
                   <a:srgbClr val="5A7299"/>
                 </a:solidFill>
@@ -9519,8 +9519,8 @@
         </p:nvSpPr>
         <p:spPr>
           <a:xfrm>
-            <a:off x="777240" y="1097280"/>
-            <a:ext cx="10637215" cy="2011680"/>
+            <a:off x="822960" y="1051560"/>
+            <a:ext cx="10545775" cy="1371600"/>
           </a:xfrm>
           <a:prstGeom prst="rect">
             <a:avLst/>
@@ -9535,11 +9535,11 @@
           <a:p>
             <a:pPr>
               <a:lnSpc>
-                <a:spcPct val="102000"/>
+                <a:spcPct val="103000"/>
               </a:lnSpc>
             </a:pPr>
             <a:r>
-              <a:rPr sz="3600" i="0">
+              <a:rPr sz="3400" i="0">
                 <a:solidFill>
                   <a:srgbClr val="0B2545"/>
                 </a:solidFill>
@@ -9548,7 +9548,7 @@
               <a:t>Assistente </a:t>
             </a:r>
             <a:r>
-              <a:rPr sz="3600" i="1">
+              <a:rPr sz="3400" i="1">
                 <a:solidFill>
                   <a:srgbClr val="14418A"/>
                 </a:solidFill>
@@ -9557,7 +9557,7 @@
               <a:t>funcional e navegável</a:t>
             </a:r>
             <a:r>
-              <a:rPr sz="3600" i="0">
+              <a:rPr sz="3400" i="0">
                 <a:solidFill>
                   <a:srgbClr val="0B2545"/>
                 </a:solidFill>
@@ -9576,8 +9576,8 @@
         </p:nvSpPr>
         <p:spPr>
           <a:xfrm>
-            <a:off x="777240" y="2240280"/>
-            <a:ext cx="38100" cy="1417320"/>
+            <a:off x="822960" y="2194560"/>
+            <a:ext cx="38100" cy="1280160"/>
           </a:xfrm>
           <a:prstGeom prst="rect">
             <a:avLst/>
@@ -9620,8 +9620,8 @@
         </p:nvSpPr>
         <p:spPr>
           <a:xfrm>
-            <a:off x="1033272" y="2194560"/>
-            <a:ext cx="2197531" cy="1554480"/>
+            <a:off x="1051560" y="2148840"/>
+            <a:ext cx="2202103" cy="1463040"/>
           </a:xfrm>
           <a:prstGeom prst="rect">
             <a:avLst/>
@@ -9640,7 +9640,7 @@
               </a:spcAft>
             </a:pPr>
             <a:r>
-              <a:rPr sz="4200" b="0" i="0">
+              <a:rPr sz="4000" b="0" i="0">
                 <a:solidFill>
                   <a:srgbClr val="14418A"/>
                 </a:solidFill>
@@ -9652,11 +9652,11 @@
           <a:p>
             <a:pPr algn="l">
               <a:lnSpc>
-                <a:spcPct val="115000"/>
+                <a:spcPct val="125000"/>
               </a:lnSpc>
             </a:pPr>
             <a:r>
-              <a:rPr sz="1800" b="0" i="0">
+              <a:rPr sz="1250" b="0" i="0">
                 <a:solidFill>
                   <a:srgbClr val="5A7299"/>
                 </a:solidFill>
@@ -9675,8 +9675,8 @@
         </p:nvSpPr>
         <p:spPr>
           <a:xfrm>
-            <a:off x="3505123" y="2240280"/>
-            <a:ext cx="38100" cy="1417320"/>
+            <a:off x="3527983" y="2194560"/>
+            <a:ext cx="38100" cy="1280160"/>
           </a:xfrm>
           <a:prstGeom prst="rect">
             <a:avLst/>
@@ -9719,8 +9719,8 @@
         </p:nvSpPr>
         <p:spPr>
           <a:xfrm>
-            <a:off x="3761155" y="2194560"/>
-            <a:ext cx="2197531" cy="1554480"/>
+            <a:off x="3756583" y="2148840"/>
+            <a:ext cx="2202103" cy="1463040"/>
           </a:xfrm>
           <a:prstGeom prst="rect">
             <a:avLst/>
@@ -9739,7 +9739,7 @@
               </a:spcAft>
             </a:pPr>
             <a:r>
-              <a:rPr sz="4200" b="0" i="0">
+              <a:rPr sz="4000" b="0" i="0">
                 <a:solidFill>
                   <a:srgbClr val="14418A"/>
                 </a:solidFill>
@@ -9751,11 +9751,11 @@
           <a:p>
             <a:pPr algn="l">
               <a:lnSpc>
-                <a:spcPct val="115000"/>
+                <a:spcPct val="125000"/>
               </a:lnSpc>
             </a:pPr>
             <a:r>
-              <a:rPr sz="1800" b="0" i="0">
+              <a:rPr sz="1250" b="0" i="0">
                 <a:solidFill>
                   <a:srgbClr val="5A7299"/>
                 </a:solidFill>
@@ -9774,8 +9774,8 @@
         </p:nvSpPr>
         <p:spPr>
           <a:xfrm>
-            <a:off x="6233007" y="2240280"/>
-            <a:ext cx="38100" cy="1417320"/>
+            <a:off x="6233007" y="2194560"/>
+            <a:ext cx="38100" cy="1280160"/>
           </a:xfrm>
           <a:prstGeom prst="rect">
             <a:avLst/>
@@ -9818,8 +9818,8 @@
         </p:nvSpPr>
         <p:spPr>
           <a:xfrm>
-            <a:off x="6489039" y="2194560"/>
-            <a:ext cx="2197531" cy="1554480"/>
+            <a:off x="6461607" y="2148840"/>
+            <a:ext cx="2202103" cy="1463040"/>
           </a:xfrm>
           <a:prstGeom prst="rect">
             <a:avLst/>
@@ -9838,7 +9838,7 @@
               </a:spcAft>
             </a:pPr>
             <a:r>
-              <a:rPr sz="4200" b="0" i="0">
+              <a:rPr sz="4000" b="0" i="0">
                 <a:solidFill>
                   <a:srgbClr val="14418A"/>
                 </a:solidFill>
@@ -9850,11 +9850,11 @@
           <a:p>
             <a:pPr algn="l">
               <a:lnSpc>
-                <a:spcPct val="115000"/>
+                <a:spcPct val="125000"/>
               </a:lnSpc>
             </a:pPr>
             <a:r>
-              <a:rPr sz="1800" b="0" i="0">
+              <a:rPr sz="1250" b="0" i="0">
                 <a:solidFill>
                   <a:srgbClr val="5A7299"/>
                 </a:solidFill>
@@ -9873,8 +9873,8 @@
         </p:nvSpPr>
         <p:spPr>
           <a:xfrm>
-            <a:off x="8960891" y="2240280"/>
-            <a:ext cx="38100" cy="1417320"/>
+            <a:off x="8938031" y="2194560"/>
+            <a:ext cx="38100" cy="1280160"/>
           </a:xfrm>
           <a:prstGeom prst="rect">
             <a:avLst/>
@@ -9917,8 +9917,8 @@
         </p:nvSpPr>
         <p:spPr>
           <a:xfrm>
-            <a:off x="9216923" y="2194560"/>
-            <a:ext cx="2197531" cy="1554480"/>
+            <a:off x="9166631" y="2148840"/>
+            <a:ext cx="2202103" cy="1463040"/>
           </a:xfrm>
           <a:prstGeom prst="rect">
             <a:avLst/>
@@ -9937,7 +9937,7 @@
               </a:spcAft>
             </a:pPr>
             <a:r>
-              <a:rPr sz="4200" b="0" i="0">
+              <a:rPr sz="4000" b="0" i="0">
                 <a:solidFill>
                   <a:srgbClr val="14418A"/>
                 </a:solidFill>
@@ -9949,11 +9949,11 @@
           <a:p>
             <a:pPr algn="l">
               <a:lnSpc>
-                <a:spcPct val="115000"/>
+                <a:spcPct val="125000"/>
               </a:lnSpc>
             </a:pPr>
             <a:r>
-              <a:rPr sz="1800" b="0" i="0">
+              <a:rPr sz="1250" b="0" i="0">
                 <a:solidFill>
                   <a:srgbClr val="5A7299"/>
                 </a:solidFill>
@@ -9972,12 +9972,12 @@
         </p:nvSpPr>
         <p:spPr>
           <a:xfrm>
-            <a:off x="777240" y="4069080"/>
-            <a:ext cx="3332378" cy="2011680"/>
+            <a:off x="822960" y="4069080"/>
+            <a:ext cx="3301898" cy="1828800"/>
           </a:xfrm>
           <a:prstGeom prst="roundRect">
             <a:avLst>
-              <a:gd name="adj" fmla="val 6000"/>
+              <a:gd name="adj" fmla="val 8000"/>
             </a:avLst>
           </a:prstGeom>
           <a:solidFill>
@@ -10020,8 +10020,8 @@
         </p:nvSpPr>
         <p:spPr>
           <a:xfrm>
-            <a:off x="1069848" y="4343400"/>
-            <a:ext cx="2747162" cy="1508760"/>
+            <a:off x="1097280" y="4325112"/>
+            <a:ext cx="2753258" cy="1371600"/>
           </a:xfrm>
           <a:prstGeom prst="rect">
             <a:avLst/>
@@ -10036,11 +10036,11 @@
           <a:p>
             <a:pPr algn="l">
               <a:spcAft>
-                <a:spcPts val="800"/>
+                <a:spcPts val="600"/>
               </a:spcAft>
             </a:pPr>
             <a:r>
-              <a:rPr sz="1300" b="1" i="0" spc="100">
+              <a:rPr sz="1000" b="1" i="0" spc="100">
                 <a:solidFill>
                   <a:srgbClr val="1D6FE0"/>
                 </a:solidFill>
@@ -10052,11 +10052,11 @@
           <a:p>
             <a:pPr algn="l">
               <a:spcAft>
-                <a:spcPts val="800"/>
+                <a:spcPts val="600"/>
               </a:spcAft>
             </a:pPr>
             <a:r>
-              <a:rPr sz="2000" b="0" i="0">
+              <a:rPr sz="1800" b="0" i="0">
                 <a:solidFill>
                   <a:srgbClr val="0B2545"/>
                 </a:solidFill>
@@ -10068,17 +10068,17 @@
           <a:p>
             <a:pPr algn="l">
               <a:lnSpc>
-                <a:spcPct val="122000"/>
+                <a:spcPct val="130000"/>
               </a:lnSpc>
             </a:pPr>
             <a:r>
-              <a:rPr sz="1800" b="0" i="0">
+              <a:rPr sz="1250" b="0" i="0">
                 <a:solidFill>
                   <a:srgbClr val="5A7299"/>
                 </a:solidFill>
                 <a:latin typeface="Inter Tight"/>
               </a:rPr>
-              <a:t>Modalidade → exame → contraste / sedação. Pedido da Karol.</a:t>
+              <a:t>Modalidade → exame → contraste / sedação / lado, com busca. Pedido da Karol no 3º checkpoint.</a:t>
             </a:r>
           </a:p>
         </p:txBody>
@@ -10091,12 +10091,12 @@
         </p:nvSpPr>
         <p:spPr>
           <a:xfrm>
-            <a:off x="4429658" y="4069080"/>
-            <a:ext cx="3332378" cy="2011680"/>
+            <a:off x="4444898" y="4069080"/>
+            <a:ext cx="3301898" cy="1828800"/>
           </a:xfrm>
           <a:prstGeom prst="roundRect">
             <a:avLst>
-              <a:gd name="adj" fmla="val 6000"/>
+              <a:gd name="adj" fmla="val 8000"/>
             </a:avLst>
           </a:prstGeom>
           <a:solidFill>
@@ -10139,8 +10139,8 @@
         </p:nvSpPr>
         <p:spPr>
           <a:xfrm>
-            <a:off x="4722266" y="4343400"/>
-            <a:ext cx="2747162" cy="1508760"/>
+            <a:off x="4719218" y="4325112"/>
+            <a:ext cx="2753258" cy="1371600"/>
           </a:xfrm>
           <a:prstGeom prst="rect">
             <a:avLst/>
@@ -10155,11 +10155,11 @@
           <a:p>
             <a:pPr algn="l">
               <a:spcAft>
-                <a:spcPts val="800"/>
+                <a:spcPts val="600"/>
               </a:spcAft>
             </a:pPr>
             <a:r>
-              <a:rPr sz="1300" b="1" i="0" spc="100">
+              <a:rPr sz="1000" b="1" i="0" spc="100">
                 <a:solidFill>
                   <a:srgbClr val="1D6FE0"/>
                 </a:solidFill>
@@ -10171,11 +10171,11 @@
           <a:p>
             <a:pPr algn="l">
               <a:spcAft>
-                <a:spcPts val="800"/>
+                <a:spcPts val="600"/>
               </a:spcAft>
             </a:pPr>
             <a:r>
-              <a:rPr sz="2000" b="0" i="0">
+              <a:rPr sz="1800" b="0" i="0">
                 <a:solidFill>
                   <a:srgbClr val="0B2545"/>
                 </a:solidFill>
@@ -10187,17 +10187,17 @@
           <a:p>
             <a:pPr algn="l">
               <a:lnSpc>
-                <a:spcPct val="122000"/>
+                <a:spcPct val="130000"/>
               </a:lnSpc>
             </a:pPr>
             <a:r>
-              <a:rPr sz="1800" b="0" i="0">
+              <a:rPr sz="1250" b="0" i="0">
                 <a:solidFill>
                   <a:srgbClr val="5A7299"/>
                 </a:solidFill>
                 <a:latin typeface="Inter Tight"/>
               </a:rPr>
-              <a:t>Profissional busca o exame e recebe o código. Paciente nunca vê.</a:t>
+              <a:t>O profissional busca o exame e recebe o código para o cadastro. O paciente nunca vê.</a:t>
             </a:r>
           </a:p>
         </p:txBody>
@@ -10210,12 +10210,12 @@
         </p:nvSpPr>
         <p:spPr>
           <a:xfrm>
-            <a:off x="8082076" y="4069080"/>
-            <a:ext cx="3332378" cy="2011680"/>
+            <a:off x="8066836" y="4069080"/>
+            <a:ext cx="3301898" cy="1828800"/>
           </a:xfrm>
           <a:prstGeom prst="roundRect">
             <a:avLst>
-              <a:gd name="adj" fmla="val 6000"/>
+              <a:gd name="adj" fmla="val 8000"/>
             </a:avLst>
           </a:prstGeom>
           <a:solidFill>
@@ -10258,8 +10258,8 @@
         </p:nvSpPr>
         <p:spPr>
           <a:xfrm>
-            <a:off x="8374684" y="4343400"/>
-            <a:ext cx="2747162" cy="1508760"/>
+            <a:off x="8341156" y="4325112"/>
+            <a:ext cx="2753258" cy="1371600"/>
           </a:xfrm>
           <a:prstGeom prst="rect">
             <a:avLst/>
@@ -10274,11 +10274,11 @@
           <a:p>
             <a:pPr algn="l">
               <a:spcAft>
-                <a:spcPts val="800"/>
+                <a:spcPts val="600"/>
               </a:spcAft>
             </a:pPr>
             <a:r>
-              <a:rPr sz="1300" b="1" i="0" spc="100">
+              <a:rPr sz="1000" b="1" i="0" spc="100">
                 <a:solidFill>
                   <a:srgbClr val="1D6FE0"/>
                 </a:solidFill>
@@ -10290,11 +10290,11 @@
           <a:p>
             <a:pPr algn="l">
               <a:spcAft>
-                <a:spcPts val="800"/>
+                <a:spcPts val="600"/>
               </a:spcAft>
             </a:pPr>
             <a:r>
-              <a:rPr sz="2000" b="0" i="0">
+              <a:rPr sz="1800" b="0" i="0">
                 <a:solidFill>
                   <a:srgbClr val="0B2545"/>
                 </a:solidFill>
@@ -10306,17 +10306,17 @@
           <a:p>
             <a:pPr algn="l">
               <a:lnSpc>
-                <a:spcPct val="122000"/>
+                <a:spcPct val="130000"/>
               </a:lnSpc>
             </a:pPr>
             <a:r>
-              <a:rPr sz="1800" b="0" i="0">
+              <a:rPr sz="1250" b="0" i="0">
                 <a:solidFill>
                   <a:srgbClr val="5A7299"/>
                 </a:solidFill>
                 <a:latin typeface="Inter Tight"/>
               </a:rPr>
-              <a:t>Recusa quando falta info; pendentes roteados ao setor.</a:t>
+              <a:t>Recusa explícita quando falta info; pendentes roteados ao setor. Não substitui a equipe.</a:t>
             </a:r>
           </a:p>
         </p:txBody>
@@ -10391,8 +10391,8 @@
         </p:nvSpPr>
         <p:spPr>
           <a:xfrm>
-            <a:off x="10271455" y="640080"/>
-            <a:ext cx="1143000" cy="320040"/>
+            <a:off x="10362895" y="566928"/>
+            <a:ext cx="1051560" cy="320040"/>
           </a:xfrm>
           <a:prstGeom prst="rect">
             <a:avLst/>
@@ -10407,7 +10407,7 @@
           <a:p>
             <a:pPr algn="r"/>
             <a:r>
-              <a:rPr sz="1300" b="1" i="0" spc="150">
+              <a:rPr sz="1000" b="1" i="0" spc="180">
                 <a:solidFill>
                   <a:srgbClr val="5A7299"/>
                 </a:solidFill>
@@ -10426,8 +10426,8 @@
         </p:nvSpPr>
         <p:spPr>
           <a:xfrm>
-            <a:off x="777240" y="640080"/>
-            <a:ext cx="8351215" cy="365760"/>
+            <a:off x="822960" y="566928"/>
+            <a:ext cx="8534095" cy="365760"/>
           </a:xfrm>
           <a:prstGeom prst="rect">
             <a:avLst/>
@@ -10441,7 +10441,7 @@
           <a:lstStyle/>
           <a:p>
             <a:r>
-              <a:rPr sz="1300">
+              <a:rPr sz="1000">
                 <a:solidFill>
                   <a:srgbClr val="1D6FE0"/>
                 </a:solidFill>
@@ -10450,7 +10450,7 @@
               <a:t>● </a:t>
             </a:r>
             <a:r>
-              <a:rPr sz="1300" b="1" spc="240">
+              <a:rPr sz="1000" b="1" spc="260">
                 <a:solidFill>
                   <a:srgbClr val="5A7299"/>
                 </a:solidFill>
@@ -10469,8 +10469,8 @@
         </p:nvSpPr>
         <p:spPr>
           <a:xfrm>
-            <a:off x="777240" y="1097280"/>
-            <a:ext cx="10637215" cy="2011680"/>
+            <a:off x="822960" y="1051560"/>
+            <a:ext cx="10545775" cy="1371600"/>
           </a:xfrm>
           <a:prstGeom prst="rect">
             <a:avLst/>
@@ -10485,11 +10485,11 @@
           <a:p>
             <a:pPr>
               <a:lnSpc>
-                <a:spcPct val="102000"/>
+                <a:spcPct val="103000"/>
               </a:lnSpc>
             </a:pPr>
             <a:r>
-              <a:rPr sz="3600" i="0">
+              <a:rPr sz="3400" i="0">
                 <a:solidFill>
                   <a:srgbClr val="0B2545"/>
                 </a:solidFill>
@@ -10498,7 +10498,7 @@
               <a:t>Da pergunta à orientação, </a:t>
             </a:r>
             <a:r>
-              <a:rPr sz="3600" i="1">
+              <a:rPr sz="3400" i="1">
                 <a:solidFill>
                   <a:srgbClr val="14418A"/>
                 </a:solidFill>
@@ -10517,12 +10517,12 @@
         </p:nvSpPr>
         <p:spPr>
           <a:xfrm>
-            <a:off x="777240" y="2057400"/>
-            <a:ext cx="5669280" cy="4343400"/>
+            <a:off x="822960" y="2148840"/>
+            <a:ext cx="5669280" cy="4114800"/>
           </a:xfrm>
           <a:prstGeom prst="roundRect">
             <a:avLst>
-              <a:gd name="adj" fmla="val 6000"/>
+              <a:gd name="adj" fmla="val 8000"/>
             </a:avLst>
           </a:prstGeom>
           <a:solidFill>
@@ -10565,8 +10565,8 @@
         </p:nvSpPr>
         <p:spPr>
           <a:xfrm>
-            <a:off x="777240" y="2057400"/>
-            <a:ext cx="5669280" cy="640080"/>
+            <a:off x="822960" y="2148840"/>
+            <a:ext cx="5669280" cy="621792"/>
           </a:xfrm>
           <a:prstGeom prst="rect">
             <a:avLst/>
@@ -10609,8 +10609,8 @@
         </p:nvSpPr>
         <p:spPr>
           <a:xfrm>
-            <a:off x="1051560" y="2057400"/>
-            <a:ext cx="3657600" cy="685800"/>
+            <a:off x="1097280" y="2148840"/>
+            <a:ext cx="3657600" cy="621792"/>
           </a:xfrm>
           <a:prstGeom prst="rect">
             <a:avLst/>
@@ -10625,7 +10625,7 @@
           <a:p>
             <a:pPr algn="l"/>
             <a:r>
-              <a:rPr sz="1500" b="0" i="0">
+              <a:rPr sz="1400" b="0" i="0">
                 <a:solidFill>
                   <a:srgbClr val="0B2545"/>
                 </a:solidFill>
@@ -10644,12 +10644,12 @@
         </p:nvSpPr>
         <p:spPr>
           <a:xfrm>
-            <a:off x="4892040" y="2221992"/>
-            <a:ext cx="1280160" cy="365760"/>
+            <a:off x="5029200" y="2304288"/>
+            <a:ext cx="1188720" cy="329184"/>
           </a:xfrm>
           <a:prstGeom prst="roundRect">
             <a:avLst>
-              <a:gd name="adj" fmla="val 6000"/>
+              <a:gd name="adj" fmla="val 8000"/>
             </a:avLst>
           </a:prstGeom>
           <a:solidFill>
@@ -10682,7 +10682,7 @@
           <a:p>
             <a:pPr algn="ctr"/>
             <a:r>
-              <a:rPr sz="1300" b="1" i="0">
+              <a:rPr sz="1000" b="1" i="0">
                 <a:solidFill>
                   <a:srgbClr val="14418A"/>
                 </a:solidFill>
@@ -10701,12 +10701,12 @@
         </p:nvSpPr>
         <p:spPr>
           <a:xfrm>
-            <a:off x="2606040" y="2807208"/>
-            <a:ext cx="3566160" cy="640080"/>
+            <a:off x="2834640" y="3017520"/>
+            <a:ext cx="3383280" cy="603504"/>
           </a:xfrm>
           <a:prstGeom prst="roundRect">
             <a:avLst>
-              <a:gd name="adj" fmla="val 6000"/>
+              <a:gd name="adj" fmla="val 8000"/>
             </a:avLst>
           </a:prstGeom>
           <a:solidFill>
@@ -10732,16 +10732,16 @@
           </a:fontRef>
         </p:style>
         <p:txBody>
-          <a:bodyPr rtlCol="0" anchor="ctr" wrap="square" lIns="139700" rIns="139700" tIns="88900" bIns="88900"/>
+          <a:bodyPr rtlCol="0" anchor="ctr" wrap="square" lIns="127000" rIns="127000" tIns="88900" bIns="88900"/>
           <a:lstStyle/>
           <a:p>
             <a:pPr algn="l">
               <a:lnSpc>
-                <a:spcPct val="115000"/>
+                <a:spcPct val="120000"/>
               </a:lnSpc>
             </a:pPr>
             <a:r>
-              <a:rPr sz="1500" b="0" i="0">
+              <a:rPr sz="1250" b="0" i="0">
                 <a:solidFill>
                   <a:srgbClr val="FFFFFF"/>
                 </a:solidFill>
@@ -10760,12 +10760,12 @@
         </p:nvSpPr>
         <p:spPr>
           <a:xfrm>
-            <a:off x="1051560" y="3557016"/>
-            <a:ext cx="4023360" cy="1097280"/>
+            <a:off x="1097280" y="3767328"/>
+            <a:ext cx="3840480" cy="822960"/>
           </a:xfrm>
           <a:prstGeom prst="roundRect">
             <a:avLst>
-              <a:gd name="adj" fmla="val 6000"/>
+              <a:gd name="adj" fmla="val 8000"/>
             </a:avLst>
           </a:prstGeom>
           <a:solidFill>
@@ -10791,28 +10791,28 @@
           </a:fontRef>
         </p:style>
         <p:txBody>
-          <a:bodyPr rtlCol="0" anchor="ctr" wrap="square" lIns="139700" rIns="139700" tIns="88900" bIns="88900"/>
+          <a:bodyPr rtlCol="0" anchor="ctr" wrap="square" lIns="127000" rIns="127000" tIns="88900" bIns="88900"/>
           <a:lstStyle/>
           <a:p>
             <a:pPr algn="l">
               <a:lnSpc>
-                <a:spcPct val="115000"/>
+                <a:spcPct val="120000"/>
               </a:lnSpc>
             </a:pPr>
             <a:r>
-              <a:rPr sz="1500" b="0" i="0">
+              <a:rPr sz="1250" b="0" i="0">
                 <a:solidFill>
                   <a:srgbClr val="0B2545"/>
                 </a:solidFill>
                 <a:latin typeface="Inter Tight"/>
               </a:rPr>
-              <a:t>Sim. Jejum de 4 horas. Leve o pedido médico e um documento com foto.</a:t>
+              <a:t>Sim. Mantenha jejum de 4 horas. Leve o pedido médico e um documento com foto.</a:t>
             </a:r>
           </a:p>
           <a:p>
             <a:pPr algn="l"/>
             <a:r>
-              <a:rPr sz="1300" b="1" i="0" spc="40">
+              <a:rPr sz="1000" b="1" i="0" spc="40">
                 <a:solidFill>
                   <a:srgbClr val="14418A"/>
                 </a:solidFill>
@@ -10831,12 +10831,12 @@
         </p:nvSpPr>
         <p:spPr>
           <a:xfrm>
-            <a:off x="3977640" y="4764024"/>
-            <a:ext cx="2194560" cy="420624"/>
+            <a:off x="4206240" y="4736592"/>
+            <a:ext cx="2011680" cy="402336"/>
           </a:xfrm>
           <a:prstGeom prst="roundRect">
             <a:avLst>
-              <a:gd name="adj" fmla="val 6000"/>
+              <a:gd name="adj" fmla="val 8000"/>
             </a:avLst>
           </a:prstGeom>
           <a:solidFill>
@@ -10862,16 +10862,16 @@
           </a:fontRef>
         </p:style>
         <p:txBody>
-          <a:bodyPr rtlCol="0" anchor="ctr" wrap="square" lIns="139700" rIns="139700" tIns="88900" bIns="88900"/>
+          <a:bodyPr rtlCol="0" anchor="ctr" wrap="square" lIns="127000" rIns="127000" tIns="88900" bIns="88900"/>
           <a:lstStyle/>
           <a:p>
             <a:pPr algn="l">
               <a:lnSpc>
-                <a:spcPct val="115000"/>
+                <a:spcPct val="120000"/>
               </a:lnSpc>
             </a:pPr>
             <a:r>
-              <a:rPr sz="1500" b="0" i="0">
+              <a:rPr sz="1250" b="0" i="0">
                 <a:solidFill>
                   <a:srgbClr val="FFFFFF"/>
                 </a:solidFill>
@@ -10890,12 +10890,12 @@
         </p:nvSpPr>
         <p:spPr>
           <a:xfrm>
-            <a:off x="1051560" y="5294376"/>
-            <a:ext cx="4023360" cy="877824"/>
+            <a:off x="1097280" y="5285232"/>
+            <a:ext cx="3840480" cy="822960"/>
           </a:xfrm>
           <a:prstGeom prst="roundRect">
             <a:avLst>
-              <a:gd name="adj" fmla="val 6000"/>
+              <a:gd name="adj" fmla="val 8000"/>
             </a:avLst>
           </a:prstGeom>
           <a:solidFill>
@@ -10921,16 +10921,16 @@
           </a:fontRef>
         </p:style>
         <p:txBody>
-          <a:bodyPr rtlCol="0" anchor="ctr" wrap="square" lIns="139700" rIns="139700" tIns="88900" bIns="88900"/>
+          <a:bodyPr rtlCol="0" anchor="ctr" wrap="square" lIns="127000" rIns="127000" tIns="88900" bIns="88900"/>
           <a:lstStyle/>
           <a:p>
             <a:pPr algn="l">
               <a:lnSpc>
-                <a:spcPct val="115000"/>
+                <a:spcPct val="120000"/>
               </a:lnSpc>
             </a:pPr>
             <a:r>
-              <a:rPr sz="1500" b="0" i="0">
+              <a:rPr sz="1250" b="0" i="0">
                 <a:solidFill>
                   <a:srgbClr val="0B2545"/>
                 </a:solidFill>
@@ -10942,7 +10942,7 @@
           <a:p>
             <a:pPr algn="l"/>
             <a:r>
-              <a:rPr sz="1300" b="1" i="0" spc="40">
+              <a:rPr sz="1000" b="1" i="0" spc="40">
                 <a:solidFill>
                   <a:srgbClr val="14418A"/>
                 </a:solidFill>
@@ -10961,8 +10961,8 @@
         </p:nvSpPr>
         <p:spPr>
           <a:xfrm>
-            <a:off x="7086600" y="2423160"/>
-            <a:ext cx="4327855" cy="1325880"/>
+            <a:off x="7132320" y="2514600"/>
+            <a:ext cx="4236415" cy="1188720"/>
           </a:xfrm>
           <a:prstGeom prst="rect">
             <a:avLst/>
@@ -10976,7 +10976,7 @@
           <a:lstStyle/>
           <a:p>
             <a:r>
-              <a:rPr sz="1800">
+              <a:rPr sz="1500">
                 <a:solidFill>
                   <a:srgbClr val="1D6FE0"/>
                 </a:solidFill>
@@ -10985,29 +10985,29 @@
               <a:t>→  </a:t>
             </a:r>
             <a:r>
-              <a:rPr sz="1800" b="1">
+              <a:rPr sz="1500" b="1">
                 <a:solidFill>
                   <a:srgbClr val="0B2545"/>
                 </a:solidFill>
                 <a:latin typeface="Inter Tight"/>
               </a:rPr>
-              <a:t>Picker guiado (paciente)</a:t>
+              <a:t>Linguagem natural</a:t>
             </a:r>
           </a:p>
           <a:p>
             <a:pPr algn="l">
               <a:lnSpc>
-                <a:spcPct val="125000"/>
+                <a:spcPct val="130000"/>
               </a:lnSpc>
             </a:pPr>
             <a:r>
-              <a:rPr sz="1800" b="0" i="0">
+              <a:rPr sz="1300" b="0" i="0">
                 <a:solidFill>
                   <a:srgbClr val="5A7299"/>
                 </a:solidFill>
                 <a:latin typeface="Inter Tight"/>
               </a:rPr>
-              <a:t>Escolhe modalidade e exame, responde contraste/sedação — sem saber o nome técnico.</a:t>
+              <a:t>O usuário pergunta como falaria — sem conhecer a sigla técnica do exame.</a:t>
             </a:r>
           </a:p>
         </p:txBody>
@@ -11020,8 +11020,8 @@
         </p:nvSpPr>
         <p:spPr>
           <a:xfrm>
-            <a:off x="7086600" y="3794760"/>
-            <a:ext cx="4327855" cy="1325880"/>
+            <a:off x="7132320" y="3794760"/>
+            <a:ext cx="4236415" cy="1188720"/>
           </a:xfrm>
           <a:prstGeom prst="rect">
             <a:avLst/>
@@ -11035,7 +11035,7 @@
           <a:lstStyle/>
           <a:p>
             <a:r>
-              <a:rPr sz="1800">
+              <a:rPr sz="1500">
                 <a:solidFill>
                   <a:srgbClr val="1D6FE0"/>
                 </a:solidFill>
@@ -11044,29 +11044,29 @@
               <a:t>→  </a:t>
             </a:r>
             <a:r>
-              <a:rPr sz="1800" b="1">
+              <a:rPr sz="1500" b="1">
                 <a:solidFill>
                   <a:srgbClr val="0B2545"/>
                 </a:solidFill>
                 <a:latin typeface="Inter Tight"/>
               </a:rPr>
-              <a:t>Código AGHU (profissional)</a:t>
+              <a:t>Fundamentação visível</a:t>
             </a:r>
           </a:p>
           <a:p>
             <a:pPr algn="l">
               <a:lnSpc>
-                <a:spcPct val="125000"/>
+                <a:spcPct val="130000"/>
               </a:lnSpc>
             </a:pPr>
             <a:r>
-              <a:rPr sz="1800" b="0" i="0">
+              <a:rPr sz="1300" b="0" i="0">
                 <a:solidFill>
                   <a:srgbClr val="5A7299"/>
                 </a:solidFill>
                 <a:latin typeface="Inter Tight"/>
               </a:rPr>
-              <a:t>Busca o exame e recebe o código para o cadastro. Paciente nunca vê.</a:t>
+              <a:t>Cada resposta aponta a origem no documento oficial do hospital.</a:t>
             </a:r>
           </a:p>
         </p:txBody>
@@ -11079,8 +11079,8 @@
         </p:nvSpPr>
         <p:spPr>
           <a:xfrm>
-            <a:off x="7086600" y="5166360"/>
-            <a:ext cx="4327855" cy="1325880"/>
+            <a:off x="7132320" y="5074920"/>
+            <a:ext cx="4236415" cy="1188720"/>
           </a:xfrm>
           <a:prstGeom prst="rect">
             <a:avLst/>
@@ -11094,7 +11094,7 @@
           <a:lstStyle/>
           <a:p>
             <a:r>
-              <a:rPr sz="1800">
+              <a:rPr sz="1500">
                 <a:solidFill>
                   <a:srgbClr val="1D6FE0"/>
                 </a:solidFill>
@@ -11103,29 +11103,29 @@
               <a:t>→  </a:t>
             </a:r>
             <a:r>
-              <a:rPr sz="1800" b="1">
+              <a:rPr sz="1500" b="1">
                 <a:solidFill>
                   <a:srgbClr val="0B2545"/>
                 </a:solidFill>
                 <a:latin typeface="Inter Tight"/>
               </a:rPr>
-              <a:t>Fundamentação + tom por perfil</a:t>
+              <a:t>Tom por perfil</a:t>
             </a:r>
           </a:p>
           <a:p>
             <a:pPr algn="l">
               <a:lnSpc>
-                <a:spcPct val="125000"/>
+                <a:spcPct val="130000"/>
               </a:lnSpc>
             </a:pPr>
             <a:r>
-              <a:rPr sz="1800" b="0" i="0">
+              <a:rPr sz="1300" b="0" i="0">
                 <a:solidFill>
                   <a:srgbClr val="5A7299"/>
                 </a:solidFill>
                 <a:latin typeface="Inter Tight"/>
               </a:rPr>
-              <a:t>Só dos documentos oficiais, no registro certo para cada público.</a:t>
+              <a:t>A mesma base responde ao paciente e ao profissional em registros diferentes.</a:t>
             </a:r>
           </a:p>
         </p:txBody>
@@ -11200,8 +11200,8 @@
         </p:nvSpPr>
         <p:spPr>
           <a:xfrm>
-            <a:off x="10271455" y="640080"/>
-            <a:ext cx="1143000" cy="320040"/>
+            <a:off x="10362895" y="566928"/>
+            <a:ext cx="1051560" cy="320040"/>
           </a:xfrm>
           <a:prstGeom prst="rect">
             <a:avLst/>
@@ -11216,7 +11216,7 @@
           <a:p>
             <a:pPr algn="r"/>
             <a:r>
-              <a:rPr sz="1300" b="1" i="0" spc="150">
+              <a:rPr sz="1000" b="1" i="0" spc="180">
                 <a:solidFill>
                   <a:srgbClr val="5A7299"/>
                 </a:solidFill>
@@ -11235,8 +11235,8 @@
         </p:nvSpPr>
         <p:spPr>
           <a:xfrm>
-            <a:off x="777240" y="640080"/>
-            <a:ext cx="8351215" cy="365760"/>
+            <a:off x="822960" y="566928"/>
+            <a:ext cx="8534095" cy="365760"/>
           </a:xfrm>
           <a:prstGeom prst="rect">
             <a:avLst/>
@@ -11250,7 +11250,7 @@
           <a:lstStyle/>
           <a:p>
             <a:r>
-              <a:rPr sz="1300">
+              <a:rPr sz="1000">
                 <a:solidFill>
                   <a:srgbClr val="1D6FE0"/>
                 </a:solidFill>
@@ -11259,7 +11259,7 @@
               <a:t>● </a:t>
             </a:r>
             <a:r>
-              <a:rPr sz="1300" b="1" spc="240">
+              <a:rPr sz="1000" b="1" spc="260">
                 <a:solidFill>
                   <a:srgbClr val="5A7299"/>
                 </a:solidFill>
@@ -11278,8 +11278,8 @@
         </p:nvSpPr>
         <p:spPr>
           <a:xfrm>
-            <a:off x="777240" y="1097280"/>
-            <a:ext cx="10637215" cy="2011680"/>
+            <a:off x="822960" y="1051560"/>
+            <a:ext cx="10545775" cy="1371600"/>
           </a:xfrm>
           <a:prstGeom prst="rect">
             <a:avLst/>
@@ -11294,11 +11294,11 @@
           <a:p>
             <a:pPr>
               <a:lnSpc>
-                <a:spcPct val="102000"/>
+                <a:spcPct val="103000"/>
               </a:lnSpc>
             </a:pPr>
             <a:r>
-              <a:rPr sz="3800" i="0">
+              <a:rPr sz="3400" i="0">
                 <a:solidFill>
                   <a:srgbClr val="0B2545"/>
                 </a:solidFill>
@@ -11307,7 +11307,7 @@
               <a:t>Pontos fortes </a:t>
             </a:r>
             <a:r>
-              <a:rPr sz="3800" i="1">
+              <a:rPr sz="3400" i="1">
                 <a:solidFill>
                   <a:srgbClr val="14418A"/>
                 </a:solidFill>
@@ -11316,7 +11316,7 @@
               <a:t>e</a:t>
             </a:r>
             <a:r>
-              <a:rPr sz="3800" i="0">
+              <a:rPr sz="3400" i="0">
                 <a:solidFill>
                   <a:srgbClr val="0B2545"/>
                 </a:solidFill>
@@ -11335,8 +11335,8 @@
         </p:nvSpPr>
         <p:spPr>
           <a:xfrm>
-            <a:off x="777240" y="2240280"/>
-            <a:ext cx="4861407" cy="365760"/>
+            <a:off x="822960" y="2194560"/>
+            <a:ext cx="4815687" cy="365760"/>
           </a:xfrm>
           <a:prstGeom prst="rect">
             <a:avLst/>
@@ -11351,7 +11351,7 @@
           <a:p>
             <a:pPr algn="l"/>
             <a:r>
-              <a:rPr sz="1500" b="1" i="0" spc="140">
+              <a:rPr sz="1100" b="1" i="0" spc="160">
                 <a:solidFill>
                   <a:srgbClr val="14418A"/>
                 </a:solidFill>
@@ -11370,8 +11370,8 @@
         </p:nvSpPr>
         <p:spPr>
           <a:xfrm>
-            <a:off x="777240" y="2880360"/>
-            <a:ext cx="4861407" cy="1234440"/>
+            <a:off x="822960" y="2788920"/>
+            <a:ext cx="4815687" cy="1143000"/>
           </a:xfrm>
           <a:prstGeom prst="rect">
             <a:avLst/>
@@ -11385,7 +11385,7 @@
           <a:lstStyle/>
           <a:p>
             <a:r>
-              <a:rPr sz="1800" b="1">
+              <a:rPr sz="1500" b="1">
                 <a:solidFill>
                   <a:srgbClr val="1D6FE0"/>
                 </a:solidFill>
@@ -11394,7 +11394,7 @@
               <a:t>+  </a:t>
             </a:r>
             <a:r>
-              <a:rPr sz="1800" b="1">
+              <a:rPr sz="1450" b="1">
                 <a:solidFill>
                   <a:srgbClr val="0B2545"/>
                 </a:solidFill>
@@ -11406,11 +11406,11 @@
           <a:p>
             <a:pPr algn="l">
               <a:lnSpc>
-                <a:spcPct val="125000"/>
+                <a:spcPct val="130000"/>
               </a:lnSpc>
             </a:pPr>
             <a:r>
-              <a:rPr sz="1800" b="0" i="0">
+              <a:rPr sz="1250" b="0" i="0">
                 <a:solidFill>
                   <a:srgbClr val="5A7299"/>
                 </a:solidFill>
@@ -11429,8 +11429,8 @@
         </p:nvSpPr>
         <p:spPr>
           <a:xfrm>
-            <a:off x="777240" y="4142232"/>
-            <a:ext cx="4861407" cy="1234440"/>
+            <a:off x="822960" y="3959352"/>
+            <a:ext cx="4815687" cy="1143000"/>
           </a:xfrm>
           <a:prstGeom prst="rect">
             <a:avLst/>
@@ -11444,7 +11444,7 @@
           <a:lstStyle/>
           <a:p>
             <a:r>
-              <a:rPr sz="1800" b="1">
+              <a:rPr sz="1500" b="1">
                 <a:solidFill>
                   <a:srgbClr val="1D6FE0"/>
                 </a:solidFill>
@@ -11453,7 +11453,7 @@
               <a:t>+  </a:t>
             </a:r>
             <a:r>
-              <a:rPr sz="1800" b="1">
+              <a:rPr sz="1450" b="1">
                 <a:solidFill>
                   <a:srgbClr val="0B2545"/>
                 </a:solidFill>
@@ -11465,17 +11465,17 @@
           <a:p>
             <a:pPr algn="l">
               <a:lnSpc>
-                <a:spcPct val="125000"/>
+                <a:spcPct val="130000"/>
               </a:lnSpc>
             </a:pPr>
             <a:r>
-              <a:rPr sz="1800" b="0" i="0">
+              <a:rPr sz="1250" b="0" i="0">
                 <a:solidFill>
                   <a:srgbClr val="5A7299"/>
                 </a:solidFill>
                 <a:latin typeface="Inter Tight"/>
               </a:rPr>
-              <a:t>Nunca presume que dispensa preparo; sem info, recusa e indica o setor.</a:t>
+              <a:t>Nunca presume que o exame dispensa preparo; sem informação, recusa e indica o setor.</a:t>
             </a:r>
           </a:p>
         </p:txBody>
@@ -11488,8 +11488,8 @@
         </p:nvSpPr>
         <p:spPr>
           <a:xfrm>
-            <a:off x="777240" y="5404104"/>
-            <a:ext cx="4861407" cy="1234440"/>
+            <a:off x="822960" y="5129784"/>
+            <a:ext cx="4815687" cy="1143000"/>
           </a:xfrm>
           <a:prstGeom prst="rect">
             <a:avLst/>
@@ -11503,7 +11503,7 @@
           <a:lstStyle/>
           <a:p>
             <a:r>
-              <a:rPr sz="1800" b="1">
+              <a:rPr sz="1500" b="1">
                 <a:solidFill>
                   <a:srgbClr val="1D6FE0"/>
                 </a:solidFill>
@@ -11512,7 +11512,7 @@
               <a:t>+  </a:t>
             </a:r>
             <a:r>
-              <a:rPr sz="1800" b="1">
+              <a:rPr sz="1450" b="1">
                 <a:solidFill>
                   <a:srgbClr val="0B2545"/>
                 </a:solidFill>
@@ -11524,11 +11524,11 @@
           <a:p>
             <a:pPr algn="l">
               <a:lnSpc>
-                <a:spcPct val="125000"/>
+                <a:spcPct val="130000"/>
               </a:lnSpc>
             </a:pPr>
             <a:r>
-              <a:rPr sz="1800" b="0" i="0">
+              <a:rPr sz="1250" b="0" i="0">
                 <a:solidFill>
                   <a:srgbClr val="5A7299"/>
                 </a:solidFill>
@@ -11547,8 +11547,8 @@
         </p:nvSpPr>
         <p:spPr>
           <a:xfrm>
-            <a:off x="6553047" y="2240280"/>
-            <a:ext cx="4861407" cy="365760"/>
+            <a:off x="6553047" y="2194560"/>
+            <a:ext cx="4815687" cy="365760"/>
           </a:xfrm>
           <a:prstGeom prst="rect">
             <a:avLst/>
@@ -11563,7 +11563,7 @@
           <a:p>
             <a:pPr algn="l"/>
             <a:r>
-              <a:rPr sz="1500" b="1" i="0" spc="140">
+              <a:rPr sz="1100" b="1" i="0" spc="160">
                 <a:solidFill>
                   <a:srgbClr val="5A7299"/>
                 </a:solidFill>
@@ -11582,8 +11582,8 @@
         </p:nvSpPr>
         <p:spPr>
           <a:xfrm>
-            <a:off x="6553047" y="2880360"/>
-            <a:ext cx="4861407" cy="1234440"/>
+            <a:off x="6553047" y="2788920"/>
+            <a:ext cx="4815687" cy="1143000"/>
           </a:xfrm>
           <a:prstGeom prst="rect">
             <a:avLst/>
@@ -11597,7 +11597,7 @@
           <a:lstStyle/>
           <a:p>
             <a:r>
-              <a:rPr sz="1800" b="1">
+              <a:rPr sz="1500" b="1">
                 <a:solidFill>
                   <a:srgbClr val="5A7299"/>
                 </a:solidFill>
@@ -11606,7 +11606,7 @@
               <a:t>–  </a:t>
             </a:r>
             <a:r>
-              <a:rPr sz="1800" b="1">
+              <a:rPr sz="1450" b="1">
                 <a:solidFill>
                   <a:srgbClr val="0B2545"/>
                 </a:solidFill>
@@ -11618,11 +11618,11 @@
           <a:p>
             <a:pPr algn="l">
               <a:lnSpc>
-                <a:spcPct val="125000"/>
+                <a:spcPct val="130000"/>
               </a:lnSpc>
             </a:pPr>
             <a:r>
-              <a:rPr sz="1800" b="0" i="0">
+              <a:rPr sz="1250" b="0" i="0">
                 <a:solidFill>
                   <a:srgbClr val="5A7299"/>
                 </a:solidFill>
@@ -11641,8 +11641,8 @@
         </p:nvSpPr>
         <p:spPr>
           <a:xfrm>
-            <a:off x="6553047" y="4142232"/>
-            <a:ext cx="4861407" cy="1234440"/>
+            <a:off x="6553047" y="3959352"/>
+            <a:ext cx="4815687" cy="1143000"/>
           </a:xfrm>
           <a:prstGeom prst="rect">
             <a:avLst/>
@@ -11656,7 +11656,7 @@
           <a:lstStyle/>
           <a:p>
             <a:r>
-              <a:rPr sz="1800" b="1">
+              <a:rPr sz="1500" b="1">
                 <a:solidFill>
                   <a:srgbClr val="5A7299"/>
                 </a:solidFill>
@@ -11665,7 +11665,7 @@
               <a:t>–  </a:t>
             </a:r>
             <a:r>
-              <a:rPr sz="1800" b="1">
+              <a:rPr sz="1450" b="1">
                 <a:solidFill>
                   <a:srgbClr val="0B2545"/>
                 </a:solidFill>
@@ -11677,11 +11677,11 @@
           <a:p>
             <a:pPr algn="l">
               <a:lnSpc>
-                <a:spcPct val="125000"/>
+                <a:spcPct val="130000"/>
               </a:lnSpc>
             </a:pPr>
             <a:r>
-              <a:rPr sz="1800" b="0" i="0">
+              <a:rPr sz="1250" b="0" i="0">
                 <a:solidFill>
                   <a:srgbClr val="5A7299"/>
                 </a:solidFill>
@@ -11700,8 +11700,8 @@
         </p:nvSpPr>
         <p:spPr>
           <a:xfrm>
-            <a:off x="6553047" y="5404104"/>
-            <a:ext cx="4861407" cy="1234440"/>
+            <a:off x="6553047" y="5129784"/>
+            <a:ext cx="4815687" cy="1143000"/>
           </a:xfrm>
           <a:prstGeom prst="rect">
             <a:avLst/>
@@ -11715,7 +11715,7 @@
           <a:lstStyle/>
           <a:p>
             <a:r>
-              <a:rPr sz="1800" b="1">
+              <a:rPr sz="1500" b="1">
                 <a:solidFill>
                   <a:srgbClr val="5A7299"/>
                 </a:solidFill>
@@ -11724,7 +11724,7 @@
               <a:t>–  </a:t>
             </a:r>
             <a:r>
-              <a:rPr sz="1800" b="1">
+              <a:rPr sz="1450" b="1">
                 <a:solidFill>
                   <a:srgbClr val="0B2545"/>
                 </a:solidFill>
@@ -11736,11 +11736,11 @@
           <a:p>
             <a:pPr algn="l">
               <a:lnSpc>
-                <a:spcPct val="125000"/>
+                <a:spcPct val="130000"/>
               </a:lnSpc>
             </a:pPr>
             <a:r>
-              <a:rPr sz="1800" b="0" i="0">
+              <a:rPr sz="1250" b="0" i="0">
                 <a:solidFill>
                   <a:srgbClr val="5A7299"/>
                 </a:solidFill>
@@ -11759,8 +11759,8 @@
         </p:nvSpPr>
         <p:spPr>
           <a:xfrm>
-            <a:off x="6095847" y="2286000"/>
-            <a:ext cx="12700" cy="3931920"/>
+            <a:off x="6095847" y="2194560"/>
+            <a:ext cx="12700" cy="3840480"/>
           </a:xfrm>
           <a:prstGeom prst="rect">
             <a:avLst/>

</xml_diff>